<commit_message>
MAJ diapos 2-7 et 12 : modèle de coût realiste Togo (902 etablissements publics, ~90% sans labo, ~8 Md FCFA, ~25x) + diapos plus data-driven
</commit_message>
<xml_diff>
--- a/VirtuLab_Togo_Presentation_Dr_Pagdame_Tiebekabe.pptx
+++ b/VirtuLab_Togo_Presentation_Dr_Pagdame_Tiebekabe.pptx
@@ -257,7 +257,7 @@
               <c:strCache>
                 <c:ptCount val="2"/>
                 <c:pt idx="0">
-                  <c:v>Sans laboratoire correctement équipé</c:v>
+                  <c:v>Sans laboratoire</c:v>
                 </c:pt>
                 <c:pt idx="1">
                   <c:v>Avec laboratoire</c:v>
@@ -5077,7 +5077,7 @@
                 <a:ea typeface="Trebuchet MS" pitchFamily="34" charset="-122"/>
                 <a:cs typeface="Trebuchet MS" pitchFamily="34" charset="-120"/>
               </a:rPr>
-              <a:t>Dès la quatrième année, l'État prend en charge hébergement et maintenance pour environ 12 M FCFA par an : environ 2 % de l'équipement physique des seuls 40 établissements du pilote.</a:t>
+              <a:t>Dès la quatrième année, l'État prend en charge hébergement et maintenance pour environ 12 M FCFA par an : environ 3 % de l'équipement physique des seuls 40 établissements du pilote.</a:t>
             </a:r>
             <a:endParaRPr lang="en-US" sz="1050" dirty="0"/>
           </a:p>
@@ -5859,7 +5859,7 @@
                 <a:ea typeface="Georgia" pitchFamily="34" charset="-122"/>
                 <a:cs typeface="Georgia" pitchFamily="34" charset="-120"/>
               </a:rPr>
-              <a:t>≈ 40 ×</a:t>
+              <a:t>≈ 25 ×</a:t>
             </a:r>
             <a:endParaRPr lang="en-US" sz="3000" dirty="0"/>
           </a:p>
@@ -5940,7 +5940,7 @@
                 <a:ea typeface="Trebuchet MS" pitchFamily="34" charset="-122"/>
                 <a:cs typeface="Trebuchet MS" pitchFamily="34" charset="-120"/>
               </a:rPr>
-              <a:t>La réforme devient exécutable partout pour 297 M FCFA, au lieu de milliards en laboratoires physiques : l'argent public va à l'usage, pas au bâti.</a:t>
+              <a:t>La réforme devient exécutable partout pour 297 M FCFA, au lieu d'environ 8 milliards en équipement physique : l'argent public va à l'usage, pas au bâti.</a:t>
             </a:r>
             <a:endParaRPr lang="en-US" sz="1050" dirty="0"/>
           </a:p>
@@ -6122,7 +6122,7 @@
         <p:spPr>
           <a:xfrm>
             <a:off x="457200" y="6035040"/>
-            <a:ext cx="11247120" cy="512064"/>
+            <a:ext cx="10698480" cy="512064"/>
           </a:xfrm>
           <a:prstGeom prst="roundRect">
             <a:avLst>
@@ -6144,7 +6144,7 @@
         <p:spPr>
           <a:xfrm>
             <a:off x="731520" y="6035040"/>
-            <a:ext cx="10698480" cy="512064"/>
+            <a:ext cx="10149840" cy="512064"/>
           </a:xfrm>
           <a:prstGeom prst="rect">
             <a:avLst/>
@@ -7710,7 +7710,7 @@
                 <a:ea typeface="Trebuchet MS" pitchFamily="34" charset="-122"/>
                 <a:cs typeface="Trebuchet MS" pitchFamily="34" charset="-120"/>
               </a:rPr>
-              <a:t>LE PROBLÈME</a:t>
+              <a:t>LE CONTEXTE</a:t>
             </a:r>
             <a:endParaRPr lang="en-US" sz="1250" dirty="0"/>
           </a:p>
@@ -7749,7 +7749,7 @@
                 <a:ea typeface="Georgia" pitchFamily="34" charset="-122"/>
                 <a:cs typeface="Georgia" pitchFamily="34" charset="-120"/>
               </a:rPr>
-              <a:t>La réforme des TP bute sur le manque de laboratoires</a:t>
+              <a:t>Une école qui grandit vite, des TP restés au tableau</a:t>
             </a:r>
             <a:endParaRPr lang="en-US" sz="2850" dirty="0"/>
           </a:p>
@@ -7777,522 +7777,24 @@
       </p:sp>
       <p:sp>
         <p:nvSpPr>
-          <p:cNvPr id="7" name="Text 4"/>
-          <p:cNvSpPr txBox="1"/>
+          <p:cNvPr id="7" name="Shape 4"/>
+          <p:cNvSpPr/>
           <p:nvPr/>
         </p:nvSpPr>
         <p:spPr>
           <a:xfrm>
             <a:off x="457200" y="1700784"/>
-            <a:ext cx="6492240" cy="603504"/>
-          </a:xfrm>
-          <a:prstGeom prst="rect">
-            <a:avLst/>
-          </a:prstGeom>
-          <a:noFill/>
-          <a:ln/>
-        </p:spPr>
-        <p:txBody>
-          <a:bodyPr wrap="square" rtlCol="0" anchor="t"/>
-          <a:lstStyle/>
-          <a:p>
-            <a:pPr algn="l" indent="0" marL="0">
-              <a:lnSpc>
-                <a:spcPct val="115000"/>
-              </a:lnSpc>
-              <a:buNone/>
-            </a:pPr>
-            <a:r>
-              <a:rPr lang="en-US" sz="1350" dirty="0">
-                <a:solidFill>
-                  <a:srgbClr val="22333B"/>
-                </a:solidFill>
-                <a:latin typeface="Trebuchet MS" pitchFamily="34" charset="0"/>
-                <a:ea typeface="Trebuchet MS" pitchFamily="34" charset="-122"/>
-                <a:cs typeface="Trebuchet MS" pitchFamily="34" charset="-120"/>
-              </a:rPr>
-              <a:t>Le ministère a inscrit les TP au programme du collège et du lycée. Le laboratoire, lui, manque presque partout.</a:t>
-            </a:r>
-            <a:endParaRPr lang="en-US" sz="1350" dirty="0"/>
-          </a:p>
-        </p:txBody>
-      </p:sp>
-      <p:sp>
-        <p:nvSpPr>
-          <p:cNvPr id="8" name="Shape 5"/>
-          <p:cNvSpPr/>
-          <p:nvPr/>
-        </p:nvSpPr>
-        <p:spPr>
-          <a:xfrm>
-            <a:off x="457200" y="2542032"/>
-            <a:ext cx="402336" cy="402336"/>
+            <a:ext cx="5394960" cy="3621024"/>
           </a:xfrm>
           <a:prstGeom prst="roundRect">
             <a:avLst>
-              <a:gd name="adj" fmla="val 13636"/>
-            </a:avLst>
-          </a:prstGeom>
-          <a:solidFill>
-            <a:srgbClr val="E0592A"/>
-          </a:solidFill>
-          <a:ln/>
-        </p:spPr>
-      </p:sp>
-      <p:sp>
-        <p:nvSpPr>
-          <p:cNvPr id="9" name="Text 6"/>
-          <p:cNvSpPr txBox="1"/>
-          <p:nvPr/>
-        </p:nvSpPr>
-        <p:spPr>
-          <a:xfrm>
-            <a:off x="457200" y="2542032"/>
-            <a:ext cx="402336" cy="402336"/>
-          </a:xfrm>
-          <a:prstGeom prst="rect">
-            <a:avLst/>
-          </a:prstGeom>
-          <a:noFill/>
-          <a:ln/>
-        </p:spPr>
-        <p:txBody>
-          <a:bodyPr wrap="square" rtlCol="0" anchor="ctr"/>
-          <a:lstStyle/>
-          <a:p>
-            <a:pPr algn="ctr" indent="0" marL="0">
-              <a:buNone/>
-            </a:pPr>
-            <a:r>
-              <a:rPr lang="en-US" sz="1600" b="1" dirty="0">
-                <a:solidFill>
-                  <a:srgbClr val="FFFFFF"/>
-                </a:solidFill>
-                <a:latin typeface="Georgia" pitchFamily="34" charset="0"/>
-                <a:ea typeface="Georgia" pitchFamily="34" charset="-122"/>
-                <a:cs typeface="Georgia" pitchFamily="34" charset="-120"/>
-              </a:rPr>
-              <a:t>1</a:t>
-            </a:r>
-            <a:endParaRPr lang="en-US" sz="1600" dirty="0"/>
-          </a:p>
-        </p:txBody>
-      </p:sp>
-      <p:sp>
-        <p:nvSpPr>
-          <p:cNvPr id="10" name="Text 7"/>
-          <p:cNvSpPr txBox="1"/>
-          <p:nvPr/>
-        </p:nvSpPr>
-        <p:spPr>
-          <a:xfrm>
-            <a:off x="1042416" y="2468880"/>
-            <a:ext cx="5897880" cy="822960"/>
-          </a:xfrm>
-          <a:prstGeom prst="rect">
-            <a:avLst/>
-          </a:prstGeom>
-          <a:noFill/>
-          <a:ln/>
-        </p:spPr>
-        <p:txBody>
-          <a:bodyPr wrap="square" rtlCol="0" anchor="ctr"/>
-          <a:lstStyle/>
-          <a:p>
-            <a:pPr algn="l" indent="0" marL="0">
-              <a:lnSpc>
-                <a:spcPct val="115000"/>
-              </a:lnSpc>
-              <a:buNone/>
-            </a:pPr>
-            <a:r>
-              <a:rPr lang="en-US" sz="1300" dirty="0">
-                <a:solidFill>
-                  <a:srgbClr val="22333B"/>
-                </a:solidFill>
-                <a:latin typeface="Trebuchet MS" pitchFamily="34" charset="0"/>
-                <a:ea typeface="Trebuchet MS" pitchFamily="34" charset="-122"/>
-                <a:cs typeface="Trebuchet MS" pitchFamily="34" charset="-120"/>
-              </a:rPr>
-              <a:t>Des TP « racontés » au tableau plutôt que pratiqués, faute de matériel dans les salles.</a:t>
-            </a:r>
-            <a:endParaRPr lang="en-US" sz="1300" dirty="0"/>
-          </a:p>
-        </p:txBody>
-      </p:sp>
-      <p:sp>
-        <p:nvSpPr>
-          <p:cNvPr id="11" name="Shape 8"/>
-          <p:cNvSpPr/>
-          <p:nvPr/>
-        </p:nvSpPr>
-        <p:spPr>
-          <a:xfrm>
-            <a:off x="457200" y="3621024"/>
-            <a:ext cx="402336" cy="402336"/>
-          </a:xfrm>
-          <a:prstGeom prst="roundRect">
-            <a:avLst>
-              <a:gd name="adj" fmla="val 13636"/>
-            </a:avLst>
-          </a:prstGeom>
-          <a:solidFill>
-            <a:srgbClr val="E0592A"/>
-          </a:solidFill>
-          <a:ln/>
-        </p:spPr>
-      </p:sp>
-      <p:sp>
-        <p:nvSpPr>
-          <p:cNvPr id="12" name="Text 9"/>
-          <p:cNvSpPr txBox="1"/>
-          <p:nvPr/>
-        </p:nvSpPr>
-        <p:spPr>
-          <a:xfrm>
-            <a:off x="457200" y="3621024"/>
-            <a:ext cx="402336" cy="402336"/>
-          </a:xfrm>
-          <a:prstGeom prst="rect">
-            <a:avLst/>
-          </a:prstGeom>
-          <a:noFill/>
-          <a:ln/>
-        </p:spPr>
-        <p:txBody>
-          <a:bodyPr wrap="square" rtlCol="0" anchor="ctr"/>
-          <a:lstStyle/>
-          <a:p>
-            <a:pPr algn="ctr" indent="0" marL="0">
-              <a:buNone/>
-            </a:pPr>
-            <a:r>
-              <a:rPr lang="en-US" sz="1600" b="1" dirty="0">
-                <a:solidFill>
-                  <a:srgbClr val="FFFFFF"/>
-                </a:solidFill>
-                <a:latin typeface="Georgia" pitchFamily="34" charset="0"/>
-                <a:ea typeface="Georgia" pitchFamily="34" charset="-122"/>
-                <a:cs typeface="Georgia" pitchFamily="34" charset="-120"/>
-              </a:rPr>
-              <a:t>2</a:t>
-            </a:r>
-            <a:endParaRPr lang="en-US" sz="1600" dirty="0"/>
-          </a:p>
-        </p:txBody>
-      </p:sp>
-      <p:sp>
-        <p:nvSpPr>
-          <p:cNvPr id="13" name="Text 10"/>
-          <p:cNvSpPr txBox="1"/>
-          <p:nvPr/>
-        </p:nvSpPr>
-        <p:spPr>
-          <a:xfrm>
-            <a:off x="1042416" y="3547872"/>
-            <a:ext cx="5897880" cy="822960"/>
-          </a:xfrm>
-          <a:prstGeom prst="rect">
-            <a:avLst/>
-          </a:prstGeom>
-          <a:noFill/>
-          <a:ln/>
-        </p:spPr>
-        <p:txBody>
-          <a:bodyPr wrap="square" rtlCol="0" anchor="ctr"/>
-          <a:lstStyle/>
-          <a:p>
-            <a:pPr algn="l" indent="0" marL="0">
-              <a:lnSpc>
-                <a:spcPct val="115000"/>
-              </a:lnSpc>
-              <a:buNone/>
-            </a:pPr>
-            <a:r>
-              <a:rPr lang="en-US" sz="1300" dirty="0">
-                <a:solidFill>
-                  <a:srgbClr val="22333B"/>
-                </a:solidFill>
-                <a:latin typeface="Trebuchet MS" pitchFamily="34" charset="0"/>
-                <a:ea typeface="Trebuchet MS" pitchFamily="34" charset="-122"/>
-                <a:cs typeface="Trebuchet MS" pitchFamily="34" charset="-120"/>
-              </a:rPr>
-              <a:t>Plusieurs millions de FCFA pour un seul laboratoire complet : hors de portée du budget public.</a:t>
-            </a:r>
-            <a:endParaRPr lang="en-US" sz="1300" dirty="0"/>
-          </a:p>
-        </p:txBody>
-      </p:sp>
-      <p:sp>
-        <p:nvSpPr>
-          <p:cNvPr id="14" name="Shape 11"/>
-          <p:cNvSpPr/>
-          <p:nvPr/>
-        </p:nvSpPr>
-        <p:spPr>
-          <a:xfrm>
-            <a:off x="457200" y="4700016"/>
-            <a:ext cx="402336" cy="402336"/>
-          </a:xfrm>
-          <a:prstGeom prst="roundRect">
-            <a:avLst>
-              <a:gd name="adj" fmla="val 13636"/>
-            </a:avLst>
-          </a:prstGeom>
-          <a:solidFill>
-            <a:srgbClr val="E0592A"/>
-          </a:solidFill>
-          <a:ln/>
-        </p:spPr>
-      </p:sp>
-      <p:sp>
-        <p:nvSpPr>
-          <p:cNvPr id="15" name="Text 12"/>
-          <p:cNvSpPr txBox="1"/>
-          <p:nvPr/>
-        </p:nvSpPr>
-        <p:spPr>
-          <a:xfrm>
-            <a:off x="457200" y="4700016"/>
-            <a:ext cx="402336" cy="402336"/>
-          </a:xfrm>
-          <a:prstGeom prst="rect">
-            <a:avLst/>
-          </a:prstGeom>
-          <a:noFill/>
-          <a:ln/>
-        </p:spPr>
-        <p:txBody>
-          <a:bodyPr wrap="square" rtlCol="0" anchor="ctr"/>
-          <a:lstStyle/>
-          <a:p>
-            <a:pPr algn="ctr" indent="0" marL="0">
-              <a:buNone/>
-            </a:pPr>
-            <a:r>
-              <a:rPr lang="en-US" sz="1600" b="1" dirty="0">
-                <a:solidFill>
-                  <a:srgbClr val="FFFFFF"/>
-                </a:solidFill>
-                <a:latin typeface="Georgia" pitchFamily="34" charset="0"/>
-                <a:ea typeface="Georgia" pitchFamily="34" charset="-122"/>
-                <a:cs typeface="Georgia" pitchFamily="34" charset="-120"/>
-              </a:rPr>
-              <a:t>3</a:t>
-            </a:r>
-            <a:endParaRPr lang="en-US" sz="1600" dirty="0"/>
-          </a:p>
-        </p:txBody>
-      </p:sp>
-      <p:sp>
-        <p:nvSpPr>
-          <p:cNvPr id="16" name="Text 13"/>
-          <p:cNvSpPr txBox="1"/>
-          <p:nvPr/>
-        </p:nvSpPr>
-        <p:spPr>
-          <a:xfrm>
-            <a:off x="1042416" y="4626864"/>
-            <a:ext cx="5897880" cy="822960"/>
-          </a:xfrm>
-          <a:prstGeom prst="rect">
-            <a:avLst/>
-          </a:prstGeom>
-          <a:noFill/>
-          <a:ln/>
-        </p:spPr>
-        <p:txBody>
-          <a:bodyPr wrap="square" rtlCol="0" anchor="ctr"/>
-          <a:lstStyle/>
-          <a:p>
-            <a:pPr algn="l" indent="0" marL="0">
-              <a:lnSpc>
-                <a:spcPct val="115000"/>
-              </a:lnSpc>
-              <a:buNone/>
-            </a:pPr>
-            <a:r>
-              <a:rPr lang="en-US" sz="1300" dirty="0">
-                <a:solidFill>
-                  <a:srgbClr val="22333B"/>
-                </a:solidFill>
-                <a:latin typeface="Trebuchet MS" pitchFamily="34" charset="0"/>
-                <a:ea typeface="Trebuchet MS" pitchFamily="34" charset="-122"/>
-                <a:cs typeface="Trebuchet MS" pitchFamily="34" charset="-120"/>
-              </a:rPr>
-              <a:t>Les élèves des zones reculées préparent des épreuves portant sur des manipulations qu'ils n'ont jamais réalisées.</a:t>
-            </a:r>
-            <a:endParaRPr lang="en-US" sz="1300" dirty="0"/>
-          </a:p>
-        </p:txBody>
-      </p:sp>
-      <p:sp>
-        <p:nvSpPr>
-          <p:cNvPr id="17" name="Shape 14"/>
-          <p:cNvSpPr/>
-          <p:nvPr/>
-        </p:nvSpPr>
-        <p:spPr>
-          <a:xfrm>
-            <a:off x="7269480" y="1700784"/>
-            <a:ext cx="4434840" cy="2194560"/>
-          </a:xfrm>
-          <a:prstGeom prst="roundRect">
-            <a:avLst>
-              <a:gd name="adj" fmla="val 4167"/>
+              <a:gd name="adj" fmla="val 2525"/>
             </a:avLst>
           </a:prstGeom>
           <a:solidFill>
             <a:srgbClr val="FFFFFF"/>
           </a:solidFill>
-          <a:ln w="19050">
-            <a:solidFill>
-              <a:srgbClr val="F8E4D9"/>
-            </a:solidFill>
-            <a:prstDash val="solid"/>
-          </a:ln>
-        </p:spPr>
-      </p:sp>
-      <p:sp>
-        <p:nvSpPr>
-          <p:cNvPr id="18" name="Text 15"/>
-          <p:cNvSpPr txBox="1"/>
-          <p:nvPr/>
-        </p:nvSpPr>
-        <p:spPr>
-          <a:xfrm>
-            <a:off x="7543800" y="1920240"/>
-            <a:ext cx="3886200" cy="713232"/>
-          </a:xfrm>
-          <a:prstGeom prst="rect">
-            <a:avLst/>
-          </a:prstGeom>
-          <a:noFill/>
-          <a:ln/>
-        </p:spPr>
-        <p:txBody>
-          <a:bodyPr wrap="square" rtlCol="0" anchor="ctr"/>
-          <a:lstStyle/>
-          <a:p>
-            <a:pPr algn="ctr" indent="0" marL="0">
-              <a:buNone/>
-            </a:pPr>
-            <a:r>
-              <a:rPr lang="en-US" sz="4200" b="1" dirty="0">
-                <a:solidFill>
-                  <a:srgbClr val="0E7C7B"/>
-                </a:solidFill>
-                <a:latin typeface="Georgia" pitchFamily="34" charset="0"/>
-                <a:ea typeface="Georgia" pitchFamily="34" charset="-122"/>
-                <a:cs typeface="Georgia" pitchFamily="34" charset="-120"/>
-              </a:rPr>
-              <a:t>915 214</a:t>
-            </a:r>
-            <a:endParaRPr lang="en-US" sz="4200" dirty="0"/>
-          </a:p>
-        </p:txBody>
-      </p:sp>
-      <p:sp>
-        <p:nvSpPr>
-          <p:cNvPr id="19" name="Text 16"/>
-          <p:cNvSpPr txBox="1"/>
-          <p:nvPr/>
-        </p:nvSpPr>
-        <p:spPr>
-          <a:xfrm>
-            <a:off x="7635240" y="2706624"/>
-            <a:ext cx="3703320" cy="822960"/>
-          </a:xfrm>
-          <a:prstGeom prst="rect">
-            <a:avLst/>
-          </a:prstGeom>
-          <a:noFill/>
-          <a:ln/>
-        </p:spPr>
-        <p:txBody>
-          <a:bodyPr wrap="square" rtlCol="0" anchor="t"/>
-          <a:lstStyle/>
-          <a:p>
-            <a:pPr algn="ctr" indent="0" marL="0">
-              <a:lnSpc>
-                <a:spcPct val="115000"/>
-              </a:lnSpc>
-              <a:buNone/>
-            </a:pPr>
-            <a:r>
-              <a:rPr lang="en-US" sz="1250" dirty="0">
-                <a:solidFill>
-                  <a:srgbClr val="22333B"/>
-                </a:solidFill>
-                <a:latin typeface="Trebuchet MS" pitchFamily="34" charset="0"/>
-                <a:ea typeface="Trebuchet MS" pitchFamily="34" charset="-122"/>
-                <a:cs typeface="Trebuchet MS" pitchFamily="34" charset="-120"/>
-              </a:rPr>
-              <a:t>élèves du secondaire au Togo sont concernés par la réforme des TP.</a:t>
-            </a:r>
-            <a:endParaRPr lang="en-US" sz="1250" dirty="0"/>
-          </a:p>
-        </p:txBody>
-      </p:sp>
-      <p:sp>
-        <p:nvSpPr>
-          <p:cNvPr id="20" name="Text 17"/>
-          <p:cNvSpPr txBox="1"/>
-          <p:nvPr/>
-        </p:nvSpPr>
-        <p:spPr>
-          <a:xfrm>
-            <a:off x="7635240" y="3529584"/>
-            <a:ext cx="3703320" cy="274320"/>
-          </a:xfrm>
-          <a:prstGeom prst="rect">
-            <a:avLst/>
-          </a:prstGeom>
-          <a:noFill/>
-          <a:ln/>
-        </p:spPr>
-        <p:txBody>
-          <a:bodyPr wrap="square" rtlCol="0" anchor="ctr"/>
-          <a:lstStyle/>
-          <a:p>
-            <a:pPr algn="ctr" indent="0" marL="0">
-              <a:buNone/>
-            </a:pPr>
-            <a:r>
-              <a:rPr lang="en-US" sz="950" i="1" dirty="0">
-                <a:solidFill>
-                  <a:srgbClr val="6E7B80"/>
-                </a:solidFill>
-                <a:latin typeface="Trebuchet MS" pitchFamily="34" charset="0"/>
-                <a:ea typeface="Trebuchet MS" pitchFamily="34" charset="-122"/>
-                <a:cs typeface="Trebuchet MS" pitchFamily="34" charset="-120"/>
-              </a:rPr>
-              <a:t>Banque mondiale et ISU, 2023</a:t>
-            </a:r>
-            <a:endParaRPr lang="en-US" sz="950" dirty="0"/>
-          </a:p>
-        </p:txBody>
-      </p:sp>
-      <p:sp>
-        <p:nvSpPr>
-          <p:cNvPr id="21" name="Shape 18"/>
-          <p:cNvSpPr/>
-          <p:nvPr/>
-        </p:nvSpPr>
-        <p:spPr>
-          <a:xfrm>
-            <a:off x="7269480" y="4133088"/>
-            <a:ext cx="4434840" cy="1938528"/>
-          </a:xfrm>
-          <a:prstGeom prst="roundRect">
-            <a:avLst>
-              <a:gd name="adj" fmla="val 4717"/>
-            </a:avLst>
-          </a:prstGeom>
-          <a:solidFill>
-            <a:srgbClr val="FFFFFF"/>
-          </a:solidFill>
-          <a:ln w="19050">
+          <a:ln w="15875">
             <a:solidFill>
               <a:srgbClr val="DCEBEA"/>
             </a:solidFill>
@@ -8302,17 +7804,258 @@
       </p:sp>
       <p:sp>
         <p:nvSpPr>
-          <p:cNvPr id="22" name="Shape 19"/>
+          <p:cNvPr id="8" name="Text 5"/>
+          <p:cNvSpPr txBox="1"/>
+          <p:nvPr/>
+        </p:nvSpPr>
+        <p:spPr>
+          <a:xfrm>
+            <a:off x="713232" y="1865376"/>
+            <a:ext cx="3657600" cy="310896"/>
+          </a:xfrm>
+          <a:prstGeom prst="rect">
+            <a:avLst/>
+          </a:prstGeom>
+          <a:noFill/>
+          <a:ln/>
+        </p:spPr>
+        <p:txBody>
+          <a:bodyPr wrap="square" rtlCol="0" anchor="ctr"/>
+          <a:lstStyle/>
+          <a:p>
+            <a:pPr algn="l" indent="0" marL="0">
+              <a:buNone/>
+            </a:pPr>
+            <a:r>
+              <a:rPr lang="en-US" sz="1300" b="1" dirty="0">
+                <a:solidFill>
+                  <a:srgbClr val="22333B"/>
+                </a:solidFill>
+                <a:latin typeface="Trebuchet MS" pitchFamily="34" charset="0"/>
+                <a:ea typeface="Trebuchet MS" pitchFamily="34" charset="-122"/>
+                <a:cs typeface="Trebuchet MS" pitchFamily="34" charset="-120"/>
+              </a:rPr>
+              <a:t>Collèges et lycées publics · Togo</a:t>
+            </a:r>
+            <a:endParaRPr lang="en-US" sz="1300" dirty="0"/>
+          </a:p>
+        </p:txBody>
+      </p:sp>
+      <p:sp>
+        <p:nvSpPr>
+          <p:cNvPr id="9" name="Shape 6"/>
           <p:cNvSpPr/>
           <p:nvPr/>
         </p:nvSpPr>
         <p:spPr>
           <a:xfrm>
-            <a:off x="7269480" y="4133088"/>
-            <a:ext cx="82296" cy="1938528"/>
-          </a:xfrm>
-          <a:prstGeom prst="rect">
-            <a:avLst/>
+            <a:off x="4279392" y="1865376"/>
+            <a:ext cx="1335024" cy="365760"/>
+          </a:xfrm>
+          <a:prstGeom prst="roundRect">
+            <a:avLst>
+              <a:gd name="adj" fmla="val 50000"/>
+            </a:avLst>
+          </a:prstGeom>
+          <a:solidFill>
+            <a:srgbClr val="F8E4D9"/>
+          </a:solidFill>
+          <a:ln/>
+        </p:spPr>
+      </p:sp>
+      <p:sp>
+        <p:nvSpPr>
+          <p:cNvPr id="10" name="Text 7"/>
+          <p:cNvSpPr txBox="1"/>
+          <p:nvPr/>
+        </p:nvSpPr>
+        <p:spPr>
+          <a:xfrm>
+            <a:off x="4279392" y="1865376"/>
+            <a:ext cx="1335024" cy="365760"/>
+          </a:xfrm>
+          <a:prstGeom prst="rect">
+            <a:avLst/>
+          </a:prstGeom>
+          <a:noFill/>
+          <a:ln/>
+        </p:spPr>
+        <p:txBody>
+          <a:bodyPr wrap="square" rtlCol="0" anchor="ctr"/>
+          <a:lstStyle/>
+          <a:p>
+            <a:pPr algn="ctr" indent="0" marL="0">
+              <a:buNone/>
+            </a:pPr>
+            <a:r>
+              <a:rPr lang="en-US" sz="1150" b="1" dirty="0">
+                <a:solidFill>
+                  <a:srgbClr val="B8431D"/>
+                </a:solidFill>
+                <a:latin typeface="Trebuchet MS" pitchFamily="34" charset="0"/>
+                <a:ea typeface="Trebuchet MS" pitchFamily="34" charset="-122"/>
+                <a:cs typeface="Trebuchet MS" pitchFamily="34" charset="-120"/>
+              </a:rPr>
+              <a:t>×3 en 13 ans</a:t>
+            </a:r>
+            <a:endParaRPr lang="en-US" sz="1150" dirty="0"/>
+          </a:p>
+        </p:txBody>
+      </p:sp>
+      <p:sp>
+        <p:nvSpPr>
+          <p:cNvPr id="11" name="Text 8"/>
+          <p:cNvSpPr txBox="1"/>
+          <p:nvPr/>
+        </p:nvSpPr>
+        <p:spPr>
+          <a:xfrm>
+            <a:off x="713232" y="2670048"/>
+            <a:ext cx="777240" cy="530352"/>
+          </a:xfrm>
+          <a:prstGeom prst="rect">
+            <a:avLst/>
+          </a:prstGeom>
+          <a:noFill/>
+          <a:ln/>
+        </p:spPr>
+        <p:txBody>
+          <a:bodyPr wrap="square" rtlCol="0" anchor="ctr"/>
+          <a:lstStyle/>
+          <a:p>
+            <a:pPr algn="l" indent="0" marL="0">
+              <a:buNone/>
+            </a:pPr>
+            <a:r>
+              <a:rPr lang="en-US" sz="1300" b="1" dirty="0">
+                <a:solidFill>
+                  <a:srgbClr val="6E7B80"/>
+                </a:solidFill>
+                <a:latin typeface="Trebuchet MS" pitchFamily="34" charset="0"/>
+                <a:ea typeface="Trebuchet MS" pitchFamily="34" charset="-122"/>
+                <a:cs typeface="Trebuchet MS" pitchFamily="34" charset="-120"/>
+              </a:rPr>
+              <a:t>2011</a:t>
+            </a:r>
+            <a:endParaRPr lang="en-US" sz="1300" dirty="0"/>
+          </a:p>
+        </p:txBody>
+      </p:sp>
+      <p:sp>
+        <p:nvSpPr>
+          <p:cNvPr id="12" name="Shape 9"/>
+          <p:cNvSpPr/>
+          <p:nvPr/>
+        </p:nvSpPr>
+        <p:spPr>
+          <a:xfrm>
+            <a:off x="1554480" y="2670048"/>
+            <a:ext cx="1058048" cy="530352"/>
+          </a:xfrm>
+          <a:prstGeom prst="roundRect">
+            <a:avLst>
+              <a:gd name="adj" fmla="val 12069"/>
+            </a:avLst>
+          </a:prstGeom>
+          <a:solidFill>
+            <a:srgbClr val="8A959B"/>
+          </a:solidFill>
+          <a:ln/>
+        </p:spPr>
+      </p:sp>
+      <p:sp>
+        <p:nvSpPr>
+          <p:cNvPr id="13" name="Text 10"/>
+          <p:cNvSpPr txBox="1"/>
+          <p:nvPr/>
+        </p:nvSpPr>
+        <p:spPr>
+          <a:xfrm>
+            <a:off x="2649104" y="2670048"/>
+            <a:ext cx="1097280" cy="530352"/>
+          </a:xfrm>
+          <a:prstGeom prst="rect">
+            <a:avLst/>
+          </a:prstGeom>
+          <a:noFill/>
+          <a:ln/>
+        </p:spPr>
+        <p:txBody>
+          <a:bodyPr wrap="square" rtlCol="0" anchor="ctr"/>
+          <a:lstStyle/>
+          <a:p>
+            <a:pPr algn="l" indent="0" marL="0">
+              <a:buNone/>
+            </a:pPr>
+            <a:r>
+              <a:rPr lang="en-US" sz="1900" b="1" dirty="0">
+                <a:solidFill>
+                  <a:srgbClr val="6E7B80"/>
+                </a:solidFill>
+                <a:latin typeface="Georgia" pitchFamily="34" charset="0"/>
+                <a:ea typeface="Georgia" pitchFamily="34" charset="-122"/>
+                <a:cs typeface="Georgia" pitchFamily="34" charset="-120"/>
+              </a:rPr>
+              <a:t>294</a:t>
+            </a:r>
+            <a:endParaRPr lang="en-US" sz="1900" dirty="0"/>
+          </a:p>
+        </p:txBody>
+      </p:sp>
+      <p:sp>
+        <p:nvSpPr>
+          <p:cNvPr id="14" name="Text 11"/>
+          <p:cNvSpPr txBox="1"/>
+          <p:nvPr/>
+        </p:nvSpPr>
+        <p:spPr>
+          <a:xfrm>
+            <a:off x="713232" y="3767328"/>
+            <a:ext cx="777240" cy="530352"/>
+          </a:xfrm>
+          <a:prstGeom prst="rect">
+            <a:avLst/>
+          </a:prstGeom>
+          <a:noFill/>
+          <a:ln/>
+        </p:spPr>
+        <p:txBody>
+          <a:bodyPr wrap="square" rtlCol="0" anchor="ctr"/>
+          <a:lstStyle/>
+          <a:p>
+            <a:pPr algn="l" indent="0" marL="0">
+              <a:buNone/>
+            </a:pPr>
+            <a:r>
+              <a:rPr lang="en-US" sz="1300" b="1" dirty="0">
+                <a:solidFill>
+                  <a:srgbClr val="22333B"/>
+                </a:solidFill>
+                <a:latin typeface="Trebuchet MS" pitchFamily="34" charset="0"/>
+                <a:ea typeface="Trebuchet MS" pitchFamily="34" charset="-122"/>
+                <a:cs typeface="Trebuchet MS" pitchFamily="34" charset="-120"/>
+              </a:rPr>
+              <a:t>2024</a:t>
+            </a:r>
+            <a:endParaRPr lang="en-US" sz="1300" dirty="0"/>
+          </a:p>
+        </p:txBody>
+      </p:sp>
+      <p:sp>
+        <p:nvSpPr>
+          <p:cNvPr id="15" name="Shape 12"/>
+          <p:cNvSpPr/>
+          <p:nvPr/>
+        </p:nvSpPr>
+        <p:spPr>
+          <a:xfrm>
+            <a:off x="1554480" y="3767328"/>
+            <a:ext cx="3246120" cy="530352"/>
+          </a:xfrm>
+          <a:prstGeom prst="roundRect">
+            <a:avLst>
+              <a:gd name="adj" fmla="val 12069"/>
+            </a:avLst>
           </a:prstGeom>
           <a:solidFill>
             <a:srgbClr val="0E7C7B"/>
@@ -8322,33 +8065,30 @@
       </p:sp>
       <p:sp>
         <p:nvSpPr>
-          <p:cNvPr id="23" name="Text 20"/>
-          <p:cNvSpPr txBox="1"/>
-          <p:nvPr/>
-        </p:nvSpPr>
-        <p:spPr>
-          <a:xfrm>
-            <a:off x="7562088" y="4334256"/>
-            <a:ext cx="3867912" cy="1005840"/>
-          </a:xfrm>
-          <a:prstGeom prst="rect">
-            <a:avLst/>
-          </a:prstGeom>
-          <a:noFill/>
-          <a:ln/>
-        </p:spPr>
-        <p:txBody>
-          <a:bodyPr wrap="square" rtlCol="0" anchor="t"/>
+          <p:cNvPr id="16" name="Text 13"/>
+          <p:cNvSpPr txBox="1"/>
+          <p:nvPr/>
+        </p:nvSpPr>
+        <p:spPr>
+          <a:xfrm>
+            <a:off x="4837176" y="3767328"/>
+            <a:ext cx="1097280" cy="530352"/>
+          </a:xfrm>
+          <a:prstGeom prst="rect">
+            <a:avLst/>
+          </a:prstGeom>
+          <a:noFill/>
+          <a:ln/>
+        </p:spPr>
+        <p:txBody>
+          <a:bodyPr wrap="square" rtlCol="0" anchor="ctr"/>
           <a:lstStyle/>
           <a:p>
             <a:pPr algn="l" indent="0" marL="0">
-              <a:lnSpc>
-                <a:spcPct val="118000"/>
-              </a:lnSpc>
-              <a:buNone/>
-            </a:pPr>
-            <a:r>
-              <a:rPr lang="en-US" sz="1450" i="1" dirty="0">
+              <a:buNone/>
+            </a:pPr>
+            <a:r>
+              <a:rPr lang="en-US" sz="2100" b="1" dirty="0">
                 <a:solidFill>
                   <a:srgbClr val="0A5C5B"/>
                 </a:solidFill>
@@ -8356,22 +8096,22 @@
                 <a:ea typeface="Georgia" pitchFamily="34" charset="-122"/>
                 <a:cs typeface="Georgia" pitchFamily="34" charset="-120"/>
               </a:rPr>
-              <a:t>« Les TP sont souvent racontés au tableau plutôt que pratiqués. »</a:t>
-            </a:r>
-            <a:endParaRPr lang="en-US" sz="1450" dirty="0"/>
-          </a:p>
-        </p:txBody>
-      </p:sp>
-      <p:sp>
-        <p:nvSpPr>
-          <p:cNvPr id="24" name="Text 21"/>
-          <p:cNvSpPr txBox="1"/>
-          <p:nvPr/>
-        </p:nvSpPr>
-        <p:spPr>
-          <a:xfrm>
-            <a:off x="7562088" y="5468112"/>
-            <a:ext cx="3867912" cy="475488"/>
+              <a:t>902</a:t>
+            </a:r>
+            <a:endParaRPr lang="en-US" sz="2100" dirty="0"/>
+          </a:p>
+        </p:txBody>
+      </p:sp>
+      <p:sp>
+        <p:nvSpPr>
+          <p:cNvPr id="17" name="Text 14"/>
+          <p:cNvSpPr txBox="1"/>
+          <p:nvPr/>
+        </p:nvSpPr>
+        <p:spPr>
+          <a:xfrm>
+            <a:off x="713232" y="4517136"/>
+            <a:ext cx="4882896" cy="512064"/>
           </a:xfrm>
           <a:prstGeom prst="rect">
             <a:avLst/>
@@ -8381,6 +8121,134 @@
         </p:spPr>
         <p:txBody>
           <a:bodyPr wrap="square" rtlCol="0" anchor="t"/>
+          <a:lstStyle/>
+          <a:p>
+            <a:pPr algn="l" indent="0" marL="0">
+              <a:lnSpc>
+                <a:spcPct val="112000"/>
+              </a:lnSpc>
+              <a:buNone/>
+            </a:pPr>
+            <a:r>
+              <a:rPr lang="en-US" sz="1100" dirty="0">
+                <a:solidFill>
+                  <a:srgbClr val="6E7B80"/>
+                </a:solidFill>
+                <a:latin typeface="Trebuchet MS" pitchFamily="34" charset="0"/>
+                <a:ea typeface="Trebuchet MS" pitchFamily="34" charset="-122"/>
+                <a:cs typeface="Trebuchet MS" pitchFamily="34" charset="-120"/>
+              </a:rPr>
+              <a:t>608 créés depuis 2011, souvent en zones rurales, sans salle de sciences ni matériel.</a:t>
+            </a:r>
+            <a:endParaRPr lang="en-US" sz="1100" dirty="0"/>
+          </a:p>
+        </p:txBody>
+      </p:sp>
+      <p:sp>
+        <p:nvSpPr>
+          <p:cNvPr id="18" name="Shape 15"/>
+          <p:cNvSpPr/>
+          <p:nvPr/>
+        </p:nvSpPr>
+        <p:spPr>
+          <a:xfrm>
+            <a:off x="6089904" y="1700784"/>
+            <a:ext cx="5614416" cy="1133856"/>
+          </a:xfrm>
+          <a:prstGeom prst="roundRect">
+            <a:avLst>
+              <a:gd name="adj" fmla="val 8065"/>
+            </a:avLst>
+          </a:prstGeom>
+          <a:solidFill>
+            <a:srgbClr val="FFFFFF"/>
+          </a:solidFill>
+          <a:ln w="15875">
+            <a:solidFill>
+              <a:srgbClr val="DCEBEA"/>
+            </a:solidFill>
+            <a:prstDash val="solid"/>
+          </a:ln>
+        </p:spPr>
+      </p:sp>
+      <p:sp>
+        <p:nvSpPr>
+          <p:cNvPr id="19" name="Shape 16"/>
+          <p:cNvSpPr/>
+          <p:nvPr/>
+        </p:nvSpPr>
+        <p:spPr>
+          <a:xfrm>
+            <a:off x="6089904" y="1700784"/>
+            <a:ext cx="82296" cy="1133856"/>
+          </a:xfrm>
+          <a:prstGeom prst="rect">
+            <a:avLst/>
+          </a:prstGeom>
+          <a:solidFill>
+            <a:srgbClr val="0E7C7B"/>
+          </a:solidFill>
+          <a:ln/>
+        </p:spPr>
+      </p:sp>
+      <p:sp>
+        <p:nvSpPr>
+          <p:cNvPr id="20" name="Text 17"/>
+          <p:cNvSpPr txBox="1"/>
+          <p:nvPr/>
+        </p:nvSpPr>
+        <p:spPr>
+          <a:xfrm>
+            <a:off x="6327648" y="1810512"/>
+            <a:ext cx="1874520" cy="914400"/>
+          </a:xfrm>
+          <a:prstGeom prst="rect">
+            <a:avLst/>
+          </a:prstGeom>
+          <a:noFill/>
+          <a:ln/>
+        </p:spPr>
+        <p:txBody>
+          <a:bodyPr wrap="square" rtlCol="0" anchor="ctr"/>
+          <a:lstStyle/>
+          <a:p>
+            <a:pPr algn="l" indent="0" marL="0">
+              <a:buNone/>
+            </a:pPr>
+            <a:r>
+              <a:rPr lang="en-US" sz="2700" b="1" dirty="0">
+                <a:solidFill>
+                  <a:srgbClr val="0E7C7B"/>
+                </a:solidFill>
+                <a:latin typeface="Georgia" pitchFamily="34" charset="0"/>
+                <a:ea typeface="Georgia" pitchFamily="34" charset="-122"/>
+                <a:cs typeface="Georgia" pitchFamily="34" charset="-120"/>
+              </a:rPr>
+              <a:t>915 214</a:t>
+            </a:r>
+            <a:endParaRPr lang="en-US" sz="2700" dirty="0"/>
+          </a:p>
+        </p:txBody>
+      </p:sp>
+      <p:sp>
+        <p:nvSpPr>
+          <p:cNvPr id="21" name="Text 18"/>
+          <p:cNvSpPr txBox="1"/>
+          <p:nvPr/>
+        </p:nvSpPr>
+        <p:spPr>
+          <a:xfrm>
+            <a:off x="8302752" y="1792224"/>
+            <a:ext cx="3163824" cy="694944"/>
+          </a:xfrm>
+          <a:prstGeom prst="rect">
+            <a:avLst/>
+          </a:prstGeom>
+          <a:noFill/>
+          <a:ln/>
+        </p:spPr>
+        <p:txBody>
+          <a:bodyPr wrap="square" rtlCol="0" anchor="ctr"/>
           <a:lstStyle/>
           <a:p>
             <a:pPr algn="l" indent="0" marL="0">
@@ -8390,30 +8258,30 @@
               <a:buNone/>
             </a:pPr>
             <a:r>
-              <a:rPr lang="en-US" sz="1000" dirty="0">
-                <a:solidFill>
-                  <a:srgbClr val="6E7B80"/>
+              <a:rPr lang="en-US" sz="1050" dirty="0">
+                <a:solidFill>
+                  <a:srgbClr val="22333B"/>
                 </a:solidFill>
                 <a:latin typeface="Trebuchet MS" pitchFamily="34" charset="0"/>
                 <a:ea typeface="Trebuchet MS" pitchFamily="34" charset="-122"/>
                 <a:cs typeface="Trebuchet MS" pitchFamily="34" charset="-120"/>
               </a:rPr>
-              <a:t>Constat récurrent des inspections dans les salles sans matériel</a:t>
-            </a:r>
-            <a:endParaRPr lang="en-US" sz="1000" dirty="0"/>
-          </a:p>
-        </p:txBody>
-      </p:sp>
-      <p:sp>
-        <p:nvSpPr>
-          <p:cNvPr id="25" name="Text 22"/>
-          <p:cNvSpPr txBox="1"/>
-          <p:nvPr/>
-        </p:nvSpPr>
-        <p:spPr>
-          <a:xfrm>
-            <a:off x="457200" y="6419088"/>
-            <a:ext cx="10515600" cy="329184"/>
+              <a:t>élèves du secondaire, public et privé, concernés par la réforme des TP.</a:t>
+            </a:r>
+            <a:endParaRPr lang="en-US" sz="1050" dirty="0"/>
+          </a:p>
+        </p:txBody>
+      </p:sp>
+      <p:sp>
+        <p:nvSpPr>
+          <p:cNvPr id="22" name="Text 19"/>
+          <p:cNvSpPr txBox="1"/>
+          <p:nvPr/>
+        </p:nvSpPr>
+        <p:spPr>
+          <a:xfrm>
+            <a:off x="8302752" y="2523744"/>
+            <a:ext cx="3163824" cy="237744"/>
           </a:xfrm>
           <a:prstGeom prst="rect">
             <a:avLst/>
@@ -8429,7 +8297,7 @@
               <a:buNone/>
             </a:pPr>
             <a:r>
-              <a:rPr lang="en-US" sz="900" dirty="0">
+              <a:rPr lang="en-US" sz="850" i="1" dirty="0">
                 <a:solidFill>
                   <a:srgbClr val="6E7B80"/>
                 </a:solidFill>
@@ -8437,7 +8305,444 @@
                 <a:ea typeface="Trebuchet MS" pitchFamily="34" charset="-122"/>
                 <a:cs typeface="Trebuchet MS" pitchFamily="34" charset="-120"/>
               </a:rPr>
-              <a:t>Sources : Banque mondiale et Institut de statistique de l'UNESCO (2023) ; Direction de la Planification de l'Éducation, Togo (2025).</a:t>
+              <a:t>Banque mondiale et ISU, 2023</a:t>
+            </a:r>
+            <a:endParaRPr lang="en-US" sz="850" dirty="0"/>
+          </a:p>
+        </p:txBody>
+      </p:sp>
+      <p:sp>
+        <p:nvSpPr>
+          <p:cNvPr id="23" name="Shape 20"/>
+          <p:cNvSpPr/>
+          <p:nvPr/>
+        </p:nvSpPr>
+        <p:spPr>
+          <a:xfrm>
+            <a:off x="6089904" y="2944368"/>
+            <a:ext cx="5614416" cy="1133856"/>
+          </a:xfrm>
+          <a:prstGeom prst="roundRect">
+            <a:avLst>
+              <a:gd name="adj" fmla="val 8065"/>
+            </a:avLst>
+          </a:prstGeom>
+          <a:solidFill>
+            <a:srgbClr val="FFFFFF"/>
+          </a:solidFill>
+          <a:ln w="15875">
+            <a:solidFill>
+              <a:srgbClr val="DCEBEA"/>
+            </a:solidFill>
+            <a:prstDash val="solid"/>
+          </a:ln>
+        </p:spPr>
+      </p:sp>
+      <p:sp>
+        <p:nvSpPr>
+          <p:cNvPr id="24" name="Shape 21"/>
+          <p:cNvSpPr/>
+          <p:nvPr/>
+        </p:nvSpPr>
+        <p:spPr>
+          <a:xfrm>
+            <a:off x="6089904" y="2944368"/>
+            <a:ext cx="82296" cy="1133856"/>
+          </a:xfrm>
+          <a:prstGeom prst="rect">
+            <a:avLst/>
+          </a:prstGeom>
+          <a:solidFill>
+            <a:srgbClr val="E0592A"/>
+          </a:solidFill>
+          <a:ln/>
+        </p:spPr>
+      </p:sp>
+      <p:sp>
+        <p:nvSpPr>
+          <p:cNvPr id="25" name="Text 22"/>
+          <p:cNvSpPr txBox="1"/>
+          <p:nvPr/>
+        </p:nvSpPr>
+        <p:spPr>
+          <a:xfrm>
+            <a:off x="6327648" y="3054096"/>
+            <a:ext cx="1874520" cy="914400"/>
+          </a:xfrm>
+          <a:prstGeom prst="rect">
+            <a:avLst/>
+          </a:prstGeom>
+          <a:noFill/>
+          <a:ln/>
+        </p:spPr>
+        <p:txBody>
+          <a:bodyPr wrap="square" rtlCol="0" anchor="ctr"/>
+          <a:lstStyle/>
+          <a:p>
+            <a:pPr algn="l" indent="0" marL="0">
+              <a:buNone/>
+            </a:pPr>
+            <a:r>
+              <a:rPr lang="en-US" sz="2700" b="1" dirty="0">
+                <a:solidFill>
+                  <a:srgbClr val="E0592A"/>
+                </a:solidFill>
+                <a:latin typeface="Georgia" pitchFamily="34" charset="0"/>
+                <a:ea typeface="Georgia" pitchFamily="34" charset="-122"/>
+                <a:cs typeface="Georgia" pitchFamily="34" charset="-120"/>
+              </a:rPr>
+              <a:t>≈ 90 %</a:t>
+            </a:r>
+            <a:endParaRPr lang="en-US" sz="2700" dirty="0"/>
+          </a:p>
+        </p:txBody>
+      </p:sp>
+      <p:sp>
+        <p:nvSpPr>
+          <p:cNvPr id="26" name="Text 23"/>
+          <p:cNvSpPr txBox="1"/>
+          <p:nvPr/>
+        </p:nvSpPr>
+        <p:spPr>
+          <a:xfrm>
+            <a:off x="8302752" y="3035808"/>
+            <a:ext cx="3163824" cy="694944"/>
+          </a:xfrm>
+          <a:prstGeom prst="rect">
+            <a:avLst/>
+          </a:prstGeom>
+          <a:noFill/>
+          <a:ln/>
+        </p:spPr>
+        <p:txBody>
+          <a:bodyPr wrap="square" rtlCol="0" anchor="ctr"/>
+          <a:lstStyle/>
+          <a:p>
+            <a:pPr algn="l" indent="0" marL="0">
+              <a:lnSpc>
+                <a:spcPct val="110000"/>
+              </a:lnSpc>
+              <a:buNone/>
+            </a:pPr>
+            <a:r>
+              <a:rPr lang="en-US" sz="1050" dirty="0">
+                <a:solidFill>
+                  <a:srgbClr val="22333B"/>
+                </a:solidFill>
+                <a:latin typeface="Trebuchet MS" pitchFamily="34" charset="0"/>
+                <a:ea typeface="Trebuchet MS" pitchFamily="34" charset="-122"/>
+                <a:cs typeface="Trebuchet MS" pitchFamily="34" charset="-120"/>
+              </a:rPr>
+              <a:t>des écoles d'Afrique subsaharienne n'ont pas de laboratoire de sciences.</a:t>
+            </a:r>
+            <a:endParaRPr lang="en-US" sz="1050" dirty="0"/>
+          </a:p>
+        </p:txBody>
+      </p:sp>
+      <p:sp>
+        <p:nvSpPr>
+          <p:cNvPr id="27" name="Text 24"/>
+          <p:cNvSpPr txBox="1"/>
+          <p:nvPr/>
+        </p:nvSpPr>
+        <p:spPr>
+          <a:xfrm>
+            <a:off x="8302752" y="3767328"/>
+            <a:ext cx="3163824" cy="237744"/>
+          </a:xfrm>
+          <a:prstGeom prst="rect">
+            <a:avLst/>
+          </a:prstGeom>
+          <a:noFill/>
+          <a:ln/>
+        </p:spPr>
+        <p:txBody>
+          <a:bodyPr wrap="square" rtlCol="0" anchor="ctr"/>
+          <a:lstStyle/>
+          <a:p>
+            <a:pPr algn="l" indent="0" marL="0">
+              <a:buNone/>
+            </a:pPr>
+            <a:r>
+              <a:rPr lang="en-US" sz="850" i="1" dirty="0">
+                <a:solidFill>
+                  <a:srgbClr val="6E7B80"/>
+                </a:solidFill>
+                <a:latin typeface="Trebuchet MS" pitchFamily="34" charset="0"/>
+                <a:ea typeface="Trebuchet MS" pitchFamily="34" charset="-122"/>
+                <a:cs typeface="Trebuchet MS" pitchFamily="34" charset="-120"/>
+              </a:rPr>
+              <a:t>Partenariat mondial pour l'éducation (GPE), 2019</a:t>
+            </a:r>
+            <a:endParaRPr lang="en-US" sz="850" dirty="0"/>
+          </a:p>
+        </p:txBody>
+      </p:sp>
+      <p:sp>
+        <p:nvSpPr>
+          <p:cNvPr id="28" name="Shape 25"/>
+          <p:cNvSpPr/>
+          <p:nvPr/>
+        </p:nvSpPr>
+        <p:spPr>
+          <a:xfrm>
+            <a:off x="6089904" y="4187952"/>
+            <a:ext cx="5614416" cy="1133856"/>
+          </a:xfrm>
+          <a:prstGeom prst="roundRect">
+            <a:avLst>
+              <a:gd name="adj" fmla="val 8065"/>
+            </a:avLst>
+          </a:prstGeom>
+          <a:solidFill>
+            <a:srgbClr val="FFFFFF"/>
+          </a:solidFill>
+          <a:ln w="15875">
+            <a:solidFill>
+              <a:srgbClr val="DCEBEA"/>
+            </a:solidFill>
+            <a:prstDash val="solid"/>
+          </a:ln>
+        </p:spPr>
+      </p:sp>
+      <p:sp>
+        <p:nvSpPr>
+          <p:cNvPr id="29" name="Shape 26"/>
+          <p:cNvSpPr/>
+          <p:nvPr/>
+        </p:nvSpPr>
+        <p:spPr>
+          <a:xfrm>
+            <a:off x="6089904" y="4187952"/>
+            <a:ext cx="82296" cy="1133856"/>
+          </a:xfrm>
+          <a:prstGeom prst="rect">
+            <a:avLst/>
+          </a:prstGeom>
+          <a:solidFill>
+            <a:srgbClr val="0E7C7B"/>
+          </a:solidFill>
+          <a:ln/>
+        </p:spPr>
+      </p:sp>
+      <p:sp>
+        <p:nvSpPr>
+          <p:cNvPr id="30" name="Text 27"/>
+          <p:cNvSpPr txBox="1"/>
+          <p:nvPr/>
+        </p:nvSpPr>
+        <p:spPr>
+          <a:xfrm>
+            <a:off x="6327648" y="4297680"/>
+            <a:ext cx="1874520" cy="914400"/>
+          </a:xfrm>
+          <a:prstGeom prst="rect">
+            <a:avLst/>
+          </a:prstGeom>
+          <a:noFill/>
+          <a:ln/>
+        </p:spPr>
+        <p:txBody>
+          <a:bodyPr wrap="square" rtlCol="0" anchor="ctr"/>
+          <a:lstStyle/>
+          <a:p>
+            <a:pPr algn="l" indent="0" marL="0">
+              <a:buNone/>
+            </a:pPr>
+            <a:r>
+              <a:rPr lang="en-US" sz="2700" b="1" dirty="0">
+                <a:solidFill>
+                  <a:srgbClr val="0E7C7B"/>
+                </a:solidFill>
+                <a:latin typeface="Georgia" pitchFamily="34" charset="0"/>
+                <a:ea typeface="Georgia" pitchFamily="34" charset="-122"/>
+                <a:cs typeface="Georgia" pitchFamily="34" charset="-120"/>
+              </a:rPr>
+              <a:t>33,9 %</a:t>
+            </a:r>
+            <a:endParaRPr lang="en-US" sz="2700" dirty="0"/>
+          </a:p>
+        </p:txBody>
+      </p:sp>
+      <p:sp>
+        <p:nvSpPr>
+          <p:cNvPr id="31" name="Text 28"/>
+          <p:cNvSpPr txBox="1"/>
+          <p:nvPr/>
+        </p:nvSpPr>
+        <p:spPr>
+          <a:xfrm>
+            <a:off x="8302752" y="4279392"/>
+            <a:ext cx="3163824" cy="694944"/>
+          </a:xfrm>
+          <a:prstGeom prst="rect">
+            <a:avLst/>
+          </a:prstGeom>
+          <a:noFill/>
+          <a:ln/>
+        </p:spPr>
+        <p:txBody>
+          <a:bodyPr wrap="square" rtlCol="0" anchor="ctr"/>
+          <a:lstStyle/>
+          <a:p>
+            <a:pPr algn="l" indent="0" marL="0">
+              <a:lnSpc>
+                <a:spcPct val="110000"/>
+              </a:lnSpc>
+              <a:buNone/>
+            </a:pPr>
+            <a:r>
+              <a:rPr lang="en-US" sz="1050" dirty="0">
+                <a:solidFill>
+                  <a:srgbClr val="22333B"/>
+                </a:solidFill>
+                <a:latin typeface="Trebuchet MS" pitchFamily="34" charset="0"/>
+                <a:ea typeface="Trebuchet MS" pitchFamily="34" charset="-122"/>
+                <a:cs typeface="Trebuchet MS" pitchFamily="34" charset="-120"/>
+              </a:rPr>
+              <a:t>d'électrification en zones rurales : un laboratoire ne s'allume pas.</a:t>
+            </a:r>
+            <a:endParaRPr lang="en-US" sz="1050" dirty="0"/>
+          </a:p>
+        </p:txBody>
+      </p:sp>
+      <p:sp>
+        <p:nvSpPr>
+          <p:cNvPr id="32" name="Text 29"/>
+          <p:cNvSpPr txBox="1"/>
+          <p:nvPr/>
+        </p:nvSpPr>
+        <p:spPr>
+          <a:xfrm>
+            <a:off x="8302752" y="5010912"/>
+            <a:ext cx="3163824" cy="237744"/>
+          </a:xfrm>
+          <a:prstGeom prst="rect">
+            <a:avLst/>
+          </a:prstGeom>
+          <a:noFill/>
+          <a:ln/>
+        </p:spPr>
+        <p:txBody>
+          <a:bodyPr wrap="square" rtlCol="0" anchor="ctr"/>
+          <a:lstStyle/>
+          <a:p>
+            <a:pPr algn="l" indent="0" marL="0">
+              <a:buNone/>
+            </a:pPr>
+            <a:r>
+              <a:rPr lang="en-US" sz="850" i="1" dirty="0">
+                <a:solidFill>
+                  <a:srgbClr val="6E7B80"/>
+                </a:solidFill>
+                <a:latin typeface="Trebuchet MS" pitchFamily="34" charset="0"/>
+                <a:ea typeface="Trebuchet MS" pitchFamily="34" charset="-122"/>
+                <a:cs typeface="Trebuchet MS" pitchFamily="34" charset="-120"/>
+              </a:rPr>
+              <a:t>Banque mondiale, 2024</a:t>
+            </a:r>
+            <a:endParaRPr lang="en-US" sz="850" dirty="0"/>
+          </a:p>
+        </p:txBody>
+      </p:sp>
+      <p:sp>
+        <p:nvSpPr>
+          <p:cNvPr id="33" name="Shape 30"/>
+          <p:cNvSpPr/>
+          <p:nvPr/>
+        </p:nvSpPr>
+        <p:spPr>
+          <a:xfrm>
+            <a:off x="457200" y="5614416"/>
+            <a:ext cx="11247120" cy="658368"/>
+          </a:xfrm>
+          <a:prstGeom prst="roundRect">
+            <a:avLst>
+              <a:gd name="adj" fmla="val 12500"/>
+            </a:avLst>
+          </a:prstGeom>
+          <a:solidFill>
+            <a:srgbClr val="0A5C5B"/>
+          </a:solidFill>
+          <a:ln/>
+        </p:spPr>
+      </p:sp>
+      <p:sp>
+        <p:nvSpPr>
+          <p:cNvPr id="34" name="Text 31"/>
+          <p:cNvSpPr txBox="1"/>
+          <p:nvPr/>
+        </p:nvSpPr>
+        <p:spPr>
+          <a:xfrm>
+            <a:off x="731520" y="5614416"/>
+            <a:ext cx="10698480" cy="658368"/>
+          </a:xfrm>
+          <a:prstGeom prst="rect">
+            <a:avLst/>
+          </a:prstGeom>
+          <a:noFill/>
+          <a:ln/>
+        </p:spPr>
+        <p:txBody>
+          <a:bodyPr wrap="square" rtlCol="0" anchor="ctr"/>
+          <a:lstStyle/>
+          <a:p>
+            <a:pPr algn="l" indent="0" marL="0">
+              <a:lnSpc>
+                <a:spcPct val="105000"/>
+              </a:lnSpc>
+              <a:buNone/>
+            </a:pPr>
+            <a:r>
+              <a:rPr lang="en-US" sz="1200" b="1" dirty="0">
+                <a:solidFill>
+                  <a:srgbClr val="FFFFFF"/>
+                </a:solidFill>
+                <a:latin typeface="Trebuchet MS" pitchFamily="34" charset="0"/>
+                <a:ea typeface="Trebuchet MS" pitchFamily="34" charset="-122"/>
+                <a:cs typeface="Trebuchet MS" pitchFamily="34" charset="-120"/>
+              </a:rPr>
+              <a:t>Le BEPC et le baccalauréat interrogent chaque année des manipulations que la majorité des élèves n'a jamais pratiquées.</a:t>
+            </a:r>
+            <a:endParaRPr lang="en-US" sz="1200" dirty="0"/>
+          </a:p>
+        </p:txBody>
+      </p:sp>
+      <p:sp>
+        <p:nvSpPr>
+          <p:cNvPr id="35" name="Text 32"/>
+          <p:cNvSpPr txBox="1"/>
+          <p:nvPr/>
+        </p:nvSpPr>
+        <p:spPr>
+          <a:xfrm>
+            <a:off x="457200" y="6419088"/>
+            <a:ext cx="10515600" cy="329184"/>
+          </a:xfrm>
+          <a:prstGeom prst="rect">
+            <a:avLst/>
+          </a:prstGeom>
+          <a:noFill/>
+          <a:ln/>
+        </p:spPr>
+        <p:txBody>
+          <a:bodyPr wrap="square" rtlCol="0" anchor="ctr"/>
+          <a:lstStyle/>
+          <a:p>
+            <a:pPr algn="l" indent="0" marL="0">
+              <a:buNone/>
+            </a:pPr>
+            <a:r>
+              <a:rPr lang="en-US" sz="900" dirty="0">
+                <a:solidFill>
+                  <a:srgbClr val="6E7B80"/>
+                </a:solidFill>
+                <a:latin typeface="Trebuchet MS" pitchFamily="34" charset="0"/>
+                <a:ea typeface="Trebuchet MS" pitchFamily="34" charset="-122"/>
+                <a:cs typeface="Trebuchet MS" pitchFamily="34" charset="-120"/>
+              </a:rPr>
+              <a:t>Sources : Ministère de l'Éducation nationale, Togo (2024) ; Banque mondiale et Institut de statistique de l'UNESCO (2023) ; GPE (2019).</a:t>
             </a:r>
             <a:endParaRPr lang="en-US" sz="900" dirty="0"/>
           </a:p>
@@ -8445,7 +8750,7 @@
       </p:sp>
       <p:sp>
         <p:nvSpPr>
-          <p:cNvPr id="26" name="Text 23"/>
+          <p:cNvPr id="36" name="Text 33"/>
           <p:cNvSpPr txBox="1"/>
           <p:nvPr/>
         </p:nvSpPr>
@@ -8624,7 +8929,7 @@
               <a:buNone/>
             </a:pPr>
             <a:r>
-              <a:rPr lang="en-US" sz="2700" b="1" dirty="0">
+              <a:rPr lang="en-US" sz="2650" b="1" dirty="0">
                 <a:solidFill>
                   <a:srgbClr val="22333B"/>
                 </a:solidFill>
@@ -8632,9 +8937,9 @@
                 <a:ea typeface="Georgia" pitchFamily="34" charset="-122"/>
                 <a:cs typeface="Georgia" pitchFamily="34" charset="-120"/>
               </a:rPr>
-              <a:t>Ce que coûterait l'équipement physique de tout le pays</a:t>
-            </a:r>
-            <a:endParaRPr lang="en-US" sz="2700" dirty="0"/>
+              <a:t>Équiper physiquement le pays : au moins 8 milliards FCFA</a:t>
+            </a:r>
+            <a:endParaRPr lang="en-US" sz="2650" dirty="0"/>
           </a:p>
         </p:txBody>
       </p:sp>
@@ -8800,7 +9105,7 @@
                 <a:ea typeface="Georgia" pitchFamily="34" charset="-122"/>
                 <a:cs typeface="Georgia" pitchFamily="34" charset="-120"/>
               </a:rPr>
-              <a:t>&gt; 90 %</a:t>
+              <a:t>≈ 90 %</a:t>
             </a:r>
             <a:endParaRPr lang="en-US" sz="3100" dirty="0"/>
           </a:p>
@@ -8842,7 +9147,7 @@
                 <a:ea typeface="Trebuchet MS" pitchFamily="34" charset="-122"/>
                 <a:cs typeface="Trebuchet MS" pitchFamily="34" charset="-120"/>
               </a:rPr>
-              <a:t>des établissements secondaires d'Afrique n'ont pas de laboratoire correctement équipé</a:t>
+              <a:t>des écoles d'Afrique subsaharienne n'ont pas de laboratoire de sciences</a:t>
             </a:r>
             <a:endParaRPr lang="en-US" sz="1100" dirty="0"/>
           </a:p>
@@ -8881,7 +9186,7 @@
                 <a:ea typeface="Trebuchet MS" pitchFamily="34" charset="-122"/>
                 <a:cs typeface="Trebuchet MS" pitchFamily="34" charset="-120"/>
               </a:rPr>
-              <a:t>MOHAC Africa, 2026</a:t>
+              <a:t>Partenariat mondial pour l'éducation (GPE), 2019</a:t>
             </a:r>
             <a:endParaRPr lang="en-US" sz="950" dirty="0"/>
           </a:p>
@@ -8918,7 +9223,7 @@
         <p:spPr>
           <a:xfrm>
             <a:off x="1005840" y="4663440"/>
-            <a:ext cx="1051560" cy="274320"/>
+            <a:ext cx="1207008" cy="274320"/>
           </a:xfrm>
           <a:prstGeom prst="rect">
             <a:avLst/>
@@ -8956,7 +9261,7 @@
         </p:nvSpPr>
         <p:spPr>
           <a:xfrm>
-            <a:off x="2011680" y="4718304"/>
+            <a:off x="2304288" y="4718304"/>
             <a:ext cx="164592" cy="164592"/>
           </a:xfrm>
           <a:prstGeom prst="roundRect">
@@ -8983,8 +9288,8 @@
         </p:nvSpPr>
         <p:spPr>
           <a:xfrm>
-            <a:off x="2231136" y="4663440"/>
-            <a:ext cx="1097280" cy="274320"/>
+            <a:off x="2523744" y="4663440"/>
+            <a:ext cx="1280160" cy="274320"/>
           </a:xfrm>
           <a:prstGeom prst="rect">
             <a:avLst/>
@@ -9087,7 +9392,7 @@
                 <a:ea typeface="Trebuchet MS" pitchFamily="34" charset="-122"/>
                 <a:cs typeface="Trebuchet MS" pitchFamily="34" charset="-120"/>
               </a:rPr>
-              <a:t>697 532 collégiens</a:t>
+              <a:t>902 collèges et lycées publics</a:t>
             </a:r>
             <a:pPr algn="l" indent="0" marL="0">
               <a:lnSpc>
@@ -9104,8 +9409,498 @@
                 <a:ea typeface="Trebuchet MS" pitchFamily="34" charset="-122"/>
                 <a:cs typeface="Trebuchet MS" pitchFamily="34" charset="-120"/>
               </a:rPr>
-              <a:t> et </a:t>
-            </a:r>
+              <a:t>, dont 608 construits depuis 2011.</a:t>
+            </a:r>
+            <a:endParaRPr lang="en-US" sz="1150" dirty="0"/>
+          </a:p>
+        </p:txBody>
+      </p:sp>
+      <p:sp>
+        <p:nvSpPr>
+          <p:cNvPr id="20" name="Text 16"/>
+          <p:cNvSpPr txBox="1"/>
+          <p:nvPr/>
+        </p:nvSpPr>
+        <p:spPr>
+          <a:xfrm>
+            <a:off x="6163056" y="1901952"/>
+            <a:ext cx="5321808" cy="292608"/>
+          </a:xfrm>
+          <a:prstGeom prst="rect">
+            <a:avLst/>
+          </a:prstGeom>
+          <a:noFill/>
+          <a:ln/>
+        </p:spPr>
+        <p:txBody>
+          <a:bodyPr wrap="square" rtlCol="0" anchor="ctr"/>
+          <a:lstStyle/>
+          <a:p>
+            <a:pPr algn="l" indent="0" marL="0">
+              <a:buNone/>
+            </a:pPr>
+            <a:r>
+              <a:rPr lang="en-US" sz="1300" b="1" dirty="0">
+                <a:solidFill>
+                  <a:srgbClr val="B8431D"/>
+                </a:solidFill>
+                <a:latin typeface="Trebuchet MS" pitchFamily="34" charset="0"/>
+                <a:ea typeface="Trebuchet MS" pitchFamily="34" charset="-122"/>
+                <a:cs typeface="Trebuchet MS" pitchFamily="34" charset="-120"/>
+              </a:rPr>
+              <a:t>Ce que coûterait le rattrapage physique, sans VirtuLab</a:t>
+            </a:r>
+            <a:endParaRPr lang="en-US" sz="1300" dirty="0"/>
+          </a:p>
+        </p:txBody>
+      </p:sp>
+      <p:sp>
+        <p:nvSpPr>
+          <p:cNvPr id="21" name="Text 17"/>
+          <p:cNvSpPr txBox="1"/>
+          <p:nvPr/>
+        </p:nvSpPr>
+        <p:spPr>
+          <a:xfrm>
+            <a:off x="6163056" y="2231136"/>
+            <a:ext cx="5321808" cy="237744"/>
+          </a:xfrm>
+          <a:prstGeom prst="rect">
+            <a:avLst/>
+          </a:prstGeom>
+          <a:noFill/>
+          <a:ln/>
+        </p:spPr>
+        <p:txBody>
+          <a:bodyPr wrap="square" rtlCol="0" anchor="ctr"/>
+          <a:lstStyle/>
+          <a:p>
+            <a:pPr algn="l" indent="0" marL="0">
+              <a:buNone/>
+            </a:pPr>
+            <a:r>
+              <a:rPr lang="en-US" sz="1000" i="1" dirty="0">
+                <a:solidFill>
+                  <a:srgbClr val="6E7B80"/>
+                </a:solidFill>
+                <a:latin typeface="Trebuchet MS" pitchFamily="34" charset="0"/>
+                <a:ea typeface="Trebuchet MS" pitchFamily="34" charset="-122"/>
+                <a:cs typeface="Trebuchet MS" pitchFamily="34" charset="-120"/>
+              </a:rPr>
+              <a:t>902 établissements publics × ≈ 90 % sans laboratoire ≈ 810 à équiper</a:t>
+            </a:r>
+            <a:endParaRPr lang="en-US" sz="1000" dirty="0"/>
+          </a:p>
+        </p:txBody>
+      </p:sp>
+      <p:sp>
+        <p:nvSpPr>
+          <p:cNvPr id="22" name="Shape 18"/>
+          <p:cNvSpPr/>
+          <p:nvPr/>
+        </p:nvSpPr>
+        <p:spPr>
+          <a:xfrm>
+            <a:off x="6181344" y="2523744"/>
+            <a:ext cx="1481328" cy="914400"/>
+          </a:xfrm>
+          <a:prstGeom prst="roundRect">
+            <a:avLst>
+              <a:gd name="adj" fmla="val 8000"/>
+            </a:avLst>
+          </a:prstGeom>
+          <a:solidFill>
+            <a:srgbClr val="F8E4D9"/>
+          </a:solidFill>
+          <a:ln/>
+        </p:spPr>
+      </p:sp>
+      <p:sp>
+        <p:nvSpPr>
+          <p:cNvPr id="23" name="Text 19"/>
+          <p:cNvSpPr txBox="1"/>
+          <p:nvPr/>
+        </p:nvSpPr>
+        <p:spPr>
+          <a:xfrm>
+            <a:off x="6181344" y="2615184"/>
+            <a:ext cx="1481328" cy="457200"/>
+          </a:xfrm>
+          <a:prstGeom prst="rect">
+            <a:avLst/>
+          </a:prstGeom>
+          <a:noFill/>
+          <a:ln/>
+        </p:spPr>
+        <p:txBody>
+          <a:bodyPr wrap="square" rtlCol="0" anchor="ctr"/>
+          <a:lstStyle/>
+          <a:p>
+            <a:pPr algn="ctr" indent="0" marL="0">
+              <a:buNone/>
+            </a:pPr>
+            <a:r>
+              <a:rPr lang="en-US" sz="1700" b="1" dirty="0">
+                <a:solidFill>
+                  <a:srgbClr val="B8431D"/>
+                </a:solidFill>
+                <a:latin typeface="Georgia" pitchFamily="34" charset="0"/>
+                <a:ea typeface="Georgia" pitchFamily="34" charset="-122"/>
+                <a:cs typeface="Georgia" pitchFamily="34" charset="-120"/>
+              </a:rPr>
+              <a:t>≈ 810</a:t>
+            </a:r>
+            <a:endParaRPr lang="en-US" sz="1700" dirty="0"/>
+          </a:p>
+        </p:txBody>
+      </p:sp>
+      <p:sp>
+        <p:nvSpPr>
+          <p:cNvPr id="24" name="Text 20"/>
+          <p:cNvSpPr txBox="1"/>
+          <p:nvPr/>
+        </p:nvSpPr>
+        <p:spPr>
+          <a:xfrm>
+            <a:off x="6236208" y="3072384"/>
+            <a:ext cx="1371600" cy="329184"/>
+          </a:xfrm>
+          <a:prstGeom prst="rect">
+            <a:avLst/>
+          </a:prstGeom>
+          <a:noFill/>
+          <a:ln/>
+        </p:spPr>
+        <p:txBody>
+          <a:bodyPr wrap="square" rtlCol="0" anchor="t"/>
+          <a:lstStyle/>
+          <a:p>
+            <a:pPr algn="ctr" indent="0" marL="0">
+              <a:lnSpc>
+                <a:spcPct val="105000"/>
+              </a:lnSpc>
+              <a:buNone/>
+            </a:pPr>
+            <a:r>
+              <a:rPr lang="en-US" sz="850" dirty="0">
+                <a:solidFill>
+                  <a:srgbClr val="22333B"/>
+                </a:solidFill>
+                <a:latin typeface="Trebuchet MS" pitchFamily="34" charset="0"/>
+                <a:ea typeface="Trebuchet MS" pitchFamily="34" charset="-122"/>
+                <a:cs typeface="Trebuchet MS" pitchFamily="34" charset="-120"/>
+              </a:rPr>
+              <a:t>établissements à équiper</a:t>
+            </a:r>
+            <a:endParaRPr lang="en-US" sz="850" dirty="0"/>
+          </a:p>
+        </p:txBody>
+      </p:sp>
+      <p:sp>
+        <p:nvSpPr>
+          <p:cNvPr id="25" name="Text 21"/>
+          <p:cNvSpPr txBox="1"/>
+          <p:nvPr/>
+        </p:nvSpPr>
+        <p:spPr>
+          <a:xfrm>
+            <a:off x="7662672" y="2523744"/>
+            <a:ext cx="237744" cy="914400"/>
+          </a:xfrm>
+          <a:prstGeom prst="rect">
+            <a:avLst/>
+          </a:prstGeom>
+          <a:noFill/>
+          <a:ln/>
+        </p:spPr>
+        <p:txBody>
+          <a:bodyPr wrap="square" rtlCol="0" anchor="ctr"/>
+          <a:lstStyle/>
+          <a:p>
+            <a:pPr algn="ctr" indent="0" marL="0">
+              <a:buNone/>
+            </a:pPr>
+            <a:r>
+              <a:rPr lang="en-US" sz="2000" b="1" dirty="0">
+                <a:solidFill>
+                  <a:srgbClr val="6E7B80"/>
+                </a:solidFill>
+                <a:latin typeface="Georgia" pitchFamily="34" charset="0"/>
+                <a:ea typeface="Georgia" pitchFamily="34" charset="-122"/>
+                <a:cs typeface="Georgia" pitchFamily="34" charset="-120"/>
+              </a:rPr>
+              <a:t>×</a:t>
+            </a:r>
+            <a:endParaRPr lang="en-US" sz="2000" dirty="0"/>
+          </a:p>
+        </p:txBody>
+      </p:sp>
+      <p:sp>
+        <p:nvSpPr>
+          <p:cNvPr id="26" name="Shape 22"/>
+          <p:cNvSpPr/>
+          <p:nvPr/>
+        </p:nvSpPr>
+        <p:spPr>
+          <a:xfrm>
+            <a:off x="7900416" y="2523744"/>
+            <a:ext cx="1517904" cy="914400"/>
+          </a:xfrm>
+          <a:prstGeom prst="roundRect">
+            <a:avLst>
+              <a:gd name="adj" fmla="val 8000"/>
+            </a:avLst>
+          </a:prstGeom>
+          <a:solidFill>
+            <a:srgbClr val="F8E4D9"/>
+          </a:solidFill>
+          <a:ln/>
+        </p:spPr>
+      </p:sp>
+      <p:sp>
+        <p:nvSpPr>
+          <p:cNvPr id="27" name="Text 23"/>
+          <p:cNvSpPr txBox="1"/>
+          <p:nvPr/>
+        </p:nvSpPr>
+        <p:spPr>
+          <a:xfrm>
+            <a:off x="7900416" y="2615184"/>
+            <a:ext cx="1517904" cy="457200"/>
+          </a:xfrm>
+          <a:prstGeom prst="rect">
+            <a:avLst/>
+          </a:prstGeom>
+          <a:noFill/>
+          <a:ln/>
+        </p:spPr>
+        <p:txBody>
+          <a:bodyPr wrap="square" rtlCol="0" anchor="ctr"/>
+          <a:lstStyle/>
+          <a:p>
+            <a:pPr algn="ctr" indent="0" marL="0">
+              <a:buNone/>
+            </a:pPr>
+            <a:r>
+              <a:rPr lang="en-US" sz="1700" b="1" dirty="0">
+                <a:solidFill>
+                  <a:srgbClr val="B8431D"/>
+                </a:solidFill>
+                <a:latin typeface="Georgia" pitchFamily="34" charset="0"/>
+                <a:ea typeface="Georgia" pitchFamily="34" charset="-122"/>
+                <a:cs typeface="Georgia" pitchFamily="34" charset="-120"/>
+              </a:rPr>
+              <a:t>10 M FCFA</a:t>
+            </a:r>
+            <a:endParaRPr lang="en-US" sz="1700" dirty="0"/>
+          </a:p>
+        </p:txBody>
+      </p:sp>
+      <p:sp>
+        <p:nvSpPr>
+          <p:cNvPr id="28" name="Text 24"/>
+          <p:cNvSpPr txBox="1"/>
+          <p:nvPr/>
+        </p:nvSpPr>
+        <p:spPr>
+          <a:xfrm>
+            <a:off x="7946136" y="3072384"/>
+            <a:ext cx="1426464" cy="329184"/>
+          </a:xfrm>
+          <a:prstGeom prst="rect">
+            <a:avLst/>
+          </a:prstGeom>
+          <a:noFill/>
+          <a:ln/>
+        </p:spPr>
+        <p:txBody>
+          <a:bodyPr wrap="square" rtlCol="0" anchor="t"/>
+          <a:lstStyle/>
+          <a:p>
+            <a:pPr algn="ctr" indent="0" marL="0">
+              <a:lnSpc>
+                <a:spcPct val="105000"/>
+              </a:lnSpc>
+              <a:buNone/>
+            </a:pPr>
+            <a:r>
+              <a:rPr lang="en-US" sz="850" dirty="0">
+                <a:solidFill>
+                  <a:srgbClr val="22333B"/>
+                </a:solidFill>
+                <a:latin typeface="Trebuchet MS" pitchFamily="34" charset="0"/>
+                <a:ea typeface="Trebuchet MS" pitchFamily="34" charset="-122"/>
+                <a:cs typeface="Trebuchet MS" pitchFamily="34" charset="-120"/>
+              </a:rPr>
+              <a:t>d'équipement min. par labo</a:t>
+            </a:r>
+            <a:endParaRPr lang="en-US" sz="850" dirty="0"/>
+          </a:p>
+        </p:txBody>
+      </p:sp>
+      <p:sp>
+        <p:nvSpPr>
+          <p:cNvPr id="29" name="Text 25"/>
+          <p:cNvSpPr txBox="1"/>
+          <p:nvPr/>
+        </p:nvSpPr>
+        <p:spPr>
+          <a:xfrm>
+            <a:off x="9418320" y="2523744"/>
+            <a:ext cx="237744" cy="914400"/>
+          </a:xfrm>
+          <a:prstGeom prst="rect">
+            <a:avLst/>
+          </a:prstGeom>
+          <a:noFill/>
+          <a:ln/>
+        </p:spPr>
+        <p:txBody>
+          <a:bodyPr wrap="square" rtlCol="0" anchor="ctr"/>
+          <a:lstStyle/>
+          <a:p>
+            <a:pPr algn="ctr" indent="0" marL="0">
+              <a:buNone/>
+            </a:pPr>
+            <a:r>
+              <a:rPr lang="en-US" sz="2000" b="1" dirty="0">
+                <a:solidFill>
+                  <a:srgbClr val="6E7B80"/>
+                </a:solidFill>
+                <a:latin typeface="Georgia" pitchFamily="34" charset="0"/>
+                <a:ea typeface="Georgia" pitchFamily="34" charset="-122"/>
+                <a:cs typeface="Georgia" pitchFamily="34" charset="-120"/>
+              </a:rPr>
+              <a:t>=</a:t>
+            </a:r>
+            <a:endParaRPr lang="en-US" sz="2000" dirty="0"/>
+          </a:p>
+        </p:txBody>
+      </p:sp>
+      <p:sp>
+        <p:nvSpPr>
+          <p:cNvPr id="30" name="Shape 26"/>
+          <p:cNvSpPr/>
+          <p:nvPr/>
+        </p:nvSpPr>
+        <p:spPr>
+          <a:xfrm>
+            <a:off x="9656064" y="2523744"/>
+            <a:ext cx="1810512" cy="914400"/>
+          </a:xfrm>
+          <a:prstGeom prst="roundRect">
+            <a:avLst>
+              <a:gd name="adj" fmla="val 8000"/>
+            </a:avLst>
+          </a:prstGeom>
+          <a:solidFill>
+            <a:srgbClr val="E0592A"/>
+          </a:solidFill>
+          <a:ln/>
+        </p:spPr>
+      </p:sp>
+      <p:sp>
+        <p:nvSpPr>
+          <p:cNvPr id="31" name="Text 27"/>
+          <p:cNvSpPr txBox="1"/>
+          <p:nvPr/>
+        </p:nvSpPr>
+        <p:spPr>
+          <a:xfrm>
+            <a:off x="9656064" y="2615184"/>
+            <a:ext cx="1810512" cy="457200"/>
+          </a:xfrm>
+          <a:prstGeom prst="rect">
+            <a:avLst/>
+          </a:prstGeom>
+          <a:noFill/>
+          <a:ln/>
+        </p:spPr>
+        <p:txBody>
+          <a:bodyPr wrap="square" rtlCol="0" anchor="ctr"/>
+          <a:lstStyle/>
+          <a:p>
+            <a:pPr algn="ctr" indent="0" marL="0">
+              <a:buNone/>
+            </a:pPr>
+            <a:r>
+              <a:rPr lang="en-US" sz="1700" b="1" dirty="0">
+                <a:solidFill>
+                  <a:srgbClr val="FFFFFF"/>
+                </a:solidFill>
+                <a:latin typeface="Georgia" pitchFamily="34" charset="0"/>
+                <a:ea typeface="Georgia" pitchFamily="34" charset="-122"/>
+                <a:cs typeface="Georgia" pitchFamily="34" charset="-120"/>
+              </a:rPr>
+              <a:t>≈ 8 milliards</a:t>
+            </a:r>
+            <a:endParaRPr lang="en-US" sz="1700" dirty="0"/>
+          </a:p>
+        </p:txBody>
+      </p:sp>
+      <p:sp>
+        <p:nvSpPr>
+          <p:cNvPr id="32" name="Text 28"/>
+          <p:cNvSpPr txBox="1"/>
+          <p:nvPr/>
+        </p:nvSpPr>
+        <p:spPr>
+          <a:xfrm>
+            <a:off x="9656064" y="3072384"/>
+            <a:ext cx="1810512" cy="329184"/>
+          </a:xfrm>
+          <a:prstGeom prst="rect">
+            <a:avLst/>
+          </a:prstGeom>
+          <a:noFill/>
+          <a:ln/>
+        </p:spPr>
+        <p:txBody>
+          <a:bodyPr wrap="square" rtlCol="0" anchor="t"/>
+          <a:lstStyle/>
+          <a:p>
+            <a:pPr algn="ctr" indent="0" marL="0">
+              <a:lnSpc>
+                <a:spcPct val="105000"/>
+              </a:lnSpc>
+              <a:buNone/>
+            </a:pPr>
+            <a:r>
+              <a:rPr lang="en-US" sz="850" dirty="0">
+                <a:solidFill>
+                  <a:srgbClr val="FFFFFF"/>
+                </a:solidFill>
+                <a:latin typeface="Trebuchet MS" pitchFamily="34" charset="0"/>
+                <a:ea typeface="Trebuchet MS" pitchFamily="34" charset="-122"/>
+                <a:cs typeface="Trebuchet MS" pitchFamily="34" charset="-120"/>
+              </a:rPr>
+              <a:t>FCFA · équipement seul</a:t>
+            </a:r>
+            <a:endParaRPr lang="en-US" sz="850" dirty="0"/>
+          </a:p>
+        </p:txBody>
+      </p:sp>
+      <p:sp>
+        <p:nvSpPr>
+          <p:cNvPr id="33" name="Text 29"/>
+          <p:cNvSpPr txBox="1"/>
+          <p:nvPr/>
+        </p:nvSpPr>
+        <p:spPr>
+          <a:xfrm>
+            <a:off x="6181344" y="3584448"/>
+            <a:ext cx="5285232" cy="512064"/>
+          </a:xfrm>
+          <a:prstGeom prst="rect">
+            <a:avLst/>
+          </a:prstGeom>
+          <a:noFill/>
+          <a:ln/>
+        </p:spPr>
+        <p:txBody>
+          <a:bodyPr wrap="square" rtlCol="0" anchor="t"/>
+          <a:lstStyle/>
+          <a:p>
             <a:pPr algn="l" indent="0" marL="0">
               <a:lnSpc>
                 <a:spcPct val="110000"/>
@@ -9113,7 +9908,7 @@
               <a:buNone/>
             </a:pPr>
             <a:r>
-              <a:rPr lang="en-US" sz="1150" b="1" dirty="0">
+              <a:rPr lang="en-US" sz="1050" b="1" dirty="0">
                 <a:solidFill>
                   <a:srgbClr val="22333B"/>
                 </a:solidFill>
@@ -9121,7 +9916,7 @@
                 <a:ea typeface="Trebuchet MS" pitchFamily="34" charset="-122"/>
                 <a:cs typeface="Trebuchet MS" pitchFamily="34" charset="-120"/>
               </a:rPr>
-              <a:t>750 lycées</a:t>
+              <a:t>Référence régionale : </a:t>
             </a:r>
             <a:pPr algn="l" indent="0" marL="0">
               <a:lnSpc>
@@ -9130,30 +9925,30 @@
               <a:buNone/>
             </a:pPr>
             <a:r>
-              <a:rPr lang="en-US" sz="1150" dirty="0">
-                <a:solidFill>
-                  <a:srgbClr val="6E7B80"/>
+              <a:rPr lang="en-US" sz="1050" dirty="0">
+                <a:solidFill>
+                  <a:srgbClr val="22333B"/>
                 </a:solidFill>
                 <a:latin typeface="Trebuchet MS" pitchFamily="34" charset="0"/>
                 <a:ea typeface="Trebuchet MS" pitchFamily="34" charset="-122"/>
                 <a:cs typeface="Trebuchet MS" pitchFamily="34" charset="-120"/>
               </a:rPr>
-              <a:t> attendent cette pratique.</a:t>
-            </a:r>
-            <a:endParaRPr lang="en-US" sz="1150" dirty="0"/>
-          </a:p>
-        </p:txBody>
-      </p:sp>
-      <p:sp>
-        <p:nvSpPr>
-          <p:cNvPr id="20" name="Text 16"/>
-          <p:cNvSpPr txBox="1"/>
-          <p:nvPr/>
-        </p:nvSpPr>
-        <p:spPr>
-          <a:xfrm>
-            <a:off x="6163056" y="1901952"/>
-            <a:ext cx="5321808" cy="292608"/>
+              <a:t>un bloc scientifique complet (salles + équipement) ≈ 250 M FCFA (Sénégal, 2014), soit ≈ 200 Md pour le pays.</a:t>
+            </a:r>
+            <a:endParaRPr lang="en-US" sz="1050" dirty="0"/>
+          </a:p>
+        </p:txBody>
+      </p:sp>
+      <p:sp>
+        <p:nvSpPr>
+          <p:cNvPr id="34" name="Text 30"/>
+          <p:cNvSpPr txBox="1"/>
+          <p:nvPr/>
+        </p:nvSpPr>
+        <p:spPr>
+          <a:xfrm>
+            <a:off x="6181344" y="4169664"/>
+            <a:ext cx="5285232" cy="274320"/>
           </a:xfrm>
           <a:prstGeom prst="rect">
             <a:avLst/>
@@ -9169,110 +9964,46 @@
               <a:buNone/>
             </a:pPr>
             <a:r>
-              <a:rPr lang="en-US" sz="1300" b="1" dirty="0">
-                <a:solidFill>
-                  <a:srgbClr val="B8431D"/>
+              <a:rPr lang="en-US" sz="1100" b="1" dirty="0">
+                <a:solidFill>
+                  <a:srgbClr val="22333B"/>
                 </a:solidFill>
                 <a:latin typeface="Trebuchet MS" pitchFamily="34" charset="0"/>
                 <a:ea typeface="Trebuchet MS" pitchFamily="34" charset="-122"/>
                 <a:cs typeface="Trebuchet MS" pitchFamily="34" charset="-120"/>
               </a:rPr>
-              <a:t>Ce que coûterait l'équipement physique, sans VirtuLab</a:t>
-            </a:r>
-            <a:endParaRPr lang="en-US" sz="1300" dirty="0"/>
-          </a:p>
-        </p:txBody>
-      </p:sp>
-      <p:sp>
-        <p:nvSpPr>
-          <p:cNvPr id="21" name="Shape 17"/>
-          <p:cNvSpPr/>
-          <p:nvPr/>
-        </p:nvSpPr>
-        <p:spPr>
-          <a:xfrm>
-            <a:off x="6181344" y="2340864"/>
-            <a:ext cx="1554480" cy="969264"/>
-          </a:xfrm>
-          <a:prstGeom prst="roundRect">
-            <a:avLst>
-              <a:gd name="adj" fmla="val 7547"/>
-            </a:avLst>
-          </a:prstGeom>
-          <a:solidFill>
-            <a:srgbClr val="F8E4D9"/>
-          </a:solidFill>
-          <a:ln/>
-        </p:spPr>
-      </p:sp>
-      <p:sp>
-        <p:nvSpPr>
-          <p:cNvPr id="22" name="Text 18"/>
-          <p:cNvSpPr txBox="1"/>
-          <p:nvPr/>
-        </p:nvSpPr>
-        <p:spPr>
-          <a:xfrm>
-            <a:off x="6181344" y="2450592"/>
-            <a:ext cx="1554480" cy="457200"/>
-          </a:xfrm>
-          <a:prstGeom prst="rect">
-            <a:avLst/>
-          </a:prstGeom>
-          <a:noFill/>
-          <a:ln/>
-        </p:spPr>
-        <p:txBody>
-          <a:bodyPr wrap="square" rtlCol="0" anchor="ctr"/>
-          <a:lstStyle/>
-          <a:p>
-            <a:pPr algn="ctr" indent="0" marL="0">
-              <a:buNone/>
-            </a:pPr>
-            <a:r>
-              <a:rPr lang="en-US" sz="1700" b="1" dirty="0">
-                <a:solidFill>
-                  <a:srgbClr val="B8431D"/>
-                </a:solidFill>
-                <a:latin typeface="Georgia" pitchFamily="34" charset="0"/>
-                <a:ea typeface="Georgia" pitchFamily="34" charset="-122"/>
-                <a:cs typeface="Georgia" pitchFamily="34" charset="-120"/>
-              </a:rPr>
-              <a:t>15 M FCFA</a:t>
-            </a:r>
-            <a:endParaRPr lang="en-US" sz="1700" dirty="0"/>
-          </a:p>
-        </p:txBody>
-      </p:sp>
-      <p:sp>
-        <p:nvSpPr>
-          <p:cNvPr id="23" name="Text 19"/>
-          <p:cNvSpPr txBox="1"/>
-          <p:nvPr/>
-        </p:nvSpPr>
-        <p:spPr>
-          <a:xfrm>
-            <a:off x="6236208" y="2907792"/>
-            <a:ext cx="1444752" cy="347472"/>
-          </a:xfrm>
-          <a:prstGeom prst="rect">
-            <a:avLst/>
-          </a:prstGeom>
-          <a:noFill/>
-          <a:ln/>
-        </p:spPr>
-        <p:txBody>
-          <a:bodyPr wrap="square" rtlCol="0" anchor="t"/>
-          <a:lstStyle/>
-          <a:p>
-            <a:pPr algn="ctr" indent="0" marL="0">
-              <a:lnSpc>
-                <a:spcPct val="105000"/>
-              </a:lnSpc>
-              <a:buNone/>
-            </a:pPr>
-            <a:r>
-              <a:rPr lang="en-US" sz="900" dirty="0">
+              <a:t>Et un laboratoire ne s'allume pas tout seul :</a:t>
+            </a:r>
+            <a:endParaRPr lang="en-US" sz="1100" dirty="0"/>
+          </a:p>
+        </p:txBody>
+      </p:sp>
+      <p:sp>
+        <p:nvSpPr>
+          <p:cNvPr id="35" name="Text 31"/>
+          <p:cNvSpPr txBox="1"/>
+          <p:nvPr/>
+        </p:nvSpPr>
+        <p:spPr>
+          <a:xfrm>
+            <a:off x="6181344" y="4480560"/>
+            <a:ext cx="4334256" cy="256032"/>
+          </a:xfrm>
+          <a:prstGeom prst="rect">
+            <a:avLst/>
+          </a:prstGeom>
+          <a:noFill/>
+          <a:ln/>
+        </p:spPr>
+        <p:txBody>
+          <a:bodyPr wrap="square" rtlCol="0" anchor="ctr"/>
+          <a:lstStyle/>
+          <a:p>
+            <a:pPr algn="l" indent="0" marL="0">
+              <a:buNone/>
+            </a:pPr>
+            <a:r>
+              <a:rPr lang="en-US" sz="1100" dirty="0">
                 <a:solidFill>
                   <a:srgbClr val="22333B"/>
                 </a:solidFill>
@@ -9280,481 +10011,60 @@
                 <a:ea typeface="Trebuchet MS" pitchFamily="34" charset="-122"/>
                 <a:cs typeface="Trebuchet MS" pitchFamily="34" charset="-120"/>
               </a:rPr>
-              <a:t>par laboratoire complet</a:t>
-            </a:r>
-            <a:endParaRPr lang="en-US" sz="900" dirty="0"/>
-          </a:p>
-        </p:txBody>
-      </p:sp>
-      <p:sp>
-        <p:nvSpPr>
-          <p:cNvPr id="24" name="Text 20"/>
-          <p:cNvSpPr txBox="1"/>
-          <p:nvPr/>
-        </p:nvSpPr>
-        <p:spPr>
-          <a:xfrm>
-            <a:off x="7735824" y="2340864"/>
-            <a:ext cx="274320" cy="969264"/>
-          </a:xfrm>
-          <a:prstGeom prst="rect">
-            <a:avLst/>
-          </a:prstGeom>
-          <a:noFill/>
-          <a:ln/>
-        </p:spPr>
-        <p:txBody>
-          <a:bodyPr wrap="square" rtlCol="0" anchor="ctr"/>
-          <a:lstStyle/>
-          <a:p>
-            <a:pPr algn="ctr" indent="0" marL="0">
-              <a:buNone/>
-            </a:pPr>
-            <a:r>
-              <a:rPr lang="en-US" sz="2000" b="1" dirty="0">
-                <a:solidFill>
-                  <a:srgbClr val="6E7B80"/>
-                </a:solidFill>
-                <a:latin typeface="Georgia" pitchFamily="34" charset="0"/>
-                <a:ea typeface="Georgia" pitchFamily="34" charset="-122"/>
-                <a:cs typeface="Georgia" pitchFamily="34" charset="-120"/>
-              </a:rPr>
-              <a:t>×</a:t>
-            </a:r>
-            <a:endParaRPr lang="en-US" sz="2000" dirty="0"/>
-          </a:p>
-        </p:txBody>
-      </p:sp>
-      <p:sp>
-        <p:nvSpPr>
-          <p:cNvPr id="25" name="Shape 21"/>
-          <p:cNvSpPr/>
-          <p:nvPr/>
-        </p:nvSpPr>
-        <p:spPr>
-          <a:xfrm>
-            <a:off x="8010144" y="2340864"/>
-            <a:ext cx="1188720" cy="969264"/>
-          </a:xfrm>
-          <a:prstGeom prst="roundRect">
-            <a:avLst>
-              <a:gd name="adj" fmla="val 7547"/>
-            </a:avLst>
-          </a:prstGeom>
-          <a:solidFill>
-            <a:srgbClr val="F8E4D9"/>
-          </a:solidFill>
-          <a:ln/>
-        </p:spPr>
-      </p:sp>
-      <p:sp>
-        <p:nvSpPr>
-          <p:cNvPr id="26" name="Text 22"/>
-          <p:cNvSpPr txBox="1"/>
-          <p:nvPr/>
-        </p:nvSpPr>
-        <p:spPr>
-          <a:xfrm>
-            <a:off x="8010144" y="2450592"/>
-            <a:ext cx="1188720" cy="457200"/>
-          </a:xfrm>
-          <a:prstGeom prst="rect">
-            <a:avLst/>
-          </a:prstGeom>
-          <a:noFill/>
-          <a:ln/>
-        </p:spPr>
-        <p:txBody>
-          <a:bodyPr wrap="square" rtlCol="0" anchor="ctr"/>
-          <a:lstStyle/>
-          <a:p>
-            <a:pPr algn="ctr" indent="0" marL="0">
-              <a:buNone/>
-            </a:pPr>
-            <a:r>
-              <a:rPr lang="en-US" sz="1700" b="1" dirty="0">
-                <a:solidFill>
-                  <a:srgbClr val="B8431D"/>
-                </a:solidFill>
-                <a:latin typeface="Georgia" pitchFamily="34" charset="0"/>
-                <a:ea typeface="Georgia" pitchFamily="34" charset="-122"/>
-                <a:cs typeface="Georgia" pitchFamily="34" charset="-120"/>
-              </a:rPr>
-              <a:t>800</a:t>
-            </a:r>
-            <a:endParaRPr lang="en-US" sz="1700" dirty="0"/>
-          </a:p>
-        </p:txBody>
-      </p:sp>
-      <p:sp>
-        <p:nvSpPr>
-          <p:cNvPr id="27" name="Text 23"/>
-          <p:cNvSpPr txBox="1"/>
-          <p:nvPr/>
-        </p:nvSpPr>
-        <p:spPr>
-          <a:xfrm>
-            <a:off x="8055864" y="2907792"/>
-            <a:ext cx="1097280" cy="347472"/>
-          </a:xfrm>
-          <a:prstGeom prst="rect">
-            <a:avLst/>
-          </a:prstGeom>
-          <a:noFill/>
-          <a:ln/>
-        </p:spPr>
-        <p:txBody>
-          <a:bodyPr wrap="square" rtlCol="0" anchor="t"/>
-          <a:lstStyle/>
-          <a:p>
-            <a:pPr algn="ctr" indent="0" marL="0">
-              <a:lnSpc>
-                <a:spcPct val="105000"/>
-              </a:lnSpc>
-              <a:buNone/>
-            </a:pPr>
-            <a:r>
-              <a:rPr lang="en-US" sz="900" dirty="0">
-                <a:solidFill>
-                  <a:srgbClr val="22333B"/>
+              <a:t>Électrification nationale</a:t>
+            </a:r>
+            <a:endParaRPr lang="en-US" sz="1100" dirty="0"/>
+          </a:p>
+        </p:txBody>
+      </p:sp>
+      <p:sp>
+        <p:nvSpPr>
+          <p:cNvPr id="36" name="Text 32"/>
+          <p:cNvSpPr txBox="1"/>
+          <p:nvPr/>
+        </p:nvSpPr>
+        <p:spPr>
+          <a:xfrm>
+            <a:off x="10515600" y="4480560"/>
+            <a:ext cx="914400" cy="256032"/>
+          </a:xfrm>
+          <a:prstGeom prst="rect">
+            <a:avLst/>
+          </a:prstGeom>
+          <a:noFill/>
+          <a:ln/>
+        </p:spPr>
+        <p:txBody>
+          <a:bodyPr wrap="square" rtlCol="0" anchor="ctr"/>
+          <a:lstStyle/>
+          <a:p>
+            <a:pPr algn="r" indent="0" marL="0">
+              <a:buNone/>
+            </a:pPr>
+            <a:r>
+              <a:rPr lang="en-US" sz="1150" b="1" dirty="0">
+                <a:solidFill>
+                  <a:srgbClr val="0E7C7B"/>
                 </a:solidFill>
                 <a:latin typeface="Trebuchet MS" pitchFamily="34" charset="0"/>
                 <a:ea typeface="Trebuchet MS" pitchFamily="34" charset="-122"/>
                 <a:cs typeface="Trebuchet MS" pitchFamily="34" charset="-120"/>
               </a:rPr>
-              <a:t>établissements visés</a:t>
-            </a:r>
-            <a:endParaRPr lang="en-US" sz="900" dirty="0"/>
-          </a:p>
-        </p:txBody>
-      </p:sp>
-      <p:sp>
-        <p:nvSpPr>
-          <p:cNvPr id="28" name="Text 24"/>
-          <p:cNvSpPr txBox="1"/>
-          <p:nvPr/>
-        </p:nvSpPr>
-        <p:spPr>
-          <a:xfrm>
-            <a:off x="9198864" y="2340864"/>
-            <a:ext cx="274320" cy="969264"/>
-          </a:xfrm>
-          <a:prstGeom prst="rect">
-            <a:avLst/>
-          </a:prstGeom>
-          <a:noFill/>
-          <a:ln/>
-        </p:spPr>
-        <p:txBody>
-          <a:bodyPr wrap="square" rtlCol="0" anchor="ctr"/>
-          <a:lstStyle/>
-          <a:p>
-            <a:pPr algn="ctr" indent="0" marL="0">
-              <a:buNone/>
-            </a:pPr>
-            <a:r>
-              <a:rPr lang="en-US" sz="2000" b="1" dirty="0">
-                <a:solidFill>
-                  <a:srgbClr val="6E7B80"/>
-                </a:solidFill>
-                <a:latin typeface="Georgia" pitchFamily="34" charset="0"/>
-                <a:ea typeface="Georgia" pitchFamily="34" charset="-122"/>
-                <a:cs typeface="Georgia" pitchFamily="34" charset="-120"/>
-              </a:rPr>
-              <a:t>=</a:t>
-            </a:r>
-            <a:endParaRPr lang="en-US" sz="2000" dirty="0"/>
-          </a:p>
-        </p:txBody>
-      </p:sp>
-      <p:sp>
-        <p:nvSpPr>
-          <p:cNvPr id="29" name="Shape 25"/>
+              <a:t>61,1 %</a:t>
+            </a:r>
+            <a:endParaRPr lang="en-US" sz="1150" dirty="0"/>
+          </a:p>
+        </p:txBody>
+      </p:sp>
+      <p:sp>
+        <p:nvSpPr>
+          <p:cNvPr id="37" name="Shape 33"/>
           <p:cNvSpPr/>
           <p:nvPr/>
         </p:nvSpPr>
         <p:spPr>
           <a:xfrm>
-            <a:off x="9473184" y="2340864"/>
-            <a:ext cx="1993392" cy="969264"/>
-          </a:xfrm>
-          <a:prstGeom prst="roundRect">
-            <a:avLst>
-              <a:gd name="adj" fmla="val 7547"/>
-            </a:avLst>
-          </a:prstGeom>
-          <a:solidFill>
-            <a:srgbClr val="E0592A"/>
-          </a:solidFill>
-          <a:ln/>
-        </p:spPr>
-      </p:sp>
-      <p:sp>
-        <p:nvSpPr>
-          <p:cNvPr id="30" name="Text 26"/>
-          <p:cNvSpPr txBox="1"/>
-          <p:nvPr/>
-        </p:nvSpPr>
-        <p:spPr>
-          <a:xfrm>
-            <a:off x="9473184" y="2450592"/>
-            <a:ext cx="1993392" cy="457200"/>
-          </a:xfrm>
-          <a:prstGeom prst="rect">
-            <a:avLst/>
-          </a:prstGeom>
-          <a:noFill/>
-          <a:ln/>
-        </p:spPr>
-        <p:txBody>
-          <a:bodyPr wrap="square" rtlCol="0" anchor="ctr"/>
-          <a:lstStyle/>
-          <a:p>
-            <a:pPr algn="ctr" indent="0" marL="0">
-              <a:buNone/>
-            </a:pPr>
-            <a:r>
-              <a:rPr lang="en-US" sz="1700" b="1" dirty="0">
-                <a:solidFill>
-                  <a:srgbClr val="FFFFFF"/>
-                </a:solidFill>
-                <a:latin typeface="Georgia" pitchFamily="34" charset="0"/>
-                <a:ea typeface="Georgia" pitchFamily="34" charset="-122"/>
-                <a:cs typeface="Georgia" pitchFamily="34" charset="-120"/>
-              </a:rPr>
-              <a:t>≈ 12 milliards</a:t>
-            </a:r>
-            <a:endParaRPr lang="en-US" sz="1700" dirty="0"/>
-          </a:p>
-        </p:txBody>
-      </p:sp>
-      <p:sp>
-        <p:nvSpPr>
-          <p:cNvPr id="31" name="Text 27"/>
-          <p:cNvSpPr txBox="1"/>
-          <p:nvPr/>
-        </p:nvSpPr>
-        <p:spPr>
-          <a:xfrm>
-            <a:off x="9473184" y="2907792"/>
-            <a:ext cx="1993392" cy="347472"/>
-          </a:xfrm>
-          <a:prstGeom prst="rect">
-            <a:avLst/>
-          </a:prstGeom>
-          <a:noFill/>
-          <a:ln/>
-        </p:spPr>
-        <p:txBody>
-          <a:bodyPr wrap="square" rtlCol="0" anchor="t"/>
-          <a:lstStyle/>
-          <a:p>
-            <a:pPr algn="ctr" indent="0" marL="0">
-              <a:lnSpc>
-                <a:spcPct val="105000"/>
-              </a:lnSpc>
-              <a:buNone/>
-            </a:pPr>
-            <a:r>
-              <a:rPr lang="en-US" sz="900" dirty="0">
-                <a:solidFill>
-                  <a:srgbClr val="FFFFFF"/>
-                </a:solidFill>
-                <a:latin typeface="Trebuchet MS" pitchFamily="34" charset="0"/>
-                <a:ea typeface="Trebuchet MS" pitchFamily="34" charset="-122"/>
-                <a:cs typeface="Trebuchet MS" pitchFamily="34" charset="-120"/>
-              </a:rPr>
-              <a:t>FCFA</a:t>
-            </a:r>
-            <a:endParaRPr lang="en-US" sz="900" dirty="0"/>
-          </a:p>
-        </p:txBody>
-      </p:sp>
-      <p:sp>
-        <p:nvSpPr>
-          <p:cNvPr id="32" name="Text 28"/>
-          <p:cNvSpPr txBox="1"/>
-          <p:nvPr/>
-        </p:nvSpPr>
-        <p:spPr>
-          <a:xfrm>
-            <a:off x="6181344" y="3474720"/>
-            <a:ext cx="5285232" cy="512064"/>
-          </a:xfrm>
-          <a:prstGeom prst="rect">
-            <a:avLst/>
-          </a:prstGeom>
-          <a:noFill/>
-          <a:ln/>
-        </p:spPr>
-        <p:txBody>
-          <a:bodyPr wrap="square" rtlCol="0" anchor="t"/>
-          <a:lstStyle/>
-          <a:p>
-            <a:pPr algn="l" indent="0" marL="0">
-              <a:lnSpc>
-                <a:spcPct val="110000"/>
-              </a:lnSpc>
-              <a:buNone/>
-            </a:pPr>
-            <a:r>
-              <a:rPr lang="en-US" sz="1100" b="1" dirty="0">
-                <a:solidFill>
-                  <a:srgbClr val="22333B"/>
-                </a:solidFill>
-                <a:latin typeface="Trebuchet MS" pitchFamily="34" charset="0"/>
-                <a:ea typeface="Trebuchet MS" pitchFamily="34" charset="-122"/>
-                <a:cs typeface="Trebuchet MS" pitchFamily="34" charset="-120"/>
-              </a:rPr>
-              <a:t>Et ce n'est pas fini : </a:t>
-            </a:r>
-            <a:pPr algn="l" indent="0" marL="0">
-              <a:lnSpc>
-                <a:spcPct val="110000"/>
-              </a:lnSpc>
-              <a:buNone/>
-            </a:pPr>
-            <a:r>
-              <a:rPr lang="en-US" sz="1100" dirty="0">
-                <a:solidFill>
-                  <a:srgbClr val="22333B"/>
-                </a:solidFill>
-                <a:latin typeface="Trebuchet MS" pitchFamily="34" charset="0"/>
-                <a:ea typeface="Trebuchet MS" pitchFamily="34" charset="-122"/>
-                <a:cs typeface="Trebuchet MS" pitchFamily="34" charset="-120"/>
-              </a:rPr>
-              <a:t>des consommables et de la maintenance à financer chaque année, dans chaque établissement.</a:t>
-            </a:r>
-            <a:endParaRPr lang="en-US" sz="1100" dirty="0"/>
-          </a:p>
-        </p:txBody>
-      </p:sp>
-      <p:sp>
-        <p:nvSpPr>
-          <p:cNvPr id="33" name="Text 29"/>
-          <p:cNvSpPr txBox="1"/>
-          <p:nvPr/>
-        </p:nvSpPr>
-        <p:spPr>
-          <a:xfrm>
-            <a:off x="6181344" y="4059936"/>
-            <a:ext cx="5285232" cy="274320"/>
-          </a:xfrm>
-          <a:prstGeom prst="rect">
-            <a:avLst/>
-          </a:prstGeom>
-          <a:noFill/>
-          <a:ln/>
-        </p:spPr>
-        <p:txBody>
-          <a:bodyPr wrap="square" rtlCol="0" anchor="ctr"/>
-          <a:lstStyle/>
-          <a:p>
-            <a:pPr algn="l" indent="0" marL="0">
-              <a:buNone/>
-            </a:pPr>
-            <a:r>
-              <a:rPr lang="en-US" sz="1100" b="1" dirty="0">
-                <a:solidFill>
-                  <a:srgbClr val="22333B"/>
-                </a:solidFill>
-                <a:latin typeface="Trebuchet MS" pitchFamily="34" charset="0"/>
-                <a:ea typeface="Trebuchet MS" pitchFamily="34" charset="-122"/>
-                <a:cs typeface="Trebuchet MS" pitchFamily="34" charset="-120"/>
-              </a:rPr>
-              <a:t>Encore faut-il l'électricité pour qu'un laboratoire fonctionne :</a:t>
-            </a:r>
-            <a:endParaRPr lang="en-US" sz="1100" dirty="0"/>
-          </a:p>
-        </p:txBody>
-      </p:sp>
-      <p:sp>
-        <p:nvSpPr>
-          <p:cNvPr id="34" name="Text 30"/>
-          <p:cNvSpPr txBox="1"/>
-          <p:nvPr/>
-        </p:nvSpPr>
-        <p:spPr>
-          <a:xfrm>
-            <a:off x="6181344" y="4370832"/>
-            <a:ext cx="4334256" cy="256032"/>
-          </a:xfrm>
-          <a:prstGeom prst="rect">
-            <a:avLst/>
-          </a:prstGeom>
-          <a:noFill/>
-          <a:ln/>
-        </p:spPr>
-        <p:txBody>
-          <a:bodyPr wrap="square" rtlCol="0" anchor="ctr"/>
-          <a:lstStyle/>
-          <a:p>
-            <a:pPr algn="l" indent="0" marL="0">
-              <a:buNone/>
-            </a:pPr>
-            <a:r>
-              <a:rPr lang="en-US" sz="1100" dirty="0">
-                <a:solidFill>
-                  <a:srgbClr val="22333B"/>
-                </a:solidFill>
-                <a:latin typeface="Trebuchet MS" pitchFamily="34" charset="0"/>
-                <a:ea typeface="Trebuchet MS" pitchFamily="34" charset="-122"/>
-                <a:cs typeface="Trebuchet MS" pitchFamily="34" charset="-120"/>
-              </a:rPr>
-              <a:t>Électrification nationale</a:t>
-            </a:r>
-            <a:endParaRPr lang="en-US" sz="1100" dirty="0"/>
-          </a:p>
-        </p:txBody>
-      </p:sp>
-      <p:sp>
-        <p:nvSpPr>
-          <p:cNvPr id="35" name="Text 31"/>
-          <p:cNvSpPr txBox="1"/>
-          <p:nvPr/>
-        </p:nvSpPr>
-        <p:spPr>
-          <a:xfrm>
-            <a:off x="10515600" y="4370832"/>
-            <a:ext cx="914400" cy="256032"/>
-          </a:xfrm>
-          <a:prstGeom prst="rect">
-            <a:avLst/>
-          </a:prstGeom>
-          <a:noFill/>
-          <a:ln/>
-        </p:spPr>
-        <p:txBody>
-          <a:bodyPr wrap="square" rtlCol="0" anchor="ctr"/>
-          <a:lstStyle/>
-          <a:p>
-            <a:pPr algn="r" indent="0" marL="0">
-              <a:buNone/>
-            </a:pPr>
-            <a:r>
-              <a:rPr lang="en-US" sz="1150" b="1" dirty="0">
-                <a:solidFill>
-                  <a:srgbClr val="0E7C7B"/>
-                </a:solidFill>
-                <a:latin typeface="Trebuchet MS" pitchFamily="34" charset="0"/>
-                <a:ea typeface="Trebuchet MS" pitchFamily="34" charset="-122"/>
-                <a:cs typeface="Trebuchet MS" pitchFamily="34" charset="-120"/>
-              </a:rPr>
-              <a:t>61,1 %</a:t>
-            </a:r>
-            <a:endParaRPr lang="en-US" sz="1150" dirty="0"/>
-          </a:p>
-        </p:txBody>
-      </p:sp>
-      <p:sp>
-        <p:nvSpPr>
-          <p:cNvPr id="36" name="Shape 32"/>
-          <p:cNvSpPr/>
-          <p:nvPr/>
-        </p:nvSpPr>
-        <p:spPr>
-          <a:xfrm>
-            <a:off x="6181344" y="4663440"/>
+            <a:off x="6181344" y="4773168"/>
             <a:ext cx="5248656" cy="128016"/>
           </a:xfrm>
           <a:prstGeom prst="roundRect">
@@ -9770,13 +10080,13 @@
       </p:sp>
       <p:sp>
         <p:nvSpPr>
-          <p:cNvPr id="37" name="Shape 33"/>
+          <p:cNvPr id="38" name="Shape 34"/>
           <p:cNvSpPr/>
           <p:nvPr/>
         </p:nvSpPr>
         <p:spPr>
           <a:xfrm>
-            <a:off x="6181344" y="4663440"/>
+            <a:off x="6181344" y="4773168"/>
             <a:ext cx="3206929" cy="128016"/>
           </a:xfrm>
           <a:prstGeom prst="roundRect">
@@ -9792,13 +10102,13 @@
       </p:sp>
       <p:sp>
         <p:nvSpPr>
-          <p:cNvPr id="38" name="Text 34"/>
-          <p:cNvSpPr txBox="1"/>
-          <p:nvPr/>
-        </p:nvSpPr>
-        <p:spPr>
-          <a:xfrm>
-            <a:off x="6181344" y="4919472"/>
+          <p:cNvPr id="39" name="Text 35"/>
+          <p:cNvSpPr txBox="1"/>
+          <p:nvPr/>
+        </p:nvSpPr>
+        <p:spPr>
+          <a:xfrm>
+            <a:off x="6181344" y="5029200"/>
             <a:ext cx="4334256" cy="256032"/>
           </a:xfrm>
           <a:prstGeom prst="rect">
@@ -9831,13 +10141,13 @@
       </p:sp>
       <p:sp>
         <p:nvSpPr>
-          <p:cNvPr id="39" name="Text 35"/>
-          <p:cNvSpPr txBox="1"/>
-          <p:nvPr/>
-        </p:nvSpPr>
-        <p:spPr>
-          <a:xfrm>
-            <a:off x="10515600" y="4919472"/>
+          <p:cNvPr id="40" name="Text 36"/>
+          <p:cNvSpPr txBox="1"/>
+          <p:nvPr/>
+        </p:nvSpPr>
+        <p:spPr>
+          <a:xfrm>
+            <a:off x="10515600" y="5029200"/>
             <a:ext cx="914400" cy="256032"/>
           </a:xfrm>
           <a:prstGeom prst="rect">
@@ -9870,13 +10180,13 @@
       </p:sp>
       <p:sp>
         <p:nvSpPr>
-          <p:cNvPr id="40" name="Shape 36"/>
+          <p:cNvPr id="41" name="Shape 37"/>
           <p:cNvSpPr/>
           <p:nvPr/>
         </p:nvSpPr>
         <p:spPr>
           <a:xfrm>
-            <a:off x="6181344" y="5212080"/>
+            <a:off x="6181344" y="5321808"/>
             <a:ext cx="5248656" cy="128016"/>
           </a:xfrm>
           <a:prstGeom prst="roundRect">
@@ -9892,13 +10202,13 @@
       </p:sp>
       <p:sp>
         <p:nvSpPr>
-          <p:cNvPr id="41" name="Shape 37"/>
+          <p:cNvPr id="42" name="Shape 38"/>
           <p:cNvSpPr/>
           <p:nvPr/>
         </p:nvSpPr>
         <p:spPr>
           <a:xfrm>
-            <a:off x="6181344" y="5212080"/>
+            <a:off x="6181344" y="5321808"/>
             <a:ext cx="1779294" cy="128016"/>
           </a:xfrm>
           <a:prstGeom prst="roundRect">
@@ -9914,18 +10224,18 @@
       </p:sp>
       <p:sp>
         <p:nvSpPr>
-          <p:cNvPr id="42" name="Shape 38"/>
+          <p:cNvPr id="43" name="Shape 39"/>
           <p:cNvSpPr/>
           <p:nvPr/>
         </p:nvSpPr>
         <p:spPr>
           <a:xfrm>
-            <a:off x="457200" y="5669280"/>
-            <a:ext cx="11247120" cy="603504"/>
+            <a:off x="457200" y="5614416"/>
+            <a:ext cx="11247120" cy="658368"/>
           </a:xfrm>
           <a:prstGeom prst="roundRect">
             <a:avLst>
-              <a:gd name="adj" fmla="val 13636"/>
+              <a:gd name="adj" fmla="val 12500"/>
             </a:avLst>
           </a:prstGeom>
           <a:solidFill>
@@ -9936,14 +10246,14 @@
       </p:sp>
       <p:sp>
         <p:nvSpPr>
-          <p:cNvPr id="43" name="Text 39"/>
-          <p:cNvSpPr txBox="1"/>
-          <p:nvPr/>
-        </p:nvSpPr>
-        <p:spPr>
-          <a:xfrm>
-            <a:off x="731520" y="5669280"/>
-            <a:ext cx="10698480" cy="603504"/>
+          <p:cNvPr id="44" name="Text 40"/>
+          <p:cNvSpPr txBox="1"/>
+          <p:nvPr/>
+        </p:nvSpPr>
+        <p:spPr>
+          <a:xfrm>
+            <a:off x="731520" y="5614416"/>
+            <a:ext cx="10698480" cy="658368"/>
           </a:xfrm>
           <a:prstGeom prst="rect">
             <a:avLst/>
@@ -9962,7 +10272,7 @@
               <a:buNone/>
             </a:pPr>
             <a:r>
-              <a:rPr lang="en-US" sz="1250" b="1" dirty="0">
+              <a:rPr lang="en-US" sz="1200" b="1" dirty="0">
                 <a:solidFill>
                   <a:srgbClr val="FFFFFF"/>
                 </a:solidFill>
@@ -9970,15 +10280,15 @@
                 <a:ea typeface="Trebuchet MS" pitchFamily="34" charset="-122"/>
                 <a:cs typeface="Trebuchet MS" pitchFamily="34" charset="-120"/>
               </a:rPr>
-              <a:t>La réforme exige des TP partout. Un budget de laboratoires partout n'existe pas : la pratique reste concentrée dans quelques établissements urbains.</a:t>
-            </a:r>
-            <a:endParaRPr lang="en-US" sz="1250" dirty="0"/>
-          </a:p>
-        </p:txBody>
-      </p:sp>
-      <p:sp>
-        <p:nvSpPr>
-          <p:cNvPr id="44" name="Text 40"/>
+              <a:t>Même frugale, la facture dépasse 8 milliards, hors salles, hors courant, hors consommables annuels : le tout-physique n'est pas une option.</a:t>
+            </a:r>
+            <a:endParaRPr lang="en-US" sz="1200" dirty="0"/>
+          </a:p>
+        </p:txBody>
+      </p:sp>
+      <p:sp>
+        <p:nvSpPr>
+          <p:cNvPr id="45" name="Text 41"/>
           <p:cNvSpPr txBox="1"/>
           <p:nvPr/>
         </p:nvSpPr>
@@ -10009,7 +10319,7 @@
                 <a:ea typeface="Trebuchet MS" pitchFamily="34" charset="-122"/>
                 <a:cs typeface="Trebuchet MS" pitchFamily="34" charset="-120"/>
               </a:rPr>
-              <a:t>Sources : MOHAC Africa (2026) ; Banque mondiale (2024). Hypothèse prudente de l'équipe : 10 à 20 M FCFA par laboratoire, à affiner avec les services du ministère.</a:t>
+              <a:t>Sources : GPE (2019) ; Ministère de l'Éducation nationale, Togo (2024) ; Banque mondiale (2024). Hypothèse : 10 M FCFA d'équipement par laboratoire, à affiner avec le ministère.</a:t>
             </a:r>
             <a:endParaRPr lang="en-US" sz="900" dirty="0"/>
           </a:p>
@@ -10017,7 +10327,7 @@
       </p:sp>
       <p:sp>
         <p:nvSpPr>
-          <p:cNvPr id="45" name="Text 41"/>
+          <p:cNvPr id="46" name="Text 42"/>
           <p:cNvSpPr txBox="1"/>
           <p:nvPr/>
         </p:nvSpPr>
@@ -10266,7 +10576,7 @@
                 <a:ea typeface="Trebuchet MS" pitchFamily="34" charset="-122"/>
                 <a:cs typeface="Trebuchet MS" pitchFamily="34" charset="-120"/>
               </a:rPr>
-              <a:t>Une plateforme web publique et gratuite : tous les TP du programme officiel en simulateurs numériques, utilisables sans réseau.</a:t>
+              <a:t>Gratuite, publique et hors ligne : 120 simulateurs alignés sur les programmes officiels, du collège au lycée.</a:t>
             </a:r>
             <a:endParaRPr lang="en-US" sz="1350" dirty="0"/>
           </a:p>
@@ -12187,7 +12497,7 @@
                 <a:ea typeface="Trebuchet MS" pitchFamily="34" charset="-122"/>
                 <a:cs typeface="Trebuchet MS" pitchFamily="34" charset="-120"/>
               </a:rPr>
-              <a:t>Cartographie des TP du programme officiel avec les inspecteurs.</a:t>
+              <a:t>Les TP du programme cartographiés avec les inspecteurs.</a:t>
             </a:r>
             <a:endParaRPr lang="en-US" sz="1050" dirty="0"/>
           </a:p>
@@ -12613,7 +12923,7 @@
                 <a:ea typeface="Trebuchet MS" pitchFamily="34" charset="-122"/>
                 <a:cs typeface="Trebuchet MS" pitchFamily="34" charset="-120"/>
               </a:rPr>
-              <a:t>Simulateur HTML5 de 1 à 3 Mo, utilisable en partie localement.</a:t>
+              <a:t>HTML5, 1 à 3 Mo par TP, conçu pour tourner hors ligne.</a:t>
             </a:r>
             <a:endParaRPr lang="en-US" sz="1050" dirty="0"/>
           </a:p>
@@ -12997,7 +13307,7 @@
                 <a:ea typeface="Georgia" pitchFamily="34" charset="-122"/>
                 <a:cs typeface="Georgia" pitchFamily="34" charset="-120"/>
               </a:rPr>
-              <a:t>Déployer, mesurer</a:t>
+              <a:t>Déployer</a:t>
             </a:r>
             <a:endParaRPr lang="en-US" sz="1450" dirty="0"/>
           </a:p>
@@ -13039,7 +13349,7 @@
                 <a:ea typeface="Trebuchet MS" pitchFamily="34" charset="-122"/>
                 <a:cs typeface="Trebuchet MS" pitchFamily="34" charset="-120"/>
               </a:rPr>
-              <a:t>Usage en classe, données agrégées, recalibrage.</a:t>
+              <a:t>Usage mesuré en classe, catalogue recalibré.</a:t>
             </a:r>
             <a:endParaRPr lang="en-US" sz="1050" dirty="0"/>
           </a:p>
@@ -13511,7 +13821,7 @@
                 <a:ea typeface="Trebuchet MS" pitchFamily="34" charset="-122"/>
                 <a:cs typeface="Trebuchet MS" pitchFamily="34" charset="-120"/>
               </a:rPr>
-              <a:t>TP officiels : fiche, protocole et quiz-jeu par séance</a:t>
+              <a:t>Fiche, protocole et quiz-jeu pour chaque séance</a:t>
             </a:r>
             <a:endParaRPr lang="en-US" sz="950" dirty="0"/>
           </a:p>
@@ -13685,7 +13995,7 @@
                 <a:ea typeface="Trebuchet MS" pitchFamily="34" charset="-122"/>
                 <a:cs typeface="Trebuchet MS" pitchFamily="34" charset="-120"/>
               </a:rPr>
-              <a:t>1 à 3 Mo par TP, fluides sur ordinateur et smartphone</a:t>
+              <a:t>1 à 3 Mo par TP, fluides sur PC et smartphone</a:t>
             </a:r>
             <a:endParaRPr lang="en-US" sz="950" dirty="0"/>
           </a:p>
@@ -13859,7 +14169,7 @@
                 <a:ea typeface="Trebuchet MS" pitchFamily="34" charset="-122"/>
                 <a:cs typeface="Trebuchet MS" pitchFamily="34" charset="-120"/>
               </a:rPr>
-              <a:t>catalogue entier en cache local, synchronisation différée</a:t>
+              <a:t>catalogue entier en cache local, sync différée</a:t>
             </a:r>
             <a:endParaRPr lang="en-US" sz="950" dirty="0"/>
           </a:p>
@@ -14033,7 +14343,7 @@
                 <a:ea typeface="Trebuchet MS" pitchFamily="34" charset="-122"/>
                 <a:cs typeface="Trebuchet MS" pitchFamily="34" charset="-120"/>
               </a:rPr>
-              <a:t>mode classe projeté ; l'élève rejoue librement chez lui</a:t>
+              <a:t>projeté en classe, rejoué librement à la maison</a:t>
             </a:r>
             <a:endParaRPr lang="en-US" sz="950" dirty="0"/>
           </a:p>
@@ -14596,7 +14906,7 @@
                 <a:ea typeface="Trebuchet MS" pitchFamily="34" charset="-122"/>
                 <a:cs typeface="Trebuchet MS" pitchFamily="34" charset="-120"/>
               </a:rPr>
-              <a:t>Usage agrégé et anonymisé : un tableau de bord pour le ministère et un recalibrage continu du catalogue.</a:t>
+              <a:t>Usage agrégé et anonymisé : un tableau de bord ministériel et un catalogue recalibré en continu.</a:t>
             </a:r>
             <a:endParaRPr lang="en-US" sz="1050" dirty="0"/>
           </a:p>
@@ -14750,7 +15060,7 @@
                 <a:ea typeface="Trebuchet MS" pitchFamily="34" charset="-122"/>
                 <a:cs typeface="Trebuchet MS" pitchFamily="34" charset="-120"/>
               </a:rPr>
-              <a:t>Points, badges et défis entre classes, aux formats BEPC et baccalauréat : la répétition qui ancre les notions devient un plaisir.</a:t>
+              <a:t>Points, badges et défis entre classes aux formats BEPC et bac : la répétition devient un plaisir.</a:t>
             </a:r>
             <a:endParaRPr lang="en-US" sz="1050" dirty="0"/>
           </a:p>
@@ -15378,7 +15688,7 @@
                 <a:ea typeface="Trebuchet MS" pitchFamily="34" charset="-122"/>
                 <a:cs typeface="Trebuchet MS" pitchFamily="34" charset="-120"/>
               </a:rPr>
-              <a:t>Laboratoires physiques · 800 établissements</a:t>
+              <a:t>Équipement physique des laboratoires</a:t>
             </a:r>
             <a:endParaRPr lang="en-US" sz="950" dirty="0"/>
           </a:p>
@@ -15417,7 +15727,7 @@
                 <a:ea typeface="Trebuchet MS" pitchFamily="34" charset="-122"/>
                 <a:cs typeface="Trebuchet MS" pitchFamily="34" charset="-120"/>
               </a:rPr>
-              <a:t>≈ 12 milliards FCFA</a:t>
+              <a:t>≈ 8 milliards FCFA</a:t>
             </a:r>
             <a:endParaRPr lang="en-US" sz="950" dirty="0"/>
           </a:p>
@@ -15478,7 +15788,7 @@
                 <a:ea typeface="Trebuchet MS" pitchFamily="34" charset="-122"/>
                 <a:cs typeface="Trebuchet MS" pitchFamily="34" charset="-120"/>
               </a:rPr>
-              <a:t>VirtuLab · mêmes 800 établissements</a:t>
+              <a:t>VirtuLab · déploiement national</a:t>
             </a:r>
             <a:endParaRPr lang="en-US" sz="950" dirty="0"/>
           </a:p>
@@ -15532,11 +15842,11 @@
         <p:spPr>
           <a:xfrm>
             <a:off x="7123176" y="5029200"/>
-            <a:ext cx="128016" cy="155448"/>
+            <a:ext cx="160934" cy="155448"/>
           </a:xfrm>
           <a:prstGeom prst="roundRect">
             <a:avLst>
-              <a:gd name="adj" fmla="val 60714"/>
+              <a:gd name="adj" fmla="val 50000"/>
             </a:avLst>
           </a:prstGeom>
           <a:solidFill>
@@ -15578,7 +15888,7 @@
                 <a:ea typeface="Georgia" pitchFamily="34" charset="-122"/>
                 <a:cs typeface="Georgia" pitchFamily="34" charset="-120"/>
               </a:rPr>
-              <a:t>≈ 40 × moins cher</a:t>
+              <a:t>≈ 25 × moins cher</a:t>
             </a:r>
             <a:endParaRPr lang="en-US" sz="2200" dirty="0"/>
           </a:p>
@@ -15698,7 +16008,7 @@
                 <a:ea typeface="Trebuchet MS" pitchFamily="34" charset="-122"/>
                 <a:cs typeface="Trebuchet MS" pitchFamily="34" charset="-120"/>
               </a:rPr>
-              <a:t>Sources : Li et Liang (2024), PLOS ONE ; Labster, Evidence Guide ; de Jong, Linn et Zacharia (2013), Science. Coûts : estimation prudente de l'équipe.</a:t>
+              <a:t>Sources : Li et Liang (2024), PLOS ONE ; Labster ; de Jong et al. (2013), Science. Coûts : hypothèse 10 M FCFA/labo, hors construction, à affiner.</a:t>
             </a:r>
             <a:endParaRPr lang="en-US" sz="900" dirty="0"/>
           </a:p>
@@ -16003,7 +16313,7 @@
                 <a:ea typeface="Trebuchet MS" pitchFamily="34" charset="-122"/>
                 <a:cs typeface="Trebuchet MS" pitchFamily="34" charset="-120"/>
               </a:rPr>
-              <a:t>Maquette du tableau de bord web · TP « Dosage acide-base » en 3e · simulation libre, protocole guidé et quiz-jeu aligné BEPC</a:t>
+              <a:t>Le tableau de bord web · TP « Dosage acide-base » en 3e · simulation libre, protocole guidé et quiz-jeu aligné BEPC</a:t>
             </a:r>
             <a:endParaRPr lang="en-US" sz="1050" dirty="0"/>
           </a:p>

</xml_diff>

<commit_message>
V3 : modele de cout calle sur les donnees reelles du Togo (UNICEF Tsevie 12M standard, formule kits ~3M, minimum national 2,4 Md au lieu de 8 Md) + diapos 2-7 redesignees data-driven
</commit_message>
<xml_diff>
--- a/VirtuLab_Togo_Presentation_Dr_Pagdame_Tiebekabe.pptx
+++ b/VirtuLab_Togo_Presentation_Dr_Pagdame_Tiebekabe.pptx
@@ -121,193 +121,6 @@
 </file>
 
 <file path=ppt/charts/chart1.xml><?xml version="1.0" encoding="utf-8"?>
-<c:chartSpace xmlns:c="http://schemas.openxmlformats.org/drawingml/2006/chart" xmlns:a="http://schemas.openxmlformats.org/drawingml/2006/main" xmlns:r="http://schemas.openxmlformats.org/officeDocument/2006/relationships">
-  <c:date1904 val="0"/>
-  <c:roundedCorners val="1"/>
-  <c:chart>
-    <c:autoTitleDeleted val="1"/>
-    <c:plotArea>
-      <c:layout/>
-      <c:doughnutChart>
-        <c:varyColors val="1"/>
-        <c:ser>
-          <c:idx val="0"/>
-          <c:order val="0"/>
-          <c:tx>
-            <c:strRef>
-              <c:f>Sheet1!$B$1</c:f>
-              <c:strCache>
-                <c:ptCount val="1"/>
-                <c:pt idx="0">
-                  <c:v>Établissements</c:v>
-                </c:pt>
-              </c:strCache>
-            </c:strRef>
-          </c:tx>
-          <c:spPr>
-            <a:solidFill>
-              <a:schemeClr val="accent1"/>
-            </a:solidFill>
-            <a:ln w="9525" cap="flat">
-              <a:solidFill>
-                <a:srgbClr val="F9F9F9"/>
-              </a:solidFill>
-              <a:prstDash val="solid"/>
-              <a:round/>
-            </a:ln>
-            <a:effectLst/>
-          </c:spPr>
-          <c:dPt>
-            <c:idx val="0"/>
-            <c:bubble3D val="0"/>
-            <c:spPr>
-              <a:solidFill>
-                <a:srgbClr val="E0592A"/>
-              </a:solidFill>
-              <a:effectLst/>
-            </c:spPr>
-          </c:dPt>
-          <c:dPt>
-            <c:idx val="1"/>
-            <c:bubble3D val="0"/>
-            <c:spPr>
-              <a:solidFill>
-                <a:srgbClr val="DCEBEA"/>
-              </a:solidFill>
-              <a:effectLst/>
-            </c:spPr>
-          </c:dPt>
-          <c:dLbls>
-            <c:dLbl>
-              <c:idx val="0"/>
-              <c:numFmt formatCode="General" sourceLinked="0"/>
-              <c:spPr/>
-              <c:txPr>
-                <a:bodyPr/>
-                <a:lstStyle/>
-                <a:p>
-                  <a:pPr>
-                    <a:defRPr sz="1200" b="0" i="0" u="none" strike="noStrike">
-                      <a:solidFill>
-                        <a:srgbClr val="000000"/>
-                      </a:solidFill>
-                      <a:latin typeface="Arial"/>
-                    </a:defRPr>
-                  </a:pPr>
-                </a:p>
-              </c:txPr>
-              <c:showLegendKey val="0"/>
-              <c:showVal val="0"/>
-              <c:showCatName val="0"/>
-              <c:showSerName val="0"/>
-              <c:showPercent val="0"/>
-              <c:showBubbleSize val="0"/>
-            </c:dLbl>
-            <c:dLbl>
-              <c:idx val="1"/>
-              <c:numFmt formatCode="General" sourceLinked="0"/>
-              <c:spPr/>
-              <c:txPr>
-                <a:bodyPr/>
-                <a:lstStyle/>
-                <a:p>
-                  <a:pPr>
-                    <a:defRPr sz="1200" b="0" i="0" u="none" strike="noStrike">
-                      <a:solidFill>
-                        <a:srgbClr val="000000"/>
-                      </a:solidFill>
-                      <a:latin typeface="Arial"/>
-                    </a:defRPr>
-                  </a:pPr>
-                </a:p>
-              </c:txPr>
-              <c:showLegendKey val="0"/>
-              <c:showVal val="0"/>
-              <c:showCatName val="0"/>
-              <c:showSerName val="0"/>
-              <c:showPercent val="0"/>
-              <c:showBubbleSize val="0"/>
-            </c:dLbl>
-            <c:numFmt formatCode="General" sourceLinked="0"/>
-            <c:txPr>
-              <a:bodyPr/>
-              <a:lstStyle/>
-              <a:p>
-                <a:pPr>
-                  <a:defRPr sz="1800" b="0" i="0" u="none" strike="noStrike">
-                    <a:solidFill>
-                      <a:srgbClr val="000000"/>
-                    </a:solidFill>
-                    <a:latin typeface="Arial"/>
-                  </a:defRPr>
-                </a:pPr>
-              </a:p>
-            </c:txPr>
-            <c:showLegendKey val="0"/>
-            <c:showVal val="0"/>
-            <c:showCatName val="1"/>
-            <c:showSerName val="0"/>
-            <c:showPercent val="1"/>
-            <c:showBubbleSize val="0"/>
-            <c:showLeaderLines val="0"/>
-          </c:dLbls>
-          <c:cat>
-            <c:strRef>
-              <c:f>Sheet1!$A$2:$A$3</c:f>
-              <c:strCache>
-                <c:ptCount val="2"/>
-                <c:pt idx="0">
-                  <c:v>Sans laboratoire</c:v>
-                </c:pt>
-                <c:pt idx="1">
-                  <c:v>Avec laboratoire</c:v>
-                </c:pt>
-              </c:strCache>
-            </c:strRef>
-          </c:cat>
-          <c:val>
-            <c:numRef>
-              <c:f>Sheet1!$B$2:$B$3</c:f>
-              <c:numCache>
-                <c:ptCount val="2"/>
-                <c:pt idx="0">
-                  <c:v>90</c:v>
-                </c:pt>
-                <c:pt idx="1">
-                  <c:v>10</c:v>
-                </c:pt>
-              </c:numCache>
-            </c:numRef>
-          </c:val>
-        </c:ser>
-        <c:firstSliceAng val="0"/>
-        <c:holeSize val="58"/>
-      </c:doughnutChart>
-      <c:spPr>
-        <a:noFill/>
-        <a:ln>
-          <a:noFill/>
-        </a:ln>
-        <a:effectLst/>
-      </c:spPr>
-    </c:plotArea>
-    <c:plotVisOnly val="1"/>
-    <c:dispBlanksAs val="span"/>
-  </c:chart>
-  <c:spPr>
-    <a:noFill/>
-    <a:ln>
-      <a:noFill/>
-    </a:ln>
-    <a:effectLst/>
-  </c:spPr>
-  <c:externalData r:id="rId1">
-    <c:autoUpdate val="0"/>
-  </c:externalData>
-</c:chartSpace>
-</file>
-
-<file path=ppt/charts/chart2.xml><?xml version="1.0" encoding="utf-8"?>
 <c:chartSpace xmlns:c="http://schemas.openxmlformats.org/drawingml/2006/chart" xmlns:a="http://schemas.openxmlformats.org/drawingml/2006/main" xmlns:r="http://schemas.openxmlformats.org/officeDocument/2006/relationships">
   <c:date1904 val="0"/>
   <c:roundedCorners val="1"/>
@@ -648,7 +461,7 @@
 </c:chartSpace>
 </file>
 
-<file path=ppt/charts/chart3.xml><?xml version="1.0" encoding="utf-8"?>
+<file path=ppt/charts/chart2.xml><?xml version="1.0" encoding="utf-8"?>
 <c:chartSpace xmlns:c="http://schemas.openxmlformats.org/drawingml/2006/chart" xmlns:a="http://schemas.openxmlformats.org/drawingml/2006/main" xmlns:r="http://schemas.openxmlformats.org/officeDocument/2006/relationships">
   <c:date1904 val="0"/>
   <c:roundedCorners val="1"/>
@@ -1048,7 +861,7 @@
 </c:chartSpace>
 </file>
 
-<file path=ppt/charts/chart4.xml><?xml version="1.0" encoding="utf-8"?>
+<file path=ppt/charts/chart3.xml><?xml version="1.0" encoding="utf-8"?>
 <c:chartSpace xmlns:c="http://schemas.openxmlformats.org/drawingml/2006/chart" xmlns:a="http://schemas.openxmlformats.org/drawingml/2006/main" xmlns:r="http://schemas.openxmlformats.org/officeDocument/2006/relationships">
   <c:date1904 val="0"/>
   <c:roundedCorners val="1"/>
@@ -5077,7 +4890,7 @@
                 <a:ea typeface="Trebuchet MS" pitchFamily="34" charset="-122"/>
                 <a:cs typeface="Trebuchet MS" pitchFamily="34" charset="-120"/>
               </a:rPr>
-              <a:t>Dès la quatrième année, l'État prend en charge hébergement et maintenance pour environ 12 M FCFA par an : environ 3 % de l'équipement physique des seuls 40 établissements du pilote.</a:t>
+              <a:t>Dès la quatrième année, l'État prend en charge hébergement et maintenance pour environ 12 M FCFA par an : environ 10 % de la seule formule minimale d'équipement des 40 établissements du pilote.</a:t>
             </a:r>
             <a:endParaRPr lang="en-US" sz="1050" dirty="0"/>
           </a:p>
@@ -5859,7 +5672,7 @@
                 <a:ea typeface="Georgia" pitchFamily="34" charset="-122"/>
                 <a:cs typeface="Georgia" pitchFamily="34" charset="-120"/>
               </a:rPr>
-              <a:t>≈ 25 ×</a:t>
+              <a:t>≈ 8 ×</a:t>
             </a:r>
             <a:endParaRPr lang="en-US" sz="3000" dirty="0"/>
           </a:p>
@@ -5940,7 +5753,7 @@
                 <a:ea typeface="Trebuchet MS" pitchFamily="34" charset="-122"/>
                 <a:cs typeface="Trebuchet MS" pitchFamily="34" charset="-120"/>
               </a:rPr>
-              <a:t>La réforme devient exécutable partout pour 297 M FCFA, au lieu d'environ 8 milliards en équipement physique : l'argent public va à l'usage, pas au bâti.</a:t>
+              <a:t>La réforme devient exécutable partout pour 297 M FCFA, au lieu d'au moins 2,4 milliards en équipement physique : l'argent public va à l'usage, pas au bâti.</a:t>
             </a:r>
             <a:endParaRPr lang="en-US" sz="1050" dirty="0"/>
           </a:p>
@@ -7910,8 +7723,8 @@
         </p:nvSpPr>
         <p:spPr>
           <a:xfrm>
-            <a:off x="713232" y="2670048"/>
-            <a:ext cx="777240" cy="530352"/>
+            <a:off x="713232" y="2560320"/>
+            <a:ext cx="777240" cy="658368"/>
           </a:xfrm>
           <a:prstGeom prst="rect">
             <a:avLst/>
@@ -7927,7 +7740,7 @@
               <a:buNone/>
             </a:pPr>
             <a:r>
-              <a:rPr lang="en-US" sz="1300" b="1" dirty="0">
+              <a:rPr lang="en-US" sz="1400" b="1" dirty="0">
                 <a:solidFill>
                   <a:srgbClr val="6E7B80"/>
                 </a:solidFill>
@@ -7937,7 +7750,7 @@
               </a:rPr>
               <a:t>2011</a:t>
             </a:r>
-            <a:endParaRPr lang="en-US" sz="1300" dirty="0"/>
+            <a:endParaRPr lang="en-US" sz="1400" dirty="0"/>
           </a:p>
         </p:txBody>
       </p:sp>
@@ -7949,12 +7762,12 @@
         </p:nvSpPr>
         <p:spPr>
           <a:xfrm>
-            <a:off x="1554480" y="2670048"/>
-            <a:ext cx="1058048" cy="530352"/>
+            <a:off x="1645920" y="2560320"/>
+            <a:ext cx="953733" cy="658368"/>
           </a:xfrm>
           <a:prstGeom prst="roundRect">
             <a:avLst>
-              <a:gd name="adj" fmla="val 12069"/>
+              <a:gd name="adj" fmla="val 9722"/>
             </a:avLst>
           </a:prstGeom>
           <a:solidFill>
@@ -7971,8 +7784,8 @@
         </p:nvSpPr>
         <p:spPr>
           <a:xfrm>
-            <a:off x="2649104" y="2670048"/>
-            <a:ext cx="1097280" cy="530352"/>
+            <a:off x="2636229" y="2560320"/>
+            <a:ext cx="1097280" cy="658368"/>
           </a:xfrm>
           <a:prstGeom prst="rect">
             <a:avLst/>
@@ -7988,7 +7801,7 @@
               <a:buNone/>
             </a:pPr>
             <a:r>
-              <a:rPr lang="en-US" sz="1900" b="1" dirty="0">
+              <a:rPr lang="en-US" sz="2100" b="1" dirty="0">
                 <a:solidFill>
                   <a:srgbClr val="6E7B80"/>
                 </a:solidFill>
@@ -7998,7 +7811,7 @@
               </a:rPr>
               <a:t>294</a:t>
             </a:r>
-            <a:endParaRPr lang="en-US" sz="1900" dirty="0"/>
+            <a:endParaRPr lang="en-US" sz="2100" dirty="0"/>
           </a:p>
         </p:txBody>
       </p:sp>
@@ -8010,8 +7823,8 @@
         </p:nvSpPr>
         <p:spPr>
           <a:xfrm>
-            <a:off x="713232" y="3767328"/>
-            <a:ext cx="777240" cy="530352"/>
+            <a:off x="713232" y="3584448"/>
+            <a:ext cx="777240" cy="658368"/>
           </a:xfrm>
           <a:prstGeom prst="rect">
             <a:avLst/>
@@ -8027,7 +7840,7 @@
               <a:buNone/>
             </a:pPr>
             <a:r>
-              <a:rPr lang="en-US" sz="1300" b="1" dirty="0">
+              <a:rPr lang="en-US" sz="1400" b="1" dirty="0">
                 <a:solidFill>
                   <a:srgbClr val="22333B"/>
                 </a:solidFill>
@@ -8037,7 +7850,7 @@
               </a:rPr>
               <a:t>2024</a:t>
             </a:r>
-            <a:endParaRPr lang="en-US" sz="1300" dirty="0"/>
+            <a:endParaRPr lang="en-US" sz="1400" dirty="0"/>
           </a:p>
         </p:txBody>
       </p:sp>
@@ -8049,12 +7862,12 @@
         </p:nvSpPr>
         <p:spPr>
           <a:xfrm>
-            <a:off x="1554480" y="3767328"/>
-            <a:ext cx="3246120" cy="530352"/>
+            <a:off x="1645920" y="3584448"/>
+            <a:ext cx="2926080" cy="658368"/>
           </a:xfrm>
           <a:prstGeom prst="roundRect">
             <a:avLst>
-              <a:gd name="adj" fmla="val 12069"/>
+              <a:gd name="adj" fmla="val 9722"/>
             </a:avLst>
           </a:prstGeom>
           <a:solidFill>
@@ -8071,8 +7884,8 @@
         </p:nvSpPr>
         <p:spPr>
           <a:xfrm>
-            <a:off x="4837176" y="3767328"/>
-            <a:ext cx="1097280" cy="530352"/>
+            <a:off x="4608576" y="3584448"/>
+            <a:ext cx="1097280" cy="658368"/>
           </a:xfrm>
           <a:prstGeom prst="rect">
             <a:avLst/>
@@ -8088,7 +7901,7 @@
               <a:buNone/>
             </a:pPr>
             <a:r>
-              <a:rPr lang="en-US" sz="2100" b="1" dirty="0">
+              <a:rPr lang="en-US" sz="2300" b="1" dirty="0">
                 <a:solidFill>
                   <a:srgbClr val="0A5C5B"/>
                 </a:solidFill>
@@ -8098,41 +7911,63 @@
               </a:rPr>
               <a:t>902</a:t>
             </a:r>
-            <a:endParaRPr lang="en-US" sz="2100" dirty="0"/>
-          </a:p>
-        </p:txBody>
-      </p:sp>
-      <p:sp>
-        <p:nvSpPr>
-          <p:cNvPr id="17" name="Text 14"/>
-          <p:cNvSpPr txBox="1"/>
-          <p:nvPr/>
-        </p:nvSpPr>
-        <p:spPr>
-          <a:xfrm>
-            <a:off x="713232" y="4517136"/>
-            <a:ext cx="4882896" cy="512064"/>
-          </a:xfrm>
-          <a:prstGeom prst="rect">
-            <a:avLst/>
-          </a:prstGeom>
-          <a:noFill/>
-          <a:ln/>
-        </p:spPr>
-        <p:txBody>
-          <a:bodyPr wrap="square" rtlCol="0" anchor="t"/>
+            <a:endParaRPr lang="en-US" sz="2300" dirty="0"/>
+          </a:p>
+        </p:txBody>
+      </p:sp>
+      <p:sp>
+        <p:nvSpPr>
+          <p:cNvPr id="17" name="Shape 14"/>
+          <p:cNvSpPr/>
+          <p:nvPr/>
+        </p:nvSpPr>
+        <p:spPr>
+          <a:xfrm>
+            <a:off x="713232" y="4572000"/>
+            <a:ext cx="4882896" cy="566928"/>
+          </a:xfrm>
+          <a:prstGeom prst="roundRect">
+            <a:avLst>
+              <a:gd name="adj" fmla="val 12903"/>
+            </a:avLst>
+          </a:prstGeom>
+          <a:solidFill>
+            <a:srgbClr val="F8E4D9"/>
+          </a:solidFill>
+          <a:ln/>
+        </p:spPr>
+      </p:sp>
+      <p:sp>
+        <p:nvSpPr>
+          <p:cNvPr id="18" name="Text 15"/>
+          <p:cNvSpPr txBox="1"/>
+          <p:nvPr/>
+        </p:nvSpPr>
+        <p:spPr>
+          <a:xfrm>
+            <a:off x="859536" y="4572000"/>
+            <a:ext cx="4590288" cy="566928"/>
+          </a:xfrm>
+          <a:prstGeom prst="rect">
+            <a:avLst/>
+          </a:prstGeom>
+          <a:noFill/>
+          <a:ln/>
+        </p:spPr>
+        <p:txBody>
+          <a:bodyPr wrap="square" rtlCol="0" anchor="ctr"/>
           <a:lstStyle/>
           <a:p>
             <a:pPr algn="l" indent="0" marL="0">
               <a:lnSpc>
-                <a:spcPct val="112000"/>
+                <a:spcPct val="110000"/>
               </a:lnSpc>
               <a:buNone/>
             </a:pPr>
             <a:r>
-              <a:rPr lang="en-US" sz="1100" dirty="0">
-                <a:solidFill>
-                  <a:srgbClr val="6E7B80"/>
+              <a:rPr lang="en-US" sz="1050" b="1" dirty="0">
+                <a:solidFill>
+                  <a:srgbClr val="B8431D"/>
                 </a:solidFill>
                 <a:latin typeface="Trebuchet MS" pitchFamily="34" charset="0"/>
                 <a:ea typeface="Trebuchet MS" pitchFamily="34" charset="-122"/>
@@ -8140,13 +7975,13 @@
               </a:rPr>
               <a:t>608 créés depuis 2011, souvent en zones rurales, sans salle de sciences ni matériel.</a:t>
             </a:r>
-            <a:endParaRPr lang="en-US" sz="1100" dirty="0"/>
-          </a:p>
-        </p:txBody>
-      </p:sp>
-      <p:sp>
-        <p:nvSpPr>
-          <p:cNvPr id="18" name="Shape 15"/>
+            <a:endParaRPr lang="en-US" sz="1050" dirty="0"/>
+          </a:p>
+        </p:txBody>
+      </p:sp>
+      <p:sp>
+        <p:nvSpPr>
+          <p:cNvPr id="19" name="Shape 16"/>
           <p:cNvSpPr/>
           <p:nvPr/>
         </p:nvSpPr>
@@ -8173,7 +8008,7 @@
       </p:sp>
       <p:sp>
         <p:nvSpPr>
-          <p:cNvPr id="19" name="Shape 16"/>
+          <p:cNvPr id="20" name="Shape 17"/>
           <p:cNvSpPr/>
           <p:nvPr/>
         </p:nvSpPr>
@@ -8193,7 +8028,7 @@
       </p:sp>
       <p:sp>
         <p:nvSpPr>
-          <p:cNvPr id="20" name="Text 17"/>
+          <p:cNvPr id="21" name="Text 18"/>
           <p:cNvSpPr txBox="1"/>
           <p:nvPr/>
         </p:nvSpPr>
@@ -8232,7 +8067,7 @@
       </p:sp>
       <p:sp>
         <p:nvSpPr>
-          <p:cNvPr id="21" name="Text 18"/>
+          <p:cNvPr id="22" name="Text 19"/>
           <p:cNvSpPr txBox="1"/>
           <p:nvPr/>
         </p:nvSpPr>
@@ -8274,7 +8109,7 @@
       </p:sp>
       <p:sp>
         <p:nvSpPr>
-          <p:cNvPr id="22" name="Text 19"/>
+          <p:cNvPr id="23" name="Text 20"/>
           <p:cNvSpPr txBox="1"/>
           <p:nvPr/>
         </p:nvSpPr>
@@ -8313,7 +8148,7 @@
       </p:sp>
       <p:sp>
         <p:nvSpPr>
-          <p:cNvPr id="23" name="Shape 20"/>
+          <p:cNvPr id="24" name="Shape 21"/>
           <p:cNvSpPr/>
           <p:nvPr/>
         </p:nvSpPr>
@@ -8340,7 +8175,7 @@
       </p:sp>
       <p:sp>
         <p:nvSpPr>
-          <p:cNvPr id="24" name="Shape 21"/>
+          <p:cNvPr id="25" name="Shape 22"/>
           <p:cNvSpPr/>
           <p:nvPr/>
         </p:nvSpPr>
@@ -8360,7 +8195,7 @@
       </p:sp>
       <p:sp>
         <p:nvSpPr>
-          <p:cNvPr id="25" name="Text 22"/>
+          <p:cNvPr id="26" name="Text 23"/>
           <p:cNvSpPr txBox="1"/>
           <p:nvPr/>
         </p:nvSpPr>
@@ -8399,7 +8234,7 @@
       </p:sp>
       <p:sp>
         <p:nvSpPr>
-          <p:cNvPr id="26" name="Text 23"/>
+          <p:cNvPr id="27" name="Text 24"/>
           <p:cNvSpPr txBox="1"/>
           <p:nvPr/>
         </p:nvSpPr>
@@ -8433,7 +8268,7 @@
                 <a:ea typeface="Trebuchet MS" pitchFamily="34" charset="-122"/>
                 <a:cs typeface="Trebuchet MS" pitchFamily="34" charset="-120"/>
               </a:rPr>
-              <a:t>des écoles d'Afrique subsaharienne n'ont pas de laboratoire de sciences.</a:t>
+              <a:t>des écoles du Togo n'ont pas de laboratoire : les TP restent théoriques.</a:t>
             </a:r>
             <a:endParaRPr lang="en-US" sz="1050" dirty="0"/>
           </a:p>
@@ -8441,7 +8276,7 @@
       </p:sp>
       <p:sp>
         <p:nvSpPr>
-          <p:cNvPr id="27" name="Text 24"/>
+          <p:cNvPr id="28" name="Text 25"/>
           <p:cNvSpPr txBox="1"/>
           <p:nvPr/>
         </p:nvSpPr>
@@ -8472,7 +8307,7 @@
                 <a:ea typeface="Trebuchet MS" pitchFamily="34" charset="-122"/>
                 <a:cs typeface="Trebuchet MS" pitchFamily="34" charset="-120"/>
               </a:rPr>
-              <a:t>Partenariat mondial pour l'éducation (GPE), 2019</a:t>
+              <a:t>GPE · récit MOBILELABO, 2019</a:t>
             </a:r>
             <a:endParaRPr lang="en-US" sz="850" dirty="0"/>
           </a:p>
@@ -8480,7 +8315,7 @@
       </p:sp>
       <p:sp>
         <p:nvSpPr>
-          <p:cNvPr id="28" name="Shape 25"/>
+          <p:cNvPr id="29" name="Shape 26"/>
           <p:cNvSpPr/>
           <p:nvPr/>
         </p:nvSpPr>
@@ -8507,7 +8342,7 @@
       </p:sp>
       <p:sp>
         <p:nvSpPr>
-          <p:cNvPr id="29" name="Shape 26"/>
+          <p:cNvPr id="30" name="Shape 27"/>
           <p:cNvSpPr/>
           <p:nvPr/>
         </p:nvSpPr>
@@ -8527,7 +8362,7 @@
       </p:sp>
       <p:sp>
         <p:nvSpPr>
-          <p:cNvPr id="30" name="Text 27"/>
+          <p:cNvPr id="31" name="Text 28"/>
           <p:cNvSpPr txBox="1"/>
           <p:nvPr/>
         </p:nvSpPr>
@@ -8566,7 +8401,7 @@
       </p:sp>
       <p:sp>
         <p:nvSpPr>
-          <p:cNvPr id="31" name="Text 28"/>
+          <p:cNvPr id="32" name="Text 29"/>
           <p:cNvSpPr txBox="1"/>
           <p:nvPr/>
         </p:nvSpPr>
@@ -8608,7 +8443,7 @@
       </p:sp>
       <p:sp>
         <p:nvSpPr>
-          <p:cNvPr id="32" name="Text 29"/>
+          <p:cNvPr id="33" name="Text 30"/>
           <p:cNvSpPr txBox="1"/>
           <p:nvPr/>
         </p:nvSpPr>
@@ -8647,7 +8482,7 @@
       </p:sp>
       <p:sp>
         <p:nvSpPr>
-          <p:cNvPr id="33" name="Shape 30"/>
+          <p:cNvPr id="34" name="Shape 31"/>
           <p:cNvSpPr/>
           <p:nvPr/>
         </p:nvSpPr>
@@ -8669,7 +8504,7 @@
       </p:sp>
       <p:sp>
         <p:nvSpPr>
-          <p:cNvPr id="34" name="Text 31"/>
+          <p:cNvPr id="35" name="Text 32"/>
           <p:cNvSpPr txBox="1"/>
           <p:nvPr/>
         </p:nvSpPr>
@@ -8711,7 +8546,7 @@
       </p:sp>
       <p:sp>
         <p:nvSpPr>
-          <p:cNvPr id="35" name="Text 32"/>
+          <p:cNvPr id="36" name="Text 33"/>
           <p:cNvSpPr txBox="1"/>
           <p:nvPr/>
         </p:nvSpPr>
@@ -8742,7 +8577,7 @@
                 <a:ea typeface="Trebuchet MS" pitchFamily="34" charset="-122"/>
                 <a:cs typeface="Trebuchet MS" pitchFamily="34" charset="-120"/>
               </a:rPr>
-              <a:t>Sources : Ministère de l'Éducation nationale, Togo (2024) ; Banque mondiale et Institut de statistique de l'UNESCO (2023) ; GPE (2019).</a:t>
+              <a:t>Sources : ministère de l'Éducation nationale, Togo (2024) ; Banque mondiale et Institut de statistique de l'UNESCO (2023) ; GPE, récit MOBILELABO (2019).</a:t>
             </a:r>
             <a:endParaRPr lang="en-US" sz="900" dirty="0"/>
           </a:p>
@@ -8750,7 +8585,7 @@
       </p:sp>
       <p:sp>
         <p:nvSpPr>
-          <p:cNvPr id="36" name="Text 33"/>
+          <p:cNvPr id="37" name="Text 34"/>
           <p:cNvSpPr txBox="1"/>
           <p:nvPr/>
         </p:nvSpPr>
@@ -8929,7 +8764,7 @@
               <a:buNone/>
             </a:pPr>
             <a:r>
-              <a:rPr lang="en-US" sz="2650" b="1" dirty="0">
+              <a:rPr lang="en-US" sz="2550" b="1" dirty="0">
                 <a:solidFill>
                   <a:srgbClr val="22333B"/>
                 </a:solidFill>
@@ -8937,9 +8772,9 @@
                 <a:ea typeface="Georgia" pitchFamily="34" charset="-122"/>
                 <a:cs typeface="Georgia" pitchFamily="34" charset="-120"/>
               </a:rPr>
-              <a:t>Équiper physiquement le pays : au moins 8 milliards FCFA</a:t>
-            </a:r>
-            <a:endParaRPr lang="en-US" sz="2650" dirty="0"/>
+              <a:t>Équiper physiquement le pays : au moins 2,4 milliards FCFA</a:t>
+            </a:r>
+            <a:endParaRPr lang="en-US" sz="2550" dirty="0"/>
           </a:p>
         </p:txBody>
       </p:sp>
@@ -8972,7 +8807,7 @@
         <p:spPr>
           <a:xfrm>
             <a:off x="457200" y="1773936"/>
-            <a:ext cx="5212080" cy="3749040"/>
+            <a:ext cx="5074920" cy="3749040"/>
           </a:xfrm>
           <a:prstGeom prst="roundRect">
             <a:avLst>
@@ -8998,8 +8833,8 @@
         </p:nvSpPr>
         <p:spPr>
           <a:xfrm>
-            <a:off x="5943600" y="1773936"/>
-            <a:ext cx="5760720" cy="3749040"/>
+            <a:off x="5760720" y="1773936"/>
+            <a:ext cx="5971032" cy="3749040"/>
           </a:xfrm>
           <a:prstGeom prst="roundRect">
             <a:avLst>
@@ -9026,7 +8861,7 @@
         <p:spPr>
           <a:xfrm>
             <a:off x="676656" y="1901952"/>
-            <a:ext cx="4773168" cy="292608"/>
+            <a:ext cx="4636008" cy="274320"/>
           </a:xfrm>
           <a:prstGeom prst="rect">
             <a:avLst/>
@@ -9050,38 +8885,22 @@
                 <a:ea typeface="Trebuchet MS" pitchFamily="34" charset="-122"/>
                 <a:cs typeface="Trebuchet MS" pitchFamily="34" charset="-120"/>
               </a:rPr>
-              <a:t>Le besoin</a:t>
+              <a:t>Ce que coûte un laboratoire, en vrai</a:t>
             </a:r>
             <a:endParaRPr lang="en-US" sz="1300" dirty="0"/>
           </a:p>
         </p:txBody>
       </p:sp>
-      <p:graphicFrame>
-        <p:nvGraphicFramePr>
-          <p:cNvPr id="10" name="Chart 0" descr=""/>
-          <p:cNvGraphicFramePr/>
-          <p:nvPr/>
-        </p:nvGraphicFramePr>
-        <p:xfrm>
-          <a:off x="731520" y="2432304"/>
-          <a:ext cx="2148840" cy="2148840"/>
-        </p:xfrm>
-        <a:graphic xmlns:a="http://schemas.openxmlformats.org/drawingml/2006/main">
-          <a:graphicData uri="http://schemas.openxmlformats.org/drawingml/2006/chart">
-            <c:chart xmlns:c="http://schemas.openxmlformats.org/drawingml/2006/chart" r:id="rId2"/>
-          </a:graphicData>
-        </a:graphic>
-      </p:graphicFrame>
-      <p:sp>
-        <p:nvSpPr>
-          <p:cNvPr id="11" name="Text 7"/>
-          <p:cNvSpPr txBox="1"/>
-          <p:nvPr/>
-        </p:nvSpPr>
-        <p:spPr>
-          <a:xfrm>
-            <a:off x="3017520" y="2560320"/>
-            <a:ext cx="2468880" cy="566928"/>
+      <p:sp>
+        <p:nvSpPr>
+          <p:cNvPr id="10" name="Text 7"/>
+          <p:cNvSpPr txBox="1"/>
+          <p:nvPr/>
+        </p:nvSpPr>
+        <p:spPr>
+          <a:xfrm>
+            <a:off x="676656" y="2286000"/>
+            <a:ext cx="1481328" cy="493776"/>
           </a:xfrm>
           <a:prstGeom prst="rect">
             <a:avLst/>
@@ -9097,7 +8916,7 @@
               <a:buNone/>
             </a:pPr>
             <a:r>
-              <a:rPr lang="en-US" sz="3100" b="1" dirty="0">
+              <a:rPr lang="en-US" sz="2800" b="1" dirty="0">
                 <a:solidFill>
                   <a:srgbClr val="B8431D"/>
                 </a:solidFill>
@@ -9105,326 +8924,485 @@
                 <a:ea typeface="Georgia" pitchFamily="34" charset="-122"/>
                 <a:cs typeface="Georgia" pitchFamily="34" charset="-120"/>
               </a:rPr>
-              <a:t>≈ 90 %</a:t>
-            </a:r>
-            <a:endParaRPr lang="en-US" sz="3100" dirty="0"/>
-          </a:p>
-        </p:txBody>
-      </p:sp>
-      <p:sp>
-        <p:nvSpPr>
-          <p:cNvPr id="12" name="Text 8"/>
-          <p:cNvSpPr txBox="1"/>
-          <p:nvPr/>
-        </p:nvSpPr>
-        <p:spPr>
-          <a:xfrm>
-            <a:off x="3017520" y="3163824"/>
-            <a:ext cx="2468880" cy="914400"/>
-          </a:xfrm>
-          <a:prstGeom prst="rect">
-            <a:avLst/>
-          </a:prstGeom>
-          <a:noFill/>
-          <a:ln/>
-        </p:spPr>
-        <p:txBody>
-          <a:bodyPr wrap="square" rtlCol="0" anchor="t"/>
+              <a:t>12 M</a:t>
+            </a:r>
+            <a:endParaRPr lang="en-US" sz="2800" dirty="0"/>
+          </a:p>
+        </p:txBody>
+      </p:sp>
+      <p:sp>
+        <p:nvSpPr>
+          <p:cNvPr id="11" name="Text 8"/>
+          <p:cNvSpPr txBox="1"/>
+          <p:nvPr/>
+        </p:nvSpPr>
+        <p:spPr>
+          <a:xfrm>
+            <a:off x="1938528" y="2340864"/>
+            <a:ext cx="566928" cy="384048"/>
+          </a:xfrm>
+          <a:prstGeom prst="rect">
+            <a:avLst/>
+          </a:prstGeom>
+          <a:noFill/>
+          <a:ln/>
+        </p:spPr>
+        <p:txBody>
+          <a:bodyPr wrap="square" rtlCol="0" anchor="ctr"/>
           <a:lstStyle/>
           <a:p>
             <a:pPr algn="l" indent="0" marL="0">
-              <a:lnSpc>
-                <a:spcPct val="114000"/>
-              </a:lnSpc>
-              <a:buNone/>
-            </a:pPr>
-            <a:r>
-              <a:rPr lang="en-US" sz="1100" dirty="0">
-                <a:solidFill>
-                  <a:srgbClr val="22333B"/>
+              <a:buNone/>
+            </a:pPr>
+            <a:r>
+              <a:rPr lang="en-US" sz="1050" b="1" dirty="0">
+                <a:solidFill>
+                  <a:srgbClr val="6E7B80"/>
                 </a:solidFill>
                 <a:latin typeface="Trebuchet MS" pitchFamily="34" charset="0"/>
                 <a:ea typeface="Trebuchet MS" pitchFamily="34" charset="-122"/>
                 <a:cs typeface="Trebuchet MS" pitchFamily="34" charset="-120"/>
               </a:rPr>
-              <a:t>des écoles d'Afrique subsaharienne n'ont pas de laboratoire de sciences</a:t>
-            </a:r>
-            <a:endParaRPr lang="en-US" sz="1100" dirty="0"/>
-          </a:p>
-        </p:txBody>
-      </p:sp>
-      <p:sp>
-        <p:nvSpPr>
-          <p:cNvPr id="13" name="Text 9"/>
-          <p:cNvSpPr txBox="1"/>
-          <p:nvPr/>
-        </p:nvSpPr>
-        <p:spPr>
-          <a:xfrm>
-            <a:off x="3017520" y="4114800"/>
-            <a:ext cx="2468880" cy="256032"/>
-          </a:xfrm>
-          <a:prstGeom prst="rect">
-            <a:avLst/>
-          </a:prstGeom>
-          <a:noFill/>
-          <a:ln/>
-        </p:spPr>
-        <p:txBody>
-          <a:bodyPr wrap="square" rtlCol="0" anchor="ctr"/>
-          <a:lstStyle/>
-          <a:p>
-            <a:pPr algn="l" indent="0" marL="0">
-              <a:buNone/>
-            </a:pPr>
-            <a:r>
-              <a:rPr lang="en-US" sz="950" i="1" dirty="0">
-                <a:solidFill>
-                  <a:srgbClr val="6E7B80"/>
+              <a:t>FCFA</a:t>
+            </a:r>
+            <a:endParaRPr lang="en-US" sz="1050" dirty="0"/>
+          </a:p>
+        </p:txBody>
+      </p:sp>
+      <p:sp>
+        <p:nvSpPr>
+          <p:cNvPr id="12" name="Shape 9"/>
+          <p:cNvSpPr/>
+          <p:nvPr/>
+        </p:nvSpPr>
+        <p:spPr>
+          <a:xfrm>
+            <a:off x="3502152" y="2368296"/>
+            <a:ext cx="1810512" cy="329184"/>
+          </a:xfrm>
+          <a:prstGeom prst="roundRect">
+            <a:avLst>
+              <a:gd name="adj" fmla="val 50000"/>
+            </a:avLst>
+          </a:prstGeom>
+          <a:solidFill>
+            <a:srgbClr val="F8E4D9"/>
+          </a:solidFill>
+          <a:ln/>
+        </p:spPr>
+      </p:sp>
+      <p:sp>
+        <p:nvSpPr>
+          <p:cNvPr id="13" name="Text 10"/>
+          <p:cNvSpPr txBox="1"/>
+          <p:nvPr/>
+        </p:nvSpPr>
+        <p:spPr>
+          <a:xfrm>
+            <a:off x="3502152" y="2368296"/>
+            <a:ext cx="1810512" cy="329184"/>
+          </a:xfrm>
+          <a:prstGeom prst="rect">
+            <a:avLst/>
+          </a:prstGeom>
+          <a:noFill/>
+          <a:ln/>
+        </p:spPr>
+        <p:txBody>
+          <a:bodyPr wrap="square" rtlCol="0" anchor="ctr"/>
+          <a:lstStyle/>
+          <a:p>
+            <a:pPr algn="ctr" indent="0" marL="0">
+              <a:buNone/>
+            </a:pPr>
+            <a:r>
+              <a:rPr lang="en-US" sz="850" b="1" spc="100" kern="0" dirty="0">
+                <a:solidFill>
+                  <a:srgbClr val="B8431D"/>
                 </a:solidFill>
                 <a:latin typeface="Trebuchet MS" pitchFamily="34" charset="0"/>
                 <a:ea typeface="Trebuchet MS" pitchFamily="34" charset="-122"/>
                 <a:cs typeface="Trebuchet MS" pitchFamily="34" charset="-120"/>
               </a:rPr>
-              <a:t>Partenariat mondial pour l'éducation (GPE), 2019</a:t>
-            </a:r>
-            <a:endParaRPr lang="en-US" sz="950" dirty="0"/>
-          </a:p>
-        </p:txBody>
-      </p:sp>
-      <p:sp>
-        <p:nvSpPr>
-          <p:cNvPr id="14" name="Shape 10"/>
-          <p:cNvSpPr/>
-          <p:nvPr/>
-        </p:nvSpPr>
-        <p:spPr>
-          <a:xfrm>
-            <a:off x="786384" y="4718304"/>
-            <a:ext cx="164592" cy="164592"/>
-          </a:xfrm>
-          <a:prstGeom prst="roundRect">
-            <a:avLst>
-              <a:gd name="adj" fmla="val 22222"/>
-            </a:avLst>
-          </a:prstGeom>
-          <a:solidFill>
-            <a:srgbClr val="E0592A"/>
-          </a:solidFill>
-          <a:ln/>
-        </p:spPr>
-      </p:sp>
-      <p:sp>
-        <p:nvSpPr>
-          <p:cNvPr id="15" name="Text 11"/>
-          <p:cNvSpPr txBox="1"/>
-          <p:nvPr/>
-        </p:nvSpPr>
-        <p:spPr>
-          <a:xfrm>
-            <a:off x="1005840" y="4663440"/>
-            <a:ext cx="1207008" cy="274320"/>
-          </a:xfrm>
-          <a:prstGeom prst="rect">
-            <a:avLst/>
-          </a:prstGeom>
-          <a:noFill/>
-          <a:ln/>
-        </p:spPr>
-        <p:txBody>
-          <a:bodyPr wrap="square" rtlCol="0" anchor="ctr"/>
+              <a:t>STANDARD COMPLET</a:t>
+            </a:r>
+            <a:endParaRPr lang="en-US" sz="850" dirty="0"/>
+          </a:p>
+        </p:txBody>
+      </p:sp>
+      <p:sp>
+        <p:nvSpPr>
+          <p:cNvPr id="14" name="Text 11"/>
+          <p:cNvSpPr txBox="1"/>
+          <p:nvPr/>
+        </p:nvSpPr>
+        <p:spPr>
+          <a:xfrm>
+            <a:off x="676656" y="2798064"/>
+            <a:ext cx="4636008" cy="512064"/>
+          </a:xfrm>
+          <a:prstGeom prst="rect">
+            <a:avLst/>
+          </a:prstGeom>
+          <a:noFill/>
+          <a:ln/>
+        </p:spPr>
+        <p:txBody>
+          <a:bodyPr wrap="square" rtlCol="0" anchor="t"/>
           <a:lstStyle/>
           <a:p>
             <a:pPr algn="l" indent="0" marL="0">
-              <a:buNone/>
-            </a:pPr>
-            <a:r>
-              <a:rPr lang="en-US" sz="900" dirty="0">
-                <a:solidFill>
-                  <a:srgbClr val="6E7B80"/>
+              <a:lnSpc>
+                <a:spcPct val="112000"/>
+              </a:lnSpc>
+              <a:buNone/>
+            </a:pPr>
+            <a:r>
+              <a:rPr lang="en-US" sz="1050" dirty="0">
+                <a:solidFill>
+                  <a:srgbClr val="22333B"/>
                 </a:solidFill>
                 <a:latin typeface="Trebuchet MS" pitchFamily="34" charset="0"/>
                 <a:ea typeface="Trebuchet MS" pitchFamily="34" charset="-122"/>
                 <a:cs typeface="Trebuchet MS" pitchFamily="34" charset="-120"/>
               </a:rPr>
-              <a:t>Sans laboratoire</a:t>
-            </a:r>
-            <a:endParaRPr lang="en-US" sz="900" dirty="0"/>
-          </a:p>
-        </p:txBody>
-      </p:sp>
-      <p:sp>
-        <p:nvSpPr>
-          <p:cNvPr id="16" name="Shape 12"/>
+              <a:t>Rénovation et équipement complets du laboratoire du lycée de Tsévié 1 : paillasses, eau, verrerie, électricité.</a:t>
+            </a:r>
+            <a:endParaRPr lang="en-US" sz="1050" dirty="0"/>
+          </a:p>
+        </p:txBody>
+      </p:sp>
+      <p:sp>
+        <p:nvSpPr>
+          <p:cNvPr id="15" name="Text 12"/>
+          <p:cNvSpPr txBox="1"/>
+          <p:nvPr/>
+        </p:nvSpPr>
+        <p:spPr>
+          <a:xfrm>
+            <a:off x="676656" y="3328416"/>
+            <a:ext cx="4636008" cy="201168"/>
+          </a:xfrm>
+          <a:prstGeom prst="rect">
+            <a:avLst/>
+          </a:prstGeom>
+          <a:noFill/>
+          <a:ln/>
+        </p:spPr>
+        <p:txBody>
+          <a:bodyPr wrap="square" rtlCol="0" anchor="ctr"/>
+          <a:lstStyle/>
+          <a:p>
+            <a:pPr algn="l" indent="0" marL="0">
+              <a:buNone/>
+            </a:pPr>
+            <a:r>
+              <a:rPr lang="en-US" sz="850" i="1" dirty="0">
+                <a:solidFill>
+                  <a:srgbClr val="6E7B80"/>
+                </a:solidFill>
+                <a:latin typeface="Trebuchet MS" pitchFamily="34" charset="0"/>
+                <a:ea typeface="Trebuchet MS" pitchFamily="34" charset="-122"/>
+                <a:cs typeface="Trebuchet MS" pitchFamily="34" charset="-120"/>
+              </a:rPr>
+              <a:t>Cas réel constaté au Togo · UNICEF, janvier 2025</a:t>
+            </a:r>
+            <a:endParaRPr lang="en-US" sz="850" dirty="0"/>
+          </a:p>
+        </p:txBody>
+      </p:sp>
+      <p:sp>
+        <p:nvSpPr>
+          <p:cNvPr id="16" name="Shape 13"/>
           <p:cNvSpPr/>
           <p:nvPr/>
         </p:nvSpPr>
         <p:spPr>
           <a:xfrm>
-            <a:off x="2304288" y="4718304"/>
-            <a:ext cx="164592" cy="164592"/>
+            <a:off x="676656" y="3602736"/>
+            <a:ext cx="4636008" cy="12802"/>
+          </a:xfrm>
+          <a:prstGeom prst="rect">
+            <a:avLst/>
+          </a:prstGeom>
+          <a:solidFill>
+            <a:srgbClr val="EDE8DA"/>
+          </a:solidFill>
+          <a:ln/>
+        </p:spPr>
+      </p:sp>
+      <p:sp>
+        <p:nvSpPr>
+          <p:cNvPr id="17" name="Text 14"/>
+          <p:cNvSpPr txBox="1"/>
+          <p:nvPr/>
+        </p:nvSpPr>
+        <p:spPr>
+          <a:xfrm>
+            <a:off x="676656" y="3712464"/>
+            <a:ext cx="1481328" cy="493776"/>
+          </a:xfrm>
+          <a:prstGeom prst="rect">
+            <a:avLst/>
+          </a:prstGeom>
+          <a:noFill/>
+          <a:ln/>
+        </p:spPr>
+        <p:txBody>
+          <a:bodyPr wrap="square" rtlCol="0" anchor="ctr"/>
+          <a:lstStyle/>
+          <a:p>
+            <a:pPr algn="l" indent="0" marL="0">
+              <a:buNone/>
+            </a:pPr>
+            <a:r>
+              <a:rPr lang="en-US" sz="2800" b="1" dirty="0">
+                <a:solidFill>
+                  <a:srgbClr val="0E7C7B"/>
+                </a:solidFill>
+                <a:latin typeface="Georgia" pitchFamily="34" charset="0"/>
+                <a:ea typeface="Georgia" pitchFamily="34" charset="-122"/>
+                <a:cs typeface="Georgia" pitchFamily="34" charset="-120"/>
+              </a:rPr>
+              <a:t>≈ 3 M</a:t>
+            </a:r>
+            <a:endParaRPr lang="en-US" sz="2800" dirty="0"/>
+          </a:p>
+        </p:txBody>
+      </p:sp>
+      <p:sp>
+        <p:nvSpPr>
+          <p:cNvPr id="18" name="Text 15"/>
+          <p:cNvSpPr txBox="1"/>
+          <p:nvPr/>
+        </p:nvSpPr>
+        <p:spPr>
+          <a:xfrm>
+            <a:off x="2084832" y="3767328"/>
+            <a:ext cx="566928" cy="384048"/>
+          </a:xfrm>
+          <a:prstGeom prst="rect">
+            <a:avLst/>
+          </a:prstGeom>
+          <a:noFill/>
+          <a:ln/>
+        </p:spPr>
+        <p:txBody>
+          <a:bodyPr wrap="square" rtlCol="0" anchor="ctr"/>
+          <a:lstStyle/>
+          <a:p>
+            <a:pPr algn="l" indent="0" marL="0">
+              <a:buNone/>
+            </a:pPr>
+            <a:r>
+              <a:rPr lang="en-US" sz="1050" b="1" dirty="0">
+                <a:solidFill>
+                  <a:srgbClr val="6E7B80"/>
+                </a:solidFill>
+                <a:latin typeface="Trebuchet MS" pitchFamily="34" charset="0"/>
+                <a:ea typeface="Trebuchet MS" pitchFamily="34" charset="-122"/>
+                <a:cs typeface="Trebuchet MS" pitchFamily="34" charset="-120"/>
+              </a:rPr>
+              <a:t>FCFA</a:t>
+            </a:r>
+            <a:endParaRPr lang="en-US" sz="1050" dirty="0"/>
+          </a:p>
+        </p:txBody>
+      </p:sp>
+      <p:sp>
+        <p:nvSpPr>
+          <p:cNvPr id="19" name="Shape 16"/>
+          <p:cNvSpPr/>
+          <p:nvPr/>
+        </p:nvSpPr>
+        <p:spPr>
+          <a:xfrm>
+            <a:off x="3319272" y="3794760"/>
+            <a:ext cx="1993392" cy="329184"/>
           </a:xfrm>
           <a:prstGeom prst="roundRect">
             <a:avLst>
-              <a:gd name="adj" fmla="val 22222"/>
+              <a:gd name="adj" fmla="val 50000"/>
             </a:avLst>
           </a:prstGeom>
           <a:solidFill>
             <a:srgbClr val="DCEBEA"/>
           </a:solidFill>
-          <a:ln w="9525">
-            <a:solidFill>
-              <a:srgbClr val="0E7C7B"/>
-            </a:solidFill>
-            <a:prstDash val="solid"/>
-          </a:ln>
-        </p:spPr>
-      </p:sp>
-      <p:sp>
-        <p:nvSpPr>
-          <p:cNvPr id="17" name="Text 13"/>
-          <p:cNvSpPr txBox="1"/>
-          <p:nvPr/>
-        </p:nvSpPr>
-        <p:spPr>
-          <a:xfrm>
-            <a:off x="2523744" y="4663440"/>
-            <a:ext cx="1280160" cy="274320"/>
-          </a:xfrm>
-          <a:prstGeom prst="rect">
-            <a:avLst/>
-          </a:prstGeom>
-          <a:noFill/>
-          <a:ln/>
-        </p:spPr>
-        <p:txBody>
-          <a:bodyPr wrap="square" rtlCol="0" anchor="ctr"/>
-          <a:lstStyle/>
-          <a:p>
-            <a:pPr algn="l" indent="0" marL="0">
-              <a:buNone/>
-            </a:pPr>
-            <a:r>
-              <a:rPr lang="en-US" sz="900" dirty="0">
-                <a:solidFill>
-                  <a:srgbClr val="6E7B80"/>
+          <a:ln/>
+        </p:spPr>
+      </p:sp>
+      <p:sp>
+        <p:nvSpPr>
+          <p:cNvPr id="20" name="Text 17"/>
+          <p:cNvSpPr txBox="1"/>
+          <p:nvPr/>
+        </p:nvSpPr>
+        <p:spPr>
+          <a:xfrm>
+            <a:off x="3319272" y="3794760"/>
+            <a:ext cx="1993392" cy="329184"/>
+          </a:xfrm>
+          <a:prstGeom prst="rect">
+            <a:avLst/>
+          </a:prstGeom>
+          <a:noFill/>
+          <a:ln/>
+        </p:spPr>
+        <p:txBody>
+          <a:bodyPr wrap="square" rtlCol="0" anchor="ctr"/>
+          <a:lstStyle/>
+          <a:p>
+            <a:pPr algn="ctr" indent="0" marL="0">
+              <a:buNone/>
+            </a:pPr>
+            <a:r>
+              <a:rPr lang="en-US" sz="850" b="1" spc="50" kern="0" dirty="0">
+                <a:solidFill>
+                  <a:srgbClr val="0A5C5B"/>
                 </a:solidFill>
                 <a:latin typeface="Trebuchet MS" pitchFamily="34" charset="0"/>
                 <a:ea typeface="Trebuchet MS" pitchFamily="34" charset="-122"/>
                 <a:cs typeface="Trebuchet MS" pitchFamily="34" charset="-120"/>
               </a:rPr>
-              <a:t>Avec laboratoire</a:t>
-            </a:r>
-            <a:endParaRPr lang="en-US" sz="900" dirty="0"/>
-          </a:p>
-        </p:txBody>
-      </p:sp>
-      <p:sp>
-        <p:nvSpPr>
-          <p:cNvPr id="18" name="Shape 14"/>
-          <p:cNvSpPr/>
-          <p:nvPr/>
-        </p:nvSpPr>
-        <p:spPr>
-          <a:xfrm>
-            <a:off x="713232" y="4901184"/>
-            <a:ext cx="4700016" cy="12802"/>
-          </a:xfrm>
-          <a:prstGeom prst="rect">
-            <a:avLst/>
-          </a:prstGeom>
-          <a:solidFill>
-            <a:srgbClr val="EDE8DA"/>
-          </a:solidFill>
-          <a:ln/>
-        </p:spPr>
-      </p:sp>
-      <p:sp>
-        <p:nvSpPr>
-          <p:cNvPr id="19" name="Text 15"/>
-          <p:cNvSpPr txBox="1"/>
-          <p:nvPr/>
-        </p:nvSpPr>
-        <p:spPr>
-          <a:xfrm>
-            <a:off x="713232" y="4992624"/>
-            <a:ext cx="4700016" cy="457200"/>
-          </a:xfrm>
-          <a:prstGeom prst="rect">
-            <a:avLst/>
-          </a:prstGeom>
-          <a:noFill/>
-          <a:ln/>
-        </p:spPr>
-        <p:txBody>
-          <a:bodyPr wrap="square" rtlCol="0" anchor="ctr"/>
+              <a:t>FORMULE MINIMALE « KITS »</a:t>
+            </a:r>
+            <a:endParaRPr lang="en-US" sz="850" dirty="0"/>
+          </a:p>
+        </p:txBody>
+      </p:sp>
+      <p:sp>
+        <p:nvSpPr>
+          <p:cNvPr id="21" name="Text 18"/>
+          <p:cNvSpPr txBox="1"/>
+          <p:nvPr/>
+        </p:nvSpPr>
+        <p:spPr>
+          <a:xfrm>
+            <a:off x="676656" y="4224528"/>
+            <a:ext cx="4636008" cy="512064"/>
+          </a:xfrm>
+          <a:prstGeom prst="rect">
+            <a:avLst/>
+          </a:prstGeom>
+          <a:noFill/>
+          <a:ln/>
+        </p:spPr>
+        <p:txBody>
+          <a:bodyPr wrap="square" rtlCol="0" anchor="t"/>
           <a:lstStyle/>
           <a:p>
             <a:pPr algn="l" indent="0" marL="0">
               <a:lnSpc>
-                <a:spcPct val="110000"/>
+                <a:spcPct val="112000"/>
               </a:lnSpc>
               <a:buNone/>
             </a:pPr>
             <a:r>
-              <a:rPr lang="en-US" sz="1150" dirty="0">
-                <a:solidFill>
-                  <a:srgbClr val="6E7B80"/>
+              <a:rPr lang="en-US" sz="1050" dirty="0">
+                <a:solidFill>
+                  <a:srgbClr val="22333B"/>
                 </a:solidFill>
                 <a:latin typeface="Trebuchet MS" pitchFamily="34" charset="0"/>
                 <a:ea typeface="Trebuchet MS" pitchFamily="34" charset="-122"/>
                 <a:cs typeface="Trebuchet MS" pitchFamily="34" charset="-120"/>
               </a:rPr>
-              <a:t>Au Togo : </a:t>
-            </a:r>
+              <a:t>Salle existante : mobilier local ≈ 1 M · kits physique-chimie et verrerie ≈ 1,2 M · SVT (microscopes, modèles) ≈ 0,8 M.</a:t>
+            </a:r>
+            <a:endParaRPr lang="en-US" sz="1050" dirty="0"/>
+          </a:p>
+        </p:txBody>
+      </p:sp>
+      <p:sp>
+        <p:nvSpPr>
+          <p:cNvPr id="22" name="Text 19"/>
+          <p:cNvSpPr txBox="1"/>
+          <p:nvPr/>
+        </p:nvSpPr>
+        <p:spPr>
+          <a:xfrm>
+            <a:off x="676656" y="4754880"/>
+            <a:ext cx="4636008" cy="201168"/>
+          </a:xfrm>
+          <a:prstGeom prst="rect">
+            <a:avLst/>
+          </a:prstGeom>
+          <a:noFill/>
+          <a:ln/>
+        </p:spPr>
+        <p:txBody>
+          <a:bodyPr wrap="square" rtlCol="0" anchor="ctr"/>
+          <a:lstStyle/>
+          <a:p>
             <a:pPr algn="l" indent="0" marL="0">
-              <a:lnSpc>
-                <a:spcPct val="110000"/>
-              </a:lnSpc>
-              <a:buNone/>
-            </a:pPr>
-            <a:r>
-              <a:rPr lang="en-US" sz="1150" b="1" dirty="0">
-                <a:solidFill>
-                  <a:srgbClr val="22333B"/>
+              <a:buNone/>
+            </a:pPr>
+            <a:r>
+              <a:rPr lang="en-US" sz="850" i="1" dirty="0">
+                <a:solidFill>
+                  <a:srgbClr val="6E7B80"/>
                 </a:solidFill>
                 <a:latin typeface="Trebuchet MS" pitchFamily="34" charset="0"/>
                 <a:ea typeface="Trebuchet MS" pitchFamily="34" charset="-122"/>
                 <a:cs typeface="Trebuchet MS" pitchFamily="34" charset="-120"/>
               </a:rPr>
-              <a:t>902 collèges et lycées publics</a:t>
-            </a:r>
+              <a:t>Formule reconstituée d'après les prix du marché togolais (kits MOBILELABO, mobilier local).</a:t>
+            </a:r>
+            <a:endParaRPr lang="en-US" sz="850" dirty="0"/>
+          </a:p>
+        </p:txBody>
+      </p:sp>
+      <p:sp>
+        <p:nvSpPr>
+          <p:cNvPr id="23" name="Text 20"/>
+          <p:cNvSpPr txBox="1"/>
+          <p:nvPr/>
+        </p:nvSpPr>
+        <p:spPr>
+          <a:xfrm>
+            <a:off x="676656" y="4974336"/>
+            <a:ext cx="4636008" cy="475488"/>
+          </a:xfrm>
+          <a:prstGeom prst="rect">
+            <a:avLst/>
+          </a:prstGeom>
+          <a:noFill/>
+          <a:ln/>
+        </p:spPr>
+        <p:txBody>
+          <a:bodyPr wrap="square" rtlCol="0" anchor="t"/>
+          <a:lstStyle/>
+          <a:p>
             <a:pPr algn="l" indent="0" marL="0">
               <a:lnSpc>
-                <a:spcPct val="110000"/>
+                <a:spcPct val="112000"/>
               </a:lnSpc>
               <a:buNone/>
             </a:pPr>
             <a:r>
-              <a:rPr lang="en-US" sz="1150" dirty="0">
-                <a:solidFill>
-                  <a:srgbClr val="6E7B80"/>
+              <a:rPr lang="en-US" sz="950" i="1" dirty="0">
+                <a:solidFill>
+                  <a:srgbClr val="22333B"/>
                 </a:solidFill>
                 <a:latin typeface="Trebuchet MS" pitchFamily="34" charset="0"/>
                 <a:ea typeface="Trebuchet MS" pitchFamily="34" charset="-122"/>
                 <a:cs typeface="Trebuchet MS" pitchFamily="34" charset="-120"/>
               </a:rPr>
-              <a:t>, dont 608 construits depuis 2011.</a:t>
-            </a:r>
-            <a:endParaRPr lang="en-US" sz="1150" dirty="0"/>
-          </a:p>
-        </p:txBody>
-      </p:sp>
-      <p:sp>
-        <p:nvSpPr>
-          <p:cNvPr id="20" name="Text 16"/>
-          <p:cNvSpPr txBox="1"/>
-          <p:nvPr/>
-        </p:nvSpPr>
-        <p:spPr>
-          <a:xfrm>
-            <a:off x="6163056" y="1901952"/>
-            <a:ext cx="5321808" cy="292608"/>
+              <a:t>Et l'équipement n'est pas la fin : consommables et remplacement peuvent ajouter jusqu'à 60 % du capital initial (UNESCO).</a:t>
+            </a:r>
+            <a:endParaRPr lang="en-US" sz="950" dirty="0"/>
+          </a:p>
+        </p:txBody>
+      </p:sp>
+      <p:sp>
+        <p:nvSpPr>
+          <p:cNvPr id="24" name="Text 21"/>
+          <p:cNvSpPr txBox="1"/>
+          <p:nvPr/>
+        </p:nvSpPr>
+        <p:spPr>
+          <a:xfrm>
+            <a:off x="5980176" y="1901952"/>
+            <a:ext cx="5532120" cy="274320"/>
           </a:xfrm>
           <a:prstGeom prst="rect">
             <a:avLst/>
@@ -9448,7 +9426,7 @@
                 <a:ea typeface="Trebuchet MS" pitchFamily="34" charset="-122"/>
                 <a:cs typeface="Trebuchet MS" pitchFamily="34" charset="-120"/>
               </a:rPr>
-              <a:t>Ce que coûterait le rattrapage physique, sans VirtuLab</a:t>
+              <a:t>La facture nationale, du minimum au standard</a:t>
             </a:r>
             <a:endParaRPr lang="en-US" sz="1300" dirty="0"/>
           </a:p>
@@ -9456,14 +9434,14 @@
       </p:sp>
       <p:sp>
         <p:nvSpPr>
-          <p:cNvPr id="21" name="Text 17"/>
-          <p:cNvSpPr txBox="1"/>
-          <p:nvPr/>
-        </p:nvSpPr>
-        <p:spPr>
-          <a:xfrm>
-            <a:off x="6163056" y="2231136"/>
-            <a:ext cx="5321808" cy="237744"/>
+          <p:cNvPr id="25" name="Text 22"/>
+          <p:cNvSpPr txBox="1"/>
+          <p:nvPr/>
+        </p:nvSpPr>
+        <p:spPr>
+          <a:xfrm>
+            <a:off x="5980176" y="2212848"/>
+            <a:ext cx="5532120" cy="237744"/>
           </a:xfrm>
           <a:prstGeom prst="rect">
             <a:avLst/>
@@ -9487,7 +9465,7 @@
                 <a:ea typeface="Trebuchet MS" pitchFamily="34" charset="-122"/>
                 <a:cs typeface="Trebuchet MS" pitchFamily="34" charset="-120"/>
               </a:rPr>
-              <a:t>902 établissements publics × ≈ 90 % sans laboratoire ≈ 810 à équiper</a:t>
+              <a:t>902 établissements publics × ≈ 90 % sans laboratoire ≈ 810 à équiper.</a:t>
             </a:r>
             <a:endParaRPr lang="en-US" sz="1000" dirty="0"/>
           </a:p>
@@ -9495,18 +9473,18 @@
       </p:sp>
       <p:sp>
         <p:nvSpPr>
-          <p:cNvPr id="22" name="Shape 18"/>
+          <p:cNvPr id="26" name="Shape 23"/>
           <p:cNvSpPr/>
           <p:nvPr/>
         </p:nvSpPr>
         <p:spPr>
           <a:xfrm>
-            <a:off x="6181344" y="2523744"/>
-            <a:ext cx="1481328" cy="914400"/>
+            <a:off x="5998464" y="2542032"/>
+            <a:ext cx="1207008" cy="822960"/>
           </a:xfrm>
           <a:prstGeom prst="roundRect">
             <a:avLst>
-              <a:gd name="adj" fmla="val 8000"/>
+              <a:gd name="adj" fmla="val 8889"/>
             </a:avLst>
           </a:prstGeom>
           <a:solidFill>
@@ -9517,14 +9495,14 @@
       </p:sp>
       <p:sp>
         <p:nvSpPr>
-          <p:cNvPr id="23" name="Text 19"/>
-          <p:cNvSpPr txBox="1"/>
-          <p:nvPr/>
-        </p:nvSpPr>
-        <p:spPr>
-          <a:xfrm>
-            <a:off x="6181344" y="2615184"/>
-            <a:ext cx="1481328" cy="457200"/>
+          <p:cNvPr id="27" name="Text 24"/>
+          <p:cNvSpPr txBox="1"/>
+          <p:nvPr/>
+        </p:nvSpPr>
+        <p:spPr>
+          <a:xfrm>
+            <a:off x="5998464" y="2615184"/>
+            <a:ext cx="1207008" cy="420624"/>
           </a:xfrm>
           <a:prstGeom prst="rect">
             <a:avLst/>
@@ -9556,14 +9534,14 @@
       </p:sp>
       <p:sp>
         <p:nvSpPr>
-          <p:cNvPr id="24" name="Text 20"/>
-          <p:cNvSpPr txBox="1"/>
-          <p:nvPr/>
-        </p:nvSpPr>
-        <p:spPr>
-          <a:xfrm>
-            <a:off x="6236208" y="3072384"/>
-            <a:ext cx="1371600" cy="329184"/>
+          <p:cNvPr id="28" name="Text 25"/>
+          <p:cNvSpPr txBox="1"/>
+          <p:nvPr/>
+        </p:nvSpPr>
+        <p:spPr>
+          <a:xfrm>
+            <a:off x="6035040" y="3035808"/>
+            <a:ext cx="1133856" cy="310896"/>
           </a:xfrm>
           <a:prstGeom prst="rect">
             <a:avLst/>
@@ -9582,7 +9560,7 @@
               <a:buNone/>
             </a:pPr>
             <a:r>
-              <a:rPr lang="en-US" sz="850" dirty="0">
+              <a:rPr lang="en-US" sz="800" dirty="0">
                 <a:solidFill>
                   <a:srgbClr val="22333B"/>
                 </a:solidFill>
@@ -9592,20 +9570,20 @@
               </a:rPr>
               <a:t>établissements à équiper</a:t>
             </a:r>
-            <a:endParaRPr lang="en-US" sz="850" dirty="0"/>
-          </a:p>
-        </p:txBody>
-      </p:sp>
-      <p:sp>
-        <p:nvSpPr>
-          <p:cNvPr id="25" name="Text 21"/>
-          <p:cNvSpPr txBox="1"/>
-          <p:nvPr/>
-        </p:nvSpPr>
-        <p:spPr>
-          <a:xfrm>
-            <a:off x="7662672" y="2523744"/>
-            <a:ext cx="237744" cy="914400"/>
+            <a:endParaRPr lang="en-US" sz="800" dirty="0"/>
+          </a:p>
+        </p:txBody>
+      </p:sp>
+      <p:sp>
+        <p:nvSpPr>
+          <p:cNvPr id="29" name="Text 26"/>
+          <p:cNvSpPr txBox="1"/>
+          <p:nvPr/>
+        </p:nvSpPr>
+        <p:spPr>
+          <a:xfrm>
+            <a:off x="7205472" y="2542032"/>
+            <a:ext cx="201168" cy="822960"/>
           </a:xfrm>
           <a:prstGeom prst="rect">
             <a:avLst/>
@@ -9637,18 +9615,18 @@
       </p:sp>
       <p:sp>
         <p:nvSpPr>
-          <p:cNvPr id="26" name="Shape 22"/>
+          <p:cNvPr id="30" name="Shape 27"/>
           <p:cNvSpPr/>
           <p:nvPr/>
         </p:nvSpPr>
         <p:spPr>
           <a:xfrm>
-            <a:off x="7900416" y="2523744"/>
-            <a:ext cx="1517904" cy="914400"/>
+            <a:off x="7406640" y="2542032"/>
+            <a:ext cx="1207008" cy="822960"/>
           </a:xfrm>
           <a:prstGeom prst="roundRect">
             <a:avLst>
-              <a:gd name="adj" fmla="val 8000"/>
+              <a:gd name="adj" fmla="val 8889"/>
             </a:avLst>
           </a:prstGeom>
           <a:solidFill>
@@ -9659,14 +9637,14 @@
       </p:sp>
       <p:sp>
         <p:nvSpPr>
-          <p:cNvPr id="27" name="Text 23"/>
-          <p:cNvSpPr txBox="1"/>
-          <p:nvPr/>
-        </p:nvSpPr>
-        <p:spPr>
-          <a:xfrm>
-            <a:off x="7900416" y="2615184"/>
-            <a:ext cx="1517904" cy="457200"/>
+          <p:cNvPr id="31" name="Text 28"/>
+          <p:cNvSpPr txBox="1"/>
+          <p:nvPr/>
+        </p:nvSpPr>
+        <p:spPr>
+          <a:xfrm>
+            <a:off x="7406640" y="2615184"/>
+            <a:ext cx="1207008" cy="420624"/>
           </a:xfrm>
           <a:prstGeom prst="rect">
             <a:avLst/>
@@ -9690,7 +9668,7 @@
                 <a:ea typeface="Georgia" pitchFamily="34" charset="-122"/>
                 <a:cs typeface="Georgia" pitchFamily="34" charset="-120"/>
               </a:rPr>
-              <a:t>10 M FCFA</a:t>
+              <a:t>≈ 3 M</a:t>
             </a:r>
             <a:endParaRPr lang="en-US" sz="1700" dirty="0"/>
           </a:p>
@@ -9698,14 +9676,14 @@
       </p:sp>
       <p:sp>
         <p:nvSpPr>
-          <p:cNvPr id="28" name="Text 24"/>
-          <p:cNvSpPr txBox="1"/>
-          <p:nvPr/>
-        </p:nvSpPr>
-        <p:spPr>
-          <a:xfrm>
-            <a:off x="7946136" y="3072384"/>
-            <a:ext cx="1426464" cy="329184"/>
+          <p:cNvPr id="32" name="Text 29"/>
+          <p:cNvSpPr txBox="1"/>
+          <p:nvPr/>
+        </p:nvSpPr>
+        <p:spPr>
+          <a:xfrm>
+            <a:off x="7434072" y="3035808"/>
+            <a:ext cx="1152144" cy="310896"/>
           </a:xfrm>
           <a:prstGeom prst="rect">
             <a:avLst/>
@@ -9724,7 +9702,7 @@
               <a:buNone/>
             </a:pPr>
             <a:r>
-              <a:rPr lang="en-US" sz="850" dirty="0">
+              <a:rPr lang="en-US" sz="800" dirty="0">
                 <a:solidFill>
                   <a:srgbClr val="22333B"/>
                 </a:solidFill>
@@ -9732,22 +9710,22 @@
                 <a:ea typeface="Trebuchet MS" pitchFamily="34" charset="-122"/>
                 <a:cs typeface="Trebuchet MS" pitchFamily="34" charset="-120"/>
               </a:rPr>
-              <a:t>d'équipement min. par labo</a:t>
-            </a:r>
-            <a:endParaRPr lang="en-US" sz="850" dirty="0"/>
-          </a:p>
-        </p:txBody>
-      </p:sp>
-      <p:sp>
-        <p:nvSpPr>
-          <p:cNvPr id="29" name="Text 25"/>
-          <p:cNvSpPr txBox="1"/>
-          <p:nvPr/>
-        </p:nvSpPr>
-        <p:spPr>
-          <a:xfrm>
-            <a:off x="9418320" y="2523744"/>
-            <a:ext cx="237744" cy="914400"/>
+              <a:t>FCFA par labo (minimum)</a:t>
+            </a:r>
+            <a:endParaRPr lang="en-US" sz="800" dirty="0"/>
+          </a:p>
+        </p:txBody>
+      </p:sp>
+      <p:sp>
+        <p:nvSpPr>
+          <p:cNvPr id="33" name="Text 30"/>
+          <p:cNvSpPr txBox="1"/>
+          <p:nvPr/>
+        </p:nvSpPr>
+        <p:spPr>
+          <a:xfrm>
+            <a:off x="8613648" y="2542032"/>
+            <a:ext cx="201168" cy="822960"/>
           </a:xfrm>
           <a:prstGeom prst="rect">
             <a:avLst/>
@@ -9779,18 +9757,18 @@
       </p:sp>
       <p:sp>
         <p:nvSpPr>
-          <p:cNvPr id="30" name="Shape 26"/>
+          <p:cNvPr id="34" name="Shape 31"/>
           <p:cNvSpPr/>
           <p:nvPr/>
         </p:nvSpPr>
         <p:spPr>
           <a:xfrm>
-            <a:off x="9656064" y="2523744"/>
-            <a:ext cx="1810512" cy="914400"/>
+            <a:off x="8814816" y="2542032"/>
+            <a:ext cx="2679192" cy="822960"/>
           </a:xfrm>
           <a:prstGeom prst="roundRect">
             <a:avLst>
-              <a:gd name="adj" fmla="val 8000"/>
+              <a:gd name="adj" fmla="val 8889"/>
             </a:avLst>
           </a:prstGeom>
           <a:solidFill>
@@ -9801,14 +9779,14 @@
       </p:sp>
       <p:sp>
         <p:nvSpPr>
-          <p:cNvPr id="31" name="Text 27"/>
-          <p:cNvSpPr txBox="1"/>
-          <p:nvPr/>
-        </p:nvSpPr>
-        <p:spPr>
-          <a:xfrm>
-            <a:off x="9656064" y="2615184"/>
-            <a:ext cx="1810512" cy="457200"/>
+          <p:cNvPr id="35" name="Text 32"/>
+          <p:cNvSpPr txBox="1"/>
+          <p:nvPr/>
+        </p:nvSpPr>
+        <p:spPr>
+          <a:xfrm>
+            <a:off x="8814816" y="2615184"/>
+            <a:ext cx="2679192" cy="420624"/>
           </a:xfrm>
           <a:prstGeom prst="rect">
             <a:avLst/>
@@ -9824,7 +9802,7 @@
               <a:buNone/>
             </a:pPr>
             <a:r>
-              <a:rPr lang="en-US" sz="1700" b="1" dirty="0">
+              <a:rPr lang="en-US" sz="1900" b="1" dirty="0">
                 <a:solidFill>
                   <a:srgbClr val="FFFFFF"/>
                 </a:solidFill>
@@ -9832,22 +9810,22 @@
                 <a:ea typeface="Georgia" pitchFamily="34" charset="-122"/>
                 <a:cs typeface="Georgia" pitchFamily="34" charset="-120"/>
               </a:rPr>
-              <a:t>≈ 8 milliards</a:t>
-            </a:r>
-            <a:endParaRPr lang="en-US" sz="1700" dirty="0"/>
-          </a:p>
-        </p:txBody>
-      </p:sp>
-      <p:sp>
-        <p:nvSpPr>
-          <p:cNvPr id="32" name="Text 28"/>
-          <p:cNvSpPr txBox="1"/>
-          <p:nvPr/>
-        </p:nvSpPr>
-        <p:spPr>
-          <a:xfrm>
-            <a:off x="9656064" y="3072384"/>
-            <a:ext cx="1810512" cy="329184"/>
+              <a:t>≈ 2,4 milliards</a:t>
+            </a:r>
+            <a:endParaRPr lang="en-US" sz="1900" dirty="0"/>
+          </a:p>
+        </p:txBody>
+      </p:sp>
+      <p:sp>
+        <p:nvSpPr>
+          <p:cNvPr id="36" name="Text 33"/>
+          <p:cNvSpPr txBox="1"/>
+          <p:nvPr/>
+        </p:nvSpPr>
+        <p:spPr>
+          <a:xfrm>
+            <a:off x="8814816" y="3035808"/>
+            <a:ext cx="2679192" cy="310896"/>
           </a:xfrm>
           <a:prstGeom prst="rect">
             <a:avLst/>
@@ -9874,7 +9852,7 @@
                 <a:ea typeface="Trebuchet MS" pitchFamily="34" charset="-122"/>
                 <a:cs typeface="Trebuchet MS" pitchFamily="34" charset="-120"/>
               </a:rPr>
-              <a:t>FCFA · équipement seul</a:t>
+              <a:t>FCFA · minimum national</a:t>
             </a:r>
             <a:endParaRPr lang="en-US" sz="850" dirty="0"/>
           </a:p>
@@ -9882,50 +9860,44 @@
       </p:sp>
       <p:sp>
         <p:nvSpPr>
-          <p:cNvPr id="33" name="Text 29"/>
-          <p:cNvSpPr txBox="1"/>
-          <p:nvPr/>
-        </p:nvSpPr>
-        <p:spPr>
-          <a:xfrm>
-            <a:off x="6181344" y="3584448"/>
-            <a:ext cx="5285232" cy="512064"/>
-          </a:xfrm>
-          <a:prstGeom prst="rect">
-            <a:avLst/>
-          </a:prstGeom>
-          <a:noFill/>
-          <a:ln/>
-        </p:spPr>
-        <p:txBody>
-          <a:bodyPr wrap="square" rtlCol="0" anchor="t"/>
+          <p:cNvPr id="37" name="Text 34"/>
+          <p:cNvSpPr txBox="1"/>
+          <p:nvPr/>
+        </p:nvSpPr>
+        <p:spPr>
+          <a:xfrm>
+            <a:off x="5998464" y="3456432"/>
+            <a:ext cx="5495544" cy="237744"/>
+          </a:xfrm>
+          <a:prstGeom prst="rect">
+            <a:avLst/>
+          </a:prstGeom>
+          <a:noFill/>
+          <a:ln/>
+        </p:spPr>
+        <p:txBody>
+          <a:bodyPr wrap="square" rtlCol="0" anchor="ctr"/>
           <a:lstStyle/>
           <a:p>
             <a:pPr algn="l" indent="0" marL="0">
-              <a:lnSpc>
-                <a:spcPct val="110000"/>
-              </a:lnSpc>
-              <a:buNone/>
-            </a:pPr>
-            <a:r>
-              <a:rPr lang="en-US" sz="1050" b="1" dirty="0">
-                <a:solidFill>
-                  <a:srgbClr val="22333B"/>
+              <a:buNone/>
+            </a:pPr>
+            <a:r>
+              <a:rPr lang="en-US" sz="1050" dirty="0">
+                <a:solidFill>
+                  <a:srgbClr val="6E7B80"/>
                 </a:solidFill>
                 <a:latin typeface="Trebuchet MS" pitchFamily="34" charset="0"/>
                 <a:ea typeface="Trebuchet MS" pitchFamily="34" charset="-122"/>
                 <a:cs typeface="Trebuchet MS" pitchFamily="34" charset="-120"/>
               </a:rPr>
-              <a:t>Référence régionale : </a:t>
+              <a:t>Au standard complet (12 M par labo) : </a:t>
             </a:r>
             <a:pPr algn="l" indent="0" marL="0">
-              <a:lnSpc>
-                <a:spcPct val="110000"/>
-              </a:lnSpc>
-              <a:buNone/>
-            </a:pPr>
-            <a:r>
-              <a:rPr lang="en-US" sz="1050" dirty="0">
+              <a:buNone/>
+            </a:pPr>
+            <a:r>
+              <a:rPr lang="en-US" sz="1050" b="1" dirty="0">
                 <a:solidFill>
                   <a:srgbClr val="22333B"/>
                 </a:solidFill>
@@ -9933,7 +9905,7 @@
                 <a:ea typeface="Trebuchet MS" pitchFamily="34" charset="-122"/>
                 <a:cs typeface="Trebuchet MS" pitchFamily="34" charset="-120"/>
               </a:rPr>
-              <a:t>un bloc scientifique complet (salles + équipement) ≈ 250 M FCFA (Sénégal, 2014), soit ≈ 200 Md pour le pays.</a:t>
+              <a:t>810 × 12 M ≈ 9,7 milliards.</a:t>
             </a:r>
             <a:endParaRPr lang="en-US" sz="1050" dirty="0"/>
           </a:p>
@@ -9941,14 +9913,14 @@
       </p:sp>
       <p:sp>
         <p:nvSpPr>
-          <p:cNvPr id="34" name="Text 30"/>
-          <p:cNvSpPr txBox="1"/>
-          <p:nvPr/>
-        </p:nvSpPr>
-        <p:spPr>
-          <a:xfrm>
-            <a:off x="6181344" y="4169664"/>
-            <a:ext cx="5285232" cy="274320"/>
+          <p:cNvPr id="38" name="Text 35"/>
+          <p:cNvSpPr txBox="1"/>
+          <p:nvPr/>
+        </p:nvSpPr>
+        <p:spPr>
+          <a:xfrm>
+            <a:off x="5998464" y="3712464"/>
+            <a:ext cx="5495544" cy="237744"/>
           </a:xfrm>
           <a:prstGeom prst="rect">
             <a:avLst/>
@@ -9972,7 +9944,7 @@
                 <a:ea typeface="Trebuchet MS" pitchFamily="34" charset="-122"/>
                 <a:cs typeface="Trebuchet MS" pitchFamily="34" charset="-120"/>
               </a:rPr>
-              <a:t>Et un laboratoire ne s'allume pas tout seul :</a:t>
+              <a:t>En face : le déploiement VirtuLab sur trois ans</a:t>
             </a:r>
             <a:endParaRPr lang="en-US" sz="1100" dirty="0"/>
           </a:p>
@@ -9980,14 +9952,14 @@
       </p:sp>
       <p:sp>
         <p:nvSpPr>
-          <p:cNvPr id="35" name="Text 31"/>
-          <p:cNvSpPr txBox="1"/>
-          <p:nvPr/>
-        </p:nvSpPr>
-        <p:spPr>
-          <a:xfrm>
-            <a:off x="6181344" y="4480560"/>
-            <a:ext cx="4334256" cy="256032"/>
+          <p:cNvPr id="39" name="Text 36"/>
+          <p:cNvSpPr txBox="1"/>
+          <p:nvPr/>
+        </p:nvSpPr>
+        <p:spPr>
+          <a:xfrm>
+            <a:off x="5998464" y="3986784"/>
+            <a:ext cx="2011680" cy="256032"/>
           </a:xfrm>
           <a:prstGeom prst="rect">
             <a:avLst/>
@@ -10003,7 +9975,7 @@
               <a:buNone/>
             </a:pPr>
             <a:r>
-              <a:rPr lang="en-US" sz="1100" dirty="0">
+              <a:rPr lang="en-US" sz="950" dirty="0">
                 <a:solidFill>
                   <a:srgbClr val="22333B"/>
                 </a:solidFill>
@@ -10011,61 +9983,22 @@
                 <a:ea typeface="Trebuchet MS" pitchFamily="34" charset="-122"/>
                 <a:cs typeface="Trebuchet MS" pitchFamily="34" charset="-120"/>
               </a:rPr>
-              <a:t>Électrification nationale</a:t>
-            </a:r>
-            <a:endParaRPr lang="en-US" sz="1100" dirty="0"/>
-          </a:p>
-        </p:txBody>
-      </p:sp>
-      <p:sp>
-        <p:nvSpPr>
-          <p:cNvPr id="36" name="Text 32"/>
-          <p:cNvSpPr txBox="1"/>
-          <p:nvPr/>
-        </p:nvSpPr>
-        <p:spPr>
-          <a:xfrm>
-            <a:off x="10515600" y="4480560"/>
-            <a:ext cx="914400" cy="256032"/>
-          </a:xfrm>
-          <a:prstGeom prst="rect">
-            <a:avLst/>
-          </a:prstGeom>
-          <a:noFill/>
-          <a:ln/>
-        </p:spPr>
-        <p:txBody>
-          <a:bodyPr wrap="square" rtlCol="0" anchor="ctr"/>
-          <a:lstStyle/>
-          <a:p>
-            <a:pPr algn="r" indent="0" marL="0">
-              <a:buNone/>
-            </a:pPr>
-            <a:r>
-              <a:rPr lang="en-US" sz="1150" b="1" dirty="0">
-                <a:solidFill>
-                  <a:srgbClr val="0E7C7B"/>
-                </a:solidFill>
-                <a:latin typeface="Trebuchet MS" pitchFamily="34" charset="0"/>
-                <a:ea typeface="Trebuchet MS" pitchFamily="34" charset="-122"/>
-                <a:cs typeface="Trebuchet MS" pitchFamily="34" charset="-120"/>
-              </a:rPr>
-              <a:t>61,1 %</a:t>
-            </a:r>
-            <a:endParaRPr lang="en-US" sz="1150" dirty="0"/>
-          </a:p>
-        </p:txBody>
-      </p:sp>
-      <p:sp>
-        <p:nvSpPr>
-          <p:cNvPr id="37" name="Shape 33"/>
+              <a:t>Standard complet</a:t>
+            </a:r>
+            <a:endParaRPr lang="en-US" sz="950" dirty="0"/>
+          </a:p>
+        </p:txBody>
+      </p:sp>
+      <p:sp>
+        <p:nvSpPr>
+          <p:cNvPr id="40" name="Shape 37"/>
           <p:cNvSpPr/>
           <p:nvPr/>
         </p:nvSpPr>
         <p:spPr>
           <a:xfrm>
-            <a:off x="6181344" y="4773168"/>
-            <a:ext cx="5248656" cy="128016"/>
+            <a:off x="8046720" y="4027932"/>
+            <a:ext cx="2203704" cy="173736"/>
           </a:xfrm>
           <a:prstGeom prst="roundRect">
             <a:avLst>
@@ -10080,14 +10013,14 @@
       </p:sp>
       <p:sp>
         <p:nvSpPr>
-          <p:cNvPr id="38" name="Shape 34"/>
+          <p:cNvPr id="41" name="Shape 38"/>
           <p:cNvSpPr/>
           <p:nvPr/>
         </p:nvSpPr>
         <p:spPr>
           <a:xfrm>
-            <a:off x="6181344" y="4773168"/>
-            <a:ext cx="3206929" cy="128016"/>
+            <a:off x="8046720" y="4027932"/>
+            <a:ext cx="2203704" cy="173736"/>
           </a:xfrm>
           <a:prstGeom prst="roundRect">
             <a:avLst>
@@ -10095,21 +10028,21 @@
             </a:avLst>
           </a:prstGeom>
           <a:solidFill>
-            <a:srgbClr val="0E7C7B"/>
+            <a:srgbClr val="8A959B"/>
           </a:solidFill>
           <a:ln/>
         </p:spPr>
       </p:sp>
       <p:sp>
         <p:nvSpPr>
-          <p:cNvPr id="39" name="Text 35"/>
-          <p:cNvSpPr txBox="1"/>
-          <p:nvPr/>
-        </p:nvSpPr>
-        <p:spPr>
-          <a:xfrm>
-            <a:off x="6181344" y="5029200"/>
-            <a:ext cx="4334256" cy="256032"/>
+          <p:cNvPr id="42" name="Text 39"/>
+          <p:cNvSpPr txBox="1"/>
+          <p:nvPr/>
+        </p:nvSpPr>
+        <p:spPr>
+          <a:xfrm>
+            <a:off x="10323576" y="3986784"/>
+            <a:ext cx="822960" cy="256032"/>
           </a:xfrm>
           <a:prstGeom prst="rect">
             <a:avLst/>
@@ -10125,7 +10058,46 @@
               <a:buNone/>
             </a:pPr>
             <a:r>
-              <a:rPr lang="en-US" sz="1100" dirty="0">
+              <a:rPr lang="en-US" sz="1150" b="1" dirty="0">
+                <a:solidFill>
+                  <a:srgbClr val="22333B"/>
+                </a:solidFill>
+                <a:latin typeface="Georgia" pitchFamily="34" charset="0"/>
+                <a:ea typeface="Georgia" pitchFamily="34" charset="-122"/>
+                <a:cs typeface="Georgia" pitchFamily="34" charset="-120"/>
+              </a:rPr>
+              <a:t>9,7 Md</a:t>
+            </a:r>
+            <a:endParaRPr lang="en-US" sz="1150" dirty="0"/>
+          </a:p>
+        </p:txBody>
+      </p:sp>
+      <p:sp>
+        <p:nvSpPr>
+          <p:cNvPr id="43" name="Text 40"/>
+          <p:cNvSpPr txBox="1"/>
+          <p:nvPr/>
+        </p:nvSpPr>
+        <p:spPr>
+          <a:xfrm>
+            <a:off x="5998464" y="4370832"/>
+            <a:ext cx="2011680" cy="256032"/>
+          </a:xfrm>
+          <a:prstGeom prst="rect">
+            <a:avLst/>
+          </a:prstGeom>
+          <a:noFill/>
+          <a:ln/>
+        </p:spPr>
+        <p:txBody>
+          <a:bodyPr wrap="square" rtlCol="0" anchor="ctr"/>
+          <a:lstStyle/>
+          <a:p>
+            <a:pPr algn="l" indent="0" marL="0">
+              <a:buNone/>
+            </a:pPr>
+            <a:r>
+              <a:rPr lang="en-US" sz="950" dirty="0">
                 <a:solidFill>
                   <a:srgbClr val="22333B"/>
                 </a:solidFill>
@@ -10133,61 +10105,22 @@
                 <a:ea typeface="Trebuchet MS" pitchFamily="34" charset="-122"/>
                 <a:cs typeface="Trebuchet MS" pitchFamily="34" charset="-120"/>
               </a:rPr>
-              <a:t>Électrification en zones rurales</a:t>
-            </a:r>
-            <a:endParaRPr lang="en-US" sz="1100" dirty="0"/>
-          </a:p>
-        </p:txBody>
-      </p:sp>
-      <p:sp>
-        <p:nvSpPr>
-          <p:cNvPr id="40" name="Text 36"/>
-          <p:cNvSpPr txBox="1"/>
-          <p:nvPr/>
-        </p:nvSpPr>
-        <p:spPr>
-          <a:xfrm>
-            <a:off x="10515600" y="5029200"/>
-            <a:ext cx="914400" cy="256032"/>
-          </a:xfrm>
-          <a:prstGeom prst="rect">
-            <a:avLst/>
-          </a:prstGeom>
-          <a:noFill/>
-          <a:ln/>
-        </p:spPr>
-        <p:txBody>
-          <a:bodyPr wrap="square" rtlCol="0" anchor="ctr"/>
-          <a:lstStyle/>
-          <a:p>
-            <a:pPr algn="r" indent="0" marL="0">
-              <a:buNone/>
-            </a:pPr>
-            <a:r>
-              <a:rPr lang="en-US" sz="1150" b="1" dirty="0">
-                <a:solidFill>
-                  <a:srgbClr val="E0592A"/>
-                </a:solidFill>
-                <a:latin typeface="Trebuchet MS" pitchFamily="34" charset="0"/>
-                <a:ea typeface="Trebuchet MS" pitchFamily="34" charset="-122"/>
-                <a:cs typeface="Trebuchet MS" pitchFamily="34" charset="-120"/>
-              </a:rPr>
-              <a:t>33,9 %</a:t>
-            </a:r>
-            <a:endParaRPr lang="en-US" sz="1150" dirty="0"/>
-          </a:p>
-        </p:txBody>
-      </p:sp>
-      <p:sp>
-        <p:nvSpPr>
-          <p:cNvPr id="41" name="Shape 37"/>
+              <a:t>Minimum « kits »</a:t>
+            </a:r>
+            <a:endParaRPr lang="en-US" sz="950" dirty="0"/>
+          </a:p>
+        </p:txBody>
+      </p:sp>
+      <p:sp>
+        <p:nvSpPr>
+          <p:cNvPr id="44" name="Shape 41"/>
           <p:cNvSpPr/>
           <p:nvPr/>
         </p:nvSpPr>
         <p:spPr>
           <a:xfrm>
-            <a:off x="6181344" y="5321808"/>
-            <a:ext cx="5248656" cy="128016"/>
+            <a:off x="8046720" y="4411980"/>
+            <a:ext cx="2203704" cy="173736"/>
           </a:xfrm>
           <a:prstGeom prst="roundRect">
             <a:avLst>
@@ -10202,14 +10135,14 @@
       </p:sp>
       <p:sp>
         <p:nvSpPr>
-          <p:cNvPr id="42" name="Shape 38"/>
+          <p:cNvPr id="45" name="Shape 42"/>
           <p:cNvSpPr/>
           <p:nvPr/>
         </p:nvSpPr>
         <p:spPr>
           <a:xfrm>
-            <a:off x="6181344" y="5321808"/>
-            <a:ext cx="1779294" cy="128016"/>
+            <a:off x="8046720" y="4411980"/>
+            <a:ext cx="550926" cy="173736"/>
           </a:xfrm>
           <a:prstGeom prst="roundRect">
             <a:avLst>
@@ -10224,7 +10157,229 @@
       </p:sp>
       <p:sp>
         <p:nvSpPr>
-          <p:cNvPr id="43" name="Shape 39"/>
+          <p:cNvPr id="46" name="Text 43"/>
+          <p:cNvSpPr txBox="1"/>
+          <p:nvPr/>
+        </p:nvSpPr>
+        <p:spPr>
+          <a:xfrm>
+            <a:off x="10323576" y="4370832"/>
+            <a:ext cx="822960" cy="256032"/>
+          </a:xfrm>
+          <a:prstGeom prst="rect">
+            <a:avLst/>
+          </a:prstGeom>
+          <a:noFill/>
+          <a:ln/>
+        </p:spPr>
+        <p:txBody>
+          <a:bodyPr wrap="square" rtlCol="0" anchor="ctr"/>
+          <a:lstStyle/>
+          <a:p>
+            <a:pPr algn="l" indent="0" marL="0">
+              <a:buNone/>
+            </a:pPr>
+            <a:r>
+              <a:rPr lang="en-US" sz="1150" b="1" dirty="0">
+                <a:solidFill>
+                  <a:srgbClr val="E0592A"/>
+                </a:solidFill>
+                <a:latin typeface="Georgia" pitchFamily="34" charset="0"/>
+                <a:ea typeface="Georgia" pitchFamily="34" charset="-122"/>
+                <a:cs typeface="Georgia" pitchFamily="34" charset="-120"/>
+              </a:rPr>
+              <a:t>2,4 Md</a:t>
+            </a:r>
+            <a:endParaRPr lang="en-US" sz="1150" dirty="0"/>
+          </a:p>
+        </p:txBody>
+      </p:sp>
+      <p:sp>
+        <p:nvSpPr>
+          <p:cNvPr id="47" name="Text 44"/>
+          <p:cNvSpPr txBox="1"/>
+          <p:nvPr/>
+        </p:nvSpPr>
+        <p:spPr>
+          <a:xfrm>
+            <a:off x="5998464" y="4754880"/>
+            <a:ext cx="2011680" cy="256032"/>
+          </a:xfrm>
+          <a:prstGeom prst="rect">
+            <a:avLst/>
+          </a:prstGeom>
+          <a:noFill/>
+          <a:ln/>
+        </p:spPr>
+        <p:txBody>
+          <a:bodyPr wrap="square" rtlCol="0" anchor="ctr"/>
+          <a:lstStyle/>
+          <a:p>
+            <a:pPr algn="l" indent="0" marL="0">
+              <a:buNone/>
+            </a:pPr>
+            <a:r>
+              <a:rPr lang="en-US" sz="950" dirty="0">
+                <a:solidFill>
+                  <a:srgbClr val="22333B"/>
+                </a:solidFill>
+                <a:latin typeface="Trebuchet MS" pitchFamily="34" charset="0"/>
+                <a:ea typeface="Trebuchet MS" pitchFamily="34" charset="-122"/>
+                <a:cs typeface="Trebuchet MS" pitchFamily="34" charset="-120"/>
+              </a:rPr>
+              <a:t>VirtuLab · 3 ans</a:t>
+            </a:r>
+            <a:endParaRPr lang="en-US" sz="950" dirty="0"/>
+          </a:p>
+        </p:txBody>
+      </p:sp>
+      <p:sp>
+        <p:nvSpPr>
+          <p:cNvPr id="48" name="Shape 45"/>
+          <p:cNvSpPr/>
+          <p:nvPr/>
+        </p:nvSpPr>
+        <p:spPr>
+          <a:xfrm>
+            <a:off x="8046720" y="4796028"/>
+            <a:ext cx="2203704" cy="173736"/>
+          </a:xfrm>
+          <a:prstGeom prst="roundRect">
+            <a:avLst>
+              <a:gd name="adj" fmla="val 50000"/>
+            </a:avLst>
+          </a:prstGeom>
+          <a:solidFill>
+            <a:srgbClr val="EDE8DA"/>
+          </a:solidFill>
+          <a:ln/>
+        </p:spPr>
+      </p:sp>
+      <p:sp>
+        <p:nvSpPr>
+          <p:cNvPr id="49" name="Shape 46"/>
+          <p:cNvSpPr/>
+          <p:nvPr/>
+        </p:nvSpPr>
+        <p:spPr>
+          <a:xfrm>
+            <a:off x="8046720" y="4796028"/>
+            <a:ext cx="109728" cy="173736"/>
+          </a:xfrm>
+          <a:prstGeom prst="roundRect">
+            <a:avLst>
+              <a:gd name="adj" fmla="val 79167"/>
+            </a:avLst>
+          </a:prstGeom>
+          <a:solidFill>
+            <a:srgbClr val="0E7C7B"/>
+          </a:solidFill>
+          <a:ln/>
+        </p:spPr>
+      </p:sp>
+      <p:sp>
+        <p:nvSpPr>
+          <p:cNvPr id="50" name="Text 47"/>
+          <p:cNvSpPr txBox="1"/>
+          <p:nvPr/>
+        </p:nvSpPr>
+        <p:spPr>
+          <a:xfrm>
+            <a:off x="10323576" y="4754880"/>
+            <a:ext cx="822960" cy="256032"/>
+          </a:xfrm>
+          <a:prstGeom prst="rect">
+            <a:avLst/>
+          </a:prstGeom>
+          <a:noFill/>
+          <a:ln/>
+        </p:spPr>
+        <p:txBody>
+          <a:bodyPr wrap="square" rtlCol="0" anchor="ctr"/>
+          <a:lstStyle/>
+          <a:p>
+            <a:pPr algn="l" indent="0" marL="0">
+              <a:buNone/>
+            </a:pPr>
+            <a:r>
+              <a:rPr lang="en-US" sz="1150" b="1" dirty="0">
+                <a:solidFill>
+                  <a:srgbClr val="0E7C7B"/>
+                </a:solidFill>
+                <a:latin typeface="Georgia" pitchFamily="34" charset="0"/>
+                <a:ea typeface="Georgia" pitchFamily="34" charset="-122"/>
+                <a:cs typeface="Georgia" pitchFamily="34" charset="-120"/>
+              </a:rPr>
+              <a:t>297 M</a:t>
+            </a:r>
+            <a:endParaRPr lang="en-US" sz="1150" dirty="0"/>
+          </a:p>
+        </p:txBody>
+      </p:sp>
+      <p:sp>
+        <p:nvSpPr>
+          <p:cNvPr id="51" name="Shape 48"/>
+          <p:cNvSpPr/>
+          <p:nvPr/>
+        </p:nvSpPr>
+        <p:spPr>
+          <a:xfrm>
+            <a:off x="5998464" y="5157216"/>
+            <a:ext cx="5495544" cy="384048"/>
+          </a:xfrm>
+          <a:prstGeom prst="roundRect">
+            <a:avLst>
+              <a:gd name="adj" fmla="val 21429"/>
+            </a:avLst>
+          </a:prstGeom>
+          <a:solidFill>
+            <a:srgbClr val="DCEBEA"/>
+          </a:solidFill>
+          <a:ln/>
+        </p:spPr>
+      </p:sp>
+      <p:sp>
+        <p:nvSpPr>
+          <p:cNvPr id="52" name="Text 49"/>
+          <p:cNvSpPr txBox="1"/>
+          <p:nvPr/>
+        </p:nvSpPr>
+        <p:spPr>
+          <a:xfrm>
+            <a:off x="6163056" y="5157216"/>
+            <a:ext cx="5166360" cy="384048"/>
+          </a:xfrm>
+          <a:prstGeom prst="rect">
+            <a:avLst/>
+          </a:prstGeom>
+          <a:noFill/>
+          <a:ln/>
+        </p:spPr>
+        <p:txBody>
+          <a:bodyPr wrap="square" rtlCol="0" anchor="ctr"/>
+          <a:lstStyle/>
+          <a:p>
+            <a:pPr algn="l" indent="0" marL="0">
+              <a:buNone/>
+            </a:pPr>
+            <a:r>
+              <a:rPr lang="en-US" sz="1150" b="1" dirty="0">
+                <a:solidFill>
+                  <a:srgbClr val="0A5C5B"/>
+                </a:solidFill>
+                <a:latin typeface="Trebuchet MS" pitchFamily="34" charset="0"/>
+                <a:ea typeface="Trebuchet MS" pitchFamily="34" charset="-122"/>
+                <a:cs typeface="Trebuchet MS" pitchFamily="34" charset="-120"/>
+              </a:rPr>
+              <a:t>Équiper physiquement coûte de 8 à 33 fois le budget VirtuLab.</a:t>
+            </a:r>
+            <a:endParaRPr lang="en-US" sz="1150" dirty="0"/>
+          </a:p>
+        </p:txBody>
+      </p:sp>
+      <p:sp>
+        <p:nvSpPr>
+          <p:cNvPr id="53" name="Shape 50"/>
           <p:cNvSpPr/>
           <p:nvPr/>
         </p:nvSpPr>
@@ -10246,7 +10401,7 @@
       </p:sp>
       <p:sp>
         <p:nvSpPr>
-          <p:cNvPr id="44" name="Text 40"/>
+          <p:cNvPr id="54" name="Text 51"/>
           <p:cNvSpPr txBox="1"/>
           <p:nvPr/>
         </p:nvSpPr>
@@ -10280,7 +10435,7 @@
                 <a:ea typeface="Trebuchet MS" pitchFamily="34" charset="-122"/>
                 <a:cs typeface="Trebuchet MS" pitchFamily="34" charset="-120"/>
               </a:rPr>
-              <a:t>Même frugale, la facture dépasse 8 milliards, hors salles, hors courant, hors consommables annuels : le tout-physique n'est pas une option.</a:t>
+              <a:t>Même frugale, la facture dépasse 2,4 milliards : hors salles, hors courant, et deux tiers des zones rurales sans électricité.</a:t>
             </a:r>
             <a:endParaRPr lang="en-US" sz="1200" dirty="0"/>
           </a:p>
@@ -10288,7 +10443,7 @@
       </p:sp>
       <p:sp>
         <p:nvSpPr>
-          <p:cNvPr id="45" name="Text 41"/>
+          <p:cNvPr id="55" name="Text 52"/>
           <p:cNvSpPr txBox="1"/>
           <p:nvPr/>
         </p:nvSpPr>
@@ -10319,7 +10474,7 @@
                 <a:ea typeface="Trebuchet MS" pitchFamily="34" charset="-122"/>
                 <a:cs typeface="Trebuchet MS" pitchFamily="34" charset="-120"/>
               </a:rPr>
-              <a:t>Sources : GPE (2019) ; Ministère de l'Éducation nationale, Togo (2024) ; Banque mondiale (2024). Hypothèse : 10 M FCFA d'équipement par laboratoire, à affiner avec le ministère.</a:t>
+              <a:t>Sources : UNICEF Togo, rénovation du laboratoire du lycée de Tsévié 1 (2025) ; GPE, récit MOBILELABO (2019) ; MENA Togo (2024) ; UNESCO, Science kits in developing countries.</a:t>
             </a:r>
             <a:endParaRPr lang="en-US" sz="900" dirty="0"/>
           </a:p>
@@ -10327,7 +10482,7 @@
       </p:sp>
       <p:sp>
         <p:nvSpPr>
-          <p:cNvPr id="46" name="Text 42"/>
+          <p:cNvPr id="56" name="Text 53"/>
           <p:cNvSpPr txBox="1"/>
           <p:nvPr/>
         </p:nvSpPr>
@@ -11197,7 +11352,7 @@
         <p:spPr>
           <a:xfrm>
             <a:off x="713232" y="4608576"/>
-            <a:ext cx="2377440" cy="804672"/>
+            <a:ext cx="2487168" cy="804672"/>
           </a:xfrm>
           <a:prstGeom prst="rect">
             <a:avLst/>
@@ -11211,12 +11366,12 @@
           <a:p>
             <a:pPr algn="l" indent="0" marL="0">
               <a:lnSpc>
-                <a:spcPct val="108000"/>
+                <a:spcPct val="105000"/>
               </a:lnSpc>
               <a:buNone/>
             </a:pPr>
             <a:r>
-              <a:rPr lang="en-US" sz="1450" b="1" dirty="0">
+              <a:rPr lang="en-US" sz="1250" b="1" dirty="0">
                 <a:solidFill>
                   <a:srgbClr val="0A5C5B"/>
                 </a:solidFill>
@@ -11226,7 +11381,7 @@
               </a:rPr>
               <a:t>De la 6e à la terminale</a:t>
             </a:r>
-            <a:endParaRPr lang="en-US" sz="1450" dirty="0"/>
+            <a:endParaRPr lang="en-US" sz="1250" dirty="0"/>
           </a:p>
         </p:txBody>
       </p:sp>
@@ -11238,7 +11393,7 @@
         </p:nvSpPr>
         <p:spPr>
           <a:xfrm>
-            <a:off x="3154680" y="4681728"/>
+            <a:off x="3246120" y="4681728"/>
             <a:ext cx="841248" cy="457200"/>
           </a:xfrm>
           <a:prstGeom prst="roundRect">
@@ -11260,7 +11415,7 @@
         </p:nvSpPr>
         <p:spPr>
           <a:xfrm>
-            <a:off x="3154680" y="4681728"/>
+            <a:off x="3246120" y="4681728"/>
             <a:ext cx="841248" cy="457200"/>
           </a:xfrm>
           <a:prstGeom prst="rect">
@@ -11299,7 +11454,7 @@
         </p:nvSpPr>
         <p:spPr>
           <a:xfrm>
-            <a:off x="4123944" y="4681728"/>
+            <a:off x="4215384" y="4681728"/>
             <a:ext cx="841248" cy="457200"/>
           </a:xfrm>
           <a:prstGeom prst="roundRect">
@@ -11321,7 +11476,7 @@
         </p:nvSpPr>
         <p:spPr>
           <a:xfrm>
-            <a:off x="4123944" y="4681728"/>
+            <a:off x="4215384" y="4681728"/>
             <a:ext cx="841248" cy="457200"/>
           </a:xfrm>
           <a:prstGeom prst="rect">
@@ -11360,7 +11515,7 @@
         </p:nvSpPr>
         <p:spPr>
           <a:xfrm>
-            <a:off x="5093208" y="4681728"/>
+            <a:off x="5184648" y="4681728"/>
             <a:ext cx="841248" cy="457200"/>
           </a:xfrm>
           <a:prstGeom prst="roundRect">
@@ -11382,7 +11537,7 @@
         </p:nvSpPr>
         <p:spPr>
           <a:xfrm>
-            <a:off x="5093208" y="4681728"/>
+            <a:off x="5184648" y="4681728"/>
             <a:ext cx="841248" cy="457200"/>
           </a:xfrm>
           <a:prstGeom prst="rect">
@@ -11421,7 +11576,7 @@
         </p:nvSpPr>
         <p:spPr>
           <a:xfrm>
-            <a:off x="6062472" y="4681728"/>
+            <a:off x="6153912" y="4681728"/>
             <a:ext cx="841248" cy="457200"/>
           </a:xfrm>
           <a:prstGeom prst="roundRect">
@@ -11443,7 +11598,7 @@
         </p:nvSpPr>
         <p:spPr>
           <a:xfrm>
-            <a:off x="6062472" y="4681728"/>
+            <a:off x="6153912" y="4681728"/>
             <a:ext cx="841248" cy="457200"/>
           </a:xfrm>
           <a:prstGeom prst="rect">
@@ -11482,7 +11637,7 @@
         </p:nvSpPr>
         <p:spPr>
           <a:xfrm>
-            <a:off x="7031736" y="4681728"/>
+            <a:off x="7123176" y="4681728"/>
             <a:ext cx="841248" cy="457200"/>
           </a:xfrm>
           <a:prstGeom prst="roundRect">
@@ -11504,7 +11659,7 @@
         </p:nvSpPr>
         <p:spPr>
           <a:xfrm>
-            <a:off x="7031736" y="4681728"/>
+            <a:off x="7123176" y="4681728"/>
             <a:ext cx="841248" cy="457200"/>
           </a:xfrm>
           <a:prstGeom prst="rect">
@@ -11543,7 +11698,7 @@
         </p:nvSpPr>
         <p:spPr>
           <a:xfrm>
-            <a:off x="8001000" y="4681728"/>
+            <a:off x="8092440" y="4681728"/>
             <a:ext cx="841248" cy="457200"/>
           </a:xfrm>
           <a:prstGeom prst="roundRect">
@@ -11565,7 +11720,7 @@
         </p:nvSpPr>
         <p:spPr>
           <a:xfrm>
-            <a:off x="8001000" y="4681728"/>
+            <a:off x="8092440" y="4681728"/>
             <a:ext cx="841248" cy="457200"/>
           </a:xfrm>
           <a:prstGeom prst="rect">
@@ -11604,7 +11759,7 @@
         </p:nvSpPr>
         <p:spPr>
           <a:xfrm>
-            <a:off x="8970264" y="4681728"/>
+            <a:off x="9061704" y="4681728"/>
             <a:ext cx="841248" cy="457200"/>
           </a:xfrm>
           <a:prstGeom prst="roundRect">
@@ -11626,7 +11781,7 @@
         </p:nvSpPr>
         <p:spPr>
           <a:xfrm>
-            <a:off x="8970264" y="4681728"/>
+            <a:off x="9061704" y="4681728"/>
             <a:ext cx="841248" cy="457200"/>
           </a:xfrm>
           <a:prstGeom prst="rect">
@@ -11665,7 +11820,7 @@
         </p:nvSpPr>
         <p:spPr>
           <a:xfrm>
-            <a:off x="3154680" y="5193792"/>
+            <a:off x="3246120" y="5193792"/>
             <a:ext cx="3749040" cy="219456"/>
           </a:xfrm>
           <a:prstGeom prst="rect">
@@ -11704,7 +11859,7 @@
         </p:nvSpPr>
         <p:spPr>
           <a:xfrm>
-            <a:off x="7031736" y="5193792"/>
+            <a:off x="7123176" y="5193792"/>
             <a:ext cx="2779776" cy="219456"/>
           </a:xfrm>
           <a:prstGeom prst="rect">
@@ -12345,7 +12500,7 @@
         </p:nvSpPr>
         <p:spPr>
           <a:xfrm>
-            <a:off x="1225296" y="2377440"/>
+            <a:off x="1225296" y="2340864"/>
             <a:ext cx="585216" cy="585216"/>
           </a:xfrm>
           <a:prstGeom prst="roundRect">
@@ -12375,7 +12530,7 @@
         </p:blipFill>
         <p:spPr>
           <a:xfrm>
-            <a:off x="1371600" y="2523744"/>
+            <a:off x="1371600" y="2487168"/>
             <a:ext cx="292608" cy="292608"/>
           </a:xfrm>
           <a:prstGeom prst="rect">
@@ -12391,7 +12546,7 @@
         </p:nvSpPr>
         <p:spPr>
           <a:xfrm>
-            <a:off x="457200" y="3090672"/>
+            <a:off x="457200" y="3035808"/>
             <a:ext cx="2121408" cy="219456"/>
           </a:xfrm>
           <a:prstGeom prst="rect">
@@ -12430,7 +12585,7 @@
         </p:nvSpPr>
         <p:spPr>
           <a:xfrm>
-            <a:off x="457200" y="3328416"/>
+            <a:off x="457200" y="3273552"/>
             <a:ext cx="2121408" cy="329184"/>
           </a:xfrm>
           <a:prstGeom prst="rect">
@@ -12469,8 +12624,8 @@
         </p:nvSpPr>
         <p:spPr>
           <a:xfrm>
-            <a:off x="621792" y="3730752"/>
-            <a:ext cx="1792224" cy="960120"/>
+            <a:off x="621792" y="3639312"/>
+            <a:ext cx="1792224" cy="658368"/>
           </a:xfrm>
           <a:prstGeom prst="rect">
             <a:avLst/>
@@ -12511,6 +12666,67 @@
         </p:nvSpPr>
         <p:spPr>
           <a:xfrm>
+            <a:off x="640080" y="4334256"/>
+            <a:ext cx="1755648" cy="329184"/>
+          </a:xfrm>
+          <a:prstGeom prst="roundRect">
+            <a:avLst>
+              <a:gd name="adj" fmla="val 50000"/>
+            </a:avLst>
+          </a:prstGeom>
+          <a:solidFill>
+            <a:srgbClr val="DCEBEA"/>
+          </a:solidFill>
+          <a:ln/>
+        </p:spPr>
+      </p:sp>
+      <p:sp>
+        <p:nvSpPr>
+          <p:cNvPr id="14" name="Text 10"/>
+          <p:cNvSpPr txBox="1"/>
+          <p:nvPr/>
+        </p:nvSpPr>
+        <p:spPr>
+          <a:xfrm>
+            <a:off x="640080" y="4334256"/>
+            <a:ext cx="1755648" cy="329184"/>
+          </a:xfrm>
+          <a:prstGeom prst="rect">
+            <a:avLst/>
+          </a:prstGeom>
+          <a:noFill/>
+          <a:ln/>
+        </p:spPr>
+        <p:txBody>
+          <a:bodyPr wrap="square" rtlCol="0" anchor="ctr"/>
+          <a:lstStyle/>
+          <a:p>
+            <a:pPr algn="ctr" indent="0" marL="0">
+              <a:buNone/>
+            </a:pPr>
+            <a:r>
+              <a:rPr lang="en-US" sz="850" b="1" dirty="0">
+                <a:solidFill>
+                  <a:srgbClr val="0A5C5B"/>
+                </a:solidFill>
+                <a:latin typeface="Trebuchet MS" pitchFamily="34" charset="0"/>
+                <a:ea typeface="Trebuchet MS" pitchFamily="34" charset="-122"/>
+                <a:cs typeface="Trebuchet MS" pitchFamily="34" charset="-120"/>
+              </a:rPr>
+              <a:t>Cartographie des TP</a:t>
+            </a:r>
+            <a:endParaRPr lang="en-US" sz="850" dirty="0"/>
+          </a:p>
+        </p:txBody>
+      </p:sp>
+      <p:sp>
+        <p:nvSpPr>
+          <p:cNvPr id="15" name="Shape 11"/>
+          <p:cNvSpPr/>
+          <p:nvPr/>
+        </p:nvSpPr>
+        <p:spPr>
+          <a:xfrm>
             <a:off x="2530602" y="3364992"/>
             <a:ext cx="256032" cy="219456"/>
           </a:xfrm>
@@ -12525,7 +12741,7 @@
       </p:sp>
       <p:sp>
         <p:nvSpPr>
-          <p:cNvPr id="14" name="Shape 10"/>
+          <p:cNvPr id="16" name="Shape 12"/>
           <p:cNvSpPr/>
           <p:nvPr/>
         </p:nvSpPr>
@@ -12552,13 +12768,13 @@
       </p:sp>
       <p:sp>
         <p:nvSpPr>
-          <p:cNvPr id="15" name="Shape 11"/>
+          <p:cNvPr id="17" name="Shape 13"/>
           <p:cNvSpPr/>
           <p:nvPr/>
         </p:nvSpPr>
         <p:spPr>
           <a:xfrm>
-            <a:off x="3506724" y="2377440"/>
+            <a:off x="3506724" y="2340864"/>
             <a:ext cx="585216" cy="585216"/>
           </a:xfrm>
           <a:prstGeom prst="roundRect">
@@ -12574,7 +12790,7 @@
       </p:sp>
       <p:pic>
         <p:nvPicPr>
-          <p:cNvPr id="16" name="Image 2" descr="/home/z/my-project/assets/deck_v2/fa_FaPencilRuler.png">    </p:cNvPr>
+          <p:cNvPr id="18" name="Image 2" descr="/home/z/my-project/assets/deck_v2/fa_FaPencilRuler.png">    </p:cNvPr>
           <p:cNvPicPr>
             <a:picLocks noChangeAspect="1"/>
           </p:cNvPicPr>
@@ -12588,7 +12804,7 @@
         </p:blipFill>
         <p:spPr>
           <a:xfrm>
-            <a:off x="3653028" y="2523744"/>
+            <a:off x="3653028" y="2487168"/>
             <a:ext cx="292608" cy="292608"/>
           </a:xfrm>
           <a:prstGeom prst="rect">
@@ -12598,13 +12814,13 @@
       </p:pic>
       <p:sp>
         <p:nvSpPr>
-          <p:cNvPr id="17" name="Text 12"/>
-          <p:cNvSpPr txBox="1"/>
-          <p:nvPr/>
-        </p:nvSpPr>
-        <p:spPr>
-          <a:xfrm>
-            <a:off x="2738628" y="3090672"/>
+          <p:cNvPr id="19" name="Text 14"/>
+          <p:cNvSpPr txBox="1"/>
+          <p:nvPr/>
+        </p:nvSpPr>
+        <p:spPr>
+          <a:xfrm>
+            <a:off x="2738628" y="3035808"/>
             <a:ext cx="2121408" cy="219456"/>
           </a:xfrm>
           <a:prstGeom prst="rect">
@@ -12637,13 +12853,13 @@
       </p:sp>
       <p:sp>
         <p:nvSpPr>
-          <p:cNvPr id="18" name="Text 13"/>
-          <p:cNvSpPr txBox="1"/>
-          <p:nvPr/>
-        </p:nvSpPr>
-        <p:spPr>
-          <a:xfrm>
-            <a:off x="2738628" y="3328416"/>
+          <p:cNvPr id="20" name="Text 15"/>
+          <p:cNvSpPr txBox="1"/>
+          <p:nvPr/>
+        </p:nvSpPr>
+        <p:spPr>
+          <a:xfrm>
+            <a:off x="2738628" y="3273552"/>
             <a:ext cx="2121408" cy="329184"/>
           </a:xfrm>
           <a:prstGeom prst="rect">
@@ -12676,14 +12892,14 @@
       </p:sp>
       <p:sp>
         <p:nvSpPr>
-          <p:cNvPr id="19" name="Text 14"/>
-          <p:cNvSpPr txBox="1"/>
-          <p:nvPr/>
-        </p:nvSpPr>
-        <p:spPr>
-          <a:xfrm>
-            <a:off x="2903220" y="3730752"/>
-            <a:ext cx="1792224" cy="960120"/>
+          <p:cNvPr id="21" name="Text 16"/>
+          <p:cNvSpPr txBox="1"/>
+          <p:nvPr/>
+        </p:nvSpPr>
+        <p:spPr>
+          <a:xfrm>
+            <a:off x="2903220" y="3639312"/>
+            <a:ext cx="1792224" cy="658368"/>
           </a:xfrm>
           <a:prstGeom prst="rect">
             <a:avLst/>
@@ -12718,7 +12934,68 @@
       </p:sp>
       <p:sp>
         <p:nvSpPr>
-          <p:cNvPr id="20" name="Shape 15"/>
+          <p:cNvPr id="22" name="Shape 17"/>
+          <p:cNvSpPr/>
+          <p:nvPr/>
+        </p:nvSpPr>
+        <p:spPr>
+          <a:xfrm>
+            <a:off x="2921508" y="4334256"/>
+            <a:ext cx="1755648" cy="329184"/>
+          </a:xfrm>
+          <a:prstGeom prst="roundRect">
+            <a:avLst>
+              <a:gd name="adj" fmla="val 50000"/>
+            </a:avLst>
+          </a:prstGeom>
+          <a:solidFill>
+            <a:srgbClr val="DCEBEA"/>
+          </a:solidFill>
+          <a:ln/>
+        </p:spPr>
+      </p:sp>
+      <p:sp>
+        <p:nvSpPr>
+          <p:cNvPr id="23" name="Text 18"/>
+          <p:cNvSpPr txBox="1"/>
+          <p:nvPr/>
+        </p:nvSpPr>
+        <p:spPr>
+          <a:xfrm>
+            <a:off x="2921508" y="4334256"/>
+            <a:ext cx="1755648" cy="329184"/>
+          </a:xfrm>
+          <a:prstGeom prst="rect">
+            <a:avLst/>
+          </a:prstGeom>
+          <a:noFill/>
+          <a:ln/>
+        </p:spPr>
+        <p:txBody>
+          <a:bodyPr wrap="square" rtlCol="0" anchor="ctr"/>
+          <a:lstStyle/>
+          <a:p>
+            <a:pPr algn="ctr" indent="0" marL="0">
+              <a:buNone/>
+            </a:pPr>
+            <a:r>
+              <a:rPr lang="en-US" sz="850" b="1" dirty="0">
+                <a:solidFill>
+                  <a:srgbClr val="0A5C5B"/>
+                </a:solidFill>
+                <a:latin typeface="Trebuchet MS" pitchFamily="34" charset="0"/>
+                <a:ea typeface="Trebuchet MS" pitchFamily="34" charset="-122"/>
+                <a:cs typeface="Trebuchet MS" pitchFamily="34" charset="-120"/>
+              </a:rPr>
+              <a:t>Fiches pédagogiques</a:t>
+            </a:r>
+            <a:endParaRPr lang="en-US" sz="850" dirty="0"/>
+          </a:p>
+        </p:txBody>
+      </p:sp>
+      <p:sp>
+        <p:nvSpPr>
+          <p:cNvPr id="24" name="Shape 19"/>
           <p:cNvSpPr/>
           <p:nvPr/>
         </p:nvSpPr>
@@ -12738,7 +13015,7 @@
       </p:sp>
       <p:sp>
         <p:nvSpPr>
-          <p:cNvPr id="21" name="Shape 16"/>
+          <p:cNvPr id="25" name="Shape 20"/>
           <p:cNvSpPr/>
           <p:nvPr/>
         </p:nvSpPr>
@@ -12765,13 +13042,13 @@
       </p:sp>
       <p:sp>
         <p:nvSpPr>
-          <p:cNvPr id="22" name="Shape 17"/>
+          <p:cNvPr id="26" name="Shape 21"/>
           <p:cNvSpPr/>
           <p:nvPr/>
         </p:nvSpPr>
         <p:spPr>
           <a:xfrm>
-            <a:off x="5788152" y="2377440"/>
+            <a:off x="5788152" y="2340864"/>
             <a:ext cx="585216" cy="585216"/>
           </a:xfrm>
           <a:prstGeom prst="roundRect">
@@ -12787,7 +13064,7 @@
       </p:sp>
       <p:pic>
         <p:nvPicPr>
-          <p:cNvPr id="23" name="Image 3" descr="/home/z/my-project/assets/deck_v2/fa_FaLaptopCode.png">    </p:cNvPr>
+          <p:cNvPr id="27" name="Image 3" descr="/home/z/my-project/assets/deck_v2/fa_FaLaptopCode.png">    </p:cNvPr>
           <p:cNvPicPr>
             <a:picLocks noChangeAspect="1"/>
           </p:cNvPicPr>
@@ -12801,7 +13078,7 @@
         </p:blipFill>
         <p:spPr>
           <a:xfrm>
-            <a:off x="5934456" y="2523744"/>
+            <a:off x="5934456" y="2487168"/>
             <a:ext cx="292608" cy="292608"/>
           </a:xfrm>
           <a:prstGeom prst="rect">
@@ -12811,13 +13088,13 @@
       </p:pic>
       <p:sp>
         <p:nvSpPr>
-          <p:cNvPr id="24" name="Text 18"/>
-          <p:cNvSpPr txBox="1"/>
-          <p:nvPr/>
-        </p:nvSpPr>
-        <p:spPr>
-          <a:xfrm>
-            <a:off x="5020056" y="3090672"/>
+          <p:cNvPr id="28" name="Text 22"/>
+          <p:cNvSpPr txBox="1"/>
+          <p:nvPr/>
+        </p:nvSpPr>
+        <p:spPr>
+          <a:xfrm>
+            <a:off x="5020056" y="3035808"/>
             <a:ext cx="2121408" cy="219456"/>
           </a:xfrm>
           <a:prstGeom prst="rect">
@@ -12850,13 +13127,13 @@
       </p:sp>
       <p:sp>
         <p:nvSpPr>
-          <p:cNvPr id="25" name="Text 19"/>
-          <p:cNvSpPr txBox="1"/>
-          <p:nvPr/>
-        </p:nvSpPr>
-        <p:spPr>
-          <a:xfrm>
-            <a:off x="5020056" y="3328416"/>
+          <p:cNvPr id="29" name="Text 23"/>
+          <p:cNvSpPr txBox="1"/>
+          <p:nvPr/>
+        </p:nvSpPr>
+        <p:spPr>
+          <a:xfrm>
+            <a:off x="5020056" y="3273552"/>
             <a:ext cx="2121408" cy="329184"/>
           </a:xfrm>
           <a:prstGeom prst="rect">
@@ -12889,14 +13166,14 @@
       </p:sp>
       <p:sp>
         <p:nvSpPr>
-          <p:cNvPr id="26" name="Text 20"/>
-          <p:cNvSpPr txBox="1"/>
-          <p:nvPr/>
-        </p:nvSpPr>
-        <p:spPr>
-          <a:xfrm>
-            <a:off x="5184648" y="3730752"/>
-            <a:ext cx="1792224" cy="960120"/>
+          <p:cNvPr id="30" name="Text 24"/>
+          <p:cNvSpPr txBox="1"/>
+          <p:nvPr/>
+        </p:nvSpPr>
+        <p:spPr>
+          <a:xfrm>
+            <a:off x="5184648" y="3639312"/>
+            <a:ext cx="1792224" cy="658368"/>
           </a:xfrm>
           <a:prstGeom prst="rect">
             <a:avLst/>
@@ -12931,7 +13208,68 @@
       </p:sp>
       <p:sp>
         <p:nvSpPr>
-          <p:cNvPr id="27" name="Shape 21"/>
+          <p:cNvPr id="31" name="Shape 25"/>
+          <p:cNvSpPr/>
+          <p:nvPr/>
+        </p:nvSpPr>
+        <p:spPr>
+          <a:xfrm>
+            <a:off x="5202936" y="4334256"/>
+            <a:ext cx="1755648" cy="329184"/>
+          </a:xfrm>
+          <a:prstGeom prst="roundRect">
+            <a:avLst>
+              <a:gd name="adj" fmla="val 50000"/>
+            </a:avLst>
+          </a:prstGeom>
+          <a:solidFill>
+            <a:srgbClr val="DCEBEA"/>
+          </a:solidFill>
+          <a:ln/>
+        </p:spPr>
+      </p:sp>
+      <p:sp>
+        <p:nvSpPr>
+          <p:cNvPr id="32" name="Text 26"/>
+          <p:cNvSpPr txBox="1"/>
+          <p:nvPr/>
+        </p:nvSpPr>
+        <p:spPr>
+          <a:xfrm>
+            <a:off x="5202936" y="4334256"/>
+            <a:ext cx="1755648" cy="329184"/>
+          </a:xfrm>
+          <a:prstGeom prst="rect">
+            <a:avLst/>
+          </a:prstGeom>
+          <a:noFill/>
+          <a:ln/>
+        </p:spPr>
+        <p:txBody>
+          <a:bodyPr wrap="square" rtlCol="0" anchor="ctr"/>
+          <a:lstStyle/>
+          <a:p>
+            <a:pPr algn="ctr" indent="0" marL="0">
+              <a:buNone/>
+            </a:pPr>
+            <a:r>
+              <a:rPr lang="en-US" sz="850" b="1" dirty="0">
+                <a:solidFill>
+                  <a:srgbClr val="0A5C5B"/>
+                </a:solidFill>
+                <a:latin typeface="Trebuchet MS" pitchFamily="34" charset="0"/>
+                <a:ea typeface="Trebuchet MS" pitchFamily="34" charset="-122"/>
+                <a:cs typeface="Trebuchet MS" pitchFamily="34" charset="-120"/>
+              </a:rPr>
+              <a:t>Simulateurs HTML5</a:t>
+            </a:r>
+            <a:endParaRPr lang="en-US" sz="850" dirty="0"/>
+          </a:p>
+        </p:txBody>
+      </p:sp>
+      <p:sp>
+        <p:nvSpPr>
+          <p:cNvPr id="33" name="Shape 27"/>
           <p:cNvSpPr/>
           <p:nvPr/>
         </p:nvSpPr>
@@ -12951,7 +13289,7 @@
       </p:sp>
       <p:sp>
         <p:nvSpPr>
-          <p:cNvPr id="28" name="Shape 22"/>
+          <p:cNvPr id="34" name="Shape 28"/>
           <p:cNvSpPr/>
           <p:nvPr/>
         </p:nvSpPr>
@@ -12978,13 +13316,13 @@
       </p:sp>
       <p:sp>
         <p:nvSpPr>
-          <p:cNvPr id="29" name="Shape 23"/>
+          <p:cNvPr id="35" name="Shape 29"/>
           <p:cNvSpPr/>
           <p:nvPr/>
         </p:nvSpPr>
         <p:spPr>
           <a:xfrm>
-            <a:off x="8069580" y="2377440"/>
+            <a:off x="8069580" y="2340864"/>
             <a:ext cx="585216" cy="585216"/>
           </a:xfrm>
           <a:prstGeom prst="roundRect">
@@ -13000,7 +13338,7 @@
       </p:sp>
       <p:pic>
         <p:nvPicPr>
-          <p:cNvPr id="30" name="Image 4" descr="/home/z/my-project/assets/deck_v2/fa_FaCheckDouble.png">    </p:cNvPr>
+          <p:cNvPr id="36" name="Image 4" descr="/home/z/my-project/assets/deck_v2/fa_FaCheckDouble.png">    </p:cNvPr>
           <p:cNvPicPr>
             <a:picLocks noChangeAspect="1"/>
           </p:cNvPicPr>
@@ -13014,7 +13352,7 @@
         </p:blipFill>
         <p:spPr>
           <a:xfrm>
-            <a:off x="8215884" y="2523744"/>
+            <a:off x="8215884" y="2487168"/>
             <a:ext cx="292608" cy="292608"/>
           </a:xfrm>
           <a:prstGeom prst="rect">
@@ -13024,13 +13362,13 @@
       </p:pic>
       <p:sp>
         <p:nvSpPr>
-          <p:cNvPr id="31" name="Text 24"/>
-          <p:cNvSpPr txBox="1"/>
-          <p:nvPr/>
-        </p:nvSpPr>
-        <p:spPr>
-          <a:xfrm>
-            <a:off x="7301484" y="3090672"/>
+          <p:cNvPr id="37" name="Text 30"/>
+          <p:cNvSpPr txBox="1"/>
+          <p:nvPr/>
+        </p:nvSpPr>
+        <p:spPr>
+          <a:xfrm>
+            <a:off x="7301484" y="3035808"/>
             <a:ext cx="2121408" cy="219456"/>
           </a:xfrm>
           <a:prstGeom prst="rect">
@@ -13063,13 +13401,13 @@
       </p:sp>
       <p:sp>
         <p:nvSpPr>
-          <p:cNvPr id="32" name="Text 25"/>
-          <p:cNvSpPr txBox="1"/>
-          <p:nvPr/>
-        </p:nvSpPr>
-        <p:spPr>
-          <a:xfrm>
-            <a:off x="7301484" y="3328416"/>
+          <p:cNvPr id="38" name="Text 31"/>
+          <p:cNvSpPr txBox="1"/>
+          <p:nvPr/>
+        </p:nvSpPr>
+        <p:spPr>
+          <a:xfrm>
+            <a:off x="7301484" y="3273552"/>
             <a:ext cx="2121408" cy="329184"/>
           </a:xfrm>
           <a:prstGeom prst="rect">
@@ -13102,14 +13440,14 @@
       </p:sp>
       <p:sp>
         <p:nvSpPr>
-          <p:cNvPr id="33" name="Text 26"/>
-          <p:cNvSpPr txBox="1"/>
-          <p:nvPr/>
-        </p:nvSpPr>
-        <p:spPr>
-          <a:xfrm>
-            <a:off x="7466076" y="3730752"/>
-            <a:ext cx="1792224" cy="960120"/>
+          <p:cNvPr id="39" name="Text 32"/>
+          <p:cNvSpPr txBox="1"/>
+          <p:nvPr/>
+        </p:nvSpPr>
+        <p:spPr>
+          <a:xfrm>
+            <a:off x="7466076" y="3639312"/>
+            <a:ext cx="1792224" cy="658368"/>
           </a:xfrm>
           <a:prstGeom prst="rect">
             <a:avLst/>
@@ -13144,7 +13482,68 @@
       </p:sp>
       <p:sp>
         <p:nvSpPr>
-          <p:cNvPr id="34" name="Shape 27"/>
+          <p:cNvPr id="40" name="Shape 33"/>
+          <p:cNvSpPr/>
+          <p:nvPr/>
+        </p:nvSpPr>
+        <p:spPr>
+          <a:xfrm>
+            <a:off x="7484364" y="4334256"/>
+            <a:ext cx="1755648" cy="329184"/>
+          </a:xfrm>
+          <a:prstGeom prst="roundRect">
+            <a:avLst>
+              <a:gd name="adj" fmla="val 50000"/>
+            </a:avLst>
+          </a:prstGeom>
+          <a:solidFill>
+            <a:srgbClr val="DCEBEA"/>
+          </a:solidFill>
+          <a:ln/>
+        </p:spPr>
+      </p:sp>
+      <p:sp>
+        <p:nvSpPr>
+          <p:cNvPr id="41" name="Text 34"/>
+          <p:cNvSpPr txBox="1"/>
+          <p:nvPr/>
+        </p:nvSpPr>
+        <p:spPr>
+          <a:xfrm>
+            <a:off x="7484364" y="4334256"/>
+            <a:ext cx="1755648" cy="329184"/>
+          </a:xfrm>
+          <a:prstGeom prst="rect">
+            <a:avLst/>
+          </a:prstGeom>
+          <a:noFill/>
+          <a:ln/>
+        </p:spPr>
+        <p:txBody>
+          <a:bodyPr wrap="square" rtlCol="0" anchor="ctr"/>
+          <a:lstStyle/>
+          <a:p>
+            <a:pPr algn="ctr" indent="0" marL="0">
+              <a:buNone/>
+            </a:pPr>
+            <a:r>
+              <a:rPr lang="en-US" sz="850" b="1" dirty="0">
+                <a:solidFill>
+                  <a:srgbClr val="0A5C5B"/>
+                </a:solidFill>
+                <a:latin typeface="Trebuchet MS" pitchFamily="34" charset="0"/>
+                <a:ea typeface="Trebuchet MS" pitchFamily="34" charset="-122"/>
+                <a:cs typeface="Trebuchet MS" pitchFamily="34" charset="-120"/>
+              </a:rPr>
+              <a:t>Catalogue validé</a:t>
+            </a:r>
+            <a:endParaRPr lang="en-US" sz="850" dirty="0"/>
+          </a:p>
+        </p:txBody>
+      </p:sp>
+      <p:sp>
+        <p:nvSpPr>
+          <p:cNvPr id="42" name="Shape 35"/>
           <p:cNvSpPr/>
           <p:nvPr/>
         </p:nvSpPr>
@@ -13164,7 +13563,7 @@
       </p:sp>
       <p:sp>
         <p:nvSpPr>
-          <p:cNvPr id="35" name="Shape 28"/>
+          <p:cNvPr id="43" name="Shape 36"/>
           <p:cNvSpPr/>
           <p:nvPr/>
         </p:nvSpPr>
@@ -13191,13 +13590,13 @@
       </p:sp>
       <p:sp>
         <p:nvSpPr>
-          <p:cNvPr id="36" name="Shape 29"/>
+          <p:cNvPr id="44" name="Shape 37"/>
           <p:cNvSpPr/>
           <p:nvPr/>
         </p:nvSpPr>
         <p:spPr>
           <a:xfrm>
-            <a:off x="10351008" y="2377440"/>
+            <a:off x="10351008" y="2340864"/>
             <a:ext cx="585216" cy="585216"/>
           </a:xfrm>
           <a:prstGeom prst="roundRect">
@@ -13213,7 +13612,7 @@
       </p:sp>
       <p:pic>
         <p:nvPicPr>
-          <p:cNvPr id="37" name="Image 5" descr="/home/z/my-project/assets/deck_v2/fa_FaChartLine.png">    </p:cNvPr>
+          <p:cNvPr id="45" name="Image 5" descr="/home/z/my-project/assets/deck_v2/fa_FaChartLine.png">    </p:cNvPr>
           <p:cNvPicPr>
             <a:picLocks noChangeAspect="1"/>
           </p:cNvPicPr>
@@ -13227,7 +13626,7 @@
         </p:blipFill>
         <p:spPr>
           <a:xfrm>
-            <a:off x="10497312" y="2523744"/>
+            <a:off x="10497312" y="2487168"/>
             <a:ext cx="292608" cy="292608"/>
           </a:xfrm>
           <a:prstGeom prst="rect">
@@ -13237,13 +13636,13 @@
       </p:pic>
       <p:sp>
         <p:nvSpPr>
-          <p:cNvPr id="38" name="Text 30"/>
-          <p:cNvSpPr txBox="1"/>
-          <p:nvPr/>
-        </p:nvSpPr>
-        <p:spPr>
-          <a:xfrm>
-            <a:off x="9582912" y="3090672"/>
+          <p:cNvPr id="46" name="Text 38"/>
+          <p:cNvSpPr txBox="1"/>
+          <p:nvPr/>
+        </p:nvSpPr>
+        <p:spPr>
+          <a:xfrm>
+            <a:off x="9582912" y="3035808"/>
             <a:ext cx="2121408" cy="219456"/>
           </a:xfrm>
           <a:prstGeom prst="rect">
@@ -13276,13 +13675,13 @@
       </p:sp>
       <p:sp>
         <p:nvSpPr>
-          <p:cNvPr id="39" name="Text 31"/>
-          <p:cNvSpPr txBox="1"/>
-          <p:nvPr/>
-        </p:nvSpPr>
-        <p:spPr>
-          <a:xfrm>
-            <a:off x="9582912" y="3328416"/>
+          <p:cNvPr id="47" name="Text 39"/>
+          <p:cNvSpPr txBox="1"/>
+          <p:nvPr/>
+        </p:nvSpPr>
+        <p:spPr>
+          <a:xfrm>
+            <a:off x="9582912" y="3273552"/>
             <a:ext cx="2121408" cy="329184"/>
           </a:xfrm>
           <a:prstGeom prst="rect">
@@ -13315,14 +13714,14 @@
       </p:sp>
       <p:sp>
         <p:nvSpPr>
-          <p:cNvPr id="40" name="Text 32"/>
-          <p:cNvSpPr txBox="1"/>
-          <p:nvPr/>
-        </p:nvSpPr>
-        <p:spPr>
-          <a:xfrm>
-            <a:off x="9747504" y="3730752"/>
-            <a:ext cx="1792224" cy="960120"/>
+          <p:cNvPr id="48" name="Text 40"/>
+          <p:cNvSpPr txBox="1"/>
+          <p:nvPr/>
+        </p:nvSpPr>
+        <p:spPr>
+          <a:xfrm>
+            <a:off x="9747504" y="3639312"/>
+            <a:ext cx="1792224" cy="658368"/>
           </a:xfrm>
           <a:prstGeom prst="rect">
             <a:avLst/>
@@ -13357,14 +13756,36 @@
       </p:sp>
       <p:sp>
         <p:nvSpPr>
-          <p:cNvPr id="41" name="Text 33"/>
-          <p:cNvSpPr txBox="1"/>
-          <p:nvPr/>
-        </p:nvSpPr>
-        <p:spPr>
-          <a:xfrm>
-            <a:off x="457200" y="4956048"/>
-            <a:ext cx="11247120" cy="274320"/>
+          <p:cNvPr id="49" name="Shape 41"/>
+          <p:cNvSpPr/>
+          <p:nvPr/>
+        </p:nvSpPr>
+        <p:spPr>
+          <a:xfrm>
+            <a:off x="9765792" y="4334256"/>
+            <a:ext cx="1755648" cy="329184"/>
+          </a:xfrm>
+          <a:prstGeom prst="roundRect">
+            <a:avLst>
+              <a:gd name="adj" fmla="val 50000"/>
+            </a:avLst>
+          </a:prstGeom>
+          <a:solidFill>
+            <a:srgbClr val="F8E4D9"/>
+          </a:solidFill>
+          <a:ln/>
+        </p:spPr>
+      </p:sp>
+      <p:sp>
+        <p:nvSpPr>
+          <p:cNvPr id="50" name="Text 42"/>
+          <p:cNvSpPr txBox="1"/>
+          <p:nvPr/>
+        </p:nvSpPr>
+        <p:spPr>
+          <a:xfrm>
+            <a:off x="9765792" y="4334256"/>
+            <a:ext cx="1755648" cy="329184"/>
           </a:xfrm>
           <a:prstGeom prst="rect">
             <a:avLst/>
@@ -13380,14 +13801,53 @@
               <a:buNone/>
             </a:pPr>
             <a:r>
-              <a:rPr lang="en-US" sz="1050" i="1" dirty="0">
-                <a:solidFill>
-                  <a:srgbClr val="6E7B80"/>
+              <a:rPr lang="en-US" sz="850" b="1" dirty="0">
+                <a:solidFill>
+                  <a:srgbClr val="B8431D"/>
                 </a:solidFill>
                 <a:latin typeface="Trebuchet MS" pitchFamily="34" charset="0"/>
                 <a:ea typeface="Trebuchet MS" pitchFamily="34" charset="-122"/>
                 <a:cs typeface="Trebuchet MS" pitchFamily="34" charset="-120"/>
               </a:rPr>
+              <a:t>Rapport d'usage</a:t>
+            </a:r>
+            <a:endParaRPr lang="en-US" sz="850" dirty="0"/>
+          </a:p>
+        </p:txBody>
+      </p:sp>
+      <p:sp>
+        <p:nvSpPr>
+          <p:cNvPr id="51" name="Text 43"/>
+          <p:cNvSpPr txBox="1"/>
+          <p:nvPr/>
+        </p:nvSpPr>
+        <p:spPr>
+          <a:xfrm>
+            <a:off x="457200" y="4956048"/>
+            <a:ext cx="11247120" cy="274320"/>
+          </a:xfrm>
+          <a:prstGeom prst="rect">
+            <a:avLst/>
+          </a:prstGeom>
+          <a:noFill/>
+          <a:ln/>
+        </p:spPr>
+        <p:txBody>
+          <a:bodyPr wrap="square" rtlCol="0" anchor="ctr"/>
+          <a:lstStyle/>
+          <a:p>
+            <a:pPr algn="ctr" indent="0" marL="0">
+              <a:buNone/>
+            </a:pPr>
+            <a:r>
+              <a:rPr lang="en-US" sz="1050" i="1" dirty="0">
+                <a:solidFill>
+                  <a:srgbClr val="6E7B80"/>
+                </a:solidFill>
+                <a:latin typeface="Trebuchet MS" pitchFamily="34" charset="0"/>
+                <a:ea typeface="Trebuchet MS" pitchFamily="34" charset="-122"/>
+                <a:cs typeface="Trebuchet MS" pitchFamily="34" charset="-120"/>
+              </a:rPr>
               <a:t>Boucle de recalibrage : les données d'usage indiquent quels contenus manquent et quoi développer ensuite.</a:t>
             </a:r>
             <a:endParaRPr lang="en-US" sz="1050" dirty="0"/>
@@ -13396,7 +13856,7 @@
       </p:sp>
       <p:sp>
         <p:nvSpPr>
-          <p:cNvPr id="42" name="Shape 34"/>
+          <p:cNvPr id="52" name="Shape 44"/>
           <p:cNvSpPr/>
           <p:nvPr/>
         </p:nvSpPr>
@@ -13418,7 +13878,7 @@
       </p:sp>
       <p:sp>
         <p:nvSpPr>
-          <p:cNvPr id="43" name="Text 35"/>
+          <p:cNvPr id="53" name="Text 45"/>
           <p:cNvSpPr txBox="1"/>
           <p:nvPr/>
         </p:nvSpPr>
@@ -13460,7 +13920,7 @@
       </p:sp>
       <p:sp>
         <p:nvSpPr>
-          <p:cNvPr id="44" name="Text 36"/>
+          <p:cNvPr id="54" name="Text 46"/>
           <p:cNvSpPr txBox="1"/>
           <p:nvPr/>
         </p:nvSpPr>
@@ -14169,7 +14629,7 @@
                 <a:ea typeface="Trebuchet MS" pitchFamily="34" charset="-122"/>
                 <a:cs typeface="Trebuchet MS" pitchFamily="34" charset="-120"/>
               </a:rPr>
-              <a:t>catalogue entier en cache local, sync différée</a:t>
+              <a:t>Catalogue entier en cache local, sync différée</a:t>
             </a:r>
             <a:endParaRPr lang="en-US" sz="950" dirty="0"/>
           </a:p>
@@ -14343,7 +14803,7 @@
                 <a:ea typeface="Trebuchet MS" pitchFamily="34" charset="-122"/>
                 <a:cs typeface="Trebuchet MS" pitchFamily="34" charset="-120"/>
               </a:rPr>
-              <a:t>projeté en classe, rejoué librement à la maison</a:t>
+              <a:t>Projeté en classe, rejoué librement à la maison</a:t>
             </a:r>
             <a:endParaRPr lang="en-US" sz="950" dirty="0"/>
           </a:p>
@@ -14380,7 +14840,7 @@
         <p:spPr>
           <a:xfrm>
             <a:off x="694944" y="3785616"/>
-            <a:ext cx="3108960" cy="713232"/>
+            <a:ext cx="2788920" cy="713232"/>
           </a:xfrm>
           <a:prstGeom prst="rect">
             <a:avLst/>
@@ -14394,12 +14854,12 @@
           <a:p>
             <a:pPr algn="l" indent="0" marL="0">
               <a:lnSpc>
-                <a:spcPct val="110000"/>
+                <a:spcPct val="120000"/>
               </a:lnSpc>
               <a:buNone/>
             </a:pPr>
             <a:r>
-              <a:rPr lang="en-US" sz="1000" b="1" spc="150" kern="0" dirty="0">
+              <a:rPr lang="en-US" sz="950" b="1" spc="150" kern="0" dirty="0">
                 <a:solidFill>
                   <a:srgbClr val="0A5C5B"/>
                 </a:solidFill>
@@ -14407,9 +14867,29 @@
                 <a:ea typeface="Trebuchet MS" pitchFamily="34" charset="-122"/>
                 <a:cs typeface="Trebuchet MS" pitchFamily="34" charset="-120"/>
               </a:rPr>
-              <a:t>TROIS CHEMINS JUSQU'À LA CLASSE</a:t>
-            </a:r>
-            <a:endParaRPr lang="en-US" sz="1000" dirty="0"/>
+              <a:t>TROIS CHEMINS</a:t>
+            </a:r>
+            <a:endParaRPr lang="en-US" sz="950" dirty="0"/>
+          </a:p>
+          <a:p>
+            <a:pPr algn="l" indent="0" marL="0">
+              <a:lnSpc>
+                <a:spcPct val="120000"/>
+              </a:lnSpc>
+              <a:buNone/>
+            </a:pPr>
+            <a:r>
+              <a:rPr lang="en-US" sz="950" b="1" spc="150" kern="0" dirty="0">
+                <a:solidFill>
+                  <a:srgbClr val="0A5C5B"/>
+                </a:solidFill>
+                <a:latin typeface="Trebuchet MS" pitchFamily="34" charset="0"/>
+                <a:ea typeface="Trebuchet MS" pitchFamily="34" charset="-122"/>
+                <a:cs typeface="Trebuchet MS" pitchFamily="34" charset="-120"/>
+              </a:rPr>
+              <a:t>JUSQU'À LA CLASSE</a:t>
+            </a:r>
+            <a:endParaRPr lang="en-US" sz="950" dirty="0"/>
           </a:p>
         </p:txBody>
       </p:sp>
@@ -15663,8 +16143,8 @@
         </p:nvSpPr>
         <p:spPr>
           <a:xfrm>
-            <a:off x="7123176" y="4279392"/>
-            <a:ext cx="2697480" cy="219456"/>
+            <a:off x="7123176" y="4261104"/>
+            <a:ext cx="2834640" cy="219456"/>
           </a:xfrm>
           <a:prstGeom prst="rect">
             <a:avLst/>
@@ -15688,7 +16168,7 @@
                 <a:ea typeface="Trebuchet MS" pitchFamily="34" charset="-122"/>
                 <a:cs typeface="Trebuchet MS" pitchFamily="34" charset="-120"/>
               </a:rPr>
-              <a:t>Équipement physique des laboratoires</a:t>
+              <a:t>Équipement physique · minimum national</a:t>
             </a:r>
             <a:endParaRPr lang="en-US" sz="950" dirty="0"/>
           </a:p>
@@ -15702,7 +16182,7 @@
         </p:nvSpPr>
         <p:spPr>
           <a:xfrm>
-            <a:off x="9720072" y="4279392"/>
+            <a:off x="9720072" y="4261104"/>
             <a:ext cx="1792224" cy="219456"/>
           </a:xfrm>
           <a:prstGeom prst="rect">
@@ -15727,7 +16207,7 @@
                 <a:ea typeface="Trebuchet MS" pitchFamily="34" charset="-122"/>
                 <a:cs typeface="Trebuchet MS" pitchFamily="34" charset="-120"/>
               </a:rPr>
-              <a:t>≈ 8 milliards FCFA</a:t>
+              <a:t>≈ 2,4 milliards FCFA</a:t>
             </a:r>
             <a:endParaRPr lang="en-US" sz="950" dirty="0"/>
           </a:p>
@@ -15741,7 +16221,7 @@
         </p:nvSpPr>
         <p:spPr>
           <a:xfrm>
-            <a:off x="7123176" y="4517136"/>
+            <a:off x="7123176" y="4498848"/>
             <a:ext cx="4389120" cy="155448"/>
           </a:xfrm>
           <a:prstGeom prst="roundRect">
@@ -15763,8 +16243,8 @@
         </p:nvSpPr>
         <p:spPr>
           <a:xfrm>
-            <a:off x="7123176" y="4791456"/>
-            <a:ext cx="2514600" cy="219456"/>
+            <a:off x="7123176" y="4718304"/>
+            <a:ext cx="4389120" cy="182880"/>
           </a:xfrm>
           <a:prstGeom prst="rect">
             <a:avLst/>
@@ -15780,7 +16260,7 @@
               <a:buNone/>
             </a:pPr>
             <a:r>
-              <a:rPr lang="en-US" sz="950" dirty="0">
+              <a:rPr lang="en-US" sz="850" i="1" dirty="0">
                 <a:solidFill>
                   <a:srgbClr val="C9DEDD"/>
                 </a:solidFill>
@@ -15788,9 +16268,9 @@
                 <a:ea typeface="Trebuchet MS" pitchFamily="34" charset="-122"/>
                 <a:cs typeface="Trebuchet MS" pitchFamily="34" charset="-120"/>
               </a:rPr>
-              <a:t>VirtuLab · déploiement national</a:t>
-            </a:r>
-            <a:endParaRPr lang="en-US" sz="950" dirty="0"/>
+              <a:t>Au standard complet (12 M par labo, UNICEF 2025) : 9,7 Md, soit 33 ×.</a:t>
+            </a:r>
+            <a:endParaRPr lang="en-US" sz="850" dirty="0"/>
           </a:p>
         </p:txBody>
       </p:sp>
@@ -15802,32 +16282,32 @@
         </p:nvSpPr>
         <p:spPr>
           <a:xfrm>
-            <a:off x="9720072" y="4791456"/>
-            <a:ext cx="1792224" cy="219456"/>
-          </a:xfrm>
-          <a:prstGeom prst="rect">
-            <a:avLst/>
-          </a:prstGeom>
-          <a:noFill/>
-          <a:ln/>
-        </p:spPr>
-        <p:txBody>
-          <a:bodyPr wrap="square" rtlCol="0" anchor="ctr"/>
-          <a:lstStyle/>
-          <a:p>
-            <a:pPr algn="r" indent="0" marL="0">
-              <a:buNone/>
-            </a:pPr>
-            <a:r>
-              <a:rPr lang="en-US" sz="950" b="1" dirty="0">
-                <a:solidFill>
-                  <a:srgbClr val="FFFFFF"/>
+            <a:off x="7123176" y="4956048"/>
+            <a:ext cx="2834640" cy="219456"/>
+          </a:xfrm>
+          <a:prstGeom prst="rect">
+            <a:avLst/>
+          </a:prstGeom>
+          <a:noFill/>
+          <a:ln/>
+        </p:spPr>
+        <p:txBody>
+          <a:bodyPr wrap="square" rtlCol="0" anchor="ctr"/>
+          <a:lstStyle/>
+          <a:p>
+            <a:pPr algn="l" indent="0" marL="0">
+              <a:buNone/>
+            </a:pPr>
+            <a:r>
+              <a:rPr lang="en-US" sz="950" dirty="0">
+                <a:solidFill>
+                  <a:srgbClr val="C9DEDD"/>
                 </a:solidFill>
                 <a:latin typeface="Trebuchet MS" pitchFamily="34" charset="0"/>
                 <a:ea typeface="Trebuchet MS" pitchFamily="34" charset="-122"/>
                 <a:cs typeface="Trebuchet MS" pitchFamily="34" charset="-120"/>
               </a:rPr>
-              <a:t>297 M FCFA sur 3 ans</a:t>
+              <a:t>VirtuLab · déploiement national (3 ans)</a:t>
             </a:r>
             <a:endParaRPr lang="en-US" sz="950" dirty="0"/>
           </a:p>
@@ -15835,14 +16315,53 @@
       </p:sp>
       <p:sp>
         <p:nvSpPr>
-          <p:cNvPr id="23" name="Shape 19"/>
+          <p:cNvPr id="23" name="Text 19"/>
+          <p:cNvSpPr txBox="1"/>
+          <p:nvPr/>
+        </p:nvSpPr>
+        <p:spPr>
+          <a:xfrm>
+            <a:off x="9720072" y="4956048"/>
+            <a:ext cx="1792224" cy="219456"/>
+          </a:xfrm>
+          <a:prstGeom prst="rect">
+            <a:avLst/>
+          </a:prstGeom>
+          <a:noFill/>
+          <a:ln/>
+        </p:spPr>
+        <p:txBody>
+          <a:bodyPr wrap="square" rtlCol="0" anchor="ctr"/>
+          <a:lstStyle/>
+          <a:p>
+            <a:pPr algn="r" indent="0" marL="0">
+              <a:buNone/>
+            </a:pPr>
+            <a:r>
+              <a:rPr lang="en-US" sz="950" b="1" dirty="0">
+                <a:solidFill>
+                  <a:srgbClr val="FFFFFF"/>
+                </a:solidFill>
+                <a:latin typeface="Trebuchet MS" pitchFamily="34" charset="0"/>
+                <a:ea typeface="Trebuchet MS" pitchFamily="34" charset="-122"/>
+                <a:cs typeface="Trebuchet MS" pitchFamily="34" charset="-120"/>
+              </a:rPr>
+              <a:t>297 M FCFA</a:t>
+            </a:r>
+            <a:endParaRPr lang="en-US" sz="950" dirty="0"/>
+          </a:p>
+        </p:txBody>
+      </p:sp>
+      <p:sp>
+        <p:nvSpPr>
+          <p:cNvPr id="24" name="Shape 20"/>
           <p:cNvSpPr/>
           <p:nvPr/>
         </p:nvSpPr>
         <p:spPr>
           <a:xfrm>
-            <a:off x="7123176" y="5029200"/>
-            <a:ext cx="160934" cy="155448"/>
+            <a:off x="7123176" y="5193792"/>
+            <a:ext cx="536448" cy="155448"/>
           </a:xfrm>
           <a:prstGeom prst="roundRect">
             <a:avLst>
@@ -15857,14 +16376,14 @@
       </p:sp>
       <p:sp>
         <p:nvSpPr>
-          <p:cNvPr id="24" name="Text 20"/>
-          <p:cNvSpPr txBox="1"/>
-          <p:nvPr/>
-        </p:nvSpPr>
-        <p:spPr>
-          <a:xfrm>
-            <a:off x="7123176" y="5285232"/>
-            <a:ext cx="3108960" cy="475488"/>
+          <p:cNvPr id="25" name="Text 21"/>
+          <p:cNvSpPr txBox="1"/>
+          <p:nvPr/>
+        </p:nvSpPr>
+        <p:spPr>
+          <a:xfrm>
+            <a:off x="7123176" y="5413248"/>
+            <a:ext cx="3108960" cy="457200"/>
           </a:xfrm>
           <a:prstGeom prst="rect">
             <a:avLst/>
@@ -15888,7 +16407,7 @@
                 <a:ea typeface="Georgia" pitchFamily="34" charset="-122"/>
                 <a:cs typeface="Georgia" pitchFamily="34" charset="-120"/>
               </a:rPr>
-              <a:t>≈ 25 × moins cher</a:t>
+              <a:t>≈ 8 × moins cher</a:t>
             </a:r>
             <a:endParaRPr lang="en-US" sz="2200" dirty="0"/>
           </a:p>
@@ -15896,14 +16415,14 @@
       </p:sp>
       <p:sp>
         <p:nvSpPr>
-          <p:cNvPr id="25" name="Text 21"/>
-          <p:cNvSpPr txBox="1"/>
-          <p:nvPr/>
-        </p:nvSpPr>
-        <p:spPr>
-          <a:xfrm>
-            <a:off x="7123176" y="5779008"/>
-            <a:ext cx="4389120" cy="274320"/>
+          <p:cNvPr id="26" name="Text 22"/>
+          <p:cNvSpPr txBox="1"/>
+          <p:nvPr/>
+        </p:nvSpPr>
+        <p:spPr>
+          <a:xfrm>
+            <a:off x="7123176" y="5833872"/>
+            <a:ext cx="4389120" cy="237744"/>
           </a:xfrm>
           <a:prstGeom prst="rect">
             <a:avLst/>
@@ -15938,7 +16457,7 @@
       </p:sp>
       <p:sp>
         <p:nvSpPr>
-          <p:cNvPr id="26" name="Text 22"/>
+          <p:cNvPr id="27" name="Text 23"/>
           <p:cNvSpPr txBox="1"/>
           <p:nvPr/>
         </p:nvSpPr>
@@ -15969,7 +16488,7 @@
                 <a:ea typeface="Trebuchet MS" pitchFamily="34" charset="-122"/>
                 <a:cs typeface="Trebuchet MS" pitchFamily="34" charset="-120"/>
               </a:rPr>
-              <a:t>Preuve issue surtout du supérieur : le pilote togolais sera évalué localement avec groupes témoins.</a:t>
+              <a:t>Preuve surtout du supérieur : pilote évalué localement avec groupes témoins.</a:t>
             </a:r>
             <a:endParaRPr lang="en-US" sz="900" dirty="0"/>
           </a:p>
@@ -15977,7 +16496,7 @@
       </p:sp>
       <p:sp>
         <p:nvSpPr>
-          <p:cNvPr id="27" name="Text 23"/>
+          <p:cNvPr id="28" name="Text 24"/>
           <p:cNvSpPr txBox="1"/>
           <p:nvPr/>
         </p:nvSpPr>
@@ -16008,7 +16527,7 @@
                 <a:ea typeface="Trebuchet MS" pitchFamily="34" charset="-122"/>
                 <a:cs typeface="Trebuchet MS" pitchFamily="34" charset="-120"/>
               </a:rPr>
-              <a:t>Sources : Li et Liang (2024), PLOS ONE ; Labster ; de Jong et al. (2013), Science. Coûts : hypothèse 10 M FCFA/labo, hors construction, à affiner.</a:t>
+              <a:t>Sources : Li et Liang (2024), PLOS ONE ; Labster ; de Jong et al. (2013). Coûts : min. ≈ 3 M/labo (marché togolais) ; standard ≈ 12 M (UNICEF, 2025).</a:t>
             </a:r>
             <a:endParaRPr lang="en-US" sz="900" dirty="0"/>
           </a:p>
@@ -16016,7 +16535,7 @@
       </p:sp>
       <p:sp>
         <p:nvSpPr>
-          <p:cNvPr id="28" name="Text 24"/>
+          <p:cNvPr id="29" name="Text 25"/>
           <p:cNvSpPr txBox="1"/>
           <p:nvPr/>
         </p:nvSpPr>

</xml_diff>

<commit_message>
VirtuLab Togo: slides 2-4-7 finalisées (TP 216 PC/286 total, slide 3 épurée, preuves slide 7)
</commit_message>
<xml_diff>
--- a/VirtuLab_Togo_Presentation_Dr_Pagdame_Tiebekabe.pptx
+++ b/VirtuLab_Togo_Presentation_Dr_Pagdame_Tiebekabe.pptx
@@ -3188,7 +3188,7 @@
                 <a:ea typeface="Georgia" pitchFamily="34" charset="-122"/>
                 <a:cs typeface="Georgia" pitchFamily="34" charset="-120"/>
               </a:rPr>
-              <a:t>120</a:t>
+              <a:t>286</a:t>
             </a:r>
             <a:endParaRPr lang="en-US" sz="1900" dirty="0"/>
           </a:p>
@@ -3227,7 +3227,7 @@
                 <a:ea typeface="Trebuchet MS" pitchFamily="34" charset="-122"/>
                 <a:cs typeface="Trebuchet MS" pitchFamily="34" charset="-120"/>
               </a:rPr>
-              <a:t>SIMULATEURS</a:t>
+              <a:t>TP SIMULÉS</a:t>
             </a:r>
             <a:endParaRPr lang="en-US" sz="780" dirty="0"/>
           </a:p>
@@ -7624,7 +7624,7 @@
         <p:spPr>
           <a:xfrm>
             <a:off x="713232" y="1865376"/>
-            <a:ext cx="3657600" cy="310896"/>
+            <a:ext cx="4882896" cy="310896"/>
           </a:xfrm>
           <a:prstGeom prst="rect">
             <a:avLst/>
@@ -7656,98 +7656,37 @@
       </p:sp>
       <p:sp>
         <p:nvSpPr>
-          <p:cNvPr id="9" name="Shape 6"/>
-          <p:cNvSpPr/>
-          <p:nvPr/>
-        </p:nvSpPr>
-        <p:spPr>
-          <a:xfrm>
-            <a:off x="4279392" y="1865376"/>
-            <a:ext cx="1335024" cy="365760"/>
-          </a:xfrm>
-          <a:prstGeom prst="roundRect">
-            <a:avLst>
-              <a:gd name="adj" fmla="val 50000"/>
-            </a:avLst>
-          </a:prstGeom>
-          <a:solidFill>
-            <a:srgbClr val="F8E4D9"/>
-          </a:solidFill>
-          <a:ln/>
-        </p:spPr>
-      </p:sp>
-      <p:sp>
-        <p:nvSpPr>
-          <p:cNvPr id="10" name="Text 7"/>
-          <p:cNvSpPr txBox="1"/>
-          <p:nvPr/>
-        </p:nvSpPr>
-        <p:spPr>
-          <a:xfrm>
-            <a:off x="4279392" y="1865376"/>
-            <a:ext cx="1335024" cy="365760"/>
-          </a:xfrm>
-          <a:prstGeom prst="rect">
-            <a:avLst/>
-          </a:prstGeom>
-          <a:noFill/>
-          <a:ln/>
-        </p:spPr>
-        <p:txBody>
-          <a:bodyPr wrap="square" rtlCol="0" anchor="ctr"/>
-          <a:lstStyle/>
-          <a:p>
-            <a:pPr algn="ctr" indent="0" marL="0">
-              <a:buNone/>
-            </a:pPr>
-            <a:r>
-              <a:rPr lang="en-US" sz="1150" b="1" dirty="0">
-                <a:solidFill>
-                  <a:srgbClr val="B8431D"/>
+          <p:cNvPr id="9" name="Text 6"/>
+          <p:cNvSpPr txBox="1"/>
+          <p:nvPr/>
+        </p:nvSpPr>
+        <p:spPr>
+          <a:xfrm>
+            <a:off x="713232" y="2560320"/>
+            <a:ext cx="777240" cy="658368"/>
+          </a:xfrm>
+          <a:prstGeom prst="rect">
+            <a:avLst/>
+          </a:prstGeom>
+          <a:noFill/>
+          <a:ln/>
+        </p:spPr>
+        <p:txBody>
+          <a:bodyPr wrap="square" rtlCol="0" anchor="ctr"/>
+          <a:lstStyle/>
+          <a:p>
+            <a:pPr algn="l" indent="0" marL="0">
+              <a:buNone/>
+            </a:pPr>
+            <a:r>
+              <a:rPr lang="en-US" sz="1400" b="1" dirty="0">
+                <a:solidFill>
+                  <a:srgbClr val="6E7B80"/>
                 </a:solidFill>
                 <a:latin typeface="Trebuchet MS" pitchFamily="34" charset="0"/>
                 <a:ea typeface="Trebuchet MS" pitchFamily="34" charset="-122"/>
                 <a:cs typeface="Trebuchet MS" pitchFamily="34" charset="-120"/>
               </a:rPr>
-              <a:t>×3 en 13 ans</a:t>
-            </a:r>
-            <a:endParaRPr lang="en-US" sz="1150" dirty="0"/>
-          </a:p>
-        </p:txBody>
-      </p:sp>
-      <p:sp>
-        <p:nvSpPr>
-          <p:cNvPr id="11" name="Text 8"/>
-          <p:cNvSpPr txBox="1"/>
-          <p:nvPr/>
-        </p:nvSpPr>
-        <p:spPr>
-          <a:xfrm>
-            <a:off x="713232" y="2560320"/>
-            <a:ext cx="777240" cy="658368"/>
-          </a:xfrm>
-          <a:prstGeom prst="rect">
-            <a:avLst/>
-          </a:prstGeom>
-          <a:noFill/>
-          <a:ln/>
-        </p:spPr>
-        <p:txBody>
-          <a:bodyPr wrap="square" rtlCol="0" anchor="ctr"/>
-          <a:lstStyle/>
-          <a:p>
-            <a:pPr algn="l" indent="0" marL="0">
-              <a:buNone/>
-            </a:pPr>
-            <a:r>
-              <a:rPr lang="en-US" sz="1400" b="1" dirty="0">
-                <a:solidFill>
-                  <a:srgbClr val="6E7B80"/>
-                </a:solidFill>
-                <a:latin typeface="Trebuchet MS" pitchFamily="34" charset="0"/>
-                <a:ea typeface="Trebuchet MS" pitchFamily="34" charset="-122"/>
-                <a:cs typeface="Trebuchet MS" pitchFamily="34" charset="-120"/>
-              </a:rPr>
               <a:t>2011</a:t>
             </a:r>
             <a:endParaRPr lang="en-US" sz="1400" dirty="0"/>
@@ -7756,7 +7695,7 @@
       </p:sp>
       <p:sp>
         <p:nvSpPr>
-          <p:cNvPr id="12" name="Shape 9"/>
+          <p:cNvPr id="10" name="Shape 7"/>
           <p:cNvSpPr/>
           <p:nvPr/>
         </p:nvSpPr>
@@ -7778,7 +7717,7 @@
       </p:sp>
       <p:sp>
         <p:nvSpPr>
-          <p:cNvPr id="13" name="Text 10"/>
+          <p:cNvPr id="11" name="Text 8"/>
           <p:cNvSpPr txBox="1"/>
           <p:nvPr/>
         </p:nvSpPr>
@@ -7817,7 +7756,7 @@
       </p:sp>
       <p:sp>
         <p:nvSpPr>
-          <p:cNvPr id="14" name="Text 11"/>
+          <p:cNvPr id="12" name="Text 9"/>
           <p:cNvSpPr txBox="1"/>
           <p:nvPr/>
         </p:nvSpPr>
@@ -7856,7 +7795,7 @@
       </p:sp>
       <p:sp>
         <p:nvSpPr>
-          <p:cNvPr id="15" name="Shape 12"/>
+          <p:cNvPr id="13" name="Shape 10"/>
           <p:cNvSpPr/>
           <p:nvPr/>
         </p:nvSpPr>
@@ -7878,7 +7817,7 @@
       </p:sp>
       <p:sp>
         <p:nvSpPr>
-          <p:cNvPr id="16" name="Text 13"/>
+          <p:cNvPr id="14" name="Text 11"/>
           <p:cNvSpPr txBox="1"/>
           <p:nvPr/>
         </p:nvSpPr>
@@ -7917,7 +7856,7 @@
       </p:sp>
       <p:sp>
         <p:nvSpPr>
-          <p:cNvPr id="17" name="Shape 14"/>
+          <p:cNvPr id="15" name="Shape 12"/>
           <p:cNvSpPr/>
           <p:nvPr/>
         </p:nvSpPr>
@@ -7939,7 +7878,7 @@
       </p:sp>
       <p:sp>
         <p:nvSpPr>
-          <p:cNvPr id="18" name="Text 15"/>
+          <p:cNvPr id="16" name="Text 13"/>
           <p:cNvSpPr txBox="1"/>
           <p:nvPr/>
         </p:nvSpPr>
@@ -7981,7 +7920,7 @@
       </p:sp>
       <p:sp>
         <p:nvSpPr>
-          <p:cNvPr id="19" name="Shape 16"/>
+          <p:cNvPr id="17" name="Shape 14"/>
           <p:cNvSpPr/>
           <p:nvPr/>
         </p:nvSpPr>
@@ -8008,7 +7947,7 @@
       </p:sp>
       <p:sp>
         <p:nvSpPr>
-          <p:cNvPr id="20" name="Shape 17"/>
+          <p:cNvPr id="18" name="Shape 15"/>
           <p:cNvSpPr/>
           <p:nvPr/>
         </p:nvSpPr>
@@ -8028,7 +7967,7 @@
       </p:sp>
       <p:sp>
         <p:nvSpPr>
-          <p:cNvPr id="21" name="Text 18"/>
+          <p:cNvPr id="19" name="Text 16"/>
           <p:cNvSpPr txBox="1"/>
           <p:nvPr/>
         </p:nvSpPr>
@@ -8067,7 +8006,7 @@
       </p:sp>
       <p:sp>
         <p:nvSpPr>
-          <p:cNvPr id="22" name="Text 19"/>
+          <p:cNvPr id="20" name="Text 17"/>
           <p:cNvSpPr txBox="1"/>
           <p:nvPr/>
         </p:nvSpPr>
@@ -8109,7 +8048,7 @@
       </p:sp>
       <p:sp>
         <p:nvSpPr>
-          <p:cNvPr id="23" name="Text 20"/>
+          <p:cNvPr id="21" name="Text 18"/>
           <p:cNvSpPr txBox="1"/>
           <p:nvPr/>
         </p:nvSpPr>
@@ -8148,7 +8087,7 @@
       </p:sp>
       <p:sp>
         <p:nvSpPr>
-          <p:cNvPr id="24" name="Shape 21"/>
+          <p:cNvPr id="22" name="Shape 19"/>
           <p:cNvSpPr/>
           <p:nvPr/>
         </p:nvSpPr>
@@ -8175,7 +8114,7 @@
       </p:sp>
       <p:sp>
         <p:nvSpPr>
-          <p:cNvPr id="25" name="Shape 22"/>
+          <p:cNvPr id="23" name="Shape 20"/>
           <p:cNvSpPr/>
           <p:nvPr/>
         </p:nvSpPr>
@@ -8195,7 +8134,7 @@
       </p:sp>
       <p:sp>
         <p:nvSpPr>
-          <p:cNvPr id="26" name="Text 23"/>
+          <p:cNvPr id="24" name="Text 21"/>
           <p:cNvSpPr txBox="1"/>
           <p:nvPr/>
         </p:nvSpPr>
@@ -8234,7 +8173,7 @@
       </p:sp>
       <p:sp>
         <p:nvSpPr>
-          <p:cNvPr id="27" name="Text 24"/>
+          <p:cNvPr id="25" name="Text 22"/>
           <p:cNvSpPr txBox="1"/>
           <p:nvPr/>
         </p:nvSpPr>
@@ -8276,7 +8215,7 @@
       </p:sp>
       <p:sp>
         <p:nvSpPr>
-          <p:cNvPr id="28" name="Text 25"/>
+          <p:cNvPr id="26" name="Text 23"/>
           <p:cNvSpPr txBox="1"/>
           <p:nvPr/>
         </p:nvSpPr>
@@ -8315,7 +8254,7 @@
       </p:sp>
       <p:sp>
         <p:nvSpPr>
-          <p:cNvPr id="29" name="Shape 26"/>
+          <p:cNvPr id="27" name="Shape 24"/>
           <p:cNvSpPr/>
           <p:nvPr/>
         </p:nvSpPr>
@@ -8342,7 +8281,7 @@
       </p:sp>
       <p:sp>
         <p:nvSpPr>
-          <p:cNvPr id="30" name="Shape 27"/>
+          <p:cNvPr id="28" name="Shape 25"/>
           <p:cNvSpPr/>
           <p:nvPr/>
         </p:nvSpPr>
@@ -8362,7 +8301,7 @@
       </p:sp>
       <p:sp>
         <p:nvSpPr>
-          <p:cNvPr id="31" name="Text 28"/>
+          <p:cNvPr id="29" name="Text 26"/>
           <p:cNvSpPr txBox="1"/>
           <p:nvPr/>
         </p:nvSpPr>
@@ -8401,7 +8340,7 @@
       </p:sp>
       <p:sp>
         <p:nvSpPr>
-          <p:cNvPr id="32" name="Text 29"/>
+          <p:cNvPr id="30" name="Text 27"/>
           <p:cNvSpPr txBox="1"/>
           <p:nvPr/>
         </p:nvSpPr>
@@ -8443,7 +8382,7 @@
       </p:sp>
       <p:sp>
         <p:nvSpPr>
-          <p:cNvPr id="33" name="Text 30"/>
+          <p:cNvPr id="31" name="Text 28"/>
           <p:cNvSpPr txBox="1"/>
           <p:nvPr/>
         </p:nvSpPr>
@@ -8482,7 +8421,7 @@
       </p:sp>
       <p:sp>
         <p:nvSpPr>
-          <p:cNvPr id="34" name="Shape 31"/>
+          <p:cNvPr id="32" name="Shape 29"/>
           <p:cNvSpPr/>
           <p:nvPr/>
         </p:nvSpPr>
@@ -8504,7 +8443,7 @@
       </p:sp>
       <p:sp>
         <p:nvSpPr>
-          <p:cNvPr id="35" name="Text 32"/>
+          <p:cNvPr id="33" name="Text 30"/>
           <p:cNvSpPr txBox="1"/>
           <p:nvPr/>
         </p:nvSpPr>
@@ -8546,7 +8485,7 @@
       </p:sp>
       <p:sp>
         <p:nvSpPr>
-          <p:cNvPr id="36" name="Text 33"/>
+          <p:cNvPr id="34" name="Text 31"/>
           <p:cNvSpPr txBox="1"/>
           <p:nvPr/>
         </p:nvSpPr>
@@ -8585,7 +8524,7 @@
       </p:sp>
       <p:sp>
         <p:nvSpPr>
-          <p:cNvPr id="37" name="Text 34"/>
+          <p:cNvPr id="35" name="Text 32"/>
           <p:cNvSpPr txBox="1"/>
           <p:nvPr/>
         </p:nvSpPr>
@@ -8806,12 +8745,12 @@
         </p:nvSpPr>
         <p:spPr>
           <a:xfrm>
-            <a:off x="457200" y="1773936"/>
-            <a:ext cx="5074920" cy="3749040"/>
+            <a:off x="457200" y="1810512"/>
+            <a:ext cx="3255264" cy="1828800"/>
           </a:xfrm>
           <a:prstGeom prst="roundRect">
             <a:avLst>
-              <a:gd name="adj" fmla="val 2439"/>
+              <a:gd name="adj" fmla="val 5000"/>
             </a:avLst>
           </a:prstGeom>
           <a:solidFill>
@@ -8833,12 +8772,227 @@
         </p:nvSpPr>
         <p:spPr>
           <a:xfrm>
-            <a:off x="5760720" y="1773936"/>
-            <a:ext cx="5971032" cy="3749040"/>
+            <a:off x="457200" y="1810512"/>
+            <a:ext cx="3255264" cy="64008"/>
+          </a:xfrm>
+          <a:prstGeom prst="rect">
+            <a:avLst/>
+          </a:prstGeom>
+          <a:solidFill>
+            <a:srgbClr val="0E7C7B"/>
+          </a:solidFill>
+          <a:ln/>
+        </p:spPr>
+      </p:sp>
+      <p:sp>
+        <p:nvSpPr>
+          <p:cNvPr id="9" name="Text 6"/>
+          <p:cNvSpPr txBox="1"/>
+          <p:nvPr/>
+        </p:nvSpPr>
+        <p:spPr>
+          <a:xfrm>
+            <a:off x="457200" y="1993392"/>
+            <a:ext cx="3255264" cy="219456"/>
+          </a:xfrm>
+          <a:prstGeom prst="rect">
+            <a:avLst/>
+          </a:prstGeom>
+          <a:noFill/>
+          <a:ln/>
+        </p:spPr>
+        <p:txBody>
+          <a:bodyPr wrap="square" rtlCol="0" anchor="ctr"/>
+          <a:lstStyle/>
+          <a:p>
+            <a:pPr algn="ctr" indent="0" marL="0">
+              <a:buNone/>
+            </a:pPr>
+            <a:r>
+              <a:rPr lang="en-US" sz="950" b="1" spc="200" kern="0" dirty="0">
+                <a:solidFill>
+                  <a:srgbClr val="6E7B80"/>
+                </a:solidFill>
+                <a:latin typeface="Trebuchet MS" pitchFamily="34" charset="0"/>
+                <a:ea typeface="Trebuchet MS" pitchFamily="34" charset="-122"/>
+                <a:cs typeface="Trebuchet MS" pitchFamily="34" charset="-120"/>
+              </a:rPr>
+              <a:t>À ÉQUIPER</a:t>
+            </a:r>
+            <a:endParaRPr lang="en-US" sz="950" dirty="0"/>
+          </a:p>
+        </p:txBody>
+      </p:sp>
+      <p:sp>
+        <p:nvSpPr>
+          <p:cNvPr id="10" name="Text 7"/>
+          <p:cNvSpPr txBox="1"/>
+          <p:nvPr/>
+        </p:nvSpPr>
+        <p:spPr>
+          <a:xfrm>
+            <a:off x="457200" y="2231136"/>
+            <a:ext cx="3255264" cy="804672"/>
+          </a:xfrm>
+          <a:prstGeom prst="rect">
+            <a:avLst/>
+          </a:prstGeom>
+          <a:noFill/>
+          <a:ln/>
+        </p:spPr>
+        <p:txBody>
+          <a:bodyPr wrap="square" rtlCol="0" anchor="ctr"/>
+          <a:lstStyle/>
+          <a:p>
+            <a:pPr algn="ctr" indent="0" marL="0">
+              <a:buNone/>
+            </a:pPr>
+            <a:r>
+              <a:rPr lang="en-US" sz="4400" b="1" dirty="0">
+                <a:solidFill>
+                  <a:srgbClr val="0A5C5B"/>
+                </a:solidFill>
+                <a:latin typeface="Georgia" pitchFamily="34" charset="0"/>
+                <a:ea typeface="Georgia" pitchFamily="34" charset="-122"/>
+                <a:cs typeface="Georgia" pitchFamily="34" charset="-120"/>
+              </a:rPr>
+              <a:t>≈ 810</a:t>
+            </a:r>
+            <a:endParaRPr lang="en-US" sz="4400" dirty="0"/>
+          </a:p>
+        </p:txBody>
+      </p:sp>
+      <p:sp>
+        <p:nvSpPr>
+          <p:cNvPr id="11" name="Text 8"/>
+          <p:cNvSpPr txBox="1"/>
+          <p:nvPr/>
+        </p:nvSpPr>
+        <p:spPr>
+          <a:xfrm>
+            <a:off x="457200" y="3090672"/>
+            <a:ext cx="3255264" cy="237744"/>
+          </a:xfrm>
+          <a:prstGeom prst="rect">
+            <a:avLst/>
+          </a:prstGeom>
+          <a:noFill/>
+          <a:ln/>
+        </p:spPr>
+        <p:txBody>
+          <a:bodyPr wrap="square" rtlCol="0" anchor="ctr"/>
+          <a:lstStyle/>
+          <a:p>
+            <a:pPr algn="ctr" indent="0" marL="0">
+              <a:buNone/>
+            </a:pPr>
+            <a:r>
+              <a:rPr lang="en-US" sz="1150" b="1" dirty="0">
+                <a:solidFill>
+                  <a:srgbClr val="22333B"/>
+                </a:solidFill>
+                <a:latin typeface="Trebuchet MS" pitchFamily="34" charset="0"/>
+                <a:ea typeface="Trebuchet MS" pitchFamily="34" charset="-122"/>
+                <a:cs typeface="Trebuchet MS" pitchFamily="34" charset="-120"/>
+              </a:rPr>
+              <a:t>laboratoires de sciences</a:t>
+            </a:r>
+            <a:endParaRPr lang="en-US" sz="1150" dirty="0"/>
+          </a:p>
+        </p:txBody>
+      </p:sp>
+      <p:sp>
+        <p:nvSpPr>
+          <p:cNvPr id="12" name="Text 9"/>
+          <p:cNvSpPr txBox="1"/>
+          <p:nvPr/>
+        </p:nvSpPr>
+        <p:spPr>
+          <a:xfrm>
+            <a:off x="566928" y="3328416"/>
+            <a:ext cx="3035808" cy="219456"/>
+          </a:xfrm>
+          <a:prstGeom prst="rect">
+            <a:avLst/>
+          </a:prstGeom>
+          <a:noFill/>
+          <a:ln/>
+        </p:spPr>
+        <p:txBody>
+          <a:bodyPr wrap="square" rtlCol="0" anchor="ctr"/>
+          <a:lstStyle/>
+          <a:p>
+            <a:pPr algn="ctr" indent="0" marL="0">
+              <a:buNone/>
+            </a:pPr>
+            <a:r>
+              <a:rPr lang="en-US" sz="850" i="1" dirty="0">
+                <a:solidFill>
+                  <a:srgbClr val="6E7B80"/>
+                </a:solidFill>
+                <a:latin typeface="Trebuchet MS" pitchFamily="34" charset="0"/>
+                <a:ea typeface="Trebuchet MS" pitchFamily="34" charset="-122"/>
+                <a:cs typeface="Trebuchet MS" pitchFamily="34" charset="-120"/>
+              </a:rPr>
+              <a:t>902 publics · ≈ 90 % sans laboratoire</a:t>
+            </a:r>
+            <a:endParaRPr lang="en-US" sz="850" dirty="0"/>
+          </a:p>
+        </p:txBody>
+      </p:sp>
+      <p:sp>
+        <p:nvSpPr>
+          <p:cNvPr id="13" name="Text 10"/>
+          <p:cNvSpPr txBox="1"/>
+          <p:nvPr/>
+        </p:nvSpPr>
+        <p:spPr>
+          <a:xfrm>
+            <a:off x="3712464" y="1810512"/>
+            <a:ext cx="740664" cy="1828800"/>
+          </a:xfrm>
+          <a:prstGeom prst="rect">
+            <a:avLst/>
+          </a:prstGeom>
+          <a:noFill/>
+          <a:ln/>
+        </p:spPr>
+        <p:txBody>
+          <a:bodyPr wrap="square" rtlCol="0" anchor="ctr"/>
+          <a:lstStyle/>
+          <a:p>
+            <a:pPr algn="ctr" indent="0" marL="0">
+              <a:buNone/>
+            </a:pPr>
+            <a:r>
+              <a:rPr lang="en-US" sz="2600" b="1" dirty="0">
+                <a:solidFill>
+                  <a:srgbClr val="8A959B"/>
+                </a:solidFill>
+                <a:latin typeface="Georgia" pitchFamily="34" charset="0"/>
+                <a:ea typeface="Georgia" pitchFamily="34" charset="-122"/>
+                <a:cs typeface="Georgia" pitchFamily="34" charset="-120"/>
+              </a:rPr>
+              <a:t>×</a:t>
+            </a:r>
+            <a:endParaRPr lang="en-US" sz="2600" dirty="0"/>
+          </a:p>
+        </p:txBody>
+      </p:sp>
+      <p:sp>
+        <p:nvSpPr>
+          <p:cNvPr id="14" name="Shape 11"/>
+          <p:cNvSpPr/>
+          <p:nvPr/>
+        </p:nvSpPr>
+        <p:spPr>
+          <a:xfrm>
+            <a:off x="4453128" y="1810512"/>
+            <a:ext cx="3255264" cy="1828800"/>
           </a:xfrm>
           <a:prstGeom prst="roundRect">
             <a:avLst>
-              <a:gd name="adj" fmla="val 2439"/>
+              <a:gd name="adj" fmla="val 5000"/>
             </a:avLst>
           </a:prstGeom>
           <a:solidFill>
@@ -8854,116 +9008,467 @@
       </p:sp>
       <p:sp>
         <p:nvSpPr>
-          <p:cNvPr id="9" name="Text 6"/>
-          <p:cNvSpPr txBox="1"/>
-          <p:nvPr/>
-        </p:nvSpPr>
-        <p:spPr>
-          <a:xfrm>
-            <a:off x="676656" y="1901952"/>
-            <a:ext cx="4636008" cy="274320"/>
-          </a:xfrm>
-          <a:prstGeom prst="rect">
-            <a:avLst/>
-          </a:prstGeom>
-          <a:noFill/>
-          <a:ln/>
-        </p:spPr>
-        <p:txBody>
-          <a:bodyPr wrap="square" rtlCol="0" anchor="ctr"/>
-          <a:lstStyle/>
-          <a:p>
-            <a:pPr algn="l" indent="0" marL="0">
-              <a:buNone/>
-            </a:pPr>
-            <a:r>
-              <a:rPr lang="en-US" sz="1300" b="1" dirty="0">
-                <a:solidFill>
-                  <a:srgbClr val="0A5C5B"/>
+          <p:cNvPr id="15" name="Shape 12"/>
+          <p:cNvSpPr/>
+          <p:nvPr/>
+        </p:nvSpPr>
+        <p:spPr>
+          <a:xfrm>
+            <a:off x="4453128" y="1810512"/>
+            <a:ext cx="3255264" cy="64008"/>
+          </a:xfrm>
+          <a:prstGeom prst="rect">
+            <a:avLst/>
+          </a:prstGeom>
+          <a:solidFill>
+            <a:srgbClr val="0E7C7B"/>
+          </a:solidFill>
+          <a:ln/>
+        </p:spPr>
+      </p:sp>
+      <p:sp>
+        <p:nvSpPr>
+          <p:cNvPr id="16" name="Text 13"/>
+          <p:cNvSpPr txBox="1"/>
+          <p:nvPr/>
+        </p:nvSpPr>
+        <p:spPr>
+          <a:xfrm>
+            <a:off x="4453128" y="1993392"/>
+            <a:ext cx="3255264" cy="219456"/>
+          </a:xfrm>
+          <a:prstGeom prst="rect">
+            <a:avLst/>
+          </a:prstGeom>
+          <a:noFill/>
+          <a:ln/>
+        </p:spPr>
+        <p:txBody>
+          <a:bodyPr wrap="square" rtlCol="0" anchor="ctr"/>
+          <a:lstStyle/>
+          <a:p>
+            <a:pPr algn="ctr" indent="0" marL="0">
+              <a:buNone/>
+            </a:pPr>
+            <a:r>
+              <a:rPr lang="en-US" sz="950" b="1" spc="200" kern="0" dirty="0">
+                <a:solidFill>
+                  <a:srgbClr val="6E7B80"/>
                 </a:solidFill>
                 <a:latin typeface="Trebuchet MS" pitchFamily="34" charset="0"/>
                 <a:ea typeface="Trebuchet MS" pitchFamily="34" charset="-122"/>
                 <a:cs typeface="Trebuchet MS" pitchFamily="34" charset="-120"/>
               </a:rPr>
-              <a:t>Ce que coûte un laboratoire, en vrai</a:t>
-            </a:r>
-            <a:endParaRPr lang="en-US" sz="1300" dirty="0"/>
-          </a:p>
-        </p:txBody>
-      </p:sp>
-      <p:sp>
-        <p:nvSpPr>
-          <p:cNvPr id="10" name="Text 7"/>
-          <p:cNvSpPr txBox="1"/>
-          <p:nvPr/>
-        </p:nvSpPr>
-        <p:spPr>
-          <a:xfrm>
-            <a:off x="676656" y="2286000"/>
-            <a:ext cx="1481328" cy="493776"/>
-          </a:xfrm>
-          <a:prstGeom prst="rect">
-            <a:avLst/>
-          </a:prstGeom>
-          <a:noFill/>
-          <a:ln/>
-        </p:spPr>
-        <p:txBody>
-          <a:bodyPr wrap="square" rtlCol="0" anchor="ctr"/>
-          <a:lstStyle/>
-          <a:p>
-            <a:pPr algn="l" indent="0" marL="0">
-              <a:buNone/>
-            </a:pPr>
-            <a:r>
-              <a:rPr lang="en-US" sz="2800" b="1" dirty="0">
-                <a:solidFill>
-                  <a:srgbClr val="B8431D"/>
+              <a:t>PAR LABORATOIRE</a:t>
+            </a:r>
+            <a:endParaRPr lang="en-US" sz="950" dirty="0"/>
+          </a:p>
+        </p:txBody>
+      </p:sp>
+      <p:sp>
+        <p:nvSpPr>
+          <p:cNvPr id="17" name="Text 14"/>
+          <p:cNvSpPr txBox="1"/>
+          <p:nvPr/>
+        </p:nvSpPr>
+        <p:spPr>
+          <a:xfrm>
+            <a:off x="4453128" y="2231136"/>
+            <a:ext cx="3255264" cy="804672"/>
+          </a:xfrm>
+          <a:prstGeom prst="rect">
+            <a:avLst/>
+          </a:prstGeom>
+          <a:noFill/>
+          <a:ln/>
+        </p:spPr>
+        <p:txBody>
+          <a:bodyPr wrap="square" rtlCol="0" anchor="ctr"/>
+          <a:lstStyle/>
+          <a:p>
+            <a:pPr algn="ctr" indent="0" marL="0">
+              <a:buNone/>
+            </a:pPr>
+            <a:r>
+              <a:rPr lang="en-US" sz="4400" b="1" dirty="0">
+                <a:solidFill>
+                  <a:srgbClr val="0A5C5B"/>
                 </a:solidFill>
                 <a:latin typeface="Georgia" pitchFamily="34" charset="0"/>
                 <a:ea typeface="Georgia" pitchFamily="34" charset="-122"/>
                 <a:cs typeface="Georgia" pitchFamily="34" charset="-120"/>
               </a:rPr>
-              <a:t>12 M</a:t>
-            </a:r>
-            <a:endParaRPr lang="en-US" sz="2800" dirty="0"/>
-          </a:p>
-        </p:txBody>
-      </p:sp>
-      <p:sp>
-        <p:nvSpPr>
-          <p:cNvPr id="11" name="Text 8"/>
-          <p:cNvSpPr txBox="1"/>
-          <p:nvPr/>
-        </p:nvSpPr>
-        <p:spPr>
-          <a:xfrm>
-            <a:off x="1938528" y="2340864"/>
-            <a:ext cx="566928" cy="384048"/>
-          </a:xfrm>
-          <a:prstGeom prst="rect">
-            <a:avLst/>
-          </a:prstGeom>
-          <a:noFill/>
-          <a:ln/>
-        </p:spPr>
-        <p:txBody>
-          <a:bodyPr wrap="square" rtlCol="0" anchor="ctr"/>
-          <a:lstStyle/>
-          <a:p>
-            <a:pPr algn="l" indent="0" marL="0">
-              <a:buNone/>
-            </a:pPr>
-            <a:r>
-              <a:rPr lang="en-US" sz="1050" b="1" dirty="0">
-                <a:solidFill>
-                  <a:srgbClr val="6E7B80"/>
+              <a:t>≈ 3 M</a:t>
+            </a:r>
+            <a:endParaRPr lang="en-US" sz="4400" dirty="0"/>
+          </a:p>
+        </p:txBody>
+      </p:sp>
+      <p:sp>
+        <p:nvSpPr>
+          <p:cNvPr id="18" name="Text 15"/>
+          <p:cNvSpPr txBox="1"/>
+          <p:nvPr/>
+        </p:nvSpPr>
+        <p:spPr>
+          <a:xfrm>
+            <a:off x="4453128" y="3090672"/>
+            <a:ext cx="3255264" cy="237744"/>
+          </a:xfrm>
+          <a:prstGeom prst="rect">
+            <a:avLst/>
+          </a:prstGeom>
+          <a:noFill/>
+          <a:ln/>
+        </p:spPr>
+        <p:txBody>
+          <a:bodyPr wrap="square" rtlCol="0" anchor="ctr"/>
+          <a:lstStyle/>
+          <a:p>
+            <a:pPr algn="ctr" indent="0" marL="0">
+              <a:buNone/>
+            </a:pPr>
+            <a:r>
+              <a:rPr lang="en-US" sz="1150" b="1" dirty="0">
+                <a:solidFill>
+                  <a:srgbClr val="22333B"/>
                 </a:solidFill>
                 <a:latin typeface="Trebuchet MS" pitchFamily="34" charset="0"/>
                 <a:ea typeface="Trebuchet MS" pitchFamily="34" charset="-122"/>
                 <a:cs typeface="Trebuchet MS" pitchFamily="34" charset="-120"/>
               </a:rPr>
-              <a:t>FCFA</a:t>
+              <a:t>FCFA · formule minimale « kits »</a:t>
+            </a:r>
+            <a:endParaRPr lang="en-US" sz="1150" dirty="0"/>
+          </a:p>
+        </p:txBody>
+      </p:sp>
+      <p:sp>
+        <p:nvSpPr>
+          <p:cNvPr id="19" name="Text 16"/>
+          <p:cNvSpPr txBox="1"/>
+          <p:nvPr/>
+        </p:nvSpPr>
+        <p:spPr>
+          <a:xfrm>
+            <a:off x="4562856" y="3328416"/>
+            <a:ext cx="3035808" cy="219456"/>
+          </a:xfrm>
+          <a:prstGeom prst="rect">
+            <a:avLst/>
+          </a:prstGeom>
+          <a:noFill/>
+          <a:ln/>
+        </p:spPr>
+        <p:txBody>
+          <a:bodyPr wrap="square" rtlCol="0" anchor="ctr"/>
+          <a:lstStyle/>
+          <a:p>
+            <a:pPr algn="ctr" indent="0" marL="0">
+              <a:buNone/>
+            </a:pPr>
+            <a:r>
+              <a:rPr lang="en-US" sz="850" i="1" dirty="0">
+                <a:solidFill>
+                  <a:srgbClr val="6E7B80"/>
+                </a:solidFill>
+                <a:latin typeface="Trebuchet MS" pitchFamily="34" charset="0"/>
+                <a:ea typeface="Trebuchet MS" pitchFamily="34" charset="-122"/>
+                <a:cs typeface="Trebuchet MS" pitchFamily="34" charset="-120"/>
+              </a:rPr>
+              <a:t>mobilier + kits PC/SVT · marché togolais</a:t>
+            </a:r>
+            <a:endParaRPr lang="en-US" sz="850" dirty="0"/>
+          </a:p>
+        </p:txBody>
+      </p:sp>
+      <p:sp>
+        <p:nvSpPr>
+          <p:cNvPr id="20" name="Text 17"/>
+          <p:cNvSpPr txBox="1"/>
+          <p:nvPr/>
+        </p:nvSpPr>
+        <p:spPr>
+          <a:xfrm>
+            <a:off x="7708392" y="1810512"/>
+            <a:ext cx="740664" cy="1828800"/>
+          </a:xfrm>
+          <a:prstGeom prst="rect">
+            <a:avLst/>
+          </a:prstGeom>
+          <a:noFill/>
+          <a:ln/>
+        </p:spPr>
+        <p:txBody>
+          <a:bodyPr wrap="square" rtlCol="0" anchor="ctr"/>
+          <a:lstStyle/>
+          <a:p>
+            <a:pPr algn="ctr" indent="0" marL="0">
+              <a:buNone/>
+            </a:pPr>
+            <a:r>
+              <a:rPr lang="en-US" sz="2600" b="1" dirty="0">
+                <a:solidFill>
+                  <a:srgbClr val="8A959B"/>
+                </a:solidFill>
+                <a:latin typeface="Georgia" pitchFamily="34" charset="0"/>
+                <a:ea typeface="Georgia" pitchFamily="34" charset="-122"/>
+                <a:cs typeface="Georgia" pitchFamily="34" charset="-120"/>
+              </a:rPr>
+              <a:t>=</a:t>
+            </a:r>
+            <a:endParaRPr lang="en-US" sz="2600" dirty="0"/>
+          </a:p>
+        </p:txBody>
+      </p:sp>
+      <p:sp>
+        <p:nvSpPr>
+          <p:cNvPr id="21" name="Shape 18"/>
+          <p:cNvSpPr/>
+          <p:nvPr/>
+        </p:nvSpPr>
+        <p:spPr>
+          <a:xfrm>
+            <a:off x="8449056" y="1810512"/>
+            <a:ext cx="3255264" cy="1828800"/>
+          </a:xfrm>
+          <a:prstGeom prst="roundRect">
+            <a:avLst>
+              <a:gd name="adj" fmla="val 5000"/>
+            </a:avLst>
+          </a:prstGeom>
+          <a:solidFill>
+            <a:srgbClr val="E0592A"/>
+          </a:solidFill>
+          <a:ln/>
+        </p:spPr>
+      </p:sp>
+      <p:sp>
+        <p:nvSpPr>
+          <p:cNvPr id="22" name="Text 19"/>
+          <p:cNvSpPr txBox="1"/>
+          <p:nvPr/>
+        </p:nvSpPr>
+        <p:spPr>
+          <a:xfrm>
+            <a:off x="8449056" y="1993392"/>
+            <a:ext cx="3255264" cy="219456"/>
+          </a:xfrm>
+          <a:prstGeom prst="rect">
+            <a:avLst/>
+          </a:prstGeom>
+          <a:noFill/>
+          <a:ln/>
+        </p:spPr>
+        <p:txBody>
+          <a:bodyPr wrap="square" rtlCol="0" anchor="ctr"/>
+          <a:lstStyle/>
+          <a:p>
+            <a:pPr algn="ctr" indent="0" marL="0">
+              <a:buNone/>
+            </a:pPr>
+            <a:r>
+              <a:rPr lang="en-US" sz="950" b="1" spc="200" kern="0" dirty="0">
+                <a:solidFill>
+                  <a:srgbClr val="F8E4D9"/>
+                </a:solidFill>
+                <a:latin typeface="Trebuchet MS" pitchFamily="34" charset="0"/>
+                <a:ea typeface="Trebuchet MS" pitchFamily="34" charset="-122"/>
+                <a:cs typeface="Trebuchet MS" pitchFamily="34" charset="-120"/>
+              </a:rPr>
+              <a:t>LA FACTURE NATIONALE</a:t>
+            </a:r>
+            <a:endParaRPr lang="en-US" sz="950" dirty="0"/>
+          </a:p>
+        </p:txBody>
+      </p:sp>
+      <p:sp>
+        <p:nvSpPr>
+          <p:cNvPr id="23" name="Text 20"/>
+          <p:cNvSpPr txBox="1"/>
+          <p:nvPr/>
+        </p:nvSpPr>
+        <p:spPr>
+          <a:xfrm>
+            <a:off x="8449056" y="2231136"/>
+            <a:ext cx="3255264" cy="804672"/>
+          </a:xfrm>
+          <a:prstGeom prst="rect">
+            <a:avLst/>
+          </a:prstGeom>
+          <a:noFill/>
+          <a:ln/>
+        </p:spPr>
+        <p:txBody>
+          <a:bodyPr wrap="square" rtlCol="0" anchor="ctr"/>
+          <a:lstStyle/>
+          <a:p>
+            <a:pPr algn="ctr" indent="0" marL="0">
+              <a:buNone/>
+            </a:pPr>
+            <a:r>
+              <a:rPr lang="en-US" sz="4400" b="1" dirty="0">
+                <a:solidFill>
+                  <a:srgbClr val="FFFFFF"/>
+                </a:solidFill>
+                <a:latin typeface="Georgia" pitchFamily="34" charset="0"/>
+                <a:ea typeface="Georgia" pitchFamily="34" charset="-122"/>
+                <a:cs typeface="Georgia" pitchFamily="34" charset="-120"/>
+              </a:rPr>
+              <a:t>2,4 Md</a:t>
+            </a:r>
+            <a:endParaRPr lang="en-US" sz="4400" dirty="0"/>
+          </a:p>
+        </p:txBody>
+      </p:sp>
+      <p:sp>
+        <p:nvSpPr>
+          <p:cNvPr id="24" name="Text 21"/>
+          <p:cNvSpPr txBox="1"/>
+          <p:nvPr/>
+        </p:nvSpPr>
+        <p:spPr>
+          <a:xfrm>
+            <a:off x="8449056" y="3090672"/>
+            <a:ext cx="3255264" cy="237744"/>
+          </a:xfrm>
+          <a:prstGeom prst="rect">
+            <a:avLst/>
+          </a:prstGeom>
+          <a:noFill/>
+          <a:ln/>
+        </p:spPr>
+        <p:txBody>
+          <a:bodyPr wrap="square" rtlCol="0" anchor="ctr"/>
+          <a:lstStyle/>
+          <a:p>
+            <a:pPr algn="ctr" indent="0" marL="0">
+              <a:buNone/>
+            </a:pPr>
+            <a:r>
+              <a:rPr lang="en-US" sz="1150" b="1" dirty="0">
+                <a:solidFill>
+                  <a:srgbClr val="FFFFFF"/>
+                </a:solidFill>
+                <a:latin typeface="Trebuchet MS" pitchFamily="34" charset="0"/>
+                <a:ea typeface="Trebuchet MS" pitchFamily="34" charset="-122"/>
+                <a:cs typeface="Trebuchet MS" pitchFamily="34" charset="-120"/>
+              </a:rPr>
+              <a:t>FCFA · minimum national</a:t>
+            </a:r>
+            <a:endParaRPr lang="en-US" sz="1150" dirty="0"/>
+          </a:p>
+        </p:txBody>
+      </p:sp>
+      <p:sp>
+        <p:nvSpPr>
+          <p:cNvPr id="25" name="Text 22"/>
+          <p:cNvSpPr txBox="1"/>
+          <p:nvPr/>
+        </p:nvSpPr>
+        <p:spPr>
+          <a:xfrm>
+            <a:off x="8558784" y="3328416"/>
+            <a:ext cx="3035808" cy="219456"/>
+          </a:xfrm>
+          <a:prstGeom prst="rect">
+            <a:avLst/>
+          </a:prstGeom>
+          <a:noFill/>
+          <a:ln/>
+        </p:spPr>
+        <p:txBody>
+          <a:bodyPr wrap="square" rtlCol="0" anchor="ctr"/>
+          <a:lstStyle/>
+          <a:p>
+            <a:pPr algn="ctr" indent="0" marL="0">
+              <a:buNone/>
+            </a:pPr>
+            <a:r>
+              <a:rPr lang="en-US" sz="850" i="1" dirty="0">
+                <a:solidFill>
+                  <a:srgbClr val="F8E4D9"/>
+                </a:solidFill>
+                <a:latin typeface="Trebuchet MS" pitchFamily="34" charset="0"/>
+                <a:ea typeface="Trebuchet MS" pitchFamily="34" charset="-122"/>
+                <a:cs typeface="Trebuchet MS" pitchFamily="34" charset="-120"/>
+              </a:rPr>
+              <a:t>hors salles neuves et raccordements électriques</a:t>
+            </a:r>
+            <a:endParaRPr lang="en-US" sz="850" dirty="0"/>
+          </a:p>
+        </p:txBody>
+      </p:sp>
+      <p:sp>
+        <p:nvSpPr>
+          <p:cNvPr id="26" name="Shape 23"/>
+          <p:cNvSpPr/>
+          <p:nvPr/>
+        </p:nvSpPr>
+        <p:spPr>
+          <a:xfrm>
+            <a:off x="457200" y="3822192"/>
+            <a:ext cx="11247120" cy="457200"/>
+          </a:xfrm>
+          <a:prstGeom prst="roundRect">
+            <a:avLst>
+              <a:gd name="adj" fmla="val 18000"/>
+            </a:avLst>
+          </a:prstGeom>
+          <a:solidFill>
+            <a:srgbClr val="EDE8DA"/>
+          </a:solidFill>
+          <a:ln/>
+        </p:spPr>
+      </p:sp>
+      <p:sp>
+        <p:nvSpPr>
+          <p:cNvPr id="27" name="Text 24"/>
+          <p:cNvSpPr txBox="1"/>
+          <p:nvPr/>
+        </p:nvSpPr>
+        <p:spPr>
+          <a:xfrm>
+            <a:off x="731520" y="3822192"/>
+            <a:ext cx="10698480" cy="457200"/>
+          </a:xfrm>
+          <a:prstGeom prst="rect">
+            <a:avLst/>
+          </a:prstGeom>
+          <a:noFill/>
+          <a:ln/>
+        </p:spPr>
+        <p:txBody>
+          <a:bodyPr wrap="square" rtlCol="0" anchor="ctr"/>
+          <a:lstStyle/>
+          <a:p>
+            <a:pPr algn="l" indent="0" marL="0">
+              <a:buNone/>
+            </a:pPr>
+            <a:r>
+              <a:rPr lang="en-US" sz="1050" b="1" dirty="0">
+                <a:solidFill>
+                  <a:srgbClr val="22333B"/>
+                </a:solidFill>
+                <a:latin typeface="Trebuchet MS" pitchFamily="34" charset="0"/>
+                <a:ea typeface="Trebuchet MS" pitchFamily="34" charset="-122"/>
+                <a:cs typeface="Trebuchet MS" pitchFamily="34" charset="-120"/>
+              </a:rPr>
+              <a:t>Référence standard : </a:t>
+            </a:r>
+            <a:pPr algn="l" indent="0" marL="0">
+              <a:buNone/>
+            </a:pPr>
+            <a:r>
+              <a:rPr lang="en-US" sz="1050" dirty="0">
+                <a:solidFill>
+                  <a:srgbClr val="22333B"/>
+                </a:solidFill>
+                <a:latin typeface="Trebuchet MS" pitchFamily="34" charset="0"/>
+                <a:ea typeface="Trebuchet MS" pitchFamily="34" charset="-122"/>
+                <a:cs typeface="Trebuchet MS" pitchFamily="34" charset="-120"/>
+              </a:rPr>
+              <a:t>12 M FCFA par laboratoire (rénovation réelle du lycée de Tsévié 1, UNICEF 2025). Au standard : 9,7 Md FCFA.</a:t>
             </a:r>
             <a:endParaRPr lang="en-US" sz="1050" dirty="0"/>
           </a:p>
@@ -8971,14 +9476,80 @@
       </p:sp>
       <p:sp>
         <p:nvSpPr>
-          <p:cNvPr id="12" name="Shape 9"/>
+          <p:cNvPr id="28" name="Shape 25"/>
           <p:cNvSpPr/>
           <p:nvPr/>
         </p:nvSpPr>
         <p:spPr>
           <a:xfrm>
-            <a:off x="3502152" y="2368296"/>
-            <a:ext cx="1810512" cy="329184"/>
+            <a:off x="457200" y="4443984"/>
+            <a:ext cx="11247120" cy="1645920"/>
+          </a:xfrm>
+          <a:prstGeom prst="roundRect">
+            <a:avLst>
+              <a:gd name="adj" fmla="val 5556"/>
+            </a:avLst>
+          </a:prstGeom>
+          <a:solidFill>
+            <a:srgbClr val="FFFFFF"/>
+          </a:solidFill>
+          <a:ln w="15875">
+            <a:solidFill>
+              <a:srgbClr val="DCEBEA"/>
+            </a:solidFill>
+            <a:prstDash val="solid"/>
+          </a:ln>
+        </p:spPr>
+      </p:sp>
+      <p:sp>
+        <p:nvSpPr>
+          <p:cNvPr id="29" name="Text 26"/>
+          <p:cNvSpPr txBox="1"/>
+          <p:nvPr/>
+        </p:nvSpPr>
+        <p:spPr>
+          <a:xfrm>
+            <a:off x="694944" y="4681728"/>
+            <a:ext cx="1828800" cy="274320"/>
+          </a:xfrm>
+          <a:prstGeom prst="rect">
+            <a:avLst/>
+          </a:prstGeom>
+          <a:noFill/>
+          <a:ln/>
+        </p:spPr>
+        <p:txBody>
+          <a:bodyPr wrap="square" rtlCol="0" anchor="ctr"/>
+          <a:lstStyle/>
+          <a:p>
+            <a:pPr algn="r" indent="0" marL="0">
+              <a:buNone/>
+            </a:pPr>
+            <a:r>
+              <a:rPr lang="en-US" sz="950" dirty="0">
+                <a:solidFill>
+                  <a:srgbClr val="22333B"/>
+                </a:solidFill>
+                <a:latin typeface="Trebuchet MS" pitchFamily="34" charset="0"/>
+                <a:ea typeface="Trebuchet MS" pitchFamily="34" charset="-122"/>
+                <a:cs typeface="Trebuchet MS" pitchFamily="34" charset="-120"/>
+              </a:rPr>
+              <a:t>Standard complet</a:t>
+            </a:r>
+            <a:endParaRPr lang="en-US" sz="950" dirty="0"/>
+          </a:p>
+        </p:txBody>
+      </p:sp>
+      <p:sp>
+        <p:nvSpPr>
+          <p:cNvPr id="30" name="Shape 27"/>
+          <p:cNvSpPr/>
+          <p:nvPr/>
+        </p:nvSpPr>
+        <p:spPr>
+          <a:xfrm>
+            <a:off x="2651760" y="4732020"/>
+            <a:ext cx="4206240" cy="173736"/>
           </a:xfrm>
           <a:prstGeom prst="roundRect">
             <a:avLst>
@@ -8986,60 +9557,385 @@
             </a:avLst>
           </a:prstGeom>
           <a:solidFill>
-            <a:srgbClr val="F8E4D9"/>
+            <a:srgbClr val="EDE8DA"/>
           </a:solidFill>
           <a:ln/>
         </p:spPr>
       </p:sp>
       <p:sp>
         <p:nvSpPr>
-          <p:cNvPr id="13" name="Text 10"/>
-          <p:cNvSpPr txBox="1"/>
-          <p:nvPr/>
-        </p:nvSpPr>
-        <p:spPr>
-          <a:xfrm>
-            <a:off x="3502152" y="2368296"/>
-            <a:ext cx="1810512" cy="329184"/>
-          </a:xfrm>
-          <a:prstGeom prst="rect">
-            <a:avLst/>
-          </a:prstGeom>
-          <a:noFill/>
-          <a:ln/>
-        </p:spPr>
-        <p:txBody>
-          <a:bodyPr wrap="square" rtlCol="0" anchor="ctr"/>
-          <a:lstStyle/>
-          <a:p>
-            <a:pPr algn="ctr" indent="0" marL="0">
-              <a:buNone/>
-            </a:pPr>
-            <a:r>
-              <a:rPr lang="en-US" sz="850" b="1" spc="100" kern="0" dirty="0">
-                <a:solidFill>
-                  <a:srgbClr val="B8431D"/>
+          <p:cNvPr id="31" name="Shape 28"/>
+          <p:cNvSpPr/>
+          <p:nvPr/>
+        </p:nvSpPr>
+        <p:spPr>
+          <a:xfrm>
+            <a:off x="2651760" y="4732020"/>
+            <a:ext cx="4206240" cy="173736"/>
+          </a:xfrm>
+          <a:prstGeom prst="roundRect">
+            <a:avLst>
+              <a:gd name="adj" fmla="val 50000"/>
+            </a:avLst>
+          </a:prstGeom>
+          <a:solidFill>
+            <a:srgbClr val="8A959B"/>
+          </a:solidFill>
+          <a:ln/>
+        </p:spPr>
+      </p:sp>
+      <p:sp>
+        <p:nvSpPr>
+          <p:cNvPr id="32" name="Text 29"/>
+          <p:cNvSpPr txBox="1"/>
+          <p:nvPr/>
+        </p:nvSpPr>
+        <p:spPr>
+          <a:xfrm>
+            <a:off x="6949440" y="4681728"/>
+            <a:ext cx="914400" cy="274320"/>
+          </a:xfrm>
+          <a:prstGeom prst="rect">
+            <a:avLst/>
+          </a:prstGeom>
+          <a:noFill/>
+          <a:ln/>
+        </p:spPr>
+        <p:txBody>
+          <a:bodyPr wrap="square" rtlCol="0" anchor="ctr"/>
+          <a:lstStyle/>
+          <a:p>
+            <a:pPr algn="l" indent="0" marL="0">
+              <a:buNone/>
+            </a:pPr>
+            <a:r>
+              <a:rPr lang="en-US" sz="1200" b="1" dirty="0">
+                <a:solidFill>
+                  <a:srgbClr val="22333B"/>
+                </a:solidFill>
+                <a:latin typeface="Georgia" pitchFamily="34" charset="0"/>
+                <a:ea typeface="Georgia" pitchFamily="34" charset="-122"/>
+                <a:cs typeface="Georgia" pitchFamily="34" charset="-120"/>
+              </a:rPr>
+              <a:t>9,7 Md</a:t>
+            </a:r>
+            <a:endParaRPr lang="en-US" sz="1200" dirty="0"/>
+          </a:p>
+        </p:txBody>
+      </p:sp>
+      <p:sp>
+        <p:nvSpPr>
+          <p:cNvPr id="33" name="Text 30"/>
+          <p:cNvSpPr txBox="1"/>
+          <p:nvPr/>
+        </p:nvSpPr>
+        <p:spPr>
+          <a:xfrm>
+            <a:off x="694944" y="5138928"/>
+            <a:ext cx="1828800" cy="274320"/>
+          </a:xfrm>
+          <a:prstGeom prst="rect">
+            <a:avLst/>
+          </a:prstGeom>
+          <a:noFill/>
+          <a:ln/>
+        </p:spPr>
+        <p:txBody>
+          <a:bodyPr wrap="square" rtlCol="0" anchor="ctr"/>
+          <a:lstStyle/>
+          <a:p>
+            <a:pPr algn="r" indent="0" marL="0">
+              <a:buNone/>
+            </a:pPr>
+            <a:r>
+              <a:rPr lang="en-US" sz="950" dirty="0">
+                <a:solidFill>
+                  <a:srgbClr val="22333B"/>
                 </a:solidFill>
                 <a:latin typeface="Trebuchet MS" pitchFamily="34" charset="0"/>
                 <a:ea typeface="Trebuchet MS" pitchFamily="34" charset="-122"/>
                 <a:cs typeface="Trebuchet MS" pitchFamily="34" charset="-120"/>
               </a:rPr>
-              <a:t>STANDARD COMPLET</a:t>
-            </a:r>
-            <a:endParaRPr lang="en-US" sz="850" dirty="0"/>
-          </a:p>
-        </p:txBody>
-      </p:sp>
-      <p:sp>
-        <p:nvSpPr>
-          <p:cNvPr id="14" name="Text 11"/>
-          <p:cNvSpPr txBox="1"/>
-          <p:nvPr/>
-        </p:nvSpPr>
-        <p:spPr>
-          <a:xfrm>
-            <a:off x="676656" y="2798064"/>
-            <a:ext cx="4636008" cy="512064"/>
+              <a:t>Minimum « kits »</a:t>
+            </a:r>
+            <a:endParaRPr lang="en-US" sz="950" dirty="0"/>
+          </a:p>
+        </p:txBody>
+      </p:sp>
+      <p:sp>
+        <p:nvSpPr>
+          <p:cNvPr id="34" name="Shape 31"/>
+          <p:cNvSpPr/>
+          <p:nvPr/>
+        </p:nvSpPr>
+        <p:spPr>
+          <a:xfrm>
+            <a:off x="2651760" y="5189220"/>
+            <a:ext cx="4206240" cy="173736"/>
+          </a:xfrm>
+          <a:prstGeom prst="roundRect">
+            <a:avLst>
+              <a:gd name="adj" fmla="val 50000"/>
+            </a:avLst>
+          </a:prstGeom>
+          <a:solidFill>
+            <a:srgbClr val="EDE8DA"/>
+          </a:solidFill>
+          <a:ln/>
+        </p:spPr>
+      </p:sp>
+      <p:sp>
+        <p:nvSpPr>
+          <p:cNvPr id="35" name="Shape 32"/>
+          <p:cNvSpPr/>
+          <p:nvPr/>
+        </p:nvSpPr>
+        <p:spPr>
+          <a:xfrm>
+            <a:off x="2651760" y="5189220"/>
+            <a:ext cx="1051560" cy="173736"/>
+          </a:xfrm>
+          <a:prstGeom prst="roundRect">
+            <a:avLst>
+              <a:gd name="adj" fmla="val 50000"/>
+            </a:avLst>
+          </a:prstGeom>
+          <a:solidFill>
+            <a:srgbClr val="E0592A"/>
+          </a:solidFill>
+          <a:ln/>
+        </p:spPr>
+      </p:sp>
+      <p:sp>
+        <p:nvSpPr>
+          <p:cNvPr id="36" name="Text 33"/>
+          <p:cNvSpPr txBox="1"/>
+          <p:nvPr/>
+        </p:nvSpPr>
+        <p:spPr>
+          <a:xfrm>
+            <a:off x="6949440" y="5138928"/>
+            <a:ext cx="914400" cy="274320"/>
+          </a:xfrm>
+          <a:prstGeom prst="rect">
+            <a:avLst/>
+          </a:prstGeom>
+          <a:noFill/>
+          <a:ln/>
+        </p:spPr>
+        <p:txBody>
+          <a:bodyPr wrap="square" rtlCol="0" anchor="ctr"/>
+          <a:lstStyle/>
+          <a:p>
+            <a:pPr algn="l" indent="0" marL="0">
+              <a:buNone/>
+            </a:pPr>
+            <a:r>
+              <a:rPr lang="en-US" sz="1200" b="1" dirty="0">
+                <a:solidFill>
+                  <a:srgbClr val="B8431D"/>
+                </a:solidFill>
+                <a:latin typeface="Georgia" pitchFamily="34" charset="0"/>
+                <a:ea typeface="Georgia" pitchFamily="34" charset="-122"/>
+                <a:cs typeface="Georgia" pitchFamily="34" charset="-120"/>
+              </a:rPr>
+              <a:t>2,4 Md</a:t>
+            </a:r>
+            <a:endParaRPr lang="en-US" sz="1200" dirty="0"/>
+          </a:p>
+        </p:txBody>
+      </p:sp>
+      <p:sp>
+        <p:nvSpPr>
+          <p:cNvPr id="37" name="Text 34"/>
+          <p:cNvSpPr txBox="1"/>
+          <p:nvPr/>
+        </p:nvSpPr>
+        <p:spPr>
+          <a:xfrm>
+            <a:off x="694944" y="5596128"/>
+            <a:ext cx="1828800" cy="274320"/>
+          </a:xfrm>
+          <a:prstGeom prst="rect">
+            <a:avLst/>
+          </a:prstGeom>
+          <a:noFill/>
+          <a:ln/>
+        </p:spPr>
+        <p:txBody>
+          <a:bodyPr wrap="square" rtlCol="0" anchor="ctr"/>
+          <a:lstStyle/>
+          <a:p>
+            <a:pPr algn="r" indent="0" marL="0">
+              <a:buNone/>
+            </a:pPr>
+            <a:r>
+              <a:rPr lang="en-US" sz="950" dirty="0">
+                <a:solidFill>
+                  <a:srgbClr val="22333B"/>
+                </a:solidFill>
+                <a:latin typeface="Trebuchet MS" pitchFamily="34" charset="0"/>
+                <a:ea typeface="Trebuchet MS" pitchFamily="34" charset="-122"/>
+                <a:cs typeface="Trebuchet MS" pitchFamily="34" charset="-120"/>
+              </a:rPr>
+              <a:t>VirtuLab · 3 ans</a:t>
+            </a:r>
+            <a:endParaRPr lang="en-US" sz="950" dirty="0"/>
+          </a:p>
+        </p:txBody>
+      </p:sp>
+      <p:sp>
+        <p:nvSpPr>
+          <p:cNvPr id="38" name="Shape 35"/>
+          <p:cNvSpPr/>
+          <p:nvPr/>
+        </p:nvSpPr>
+        <p:spPr>
+          <a:xfrm>
+            <a:off x="2651760" y="5646420"/>
+            <a:ext cx="4206240" cy="173736"/>
+          </a:xfrm>
+          <a:prstGeom prst="roundRect">
+            <a:avLst>
+              <a:gd name="adj" fmla="val 50000"/>
+            </a:avLst>
+          </a:prstGeom>
+          <a:solidFill>
+            <a:srgbClr val="EDE8DA"/>
+          </a:solidFill>
+          <a:ln/>
+        </p:spPr>
+      </p:sp>
+      <p:sp>
+        <p:nvSpPr>
+          <p:cNvPr id="39" name="Shape 36"/>
+          <p:cNvSpPr/>
+          <p:nvPr/>
+        </p:nvSpPr>
+        <p:spPr>
+          <a:xfrm>
+            <a:off x="2651760" y="5646420"/>
+            <a:ext cx="128524" cy="173736"/>
+          </a:xfrm>
+          <a:prstGeom prst="roundRect">
+            <a:avLst>
+              <a:gd name="adj" fmla="val 67589"/>
+            </a:avLst>
+          </a:prstGeom>
+          <a:solidFill>
+            <a:srgbClr val="0E7C7B"/>
+          </a:solidFill>
+          <a:ln/>
+        </p:spPr>
+      </p:sp>
+      <p:sp>
+        <p:nvSpPr>
+          <p:cNvPr id="40" name="Text 37"/>
+          <p:cNvSpPr txBox="1"/>
+          <p:nvPr/>
+        </p:nvSpPr>
+        <p:spPr>
+          <a:xfrm>
+            <a:off x="6949440" y="5596128"/>
+            <a:ext cx="914400" cy="274320"/>
+          </a:xfrm>
+          <a:prstGeom prst="rect">
+            <a:avLst/>
+          </a:prstGeom>
+          <a:noFill/>
+          <a:ln/>
+        </p:spPr>
+        <p:txBody>
+          <a:bodyPr wrap="square" rtlCol="0" anchor="ctr"/>
+          <a:lstStyle/>
+          <a:p>
+            <a:pPr algn="l" indent="0" marL="0">
+              <a:buNone/>
+            </a:pPr>
+            <a:r>
+              <a:rPr lang="en-US" sz="1200" b="1" dirty="0">
+                <a:solidFill>
+                  <a:srgbClr val="0A5C5B"/>
+                </a:solidFill>
+                <a:latin typeface="Georgia" pitchFamily="34" charset="0"/>
+                <a:ea typeface="Georgia" pitchFamily="34" charset="-122"/>
+                <a:cs typeface="Georgia" pitchFamily="34" charset="-120"/>
+              </a:rPr>
+              <a:t>297 M</a:t>
+            </a:r>
+            <a:endParaRPr lang="en-US" sz="1200" dirty="0"/>
+          </a:p>
+        </p:txBody>
+      </p:sp>
+      <p:sp>
+        <p:nvSpPr>
+          <p:cNvPr id="41" name="Shape 38"/>
+          <p:cNvSpPr/>
+          <p:nvPr/>
+        </p:nvSpPr>
+        <p:spPr>
+          <a:xfrm>
+            <a:off x="8092440" y="4700016"/>
+            <a:ext cx="12802" cy="1152144"/>
+          </a:xfrm>
+          <a:prstGeom prst="rect">
+            <a:avLst/>
+          </a:prstGeom>
+          <a:solidFill>
+            <a:srgbClr val="EDE8DA"/>
+          </a:solidFill>
+          <a:ln/>
+        </p:spPr>
+      </p:sp>
+      <p:sp>
+        <p:nvSpPr>
+          <p:cNvPr id="42" name="Text 39"/>
+          <p:cNvSpPr txBox="1"/>
+          <p:nvPr/>
+        </p:nvSpPr>
+        <p:spPr>
+          <a:xfrm>
+            <a:off x="8321040" y="4736592"/>
+            <a:ext cx="3108960" cy="566928"/>
+          </a:xfrm>
+          <a:prstGeom prst="rect">
+            <a:avLst/>
+          </a:prstGeom>
+          <a:noFill/>
+          <a:ln/>
+        </p:spPr>
+        <p:txBody>
+          <a:bodyPr wrap="square" rtlCol="0" anchor="ctr"/>
+          <a:lstStyle/>
+          <a:p>
+            <a:pPr algn="l" indent="0" marL="0">
+              <a:buNone/>
+            </a:pPr>
+            <a:r>
+              <a:rPr lang="en-US" sz="3000" b="1" dirty="0">
+                <a:solidFill>
+                  <a:srgbClr val="B8431D"/>
+                </a:solidFill>
+                <a:latin typeface="Georgia" pitchFamily="34" charset="0"/>
+                <a:ea typeface="Georgia" pitchFamily="34" charset="-122"/>
+                <a:cs typeface="Georgia" pitchFamily="34" charset="-120"/>
+              </a:rPr>
+              <a:t>8 à 33 fois</a:t>
+            </a:r>
+            <a:endParaRPr lang="en-US" sz="3000" dirty="0"/>
+          </a:p>
+        </p:txBody>
+      </p:sp>
+      <p:sp>
+        <p:nvSpPr>
+          <p:cNvPr id="43" name="Text 40"/>
+          <p:cNvSpPr txBox="1"/>
+          <p:nvPr/>
+        </p:nvSpPr>
+        <p:spPr>
+          <a:xfrm>
+            <a:off x="8321040" y="5376672"/>
+            <a:ext cx="2926080" cy="512064"/>
           </a:xfrm>
           <a:prstGeom prst="rect">
             <a:avLst/>
@@ -9058,30 +9954,30 @@
               <a:buNone/>
             </a:pPr>
             <a:r>
-              <a:rPr lang="en-US" sz="1050" dirty="0">
-                <a:solidFill>
-                  <a:srgbClr val="22333B"/>
+              <a:rPr lang="en-US" sz="1000" dirty="0">
+                <a:solidFill>
+                  <a:srgbClr val="6E7B80"/>
                 </a:solidFill>
                 <a:latin typeface="Trebuchet MS" pitchFamily="34" charset="0"/>
                 <a:ea typeface="Trebuchet MS" pitchFamily="34" charset="-122"/>
                 <a:cs typeface="Trebuchet MS" pitchFamily="34" charset="-120"/>
               </a:rPr>
-              <a:t>Rénovation et équipement complets du laboratoire du lycée de Tsévié 1 : paillasses, eau, verrerie, électricité.</a:t>
-            </a:r>
-            <a:endParaRPr lang="en-US" sz="1050" dirty="0"/>
-          </a:p>
-        </p:txBody>
-      </p:sp>
-      <p:sp>
-        <p:nvSpPr>
-          <p:cNvPr id="15" name="Text 12"/>
-          <p:cNvSpPr txBox="1"/>
-          <p:nvPr/>
-        </p:nvSpPr>
-        <p:spPr>
-          <a:xfrm>
-            <a:off x="676656" y="3328416"/>
-            <a:ext cx="4636008" cy="201168"/>
+              <a:t>le budget VirtuLab : 297 M FCFA sur trois ans</a:t>
+            </a:r>
+            <a:endParaRPr lang="en-US" sz="1000" dirty="0"/>
+          </a:p>
+        </p:txBody>
+      </p:sp>
+      <p:sp>
+        <p:nvSpPr>
+          <p:cNvPr id="44" name="Text 41"/>
+          <p:cNvSpPr txBox="1"/>
+          <p:nvPr/>
+        </p:nvSpPr>
+        <p:spPr>
+          <a:xfrm>
+            <a:off x="457200" y="6419088"/>
+            <a:ext cx="10515600" cy="329184"/>
           </a:xfrm>
           <a:prstGeom prst="rect">
             <a:avLst/>
@@ -9097,7 +9993,7 @@
               <a:buNone/>
             </a:pPr>
             <a:r>
-              <a:rPr lang="en-US" sz="850" i="1" dirty="0">
+              <a:rPr lang="en-US" sz="900" dirty="0">
                 <a:solidFill>
                   <a:srgbClr val="6E7B80"/>
                 </a:solidFill>
@@ -9105,1376 +10001,7 @@
                 <a:ea typeface="Trebuchet MS" pitchFamily="34" charset="-122"/>
                 <a:cs typeface="Trebuchet MS" pitchFamily="34" charset="-120"/>
               </a:rPr>
-              <a:t>Cas réel constaté au Togo · UNICEF, janvier 2025</a:t>
-            </a:r>
-            <a:endParaRPr lang="en-US" sz="850" dirty="0"/>
-          </a:p>
-        </p:txBody>
-      </p:sp>
-      <p:sp>
-        <p:nvSpPr>
-          <p:cNvPr id="16" name="Shape 13"/>
-          <p:cNvSpPr/>
-          <p:nvPr/>
-        </p:nvSpPr>
-        <p:spPr>
-          <a:xfrm>
-            <a:off x="676656" y="3602736"/>
-            <a:ext cx="4636008" cy="12802"/>
-          </a:xfrm>
-          <a:prstGeom prst="rect">
-            <a:avLst/>
-          </a:prstGeom>
-          <a:solidFill>
-            <a:srgbClr val="EDE8DA"/>
-          </a:solidFill>
-          <a:ln/>
-        </p:spPr>
-      </p:sp>
-      <p:sp>
-        <p:nvSpPr>
-          <p:cNvPr id="17" name="Text 14"/>
-          <p:cNvSpPr txBox="1"/>
-          <p:nvPr/>
-        </p:nvSpPr>
-        <p:spPr>
-          <a:xfrm>
-            <a:off x="676656" y="3712464"/>
-            <a:ext cx="1481328" cy="493776"/>
-          </a:xfrm>
-          <a:prstGeom prst="rect">
-            <a:avLst/>
-          </a:prstGeom>
-          <a:noFill/>
-          <a:ln/>
-        </p:spPr>
-        <p:txBody>
-          <a:bodyPr wrap="square" rtlCol="0" anchor="ctr"/>
-          <a:lstStyle/>
-          <a:p>
-            <a:pPr algn="l" indent="0" marL="0">
-              <a:buNone/>
-            </a:pPr>
-            <a:r>
-              <a:rPr lang="en-US" sz="2800" b="1" dirty="0">
-                <a:solidFill>
-                  <a:srgbClr val="0E7C7B"/>
-                </a:solidFill>
-                <a:latin typeface="Georgia" pitchFamily="34" charset="0"/>
-                <a:ea typeface="Georgia" pitchFamily="34" charset="-122"/>
-                <a:cs typeface="Georgia" pitchFamily="34" charset="-120"/>
-              </a:rPr>
-              <a:t>≈ 3 M</a:t>
-            </a:r>
-            <a:endParaRPr lang="en-US" sz="2800" dirty="0"/>
-          </a:p>
-        </p:txBody>
-      </p:sp>
-      <p:sp>
-        <p:nvSpPr>
-          <p:cNvPr id="18" name="Text 15"/>
-          <p:cNvSpPr txBox="1"/>
-          <p:nvPr/>
-        </p:nvSpPr>
-        <p:spPr>
-          <a:xfrm>
-            <a:off x="2084832" y="3767328"/>
-            <a:ext cx="566928" cy="384048"/>
-          </a:xfrm>
-          <a:prstGeom prst="rect">
-            <a:avLst/>
-          </a:prstGeom>
-          <a:noFill/>
-          <a:ln/>
-        </p:spPr>
-        <p:txBody>
-          <a:bodyPr wrap="square" rtlCol="0" anchor="ctr"/>
-          <a:lstStyle/>
-          <a:p>
-            <a:pPr algn="l" indent="0" marL="0">
-              <a:buNone/>
-            </a:pPr>
-            <a:r>
-              <a:rPr lang="en-US" sz="1050" b="1" dirty="0">
-                <a:solidFill>
-                  <a:srgbClr val="6E7B80"/>
-                </a:solidFill>
-                <a:latin typeface="Trebuchet MS" pitchFamily="34" charset="0"/>
-                <a:ea typeface="Trebuchet MS" pitchFamily="34" charset="-122"/>
-                <a:cs typeface="Trebuchet MS" pitchFamily="34" charset="-120"/>
-              </a:rPr>
-              <a:t>FCFA</a:t>
-            </a:r>
-            <a:endParaRPr lang="en-US" sz="1050" dirty="0"/>
-          </a:p>
-        </p:txBody>
-      </p:sp>
-      <p:sp>
-        <p:nvSpPr>
-          <p:cNvPr id="19" name="Shape 16"/>
-          <p:cNvSpPr/>
-          <p:nvPr/>
-        </p:nvSpPr>
-        <p:spPr>
-          <a:xfrm>
-            <a:off x="3319272" y="3794760"/>
-            <a:ext cx="1993392" cy="329184"/>
-          </a:xfrm>
-          <a:prstGeom prst="roundRect">
-            <a:avLst>
-              <a:gd name="adj" fmla="val 50000"/>
-            </a:avLst>
-          </a:prstGeom>
-          <a:solidFill>
-            <a:srgbClr val="DCEBEA"/>
-          </a:solidFill>
-          <a:ln/>
-        </p:spPr>
-      </p:sp>
-      <p:sp>
-        <p:nvSpPr>
-          <p:cNvPr id="20" name="Text 17"/>
-          <p:cNvSpPr txBox="1"/>
-          <p:nvPr/>
-        </p:nvSpPr>
-        <p:spPr>
-          <a:xfrm>
-            <a:off x="3319272" y="3794760"/>
-            <a:ext cx="1993392" cy="329184"/>
-          </a:xfrm>
-          <a:prstGeom prst="rect">
-            <a:avLst/>
-          </a:prstGeom>
-          <a:noFill/>
-          <a:ln/>
-        </p:spPr>
-        <p:txBody>
-          <a:bodyPr wrap="square" rtlCol="0" anchor="ctr"/>
-          <a:lstStyle/>
-          <a:p>
-            <a:pPr algn="ctr" indent="0" marL="0">
-              <a:buNone/>
-            </a:pPr>
-            <a:r>
-              <a:rPr lang="en-US" sz="850" b="1" spc="50" kern="0" dirty="0">
-                <a:solidFill>
-                  <a:srgbClr val="0A5C5B"/>
-                </a:solidFill>
-                <a:latin typeface="Trebuchet MS" pitchFamily="34" charset="0"/>
-                <a:ea typeface="Trebuchet MS" pitchFamily="34" charset="-122"/>
-                <a:cs typeface="Trebuchet MS" pitchFamily="34" charset="-120"/>
-              </a:rPr>
-              <a:t>FORMULE MINIMALE « KITS »</a:t>
-            </a:r>
-            <a:endParaRPr lang="en-US" sz="850" dirty="0"/>
-          </a:p>
-        </p:txBody>
-      </p:sp>
-      <p:sp>
-        <p:nvSpPr>
-          <p:cNvPr id="21" name="Text 18"/>
-          <p:cNvSpPr txBox="1"/>
-          <p:nvPr/>
-        </p:nvSpPr>
-        <p:spPr>
-          <a:xfrm>
-            <a:off x="676656" y="4224528"/>
-            <a:ext cx="4636008" cy="512064"/>
-          </a:xfrm>
-          <a:prstGeom prst="rect">
-            <a:avLst/>
-          </a:prstGeom>
-          <a:noFill/>
-          <a:ln/>
-        </p:spPr>
-        <p:txBody>
-          <a:bodyPr wrap="square" rtlCol="0" anchor="t"/>
-          <a:lstStyle/>
-          <a:p>
-            <a:pPr algn="l" indent="0" marL="0">
-              <a:lnSpc>
-                <a:spcPct val="112000"/>
-              </a:lnSpc>
-              <a:buNone/>
-            </a:pPr>
-            <a:r>
-              <a:rPr lang="en-US" sz="1050" dirty="0">
-                <a:solidFill>
-                  <a:srgbClr val="22333B"/>
-                </a:solidFill>
-                <a:latin typeface="Trebuchet MS" pitchFamily="34" charset="0"/>
-                <a:ea typeface="Trebuchet MS" pitchFamily="34" charset="-122"/>
-                <a:cs typeface="Trebuchet MS" pitchFamily="34" charset="-120"/>
-              </a:rPr>
-              <a:t>Salle existante : mobilier local ≈ 1 M · kits physique-chimie et verrerie ≈ 1,2 M · SVT (microscopes, modèles) ≈ 0,8 M.</a:t>
-            </a:r>
-            <a:endParaRPr lang="en-US" sz="1050" dirty="0"/>
-          </a:p>
-        </p:txBody>
-      </p:sp>
-      <p:sp>
-        <p:nvSpPr>
-          <p:cNvPr id="22" name="Text 19"/>
-          <p:cNvSpPr txBox="1"/>
-          <p:nvPr/>
-        </p:nvSpPr>
-        <p:spPr>
-          <a:xfrm>
-            <a:off x="676656" y="4754880"/>
-            <a:ext cx="4636008" cy="201168"/>
-          </a:xfrm>
-          <a:prstGeom prst="rect">
-            <a:avLst/>
-          </a:prstGeom>
-          <a:noFill/>
-          <a:ln/>
-        </p:spPr>
-        <p:txBody>
-          <a:bodyPr wrap="square" rtlCol="0" anchor="ctr"/>
-          <a:lstStyle/>
-          <a:p>
-            <a:pPr algn="l" indent="0" marL="0">
-              <a:buNone/>
-            </a:pPr>
-            <a:r>
-              <a:rPr lang="en-US" sz="850" i="1" dirty="0">
-                <a:solidFill>
-                  <a:srgbClr val="6E7B80"/>
-                </a:solidFill>
-                <a:latin typeface="Trebuchet MS" pitchFamily="34" charset="0"/>
-                <a:ea typeface="Trebuchet MS" pitchFamily="34" charset="-122"/>
-                <a:cs typeface="Trebuchet MS" pitchFamily="34" charset="-120"/>
-              </a:rPr>
-              <a:t>Formule reconstituée d'après les prix du marché togolais (kits MOBILELABO, mobilier local).</a:t>
-            </a:r>
-            <a:endParaRPr lang="en-US" sz="850" dirty="0"/>
-          </a:p>
-        </p:txBody>
-      </p:sp>
-      <p:sp>
-        <p:nvSpPr>
-          <p:cNvPr id="23" name="Text 20"/>
-          <p:cNvSpPr txBox="1"/>
-          <p:nvPr/>
-        </p:nvSpPr>
-        <p:spPr>
-          <a:xfrm>
-            <a:off x="676656" y="4974336"/>
-            <a:ext cx="4636008" cy="475488"/>
-          </a:xfrm>
-          <a:prstGeom prst="rect">
-            <a:avLst/>
-          </a:prstGeom>
-          <a:noFill/>
-          <a:ln/>
-        </p:spPr>
-        <p:txBody>
-          <a:bodyPr wrap="square" rtlCol="0" anchor="t"/>
-          <a:lstStyle/>
-          <a:p>
-            <a:pPr algn="l" indent="0" marL="0">
-              <a:lnSpc>
-                <a:spcPct val="112000"/>
-              </a:lnSpc>
-              <a:buNone/>
-            </a:pPr>
-            <a:r>
-              <a:rPr lang="en-US" sz="950" i="1" dirty="0">
-                <a:solidFill>
-                  <a:srgbClr val="22333B"/>
-                </a:solidFill>
-                <a:latin typeface="Trebuchet MS" pitchFamily="34" charset="0"/>
-                <a:ea typeface="Trebuchet MS" pitchFamily="34" charset="-122"/>
-                <a:cs typeface="Trebuchet MS" pitchFamily="34" charset="-120"/>
-              </a:rPr>
-              <a:t>Et l'équipement n'est pas la fin : consommables et remplacement peuvent ajouter jusqu'à 60 % du capital initial (UNESCO).</a:t>
-            </a:r>
-            <a:endParaRPr lang="en-US" sz="950" dirty="0"/>
-          </a:p>
-        </p:txBody>
-      </p:sp>
-      <p:sp>
-        <p:nvSpPr>
-          <p:cNvPr id="24" name="Text 21"/>
-          <p:cNvSpPr txBox="1"/>
-          <p:nvPr/>
-        </p:nvSpPr>
-        <p:spPr>
-          <a:xfrm>
-            <a:off x="5980176" y="1901952"/>
-            <a:ext cx="5532120" cy="274320"/>
-          </a:xfrm>
-          <a:prstGeom prst="rect">
-            <a:avLst/>
-          </a:prstGeom>
-          <a:noFill/>
-          <a:ln/>
-        </p:spPr>
-        <p:txBody>
-          <a:bodyPr wrap="square" rtlCol="0" anchor="ctr"/>
-          <a:lstStyle/>
-          <a:p>
-            <a:pPr algn="l" indent="0" marL="0">
-              <a:buNone/>
-            </a:pPr>
-            <a:r>
-              <a:rPr lang="en-US" sz="1300" b="1" dirty="0">
-                <a:solidFill>
-                  <a:srgbClr val="B8431D"/>
-                </a:solidFill>
-                <a:latin typeface="Trebuchet MS" pitchFamily="34" charset="0"/>
-                <a:ea typeface="Trebuchet MS" pitchFamily="34" charset="-122"/>
-                <a:cs typeface="Trebuchet MS" pitchFamily="34" charset="-120"/>
-              </a:rPr>
-              <a:t>La facture nationale, du minimum au standard</a:t>
-            </a:r>
-            <a:endParaRPr lang="en-US" sz="1300" dirty="0"/>
-          </a:p>
-        </p:txBody>
-      </p:sp>
-      <p:sp>
-        <p:nvSpPr>
-          <p:cNvPr id="25" name="Text 22"/>
-          <p:cNvSpPr txBox="1"/>
-          <p:nvPr/>
-        </p:nvSpPr>
-        <p:spPr>
-          <a:xfrm>
-            <a:off x="5980176" y="2212848"/>
-            <a:ext cx="5532120" cy="237744"/>
-          </a:xfrm>
-          <a:prstGeom prst="rect">
-            <a:avLst/>
-          </a:prstGeom>
-          <a:noFill/>
-          <a:ln/>
-        </p:spPr>
-        <p:txBody>
-          <a:bodyPr wrap="square" rtlCol="0" anchor="ctr"/>
-          <a:lstStyle/>
-          <a:p>
-            <a:pPr algn="l" indent="0" marL="0">
-              <a:buNone/>
-            </a:pPr>
-            <a:r>
-              <a:rPr lang="en-US" sz="1000" i="1" dirty="0">
-                <a:solidFill>
-                  <a:srgbClr val="6E7B80"/>
-                </a:solidFill>
-                <a:latin typeface="Trebuchet MS" pitchFamily="34" charset="0"/>
-                <a:ea typeface="Trebuchet MS" pitchFamily="34" charset="-122"/>
-                <a:cs typeface="Trebuchet MS" pitchFamily="34" charset="-120"/>
-              </a:rPr>
-              <a:t>902 établissements publics × ≈ 90 % sans laboratoire ≈ 810 à équiper.</a:t>
-            </a:r>
-            <a:endParaRPr lang="en-US" sz="1000" dirty="0"/>
-          </a:p>
-        </p:txBody>
-      </p:sp>
-      <p:sp>
-        <p:nvSpPr>
-          <p:cNvPr id="26" name="Shape 23"/>
-          <p:cNvSpPr/>
-          <p:nvPr/>
-        </p:nvSpPr>
-        <p:spPr>
-          <a:xfrm>
-            <a:off x="5998464" y="2542032"/>
-            <a:ext cx="1207008" cy="822960"/>
-          </a:xfrm>
-          <a:prstGeom prst="roundRect">
-            <a:avLst>
-              <a:gd name="adj" fmla="val 8889"/>
-            </a:avLst>
-          </a:prstGeom>
-          <a:solidFill>
-            <a:srgbClr val="F8E4D9"/>
-          </a:solidFill>
-          <a:ln/>
-        </p:spPr>
-      </p:sp>
-      <p:sp>
-        <p:nvSpPr>
-          <p:cNvPr id="27" name="Text 24"/>
-          <p:cNvSpPr txBox="1"/>
-          <p:nvPr/>
-        </p:nvSpPr>
-        <p:spPr>
-          <a:xfrm>
-            <a:off x="5998464" y="2615184"/>
-            <a:ext cx="1207008" cy="420624"/>
-          </a:xfrm>
-          <a:prstGeom prst="rect">
-            <a:avLst/>
-          </a:prstGeom>
-          <a:noFill/>
-          <a:ln/>
-        </p:spPr>
-        <p:txBody>
-          <a:bodyPr wrap="square" rtlCol="0" anchor="ctr"/>
-          <a:lstStyle/>
-          <a:p>
-            <a:pPr algn="ctr" indent="0" marL="0">
-              <a:buNone/>
-            </a:pPr>
-            <a:r>
-              <a:rPr lang="en-US" sz="1700" b="1" dirty="0">
-                <a:solidFill>
-                  <a:srgbClr val="B8431D"/>
-                </a:solidFill>
-                <a:latin typeface="Georgia" pitchFamily="34" charset="0"/>
-                <a:ea typeface="Georgia" pitchFamily="34" charset="-122"/>
-                <a:cs typeface="Georgia" pitchFamily="34" charset="-120"/>
-              </a:rPr>
-              <a:t>≈ 810</a:t>
-            </a:r>
-            <a:endParaRPr lang="en-US" sz="1700" dirty="0"/>
-          </a:p>
-        </p:txBody>
-      </p:sp>
-      <p:sp>
-        <p:nvSpPr>
-          <p:cNvPr id="28" name="Text 25"/>
-          <p:cNvSpPr txBox="1"/>
-          <p:nvPr/>
-        </p:nvSpPr>
-        <p:spPr>
-          <a:xfrm>
-            <a:off x="6035040" y="3035808"/>
-            <a:ext cx="1133856" cy="310896"/>
-          </a:xfrm>
-          <a:prstGeom prst="rect">
-            <a:avLst/>
-          </a:prstGeom>
-          <a:noFill/>
-          <a:ln/>
-        </p:spPr>
-        <p:txBody>
-          <a:bodyPr wrap="square" rtlCol="0" anchor="t"/>
-          <a:lstStyle/>
-          <a:p>
-            <a:pPr algn="ctr" indent="0" marL="0">
-              <a:lnSpc>
-                <a:spcPct val="105000"/>
-              </a:lnSpc>
-              <a:buNone/>
-            </a:pPr>
-            <a:r>
-              <a:rPr lang="en-US" sz="800" dirty="0">
-                <a:solidFill>
-                  <a:srgbClr val="22333B"/>
-                </a:solidFill>
-                <a:latin typeface="Trebuchet MS" pitchFamily="34" charset="0"/>
-                <a:ea typeface="Trebuchet MS" pitchFamily="34" charset="-122"/>
-                <a:cs typeface="Trebuchet MS" pitchFamily="34" charset="-120"/>
-              </a:rPr>
-              <a:t>établissements à équiper</a:t>
-            </a:r>
-            <a:endParaRPr lang="en-US" sz="800" dirty="0"/>
-          </a:p>
-        </p:txBody>
-      </p:sp>
-      <p:sp>
-        <p:nvSpPr>
-          <p:cNvPr id="29" name="Text 26"/>
-          <p:cNvSpPr txBox="1"/>
-          <p:nvPr/>
-        </p:nvSpPr>
-        <p:spPr>
-          <a:xfrm>
-            <a:off x="7205472" y="2542032"/>
-            <a:ext cx="201168" cy="822960"/>
-          </a:xfrm>
-          <a:prstGeom prst="rect">
-            <a:avLst/>
-          </a:prstGeom>
-          <a:noFill/>
-          <a:ln/>
-        </p:spPr>
-        <p:txBody>
-          <a:bodyPr wrap="square" rtlCol="0" anchor="ctr"/>
-          <a:lstStyle/>
-          <a:p>
-            <a:pPr algn="ctr" indent="0" marL="0">
-              <a:buNone/>
-            </a:pPr>
-            <a:r>
-              <a:rPr lang="en-US" sz="2000" b="1" dirty="0">
-                <a:solidFill>
-                  <a:srgbClr val="6E7B80"/>
-                </a:solidFill>
-                <a:latin typeface="Georgia" pitchFamily="34" charset="0"/>
-                <a:ea typeface="Georgia" pitchFamily="34" charset="-122"/>
-                <a:cs typeface="Georgia" pitchFamily="34" charset="-120"/>
-              </a:rPr>
-              <a:t>×</a:t>
-            </a:r>
-            <a:endParaRPr lang="en-US" sz="2000" dirty="0"/>
-          </a:p>
-        </p:txBody>
-      </p:sp>
-      <p:sp>
-        <p:nvSpPr>
-          <p:cNvPr id="30" name="Shape 27"/>
-          <p:cNvSpPr/>
-          <p:nvPr/>
-        </p:nvSpPr>
-        <p:spPr>
-          <a:xfrm>
-            <a:off x="7406640" y="2542032"/>
-            <a:ext cx="1207008" cy="822960"/>
-          </a:xfrm>
-          <a:prstGeom prst="roundRect">
-            <a:avLst>
-              <a:gd name="adj" fmla="val 8889"/>
-            </a:avLst>
-          </a:prstGeom>
-          <a:solidFill>
-            <a:srgbClr val="F8E4D9"/>
-          </a:solidFill>
-          <a:ln/>
-        </p:spPr>
-      </p:sp>
-      <p:sp>
-        <p:nvSpPr>
-          <p:cNvPr id="31" name="Text 28"/>
-          <p:cNvSpPr txBox="1"/>
-          <p:nvPr/>
-        </p:nvSpPr>
-        <p:spPr>
-          <a:xfrm>
-            <a:off x="7406640" y="2615184"/>
-            <a:ext cx="1207008" cy="420624"/>
-          </a:xfrm>
-          <a:prstGeom prst="rect">
-            <a:avLst/>
-          </a:prstGeom>
-          <a:noFill/>
-          <a:ln/>
-        </p:spPr>
-        <p:txBody>
-          <a:bodyPr wrap="square" rtlCol="0" anchor="ctr"/>
-          <a:lstStyle/>
-          <a:p>
-            <a:pPr algn="ctr" indent="0" marL="0">
-              <a:buNone/>
-            </a:pPr>
-            <a:r>
-              <a:rPr lang="en-US" sz="1700" b="1" dirty="0">
-                <a:solidFill>
-                  <a:srgbClr val="B8431D"/>
-                </a:solidFill>
-                <a:latin typeface="Georgia" pitchFamily="34" charset="0"/>
-                <a:ea typeface="Georgia" pitchFamily="34" charset="-122"/>
-                <a:cs typeface="Georgia" pitchFamily="34" charset="-120"/>
-              </a:rPr>
-              <a:t>≈ 3 M</a:t>
-            </a:r>
-            <a:endParaRPr lang="en-US" sz="1700" dirty="0"/>
-          </a:p>
-        </p:txBody>
-      </p:sp>
-      <p:sp>
-        <p:nvSpPr>
-          <p:cNvPr id="32" name="Text 29"/>
-          <p:cNvSpPr txBox="1"/>
-          <p:nvPr/>
-        </p:nvSpPr>
-        <p:spPr>
-          <a:xfrm>
-            <a:off x="7434072" y="3035808"/>
-            <a:ext cx="1152144" cy="310896"/>
-          </a:xfrm>
-          <a:prstGeom prst="rect">
-            <a:avLst/>
-          </a:prstGeom>
-          <a:noFill/>
-          <a:ln/>
-        </p:spPr>
-        <p:txBody>
-          <a:bodyPr wrap="square" rtlCol="0" anchor="t"/>
-          <a:lstStyle/>
-          <a:p>
-            <a:pPr algn="ctr" indent="0" marL="0">
-              <a:lnSpc>
-                <a:spcPct val="105000"/>
-              </a:lnSpc>
-              <a:buNone/>
-            </a:pPr>
-            <a:r>
-              <a:rPr lang="en-US" sz="800" dirty="0">
-                <a:solidFill>
-                  <a:srgbClr val="22333B"/>
-                </a:solidFill>
-                <a:latin typeface="Trebuchet MS" pitchFamily="34" charset="0"/>
-                <a:ea typeface="Trebuchet MS" pitchFamily="34" charset="-122"/>
-                <a:cs typeface="Trebuchet MS" pitchFamily="34" charset="-120"/>
-              </a:rPr>
-              <a:t>FCFA par labo (minimum)</a:t>
-            </a:r>
-            <a:endParaRPr lang="en-US" sz="800" dirty="0"/>
-          </a:p>
-        </p:txBody>
-      </p:sp>
-      <p:sp>
-        <p:nvSpPr>
-          <p:cNvPr id="33" name="Text 30"/>
-          <p:cNvSpPr txBox="1"/>
-          <p:nvPr/>
-        </p:nvSpPr>
-        <p:spPr>
-          <a:xfrm>
-            <a:off x="8613648" y="2542032"/>
-            <a:ext cx="201168" cy="822960"/>
-          </a:xfrm>
-          <a:prstGeom prst="rect">
-            <a:avLst/>
-          </a:prstGeom>
-          <a:noFill/>
-          <a:ln/>
-        </p:spPr>
-        <p:txBody>
-          <a:bodyPr wrap="square" rtlCol="0" anchor="ctr"/>
-          <a:lstStyle/>
-          <a:p>
-            <a:pPr algn="ctr" indent="0" marL="0">
-              <a:buNone/>
-            </a:pPr>
-            <a:r>
-              <a:rPr lang="en-US" sz="2000" b="1" dirty="0">
-                <a:solidFill>
-                  <a:srgbClr val="6E7B80"/>
-                </a:solidFill>
-                <a:latin typeface="Georgia" pitchFamily="34" charset="0"/>
-                <a:ea typeface="Georgia" pitchFamily="34" charset="-122"/>
-                <a:cs typeface="Georgia" pitchFamily="34" charset="-120"/>
-              </a:rPr>
-              <a:t>=</a:t>
-            </a:r>
-            <a:endParaRPr lang="en-US" sz="2000" dirty="0"/>
-          </a:p>
-        </p:txBody>
-      </p:sp>
-      <p:sp>
-        <p:nvSpPr>
-          <p:cNvPr id="34" name="Shape 31"/>
-          <p:cNvSpPr/>
-          <p:nvPr/>
-        </p:nvSpPr>
-        <p:spPr>
-          <a:xfrm>
-            <a:off x="8814816" y="2542032"/>
-            <a:ext cx="2679192" cy="822960"/>
-          </a:xfrm>
-          <a:prstGeom prst="roundRect">
-            <a:avLst>
-              <a:gd name="adj" fmla="val 8889"/>
-            </a:avLst>
-          </a:prstGeom>
-          <a:solidFill>
-            <a:srgbClr val="E0592A"/>
-          </a:solidFill>
-          <a:ln/>
-        </p:spPr>
-      </p:sp>
-      <p:sp>
-        <p:nvSpPr>
-          <p:cNvPr id="35" name="Text 32"/>
-          <p:cNvSpPr txBox="1"/>
-          <p:nvPr/>
-        </p:nvSpPr>
-        <p:spPr>
-          <a:xfrm>
-            <a:off x="8814816" y="2615184"/>
-            <a:ext cx="2679192" cy="420624"/>
-          </a:xfrm>
-          <a:prstGeom prst="rect">
-            <a:avLst/>
-          </a:prstGeom>
-          <a:noFill/>
-          <a:ln/>
-        </p:spPr>
-        <p:txBody>
-          <a:bodyPr wrap="square" rtlCol="0" anchor="ctr"/>
-          <a:lstStyle/>
-          <a:p>
-            <a:pPr algn="ctr" indent="0" marL="0">
-              <a:buNone/>
-            </a:pPr>
-            <a:r>
-              <a:rPr lang="en-US" sz="1900" b="1" dirty="0">
-                <a:solidFill>
-                  <a:srgbClr val="FFFFFF"/>
-                </a:solidFill>
-                <a:latin typeface="Georgia" pitchFamily="34" charset="0"/>
-                <a:ea typeface="Georgia" pitchFamily="34" charset="-122"/>
-                <a:cs typeface="Georgia" pitchFamily="34" charset="-120"/>
-              </a:rPr>
-              <a:t>≈ 2,4 milliards</a:t>
-            </a:r>
-            <a:endParaRPr lang="en-US" sz="1900" dirty="0"/>
-          </a:p>
-        </p:txBody>
-      </p:sp>
-      <p:sp>
-        <p:nvSpPr>
-          <p:cNvPr id="36" name="Text 33"/>
-          <p:cNvSpPr txBox="1"/>
-          <p:nvPr/>
-        </p:nvSpPr>
-        <p:spPr>
-          <a:xfrm>
-            <a:off x="8814816" y="3035808"/>
-            <a:ext cx="2679192" cy="310896"/>
-          </a:xfrm>
-          <a:prstGeom prst="rect">
-            <a:avLst/>
-          </a:prstGeom>
-          <a:noFill/>
-          <a:ln/>
-        </p:spPr>
-        <p:txBody>
-          <a:bodyPr wrap="square" rtlCol="0" anchor="t"/>
-          <a:lstStyle/>
-          <a:p>
-            <a:pPr algn="ctr" indent="0" marL="0">
-              <a:lnSpc>
-                <a:spcPct val="105000"/>
-              </a:lnSpc>
-              <a:buNone/>
-            </a:pPr>
-            <a:r>
-              <a:rPr lang="en-US" sz="850" dirty="0">
-                <a:solidFill>
-                  <a:srgbClr val="FFFFFF"/>
-                </a:solidFill>
-                <a:latin typeface="Trebuchet MS" pitchFamily="34" charset="0"/>
-                <a:ea typeface="Trebuchet MS" pitchFamily="34" charset="-122"/>
-                <a:cs typeface="Trebuchet MS" pitchFamily="34" charset="-120"/>
-              </a:rPr>
-              <a:t>FCFA · minimum national</a:t>
-            </a:r>
-            <a:endParaRPr lang="en-US" sz="850" dirty="0"/>
-          </a:p>
-        </p:txBody>
-      </p:sp>
-      <p:sp>
-        <p:nvSpPr>
-          <p:cNvPr id="37" name="Text 34"/>
-          <p:cNvSpPr txBox="1"/>
-          <p:nvPr/>
-        </p:nvSpPr>
-        <p:spPr>
-          <a:xfrm>
-            <a:off x="5998464" y="3456432"/>
-            <a:ext cx="5495544" cy="237744"/>
-          </a:xfrm>
-          <a:prstGeom prst="rect">
-            <a:avLst/>
-          </a:prstGeom>
-          <a:noFill/>
-          <a:ln/>
-        </p:spPr>
-        <p:txBody>
-          <a:bodyPr wrap="square" rtlCol="0" anchor="ctr"/>
-          <a:lstStyle/>
-          <a:p>
-            <a:pPr algn="l" indent="0" marL="0">
-              <a:buNone/>
-            </a:pPr>
-            <a:r>
-              <a:rPr lang="en-US" sz="1050" dirty="0">
-                <a:solidFill>
-                  <a:srgbClr val="6E7B80"/>
-                </a:solidFill>
-                <a:latin typeface="Trebuchet MS" pitchFamily="34" charset="0"/>
-                <a:ea typeface="Trebuchet MS" pitchFamily="34" charset="-122"/>
-                <a:cs typeface="Trebuchet MS" pitchFamily="34" charset="-120"/>
-              </a:rPr>
-              <a:t>Au standard complet (12 M par labo) : </a:t>
-            </a:r>
-            <a:pPr algn="l" indent="0" marL="0">
-              <a:buNone/>
-            </a:pPr>
-            <a:r>
-              <a:rPr lang="en-US" sz="1050" b="1" dirty="0">
-                <a:solidFill>
-                  <a:srgbClr val="22333B"/>
-                </a:solidFill>
-                <a:latin typeface="Trebuchet MS" pitchFamily="34" charset="0"/>
-                <a:ea typeface="Trebuchet MS" pitchFamily="34" charset="-122"/>
-                <a:cs typeface="Trebuchet MS" pitchFamily="34" charset="-120"/>
-              </a:rPr>
-              <a:t>810 × 12 M ≈ 9,7 milliards.</a:t>
-            </a:r>
-            <a:endParaRPr lang="en-US" sz="1050" dirty="0"/>
-          </a:p>
-        </p:txBody>
-      </p:sp>
-      <p:sp>
-        <p:nvSpPr>
-          <p:cNvPr id="38" name="Text 35"/>
-          <p:cNvSpPr txBox="1"/>
-          <p:nvPr/>
-        </p:nvSpPr>
-        <p:spPr>
-          <a:xfrm>
-            <a:off x="5998464" y="3712464"/>
-            <a:ext cx="5495544" cy="237744"/>
-          </a:xfrm>
-          <a:prstGeom prst="rect">
-            <a:avLst/>
-          </a:prstGeom>
-          <a:noFill/>
-          <a:ln/>
-        </p:spPr>
-        <p:txBody>
-          <a:bodyPr wrap="square" rtlCol="0" anchor="ctr"/>
-          <a:lstStyle/>
-          <a:p>
-            <a:pPr algn="l" indent="0" marL="0">
-              <a:buNone/>
-            </a:pPr>
-            <a:r>
-              <a:rPr lang="en-US" sz="1100" b="1" dirty="0">
-                <a:solidFill>
-                  <a:srgbClr val="22333B"/>
-                </a:solidFill>
-                <a:latin typeface="Trebuchet MS" pitchFamily="34" charset="0"/>
-                <a:ea typeface="Trebuchet MS" pitchFamily="34" charset="-122"/>
-                <a:cs typeface="Trebuchet MS" pitchFamily="34" charset="-120"/>
-              </a:rPr>
-              <a:t>En face : le déploiement VirtuLab sur trois ans</a:t>
-            </a:r>
-            <a:endParaRPr lang="en-US" sz="1100" dirty="0"/>
-          </a:p>
-        </p:txBody>
-      </p:sp>
-      <p:sp>
-        <p:nvSpPr>
-          <p:cNvPr id="39" name="Text 36"/>
-          <p:cNvSpPr txBox="1"/>
-          <p:nvPr/>
-        </p:nvSpPr>
-        <p:spPr>
-          <a:xfrm>
-            <a:off x="5998464" y="3986784"/>
-            <a:ext cx="2011680" cy="256032"/>
-          </a:xfrm>
-          <a:prstGeom prst="rect">
-            <a:avLst/>
-          </a:prstGeom>
-          <a:noFill/>
-          <a:ln/>
-        </p:spPr>
-        <p:txBody>
-          <a:bodyPr wrap="square" rtlCol="0" anchor="ctr"/>
-          <a:lstStyle/>
-          <a:p>
-            <a:pPr algn="l" indent="0" marL="0">
-              <a:buNone/>
-            </a:pPr>
-            <a:r>
-              <a:rPr lang="en-US" sz="950" dirty="0">
-                <a:solidFill>
-                  <a:srgbClr val="22333B"/>
-                </a:solidFill>
-                <a:latin typeface="Trebuchet MS" pitchFamily="34" charset="0"/>
-                <a:ea typeface="Trebuchet MS" pitchFamily="34" charset="-122"/>
-                <a:cs typeface="Trebuchet MS" pitchFamily="34" charset="-120"/>
-              </a:rPr>
-              <a:t>Standard complet</a:t>
-            </a:r>
-            <a:endParaRPr lang="en-US" sz="950" dirty="0"/>
-          </a:p>
-        </p:txBody>
-      </p:sp>
-      <p:sp>
-        <p:nvSpPr>
-          <p:cNvPr id="40" name="Shape 37"/>
-          <p:cNvSpPr/>
-          <p:nvPr/>
-        </p:nvSpPr>
-        <p:spPr>
-          <a:xfrm>
-            <a:off x="8046720" y="4027932"/>
-            <a:ext cx="2203704" cy="173736"/>
-          </a:xfrm>
-          <a:prstGeom prst="roundRect">
-            <a:avLst>
-              <a:gd name="adj" fmla="val 50000"/>
-            </a:avLst>
-          </a:prstGeom>
-          <a:solidFill>
-            <a:srgbClr val="EDE8DA"/>
-          </a:solidFill>
-          <a:ln/>
-        </p:spPr>
-      </p:sp>
-      <p:sp>
-        <p:nvSpPr>
-          <p:cNvPr id="41" name="Shape 38"/>
-          <p:cNvSpPr/>
-          <p:nvPr/>
-        </p:nvSpPr>
-        <p:spPr>
-          <a:xfrm>
-            <a:off x="8046720" y="4027932"/>
-            <a:ext cx="2203704" cy="173736"/>
-          </a:xfrm>
-          <a:prstGeom prst="roundRect">
-            <a:avLst>
-              <a:gd name="adj" fmla="val 50000"/>
-            </a:avLst>
-          </a:prstGeom>
-          <a:solidFill>
-            <a:srgbClr val="8A959B"/>
-          </a:solidFill>
-          <a:ln/>
-        </p:spPr>
-      </p:sp>
-      <p:sp>
-        <p:nvSpPr>
-          <p:cNvPr id="42" name="Text 39"/>
-          <p:cNvSpPr txBox="1"/>
-          <p:nvPr/>
-        </p:nvSpPr>
-        <p:spPr>
-          <a:xfrm>
-            <a:off x="10323576" y="3986784"/>
-            <a:ext cx="822960" cy="256032"/>
-          </a:xfrm>
-          <a:prstGeom prst="rect">
-            <a:avLst/>
-          </a:prstGeom>
-          <a:noFill/>
-          <a:ln/>
-        </p:spPr>
-        <p:txBody>
-          <a:bodyPr wrap="square" rtlCol="0" anchor="ctr"/>
-          <a:lstStyle/>
-          <a:p>
-            <a:pPr algn="l" indent="0" marL="0">
-              <a:buNone/>
-            </a:pPr>
-            <a:r>
-              <a:rPr lang="en-US" sz="1150" b="1" dirty="0">
-                <a:solidFill>
-                  <a:srgbClr val="22333B"/>
-                </a:solidFill>
-                <a:latin typeface="Georgia" pitchFamily="34" charset="0"/>
-                <a:ea typeface="Georgia" pitchFamily="34" charset="-122"/>
-                <a:cs typeface="Georgia" pitchFamily="34" charset="-120"/>
-              </a:rPr>
-              <a:t>9,7 Md</a:t>
-            </a:r>
-            <a:endParaRPr lang="en-US" sz="1150" dirty="0"/>
-          </a:p>
-        </p:txBody>
-      </p:sp>
-      <p:sp>
-        <p:nvSpPr>
-          <p:cNvPr id="43" name="Text 40"/>
-          <p:cNvSpPr txBox="1"/>
-          <p:nvPr/>
-        </p:nvSpPr>
-        <p:spPr>
-          <a:xfrm>
-            <a:off x="5998464" y="4370832"/>
-            <a:ext cx="2011680" cy="256032"/>
-          </a:xfrm>
-          <a:prstGeom prst="rect">
-            <a:avLst/>
-          </a:prstGeom>
-          <a:noFill/>
-          <a:ln/>
-        </p:spPr>
-        <p:txBody>
-          <a:bodyPr wrap="square" rtlCol="0" anchor="ctr"/>
-          <a:lstStyle/>
-          <a:p>
-            <a:pPr algn="l" indent="0" marL="0">
-              <a:buNone/>
-            </a:pPr>
-            <a:r>
-              <a:rPr lang="en-US" sz="950" dirty="0">
-                <a:solidFill>
-                  <a:srgbClr val="22333B"/>
-                </a:solidFill>
-                <a:latin typeface="Trebuchet MS" pitchFamily="34" charset="0"/>
-                <a:ea typeface="Trebuchet MS" pitchFamily="34" charset="-122"/>
-                <a:cs typeface="Trebuchet MS" pitchFamily="34" charset="-120"/>
-              </a:rPr>
-              <a:t>Minimum « kits »</a:t>
-            </a:r>
-            <a:endParaRPr lang="en-US" sz="950" dirty="0"/>
-          </a:p>
-        </p:txBody>
-      </p:sp>
-      <p:sp>
-        <p:nvSpPr>
-          <p:cNvPr id="44" name="Shape 41"/>
-          <p:cNvSpPr/>
-          <p:nvPr/>
-        </p:nvSpPr>
-        <p:spPr>
-          <a:xfrm>
-            <a:off x="8046720" y="4411980"/>
-            <a:ext cx="2203704" cy="173736"/>
-          </a:xfrm>
-          <a:prstGeom prst="roundRect">
-            <a:avLst>
-              <a:gd name="adj" fmla="val 50000"/>
-            </a:avLst>
-          </a:prstGeom>
-          <a:solidFill>
-            <a:srgbClr val="EDE8DA"/>
-          </a:solidFill>
-          <a:ln/>
-        </p:spPr>
-      </p:sp>
-      <p:sp>
-        <p:nvSpPr>
-          <p:cNvPr id="45" name="Shape 42"/>
-          <p:cNvSpPr/>
-          <p:nvPr/>
-        </p:nvSpPr>
-        <p:spPr>
-          <a:xfrm>
-            <a:off x="8046720" y="4411980"/>
-            <a:ext cx="550926" cy="173736"/>
-          </a:xfrm>
-          <a:prstGeom prst="roundRect">
-            <a:avLst>
-              <a:gd name="adj" fmla="val 50000"/>
-            </a:avLst>
-          </a:prstGeom>
-          <a:solidFill>
-            <a:srgbClr val="E0592A"/>
-          </a:solidFill>
-          <a:ln/>
-        </p:spPr>
-      </p:sp>
-      <p:sp>
-        <p:nvSpPr>
-          <p:cNvPr id="46" name="Text 43"/>
-          <p:cNvSpPr txBox="1"/>
-          <p:nvPr/>
-        </p:nvSpPr>
-        <p:spPr>
-          <a:xfrm>
-            <a:off x="10323576" y="4370832"/>
-            <a:ext cx="822960" cy="256032"/>
-          </a:xfrm>
-          <a:prstGeom prst="rect">
-            <a:avLst/>
-          </a:prstGeom>
-          <a:noFill/>
-          <a:ln/>
-        </p:spPr>
-        <p:txBody>
-          <a:bodyPr wrap="square" rtlCol="0" anchor="ctr"/>
-          <a:lstStyle/>
-          <a:p>
-            <a:pPr algn="l" indent="0" marL="0">
-              <a:buNone/>
-            </a:pPr>
-            <a:r>
-              <a:rPr lang="en-US" sz="1150" b="1" dirty="0">
-                <a:solidFill>
-                  <a:srgbClr val="E0592A"/>
-                </a:solidFill>
-                <a:latin typeface="Georgia" pitchFamily="34" charset="0"/>
-                <a:ea typeface="Georgia" pitchFamily="34" charset="-122"/>
-                <a:cs typeface="Georgia" pitchFamily="34" charset="-120"/>
-              </a:rPr>
-              <a:t>2,4 Md</a:t>
-            </a:r>
-            <a:endParaRPr lang="en-US" sz="1150" dirty="0"/>
-          </a:p>
-        </p:txBody>
-      </p:sp>
-      <p:sp>
-        <p:nvSpPr>
-          <p:cNvPr id="47" name="Text 44"/>
-          <p:cNvSpPr txBox="1"/>
-          <p:nvPr/>
-        </p:nvSpPr>
-        <p:spPr>
-          <a:xfrm>
-            <a:off x="5998464" y="4754880"/>
-            <a:ext cx="2011680" cy="256032"/>
-          </a:xfrm>
-          <a:prstGeom prst="rect">
-            <a:avLst/>
-          </a:prstGeom>
-          <a:noFill/>
-          <a:ln/>
-        </p:spPr>
-        <p:txBody>
-          <a:bodyPr wrap="square" rtlCol="0" anchor="ctr"/>
-          <a:lstStyle/>
-          <a:p>
-            <a:pPr algn="l" indent="0" marL="0">
-              <a:buNone/>
-            </a:pPr>
-            <a:r>
-              <a:rPr lang="en-US" sz="950" dirty="0">
-                <a:solidFill>
-                  <a:srgbClr val="22333B"/>
-                </a:solidFill>
-                <a:latin typeface="Trebuchet MS" pitchFamily="34" charset="0"/>
-                <a:ea typeface="Trebuchet MS" pitchFamily="34" charset="-122"/>
-                <a:cs typeface="Trebuchet MS" pitchFamily="34" charset="-120"/>
-              </a:rPr>
-              <a:t>VirtuLab · 3 ans</a:t>
-            </a:r>
-            <a:endParaRPr lang="en-US" sz="950" dirty="0"/>
-          </a:p>
-        </p:txBody>
-      </p:sp>
-      <p:sp>
-        <p:nvSpPr>
-          <p:cNvPr id="48" name="Shape 45"/>
-          <p:cNvSpPr/>
-          <p:nvPr/>
-        </p:nvSpPr>
-        <p:spPr>
-          <a:xfrm>
-            <a:off x="8046720" y="4796028"/>
-            <a:ext cx="2203704" cy="173736"/>
-          </a:xfrm>
-          <a:prstGeom prst="roundRect">
-            <a:avLst>
-              <a:gd name="adj" fmla="val 50000"/>
-            </a:avLst>
-          </a:prstGeom>
-          <a:solidFill>
-            <a:srgbClr val="EDE8DA"/>
-          </a:solidFill>
-          <a:ln/>
-        </p:spPr>
-      </p:sp>
-      <p:sp>
-        <p:nvSpPr>
-          <p:cNvPr id="49" name="Shape 46"/>
-          <p:cNvSpPr/>
-          <p:nvPr/>
-        </p:nvSpPr>
-        <p:spPr>
-          <a:xfrm>
-            <a:off x="8046720" y="4796028"/>
-            <a:ext cx="109728" cy="173736"/>
-          </a:xfrm>
-          <a:prstGeom prst="roundRect">
-            <a:avLst>
-              <a:gd name="adj" fmla="val 79167"/>
-            </a:avLst>
-          </a:prstGeom>
-          <a:solidFill>
-            <a:srgbClr val="0E7C7B"/>
-          </a:solidFill>
-          <a:ln/>
-        </p:spPr>
-      </p:sp>
-      <p:sp>
-        <p:nvSpPr>
-          <p:cNvPr id="50" name="Text 47"/>
-          <p:cNvSpPr txBox="1"/>
-          <p:nvPr/>
-        </p:nvSpPr>
-        <p:spPr>
-          <a:xfrm>
-            <a:off x="10323576" y="4754880"/>
-            <a:ext cx="822960" cy="256032"/>
-          </a:xfrm>
-          <a:prstGeom prst="rect">
-            <a:avLst/>
-          </a:prstGeom>
-          <a:noFill/>
-          <a:ln/>
-        </p:spPr>
-        <p:txBody>
-          <a:bodyPr wrap="square" rtlCol="0" anchor="ctr"/>
-          <a:lstStyle/>
-          <a:p>
-            <a:pPr algn="l" indent="0" marL="0">
-              <a:buNone/>
-            </a:pPr>
-            <a:r>
-              <a:rPr lang="en-US" sz="1150" b="1" dirty="0">
-                <a:solidFill>
-                  <a:srgbClr val="0E7C7B"/>
-                </a:solidFill>
-                <a:latin typeface="Georgia" pitchFamily="34" charset="0"/>
-                <a:ea typeface="Georgia" pitchFamily="34" charset="-122"/>
-                <a:cs typeface="Georgia" pitchFamily="34" charset="-120"/>
-              </a:rPr>
-              <a:t>297 M</a:t>
-            </a:r>
-            <a:endParaRPr lang="en-US" sz="1150" dirty="0"/>
-          </a:p>
-        </p:txBody>
-      </p:sp>
-      <p:sp>
-        <p:nvSpPr>
-          <p:cNvPr id="51" name="Shape 48"/>
-          <p:cNvSpPr/>
-          <p:nvPr/>
-        </p:nvSpPr>
-        <p:spPr>
-          <a:xfrm>
-            <a:off x="5998464" y="5157216"/>
-            <a:ext cx="5495544" cy="384048"/>
-          </a:xfrm>
-          <a:prstGeom prst="roundRect">
-            <a:avLst>
-              <a:gd name="adj" fmla="val 21429"/>
-            </a:avLst>
-          </a:prstGeom>
-          <a:solidFill>
-            <a:srgbClr val="DCEBEA"/>
-          </a:solidFill>
-          <a:ln/>
-        </p:spPr>
-      </p:sp>
-      <p:sp>
-        <p:nvSpPr>
-          <p:cNvPr id="52" name="Text 49"/>
-          <p:cNvSpPr txBox="1"/>
-          <p:nvPr/>
-        </p:nvSpPr>
-        <p:spPr>
-          <a:xfrm>
-            <a:off x="6163056" y="5157216"/>
-            <a:ext cx="5166360" cy="384048"/>
-          </a:xfrm>
-          <a:prstGeom prst="rect">
-            <a:avLst/>
-          </a:prstGeom>
-          <a:noFill/>
-          <a:ln/>
-        </p:spPr>
-        <p:txBody>
-          <a:bodyPr wrap="square" rtlCol="0" anchor="ctr"/>
-          <a:lstStyle/>
-          <a:p>
-            <a:pPr algn="l" indent="0" marL="0">
-              <a:buNone/>
-            </a:pPr>
-            <a:r>
-              <a:rPr lang="en-US" sz="1150" b="1" dirty="0">
-                <a:solidFill>
-                  <a:srgbClr val="0A5C5B"/>
-                </a:solidFill>
-                <a:latin typeface="Trebuchet MS" pitchFamily="34" charset="0"/>
-                <a:ea typeface="Trebuchet MS" pitchFamily="34" charset="-122"/>
-                <a:cs typeface="Trebuchet MS" pitchFamily="34" charset="-120"/>
-              </a:rPr>
-              <a:t>Équiper physiquement coûte de 8 à 33 fois le budget VirtuLab.</a:t>
-            </a:r>
-            <a:endParaRPr lang="en-US" sz="1150" dirty="0"/>
-          </a:p>
-        </p:txBody>
-      </p:sp>
-      <p:sp>
-        <p:nvSpPr>
-          <p:cNvPr id="53" name="Shape 50"/>
-          <p:cNvSpPr/>
-          <p:nvPr/>
-        </p:nvSpPr>
-        <p:spPr>
-          <a:xfrm>
-            <a:off x="457200" y="5614416"/>
-            <a:ext cx="11247120" cy="658368"/>
-          </a:xfrm>
-          <a:prstGeom prst="roundRect">
-            <a:avLst>
-              <a:gd name="adj" fmla="val 12500"/>
-            </a:avLst>
-          </a:prstGeom>
-          <a:solidFill>
-            <a:srgbClr val="0A5C5B"/>
-          </a:solidFill>
-          <a:ln/>
-        </p:spPr>
-      </p:sp>
-      <p:sp>
-        <p:nvSpPr>
-          <p:cNvPr id="54" name="Text 51"/>
-          <p:cNvSpPr txBox="1"/>
-          <p:nvPr/>
-        </p:nvSpPr>
-        <p:spPr>
-          <a:xfrm>
-            <a:off x="731520" y="5614416"/>
-            <a:ext cx="10698480" cy="658368"/>
-          </a:xfrm>
-          <a:prstGeom prst="rect">
-            <a:avLst/>
-          </a:prstGeom>
-          <a:noFill/>
-          <a:ln/>
-        </p:spPr>
-        <p:txBody>
-          <a:bodyPr wrap="square" rtlCol="0" anchor="ctr"/>
-          <a:lstStyle/>
-          <a:p>
-            <a:pPr algn="l" indent="0" marL="0">
-              <a:lnSpc>
-                <a:spcPct val="105000"/>
-              </a:lnSpc>
-              <a:buNone/>
-            </a:pPr>
-            <a:r>
-              <a:rPr lang="en-US" sz="1200" b="1" dirty="0">
-                <a:solidFill>
-                  <a:srgbClr val="FFFFFF"/>
-                </a:solidFill>
-                <a:latin typeface="Trebuchet MS" pitchFamily="34" charset="0"/>
-                <a:ea typeface="Trebuchet MS" pitchFamily="34" charset="-122"/>
-                <a:cs typeface="Trebuchet MS" pitchFamily="34" charset="-120"/>
-              </a:rPr>
-              <a:t>Même frugale, la facture dépasse 2,4 milliards : hors salles, hors courant, et deux tiers des zones rurales sans électricité.</a:t>
-            </a:r>
-            <a:endParaRPr lang="en-US" sz="1200" dirty="0"/>
-          </a:p>
-        </p:txBody>
-      </p:sp>
-      <p:sp>
-        <p:nvSpPr>
-          <p:cNvPr id="55" name="Text 52"/>
-          <p:cNvSpPr txBox="1"/>
-          <p:nvPr/>
-        </p:nvSpPr>
-        <p:spPr>
-          <a:xfrm>
-            <a:off x="457200" y="6419088"/>
-            <a:ext cx="10515600" cy="329184"/>
-          </a:xfrm>
-          <a:prstGeom prst="rect">
-            <a:avLst/>
-          </a:prstGeom>
-          <a:noFill/>
-          <a:ln/>
-        </p:spPr>
-        <p:txBody>
-          <a:bodyPr wrap="square" rtlCol="0" anchor="ctr"/>
-          <a:lstStyle/>
-          <a:p>
-            <a:pPr algn="l" indent="0" marL="0">
-              <a:buNone/>
-            </a:pPr>
-            <a:r>
-              <a:rPr lang="en-US" sz="900" dirty="0">
-                <a:solidFill>
-                  <a:srgbClr val="6E7B80"/>
-                </a:solidFill>
-                <a:latin typeface="Trebuchet MS" pitchFamily="34" charset="0"/>
-                <a:ea typeface="Trebuchet MS" pitchFamily="34" charset="-122"/>
-                <a:cs typeface="Trebuchet MS" pitchFamily="34" charset="-120"/>
-              </a:rPr>
-              <a:t>Sources : UNICEF Togo, rénovation du laboratoire du lycée de Tsévié 1 (2025) ; GPE, récit MOBILELABO (2019) ; MENA Togo (2024) ; UNESCO, Science kits in developing countries.</a:t>
+              <a:t>Sources : UNICEF Togo, rénovation du laboratoire du lycée de Tsévié 1 (2025) ; GPE, récit MOBILELABO (2019) ; prix du marché togolais (2024).</a:t>
             </a:r>
             <a:endParaRPr lang="en-US" sz="900" dirty="0"/>
           </a:p>
@@ -10482,7 +10009,7 @@
       </p:sp>
       <p:sp>
         <p:nvSpPr>
-          <p:cNvPr id="56" name="Text 53"/>
+          <p:cNvPr id="45" name="Text 42"/>
           <p:cNvSpPr txBox="1"/>
           <p:nvPr/>
         </p:nvSpPr>
@@ -10731,7 +10258,7 @@
                 <a:ea typeface="Trebuchet MS" pitchFamily="34" charset="-122"/>
                 <a:cs typeface="Trebuchet MS" pitchFamily="34" charset="-120"/>
               </a:rPr>
-              <a:t>Gratuite, publique et hors ligne : 120 simulateurs alignés sur les programmes officiels, du collège au lycée.</a:t>
+              <a:t>Gratuite, publique et hors ligne : 286 TP alignés sur les programmes officiels, du collège au lycée.</a:t>
             </a:r>
             <a:endParaRPr lang="en-US" sz="1350" dirty="0"/>
           </a:p>
@@ -10818,8 +10345,8 @@
         </p:nvSpPr>
         <p:spPr>
           <a:xfrm>
-            <a:off x="2514600" y="2432304"/>
-            <a:ext cx="1316736" cy="512064"/>
+            <a:off x="2240280" y="2432304"/>
+            <a:ext cx="1591056" cy="512064"/>
           </a:xfrm>
           <a:prstGeom prst="rect">
             <a:avLst/>
@@ -10843,7 +10370,7 @@
                 <a:ea typeface="Georgia" pitchFamily="34" charset="-122"/>
                 <a:cs typeface="Georgia" pitchFamily="34" charset="-120"/>
               </a:rPr>
-              <a:t>50 TP</a:t>
+              <a:t>216 TP</a:t>
             </a:r>
             <a:endParaRPr lang="en-US" sz="2400" dirty="0"/>
           </a:p>
@@ -10924,7 +10451,7 @@
                 <a:ea typeface="Trebuchet MS" pitchFamily="34" charset="-122"/>
                 <a:cs typeface="Trebuchet MS" pitchFamily="34" charset="-120"/>
               </a:rPr>
-              <a:t>Circuits, optique, mécanique, dosage des solutions</a:t>
+              <a:t>Guides officiels PCT, 6e → Tle : 96 au collège, 120 au lycée</a:t>
             </a:r>
             <a:endParaRPr lang="en-US" sz="1100" dirty="0"/>
           </a:p>
@@ -11011,8 +10538,8 @@
         </p:nvSpPr>
         <p:spPr>
           <a:xfrm>
-            <a:off x="6332220" y="2432304"/>
-            <a:ext cx="1316736" cy="512064"/>
+            <a:off x="6057900" y="2432304"/>
+            <a:ext cx="1591056" cy="512064"/>
           </a:xfrm>
           <a:prstGeom prst="rect">
             <a:avLst/>
@@ -11204,8 +10731,8 @@
         </p:nvSpPr>
         <p:spPr>
           <a:xfrm>
-            <a:off x="10149840" y="2432304"/>
-            <a:ext cx="1316736" cy="512064"/>
+            <a:off x="9875520" y="2432304"/>
+            <a:ext cx="1591056" cy="512064"/>
           </a:xfrm>
           <a:prstGeom prst="rect">
             <a:avLst/>
@@ -15867,11 +15394,11 @@
         <p:spPr>
           <a:xfrm>
             <a:off x="6903720" y="1719072"/>
-            <a:ext cx="4828032" cy="859536"/>
+            <a:ext cx="4828032" cy="1024128"/>
           </a:xfrm>
           <a:prstGeom prst="roundRect">
             <a:avLst>
-              <a:gd name="adj" fmla="val 10638"/>
+              <a:gd name="adj" fmla="val 8929"/>
             </a:avLst>
           </a:prstGeom>
           <a:solidFill>
@@ -15887,14 +15414,34 @@
       </p:sp>
       <p:sp>
         <p:nvSpPr>
-          <p:cNvPr id="11" name="Text 7"/>
-          <p:cNvSpPr txBox="1"/>
-          <p:nvPr/>
-        </p:nvSpPr>
-        <p:spPr>
-          <a:xfrm>
-            <a:off x="7050024" y="1773936"/>
-            <a:ext cx="1188720" cy="749808"/>
+          <p:cNvPr id="11" name="Shape 7"/>
+          <p:cNvSpPr/>
+          <p:nvPr/>
+        </p:nvSpPr>
+        <p:spPr>
+          <a:xfrm>
+            <a:off x="6903720" y="1719072"/>
+            <a:ext cx="82296" cy="1024128"/>
+          </a:xfrm>
+          <a:prstGeom prst="rect">
+            <a:avLst/>
+          </a:prstGeom>
+          <a:solidFill>
+            <a:srgbClr val="0E7C7B"/>
+          </a:solidFill>
+          <a:ln/>
+        </p:spPr>
+      </p:sp>
+      <p:sp>
+        <p:nvSpPr>
+          <p:cNvPr id="12" name="Text 8"/>
+          <p:cNvSpPr txBox="1"/>
+          <p:nvPr/>
+        </p:nvSpPr>
+        <p:spPr>
+          <a:xfrm>
+            <a:off x="7141464" y="1810512"/>
+            <a:ext cx="1234440" cy="841248"/>
           </a:xfrm>
           <a:prstGeom prst="rect">
             <a:avLst/>
@@ -15910,7 +15457,7 @@
               <a:buNone/>
             </a:pPr>
             <a:r>
-              <a:rPr lang="en-US" sz="1700" b="1" dirty="0">
+              <a:rPr lang="en-US" sz="2500" b="1" dirty="0">
                 <a:solidFill>
                   <a:srgbClr val="0E7C7B"/>
                 </a:solidFill>
@@ -15920,20 +15467,20 @@
               </a:rPr>
               <a:t>89 %</a:t>
             </a:r>
-            <a:endParaRPr lang="en-US" sz="1700" dirty="0"/>
-          </a:p>
-        </p:txBody>
-      </p:sp>
-      <p:sp>
-        <p:nvSpPr>
-          <p:cNvPr id="12" name="Text 8"/>
-          <p:cNvSpPr txBox="1"/>
-          <p:nvPr/>
-        </p:nvSpPr>
-        <p:spPr>
-          <a:xfrm>
-            <a:off x="8293608" y="1773936"/>
-            <a:ext cx="3273552" cy="749808"/>
+            <a:endParaRPr lang="en-US" sz="2500" dirty="0"/>
+          </a:p>
+        </p:txBody>
+      </p:sp>
+      <p:sp>
+        <p:nvSpPr>
+          <p:cNvPr id="13" name="Text 9"/>
+          <p:cNvSpPr txBox="1"/>
+          <p:nvPr/>
+        </p:nvSpPr>
+        <p:spPr>
+          <a:xfrm>
+            <a:off x="8476488" y="1792224"/>
+            <a:ext cx="3017520" cy="877824"/>
           </a:xfrm>
           <a:prstGeom prst="rect">
             <a:avLst/>
@@ -15947,12 +15494,12 @@
           <a:p>
             <a:pPr algn="l" indent="0" marL="0">
               <a:lnSpc>
-                <a:spcPct val="110000"/>
+                <a:spcPct val="112000"/>
               </a:lnSpc>
               <a:buNone/>
             </a:pPr>
             <a:r>
-              <a:rPr lang="en-US" sz="1000" dirty="0">
+              <a:rPr lang="en-US" sz="1050" dirty="0">
                 <a:solidFill>
                   <a:srgbClr val="22333B"/>
                 </a:solidFill>
@@ -15962,47 +15509,42 @@
               </a:rPr>
               <a:t>des élèves montrent des gains de connaissances mesurables avec les laboratoires virtuels (Labster).</a:t>
             </a:r>
-            <a:endParaRPr lang="en-US" sz="1000" dirty="0"/>
-          </a:p>
-        </p:txBody>
-      </p:sp>
-      <p:sp>
-        <p:nvSpPr>
-          <p:cNvPr id="13" name="Shape 9"/>
+            <a:endParaRPr lang="en-US" sz="1050" dirty="0"/>
+          </a:p>
+        </p:txBody>
+      </p:sp>
+      <p:sp>
+        <p:nvSpPr>
+          <p:cNvPr id="14" name="Shape 10"/>
           <p:cNvSpPr/>
           <p:nvPr/>
         </p:nvSpPr>
         <p:spPr>
           <a:xfrm>
-            <a:off x="6903720" y="2688336"/>
-            <a:ext cx="4828032" cy="859536"/>
+            <a:off x="6903720" y="2999232"/>
+            <a:ext cx="4828032" cy="2542032"/>
           </a:xfrm>
           <a:prstGeom prst="roundRect">
             <a:avLst>
-              <a:gd name="adj" fmla="val 10638"/>
+              <a:gd name="adj" fmla="val 3597"/>
             </a:avLst>
           </a:prstGeom>
           <a:solidFill>
-            <a:srgbClr val="FFFFFF"/>
+            <a:srgbClr val="0A5C5B"/>
           </a:solidFill>
-          <a:ln w="15875">
-            <a:solidFill>
-              <a:srgbClr val="DCEBEA"/>
-            </a:solidFill>
-            <a:prstDash val="solid"/>
-          </a:ln>
-        </p:spPr>
-      </p:sp>
-      <p:sp>
-        <p:nvSpPr>
-          <p:cNvPr id="14" name="Text 10"/>
-          <p:cNvSpPr txBox="1"/>
-          <p:nvPr/>
-        </p:nvSpPr>
-        <p:spPr>
-          <a:xfrm>
-            <a:off x="7050024" y="2743200"/>
-            <a:ext cx="1188720" cy="749808"/>
+          <a:ln/>
+        </p:spPr>
+      </p:sp>
+      <p:sp>
+        <p:nvSpPr>
+          <p:cNvPr id="15" name="Text 11"/>
+          <p:cNvSpPr txBox="1"/>
+          <p:nvPr/>
+        </p:nvSpPr>
+        <p:spPr>
+          <a:xfrm>
+            <a:off x="7123176" y="3145536"/>
+            <a:ext cx="4389120" cy="274320"/>
           </a:xfrm>
           <a:prstGeom prst="rect">
             <a:avLst/>
@@ -16018,15 +15560,96 @@
               <a:buNone/>
             </a:pPr>
             <a:r>
+              <a:rPr lang="en-US" sz="1150" b="1" spc="50" kern="0" dirty="0">
+                <a:solidFill>
+                  <a:srgbClr val="F8E4D9"/>
+                </a:solidFill>
+                <a:latin typeface="Trebuchet MS" pitchFamily="34" charset="0"/>
+                <a:ea typeface="Trebuchet MS" pitchFamily="34" charset="-122"/>
+                <a:cs typeface="Trebuchet MS" pitchFamily="34" charset="-120"/>
+              </a:rPr>
+              <a:t>Ce qu'on gagne en choisissant le virtuel</a:t>
+            </a:r>
+            <a:endParaRPr lang="en-US" sz="1150" dirty="0"/>
+          </a:p>
+        </p:txBody>
+      </p:sp>
+      <p:sp>
+        <p:nvSpPr>
+          <p:cNvPr id="16" name="Text 12"/>
+          <p:cNvSpPr txBox="1"/>
+          <p:nvPr/>
+        </p:nvSpPr>
+        <p:spPr>
+          <a:xfrm>
+            <a:off x="7123176" y="3511296"/>
+            <a:ext cx="2331720" cy="329184"/>
+          </a:xfrm>
+          <a:prstGeom prst="rect">
+            <a:avLst/>
+          </a:prstGeom>
+          <a:noFill/>
+          <a:ln/>
+        </p:spPr>
+        <p:txBody>
+          <a:bodyPr wrap="square" rtlCol="0" anchor="ctr"/>
+          <a:lstStyle/>
+          <a:p>
+            <a:pPr algn="l" indent="0" marL="0">
+              <a:lnSpc>
+                <a:spcPct val="105000"/>
+              </a:lnSpc>
+              <a:buNone/>
+            </a:pPr>
+            <a:r>
+              <a:rPr lang="en-US" sz="950" dirty="0">
+                <a:solidFill>
+                  <a:srgbClr val="C9DEDD"/>
+                </a:solidFill>
+                <a:latin typeface="Trebuchet MS" pitchFamily="34" charset="0"/>
+                <a:ea typeface="Trebuchet MS" pitchFamily="34" charset="-122"/>
+                <a:cs typeface="Trebuchet MS" pitchFamily="34" charset="-120"/>
+              </a:rPr>
+              <a:t>Équipement physique · minimum national</a:t>
+            </a:r>
+            <a:endParaRPr lang="en-US" sz="950" dirty="0"/>
+          </a:p>
+        </p:txBody>
+      </p:sp>
+      <p:sp>
+        <p:nvSpPr>
+          <p:cNvPr id="17" name="Text 13"/>
+          <p:cNvSpPr txBox="1"/>
+          <p:nvPr/>
+        </p:nvSpPr>
+        <p:spPr>
+          <a:xfrm>
+            <a:off x="9500616" y="3456432"/>
+            <a:ext cx="2011680" cy="365760"/>
+          </a:xfrm>
+          <a:prstGeom prst="rect">
+            <a:avLst/>
+          </a:prstGeom>
+          <a:noFill/>
+          <a:ln/>
+        </p:spPr>
+        <p:txBody>
+          <a:bodyPr wrap="square" rtlCol="0" anchor="ctr"/>
+          <a:lstStyle/>
+          <a:p>
+            <a:pPr algn="r" indent="0" marL="0">
+              <a:buNone/>
+            </a:pPr>
+            <a:r>
               <a:rPr lang="en-US" sz="1700" b="1" dirty="0">
                 <a:solidFill>
-                  <a:srgbClr val="0E7C7B"/>
+                  <a:srgbClr val="FFFFFF"/>
                 </a:solidFill>
                 <a:latin typeface="Georgia" pitchFamily="34" charset="0"/>
                 <a:ea typeface="Georgia" pitchFamily="34" charset="-122"/>
                 <a:cs typeface="Georgia" pitchFamily="34" charset="-120"/>
               </a:rPr>
-              <a:t>Science</a:t>
+              <a:t>2,4 Md FCFA</a:t>
             </a:r>
             <a:endParaRPr lang="en-US" sz="1700" dirty="0"/>
           </a:p>
@@ -16034,195 +15657,14 @@
       </p:sp>
       <p:sp>
         <p:nvSpPr>
-          <p:cNvPr id="15" name="Text 11"/>
-          <p:cNvSpPr txBox="1"/>
-          <p:nvPr/>
-        </p:nvSpPr>
-        <p:spPr>
-          <a:xfrm>
-            <a:off x="8293608" y="2743200"/>
-            <a:ext cx="3273552" cy="749808"/>
-          </a:xfrm>
-          <a:prstGeom prst="rect">
-            <a:avLst/>
-          </a:prstGeom>
-          <a:noFill/>
-          <a:ln/>
-        </p:spPr>
-        <p:txBody>
-          <a:bodyPr wrap="square" rtlCol="0" anchor="ctr"/>
-          <a:lstStyle/>
-          <a:p>
-            <a:pPr algn="l" indent="0" marL="0">
-              <a:lnSpc>
-                <a:spcPct val="110000"/>
-              </a:lnSpc>
-              <a:buNone/>
-            </a:pPr>
-            <a:r>
-              <a:rPr lang="en-US" sz="1000" dirty="0">
-                <a:solidFill>
-                  <a:srgbClr val="22333B"/>
-                </a:solidFill>
-                <a:latin typeface="Trebuchet MS" pitchFamily="34" charset="0"/>
-                <a:ea typeface="Trebuchet MS" pitchFamily="34" charset="-122"/>
-                <a:cs typeface="Trebuchet MS" pitchFamily="34" charset="-120"/>
-              </a:rPr>
-              <a:t>de Jong, Linn et Zacharia (2013) : combiné virtuel + réel, les meilleurs apprentissages.</a:t>
-            </a:r>
-            <a:endParaRPr lang="en-US" sz="1000" dirty="0"/>
-          </a:p>
-        </p:txBody>
-      </p:sp>
-      <p:sp>
-        <p:nvSpPr>
-          <p:cNvPr id="16" name="Shape 12"/>
+          <p:cNvPr id="18" name="Shape 14"/>
           <p:cNvSpPr/>
           <p:nvPr/>
         </p:nvSpPr>
         <p:spPr>
           <a:xfrm>
-            <a:off x="6903720" y="3767328"/>
-            <a:ext cx="4828032" cy="2340864"/>
-          </a:xfrm>
-          <a:prstGeom prst="roundRect">
-            <a:avLst>
-              <a:gd name="adj" fmla="val 3906"/>
-            </a:avLst>
-          </a:prstGeom>
-          <a:solidFill>
-            <a:srgbClr val="0A5C5B"/>
-          </a:solidFill>
-          <a:ln/>
-        </p:spPr>
-      </p:sp>
-      <p:sp>
-        <p:nvSpPr>
-          <p:cNvPr id="17" name="Text 13"/>
-          <p:cNvSpPr txBox="1"/>
-          <p:nvPr/>
-        </p:nvSpPr>
-        <p:spPr>
-          <a:xfrm>
-            <a:off x="7123176" y="3895344"/>
-            <a:ext cx="4389120" cy="292608"/>
-          </a:xfrm>
-          <a:prstGeom prst="rect">
-            <a:avLst/>
-          </a:prstGeom>
-          <a:noFill/>
-          <a:ln/>
-        </p:spPr>
-        <p:txBody>
-          <a:bodyPr wrap="square" rtlCol="0" anchor="ctr"/>
-          <a:lstStyle/>
-          <a:p>
-            <a:pPr algn="l" indent="0" marL="0">
-              <a:buNone/>
-            </a:pPr>
-            <a:r>
-              <a:rPr lang="en-US" sz="1200" b="1" spc="50" kern="0" dirty="0">
-                <a:solidFill>
-                  <a:srgbClr val="F8E4D9"/>
-                </a:solidFill>
-                <a:latin typeface="Trebuchet MS" pitchFamily="34" charset="0"/>
-                <a:ea typeface="Trebuchet MS" pitchFamily="34" charset="-122"/>
-                <a:cs typeface="Trebuchet MS" pitchFamily="34" charset="-120"/>
-              </a:rPr>
-              <a:t>Ce qu'on gagne en choisissant le virtuel</a:t>
-            </a:r>
-            <a:endParaRPr lang="en-US" sz="1200" dirty="0"/>
-          </a:p>
-        </p:txBody>
-      </p:sp>
-      <p:sp>
-        <p:nvSpPr>
-          <p:cNvPr id="18" name="Text 14"/>
-          <p:cNvSpPr txBox="1"/>
-          <p:nvPr/>
-        </p:nvSpPr>
-        <p:spPr>
-          <a:xfrm>
-            <a:off x="7123176" y="4261104"/>
-            <a:ext cx="2834640" cy="219456"/>
-          </a:xfrm>
-          <a:prstGeom prst="rect">
-            <a:avLst/>
-          </a:prstGeom>
-          <a:noFill/>
-          <a:ln/>
-        </p:spPr>
-        <p:txBody>
-          <a:bodyPr wrap="square" rtlCol="0" anchor="ctr"/>
-          <a:lstStyle/>
-          <a:p>
-            <a:pPr algn="l" indent="0" marL="0">
-              <a:buNone/>
-            </a:pPr>
-            <a:r>
-              <a:rPr lang="en-US" sz="950" dirty="0">
-                <a:solidFill>
-                  <a:srgbClr val="C9DEDD"/>
-                </a:solidFill>
-                <a:latin typeface="Trebuchet MS" pitchFamily="34" charset="0"/>
-                <a:ea typeface="Trebuchet MS" pitchFamily="34" charset="-122"/>
-                <a:cs typeface="Trebuchet MS" pitchFamily="34" charset="-120"/>
-              </a:rPr>
-              <a:t>Équipement physique · minimum national</a:t>
-            </a:r>
-            <a:endParaRPr lang="en-US" sz="950" dirty="0"/>
-          </a:p>
-        </p:txBody>
-      </p:sp>
-      <p:sp>
-        <p:nvSpPr>
-          <p:cNvPr id="19" name="Text 15"/>
-          <p:cNvSpPr txBox="1"/>
-          <p:nvPr/>
-        </p:nvSpPr>
-        <p:spPr>
-          <a:xfrm>
-            <a:off x="9720072" y="4261104"/>
-            <a:ext cx="1792224" cy="219456"/>
-          </a:xfrm>
-          <a:prstGeom prst="rect">
-            <a:avLst/>
-          </a:prstGeom>
-          <a:noFill/>
-          <a:ln/>
-        </p:spPr>
-        <p:txBody>
-          <a:bodyPr wrap="square" rtlCol="0" anchor="ctr"/>
-          <a:lstStyle/>
-          <a:p>
-            <a:pPr algn="r" indent="0" marL="0">
-              <a:buNone/>
-            </a:pPr>
-            <a:r>
-              <a:rPr lang="en-US" sz="950" b="1" dirty="0">
-                <a:solidFill>
-                  <a:srgbClr val="FFFFFF"/>
-                </a:solidFill>
-                <a:latin typeface="Trebuchet MS" pitchFamily="34" charset="0"/>
-                <a:ea typeface="Trebuchet MS" pitchFamily="34" charset="-122"/>
-                <a:cs typeface="Trebuchet MS" pitchFamily="34" charset="-120"/>
-              </a:rPr>
-              <a:t>≈ 2,4 milliards FCFA</a:t>
-            </a:r>
-            <a:endParaRPr lang="en-US" sz="950" dirty="0"/>
-          </a:p>
-        </p:txBody>
-      </p:sp>
-      <p:sp>
-        <p:nvSpPr>
-          <p:cNvPr id="20" name="Shape 16"/>
-          <p:cNvSpPr/>
-          <p:nvPr/>
-        </p:nvSpPr>
-        <p:spPr>
-          <a:xfrm>
-            <a:off x="7123176" y="4498848"/>
-            <a:ext cx="4389120" cy="155448"/>
+            <a:off x="7123176" y="3858768"/>
+            <a:ext cx="4389120" cy="146304"/>
           </a:xfrm>
           <a:prstGeom prst="roundRect">
             <a:avLst>
@@ -16237,14 +15679,14 @@
       </p:sp>
       <p:sp>
         <p:nvSpPr>
-          <p:cNvPr id="21" name="Text 17"/>
-          <p:cNvSpPr txBox="1"/>
-          <p:nvPr/>
-        </p:nvSpPr>
-        <p:spPr>
-          <a:xfrm>
-            <a:off x="7123176" y="4718304"/>
-            <a:ext cx="4389120" cy="182880"/>
+          <p:cNvPr id="19" name="Text 15"/>
+          <p:cNvSpPr txBox="1"/>
+          <p:nvPr/>
+        </p:nvSpPr>
+        <p:spPr>
+          <a:xfrm>
+            <a:off x="7123176" y="4133088"/>
+            <a:ext cx="2331720" cy="329184"/>
           </a:xfrm>
           <a:prstGeom prst="rect">
             <a:avLst/>
@@ -16257,10 +15699,13 @@
           <a:lstStyle/>
           <a:p>
             <a:pPr algn="l" indent="0" marL="0">
-              <a:buNone/>
-            </a:pPr>
-            <a:r>
-              <a:rPr lang="en-US" sz="850" i="1" dirty="0">
+              <a:lnSpc>
+                <a:spcPct val="105000"/>
+              </a:lnSpc>
+              <a:buNone/>
+            </a:pPr>
+            <a:r>
+              <a:rPr lang="en-US" sz="950" dirty="0">
                 <a:solidFill>
                   <a:srgbClr val="C9DEDD"/>
                 </a:solidFill>
@@ -16268,46 +15713,7 @@
                 <a:ea typeface="Trebuchet MS" pitchFamily="34" charset="-122"/>
                 <a:cs typeface="Trebuchet MS" pitchFamily="34" charset="-120"/>
               </a:rPr>
-              <a:t>Au standard complet (12 M par labo, UNICEF 2025) : 9,7 Md, soit 33 ×.</a:t>
-            </a:r>
-            <a:endParaRPr lang="en-US" sz="850" dirty="0"/>
-          </a:p>
-        </p:txBody>
-      </p:sp>
-      <p:sp>
-        <p:nvSpPr>
-          <p:cNvPr id="22" name="Text 18"/>
-          <p:cNvSpPr txBox="1"/>
-          <p:nvPr/>
-        </p:nvSpPr>
-        <p:spPr>
-          <a:xfrm>
-            <a:off x="7123176" y="4956048"/>
-            <a:ext cx="2834640" cy="219456"/>
-          </a:xfrm>
-          <a:prstGeom prst="rect">
-            <a:avLst/>
-          </a:prstGeom>
-          <a:noFill/>
-          <a:ln/>
-        </p:spPr>
-        <p:txBody>
-          <a:bodyPr wrap="square" rtlCol="0" anchor="ctr"/>
-          <a:lstStyle/>
-          <a:p>
-            <a:pPr algn="l" indent="0" marL="0">
-              <a:buNone/>
-            </a:pPr>
-            <a:r>
-              <a:rPr lang="en-US" sz="950" dirty="0">
-                <a:solidFill>
-                  <a:srgbClr val="C9DEDD"/>
-                </a:solidFill>
-                <a:latin typeface="Trebuchet MS" pitchFamily="34" charset="0"/>
-                <a:ea typeface="Trebuchet MS" pitchFamily="34" charset="-122"/>
-                <a:cs typeface="Trebuchet MS" pitchFamily="34" charset="-120"/>
-              </a:rPr>
-              <a:t>VirtuLab · déploiement national (3 ans)</a:t>
+              <a:t>VirtuLab · national, trois ans</a:t>
             </a:r>
             <a:endParaRPr lang="en-US" sz="950" dirty="0"/>
           </a:p>
@@ -16315,14 +15721,14 @@
       </p:sp>
       <p:sp>
         <p:nvSpPr>
-          <p:cNvPr id="23" name="Text 19"/>
-          <p:cNvSpPr txBox="1"/>
-          <p:nvPr/>
-        </p:nvSpPr>
-        <p:spPr>
-          <a:xfrm>
-            <a:off x="9720072" y="4956048"/>
-            <a:ext cx="1792224" cy="219456"/>
+          <p:cNvPr id="20" name="Text 16"/>
+          <p:cNvSpPr txBox="1"/>
+          <p:nvPr/>
+        </p:nvSpPr>
+        <p:spPr>
+          <a:xfrm>
+            <a:off x="9500616" y="4078224"/>
+            <a:ext cx="2011680" cy="365760"/>
           </a:xfrm>
           <a:prstGeom prst="rect">
             <a:avLst/>
@@ -16338,30 +15744,30 @@
               <a:buNone/>
             </a:pPr>
             <a:r>
-              <a:rPr lang="en-US" sz="950" b="1" dirty="0">
-                <a:solidFill>
-                  <a:srgbClr val="FFFFFF"/>
-                </a:solidFill>
-                <a:latin typeface="Trebuchet MS" pitchFamily="34" charset="0"/>
-                <a:ea typeface="Trebuchet MS" pitchFamily="34" charset="-122"/>
-                <a:cs typeface="Trebuchet MS" pitchFamily="34" charset="-120"/>
+              <a:rPr lang="en-US" sz="1700" b="1" dirty="0">
+                <a:solidFill>
+                  <a:srgbClr val="DCEBEA"/>
+                </a:solidFill>
+                <a:latin typeface="Georgia" pitchFamily="34" charset="0"/>
+                <a:ea typeface="Georgia" pitchFamily="34" charset="-122"/>
+                <a:cs typeface="Georgia" pitchFamily="34" charset="-120"/>
               </a:rPr>
               <a:t>297 M FCFA</a:t>
             </a:r>
-            <a:endParaRPr lang="en-US" sz="950" dirty="0"/>
-          </a:p>
-        </p:txBody>
-      </p:sp>
-      <p:sp>
-        <p:nvSpPr>
-          <p:cNvPr id="24" name="Shape 20"/>
+            <a:endParaRPr lang="en-US" sz="1700" dirty="0"/>
+          </a:p>
+        </p:txBody>
+      </p:sp>
+      <p:sp>
+        <p:nvSpPr>
+          <p:cNvPr id="21" name="Shape 17"/>
           <p:cNvSpPr/>
           <p:nvPr/>
         </p:nvSpPr>
         <p:spPr>
           <a:xfrm>
-            <a:off x="7123176" y="5193792"/>
-            <a:ext cx="536448" cy="155448"/>
+            <a:off x="7123176" y="4480560"/>
+            <a:ext cx="536448" cy="146304"/>
           </a:xfrm>
           <a:prstGeom prst="roundRect">
             <a:avLst>
@@ -16376,14 +15782,14 @@
       </p:sp>
       <p:sp>
         <p:nvSpPr>
-          <p:cNvPr id="25" name="Text 21"/>
-          <p:cNvSpPr txBox="1"/>
-          <p:nvPr/>
-        </p:nvSpPr>
-        <p:spPr>
-          <a:xfrm>
-            <a:off x="7123176" y="5413248"/>
-            <a:ext cx="3108960" cy="457200"/>
+          <p:cNvPr id="22" name="Text 18"/>
+          <p:cNvSpPr txBox="1"/>
+          <p:nvPr/>
+        </p:nvSpPr>
+        <p:spPr>
+          <a:xfrm>
+            <a:off x="7123176" y="4736592"/>
+            <a:ext cx="4389120" cy="512064"/>
           </a:xfrm>
           <a:prstGeom prst="rect">
             <a:avLst/>
@@ -16399,7 +15805,7 @@
               <a:buNone/>
             </a:pPr>
             <a:r>
-              <a:rPr lang="en-US" sz="2200" b="1" dirty="0">
+              <a:rPr lang="en-US" sz="3000" b="1" dirty="0">
                 <a:solidFill>
                   <a:srgbClr val="F8E4D9"/>
                 </a:solidFill>
@@ -16409,39 +15815,36 @@
               </a:rPr>
               <a:t>≈ 8 × moins cher</a:t>
             </a:r>
-            <a:endParaRPr lang="en-US" sz="2200" dirty="0"/>
-          </a:p>
-        </p:txBody>
-      </p:sp>
-      <p:sp>
-        <p:nvSpPr>
-          <p:cNvPr id="26" name="Text 22"/>
-          <p:cNvSpPr txBox="1"/>
-          <p:nvPr/>
-        </p:nvSpPr>
-        <p:spPr>
-          <a:xfrm>
-            <a:off x="7123176" y="5833872"/>
-            <a:ext cx="4389120" cy="237744"/>
-          </a:xfrm>
-          <a:prstGeom prst="rect">
-            <a:avLst/>
-          </a:prstGeom>
-          <a:noFill/>
-          <a:ln/>
-        </p:spPr>
-        <p:txBody>
-          <a:bodyPr wrap="square" rtlCol="0" anchor="t"/>
+            <a:endParaRPr lang="en-US" sz="3000" dirty="0"/>
+          </a:p>
+        </p:txBody>
+      </p:sp>
+      <p:sp>
+        <p:nvSpPr>
+          <p:cNvPr id="23" name="Text 19"/>
+          <p:cNvSpPr txBox="1"/>
+          <p:nvPr/>
+        </p:nvSpPr>
+        <p:spPr>
+          <a:xfrm>
+            <a:off x="7123176" y="5266944"/>
+            <a:ext cx="4389120" cy="219456"/>
+          </a:xfrm>
+          <a:prstGeom prst="rect">
+            <a:avLst/>
+          </a:prstGeom>
+          <a:noFill/>
+          <a:ln/>
+        </p:spPr>
+        <p:txBody>
+          <a:bodyPr wrap="square" rtlCol="0" anchor="ctr"/>
           <a:lstStyle/>
           <a:p>
             <a:pPr algn="l" indent="0" marL="0">
-              <a:lnSpc>
-                <a:spcPct val="110000"/>
-              </a:lnSpc>
-              <a:buNone/>
-            </a:pPr>
-            <a:r>
-              <a:rPr lang="en-US" sz="950" dirty="0">
+              <a:buNone/>
+            </a:pPr>
+            <a:r>
+              <a:rPr lang="en-US" sz="900" i="1" dirty="0">
                 <a:solidFill>
                   <a:srgbClr val="C9DEDD"/>
                 </a:solidFill>
@@ -16449,21 +15852,21 @@
                 <a:ea typeface="Trebuchet MS" pitchFamily="34" charset="-122"/>
                 <a:cs typeface="Trebuchet MS" pitchFamily="34" charset="-120"/>
               </a:rPr>
-              <a:t>et il fonctionne là où le courant et le réseau manquent.</a:t>
-            </a:r>
-            <a:endParaRPr lang="en-US" sz="950" dirty="0"/>
-          </a:p>
-        </p:txBody>
-      </p:sp>
-      <p:sp>
-        <p:nvSpPr>
-          <p:cNvPr id="27" name="Text 23"/>
-          <p:cNvSpPr txBox="1"/>
-          <p:nvPr/>
-        </p:nvSpPr>
-        <p:spPr>
-          <a:xfrm>
-            <a:off x="6903720" y="6199632"/>
+              <a:t>et jusqu'à 33 × au standard complet (12 M par labo, UNICEF 2025).</a:t>
+            </a:r>
+            <a:endParaRPr lang="en-US" sz="900" dirty="0"/>
+          </a:p>
+        </p:txBody>
+      </p:sp>
+      <p:sp>
+        <p:nvSpPr>
+          <p:cNvPr id="24" name="Text 20"/>
+          <p:cNvSpPr txBox="1"/>
+          <p:nvPr/>
+        </p:nvSpPr>
+        <p:spPr>
+          <a:xfrm>
+            <a:off x="6903720" y="5897880"/>
             <a:ext cx="4828032" cy="274320"/>
           </a:xfrm>
           <a:prstGeom prst="rect">
@@ -16496,7 +15899,7 @@
       </p:sp>
       <p:sp>
         <p:nvSpPr>
-          <p:cNvPr id="28" name="Text 24"/>
+          <p:cNvPr id="25" name="Text 21"/>
           <p:cNvSpPr txBox="1"/>
           <p:nvPr/>
         </p:nvSpPr>
@@ -16527,7 +15930,7 @@
                 <a:ea typeface="Trebuchet MS" pitchFamily="34" charset="-122"/>
                 <a:cs typeface="Trebuchet MS" pitchFamily="34" charset="-120"/>
               </a:rPr>
-              <a:t>Sources : Li et Liang (2024), PLOS ONE ; Labster ; de Jong et al. (2013). Coûts : min. ≈ 3 M/labo (marché togolais) ; standard ≈ 12 M (UNICEF, 2025).</a:t>
+              <a:t>Sources : Li et Liang (2024), PLOS ONE ; Labster. Coûts : minimum ≈ 3 M FCFA par labo (marché togolais) ; standard 12 M (UNICEF, 2025).</a:t>
             </a:r>
             <a:endParaRPr lang="en-US" sz="900" dirty="0"/>
           </a:p>
@@ -16535,7 +15938,7 @@
       </p:sp>
       <p:sp>
         <p:nvSpPr>
-          <p:cNvPr id="29" name="Text 25"/>
+          <p:cNvPr id="26" name="Text 22"/>
           <p:cNvSpPr txBox="1"/>
           <p:nvPr/>
         </p:nvSpPr>

</xml_diff>